<commit_message>
feat(ppt-v2.0.0): overview + dataset/graph + algorithms slides (Task 2)
Co-Authored-By: Claude Fable 5 <noreply@anthropic.com>
</commit_message>
<xml_diff>
--- a/docs/ppt-v2.0.0/答辩PPT-v2.0.0.pptx
+++ b/docs/ppt-v2.0.0/答辩PPT-v2.0.0.pptx
@@ -6,6 +6,9 @@
   </p:sldMasterIdLst>
   <p:sldIdLst>
     <p:sldId id="256" r:id="rId7"/>
+    <p:sldId id="257" r:id="rId8"/>
+    <p:sldId id="258" r:id="rId9"/>
+    <p:sldId id="259" r:id="rId10"/>
   </p:sldIdLst>
   <p:sldSz cx="12192000" cy="6858000" type="screen4x3"/>
   <p:notesSz cx="6858000" cy="9144000"/>
@@ -3719,6 +3722,4954 @@
                 <a:cs typeface="Arial"/>
               </a:rPr>
               <a:t>v2.0.0 · 小组答辩版 · github.com/Weishi-corroding/shanghai-metro-pathfinder</a:t>
+            </a:r>
+          </a:p>
+        </p:txBody>
+      </p:sp>
+    </p:spTree>
+  </p:cSld>
+  <p:clrMapOvr>
+    <a:masterClrMapping/>
+  </p:clrMapOvr>
+  <p:transition xmlns:p14="http://schemas.microsoft.com/office/powerpoint/2010/main" p14:dur="400">
+    <p:fade/>
+  </p:transition>
+</p:sld>
+</file>
+
+<file path=ppt/slides/slide2.xml><?xml version="1.0" encoding="utf-8"?>
+<p:sld xmlns:a="http://schemas.openxmlformats.org/drawingml/2006/main" xmlns:r="http://schemas.openxmlformats.org/officeDocument/2006/relationships" xmlns:p="http://schemas.openxmlformats.org/presentationml/2006/main">
+  <p:cSld>
+    <p:spTree>
+      <p:nvGrpSpPr>
+        <p:cNvPr id="1" name=""/>
+        <p:cNvGrpSpPr/>
+        <p:nvPr/>
+      </p:nvGrpSpPr>
+      <p:grpSpPr>
+        <a:xfrm>
+          <a:off x="0" y="0"/>
+          <a:ext cx="0" cy="0"/>
+          <a:chOff x="0" y="0"/>
+          <a:chExt cx="0" cy="0"/>
+        </a:xfrm>
+      </p:grpSpPr>
+      <p:sp>
+        <p:nvSpPr>
+          <p:cNvPr id="2" name="Rectangle 2"/>
+          <p:cNvSpPr/>
+          <p:nvPr/>
+        </p:nvSpPr>
+        <p:spPr>
+          <a:xfrm>
+            <a:off x="0" y="0"/>
+            <a:ext cx="12192000" cy="6858000"/>
+          </a:xfrm>
+          <a:prstGeom prst="rect">
+            <a:avLst/>
+          </a:prstGeom>
+          <a:solidFill>
+            <a:srgbClr val="0B1F3A"/>
+          </a:solidFill>
+          <a:ln>
+            <a:noFill/>
+          </a:ln>
+        </p:spPr>
+      </p:sp>
+      <p:sp>
+        <p:nvSpPr>
+          <p:cNvPr id="3" name="TextBox 3"/>
+          <p:cNvSpPr txBox="1"/>
+          <p:nvPr/>
+        </p:nvSpPr>
+        <p:spPr>
+          <a:xfrm>
+            <a:off x="745236" y="501015"/>
+            <a:ext cx="1899361" cy="645414"/>
+          </a:xfrm>
+          <a:prstGeom prst="rect">
+            <a:avLst/>
+          </a:prstGeom>
+          <a:noFill/>
+          <a:ln>
+            <a:noFill/>
+          </a:ln>
+        </p:spPr>
+        <p:txBody>
+          <a:bodyPr wrap="none" lIns="0" tIns="0" rIns="0" bIns="0" anchor="t" anchorCtr="0">
+            <a:spAutoFit/>
+          </a:bodyPr>
+          <a:lstStyle/>
+          <a:p>
+            <a:pPr algn="l"/>
+            <a:r>
+              <a:rPr lang="zh-CN" sz="3300" b="1" dirty="0">
+                <a:solidFill>
+                  <a:srgbClr val="FFFFFF"/>
+                </a:solidFill>
+                <a:latin typeface="Arial"/>
+                <a:ea typeface="Microsoft YaHei"/>
+                <a:cs typeface="Arial"/>
+              </a:rPr>
+              <a:t>项目概览</a:t>
+            </a:r>
+          </a:p>
+        </p:txBody>
+      </p:sp>
+      <p:sp>
+        <p:nvSpPr>
+          <p:cNvPr id="4" name="Line 4"/>
+          <p:cNvSpPr/>
+          <p:nvPr/>
+        </p:nvSpPr>
+        <p:spPr>
+          <a:xfrm>
+            <a:off x="762000" y="1047750"/>
+            <a:ext cx="10668000" cy="9525"/>
+          </a:xfrm>
+          <a:custGeom>
+            <a:avLst/>
+            <a:gdLst/>
+            <a:ahLst/>
+            <a:cxnLst/>
+            <a:rect l="l" t="t" r="r" b="b"/>
+            <a:pathLst>
+              <a:path w="10668000" h="9525">
+                <a:moveTo>
+                  <a:pt x="0" y="0"/>
+                </a:moveTo>
+                <a:lnTo>
+                  <a:pt x="10668000" y="0"/>
+                </a:lnTo>
+              </a:path>
+            </a:pathLst>
+          </a:custGeom>
+          <a:noFill/>
+          <a:ln w="28575" cap="rnd">
+            <a:solidFill>
+              <a:srgbClr val="E4002B"/>
+            </a:solidFill>
+          </a:ln>
+        </p:spPr>
+      </p:sp>
+      <p:sp>
+        <p:nvSpPr>
+          <p:cNvPr id="5" name="TextBox 5"/>
+          <p:cNvSpPr txBox="1"/>
+          <p:nvPr/>
+        </p:nvSpPr>
+        <p:spPr>
+          <a:xfrm>
+            <a:off x="753618" y="1203008"/>
+            <a:ext cx="2937681" cy="322707"/>
+          </a:xfrm>
+          <a:prstGeom prst="rect">
+            <a:avLst/>
+          </a:prstGeom>
+          <a:noFill/>
+          <a:ln>
+            <a:noFill/>
+          </a:ln>
+        </p:spPr>
+        <p:txBody>
+          <a:bodyPr wrap="none" lIns="0" tIns="0" rIns="0" bIns="0" anchor="t" anchorCtr="0">
+            <a:spAutoFit/>
+          </a:bodyPr>
+          <a:lstStyle/>
+          <a:p>
+            <a:pPr algn="l"/>
+            <a:r>
+              <a:rPr lang="zh-CN" sz="1650" dirty="0">
+                <a:solidFill>
+                  <a:srgbClr val="B7C7DE"/>
+                </a:solidFill>
+                <a:latin typeface="Arial"/>
+                <a:ea typeface="Microsoft YaHei"/>
+                <a:cs typeface="Arial"/>
+              </a:rPr>
+              <a:t>三大功能模块 · 系统数据规模</a:t>
+            </a:r>
+          </a:p>
+        </p:txBody>
+      </p:sp>
+      <p:sp>
+        <p:nvSpPr>
+          <p:cNvPr id="6" name="Rectangle 6"/>
+          <p:cNvSpPr/>
+          <p:nvPr/>
+        </p:nvSpPr>
+        <p:spPr>
+          <a:xfrm>
+            <a:off x="762000" y="1714500"/>
+            <a:ext cx="3619500" cy="2476500"/>
+          </a:xfrm>
+          <a:prstGeom prst="roundRect">
+            <a:avLst>
+              <a:gd name="adj" fmla="val 4615"/>
+            </a:avLst>
+          </a:prstGeom>
+          <a:solidFill>
+            <a:srgbClr val="132846"/>
+          </a:solidFill>
+          <a:ln w="19050">
+            <a:solidFill>
+              <a:srgbClr val="1E3A5F"/>
+            </a:solidFill>
+          </a:ln>
+        </p:spPr>
+      </p:sp>
+      <p:sp>
+        <p:nvSpPr>
+          <p:cNvPr id="7" name="TextBox 7"/>
+          <p:cNvSpPr txBox="1"/>
+          <p:nvPr/>
+        </p:nvSpPr>
+        <p:spPr>
+          <a:xfrm>
+            <a:off x="941832" y="1868805"/>
+            <a:ext cx="1624256" cy="410718"/>
+          </a:xfrm>
+          <a:prstGeom prst="rect">
+            <a:avLst/>
+          </a:prstGeom>
+          <a:noFill/>
+          <a:ln>
+            <a:noFill/>
+          </a:ln>
+        </p:spPr>
+        <p:txBody>
+          <a:bodyPr wrap="none" lIns="0" tIns="0" rIns="0" bIns="0" anchor="t" anchorCtr="0">
+            <a:spAutoFit/>
+          </a:bodyPr>
+          <a:lstStyle/>
+          <a:p>
+            <a:pPr algn="l"/>
+            <a:r>
+              <a:rPr lang="zh-CN" sz="2100" b="1" dirty="0">
+                <a:solidFill>
+                  <a:srgbClr val="FFD54F"/>
+                </a:solidFill>
+                <a:latin typeface="Arial"/>
+                <a:ea typeface="Microsoft YaHei"/>
+                <a:cs typeface="Arial"/>
+              </a:rPr>
+              <a:t>🗺️ 路径规划</a:t>
+            </a:r>
+          </a:p>
+        </p:txBody>
+      </p:sp>
+      <p:sp>
+        <p:nvSpPr>
+          <p:cNvPr id="8" name="TextBox 8"/>
+          <p:cNvSpPr txBox="1"/>
+          <p:nvPr/>
+        </p:nvSpPr>
+        <p:spPr>
+          <a:xfrm>
+            <a:off x="944880" y="2505075"/>
+            <a:ext cx="1862900" cy="293370"/>
+          </a:xfrm>
+          <a:prstGeom prst="rect">
+            <a:avLst/>
+          </a:prstGeom>
+          <a:noFill/>
+          <a:ln>
+            <a:noFill/>
+          </a:ln>
+        </p:spPr>
+        <p:txBody>
+          <a:bodyPr wrap="none" lIns="0" tIns="0" rIns="0" bIns="0" anchor="t" anchorCtr="0">
+            <a:spAutoFit/>
+          </a:bodyPr>
+          <a:lstStyle/>
+          <a:p>
+            <a:pPr algn="l"/>
+            <a:r>
+              <a:rPr lang="zh-CN" sz="1500" dirty="0">
+                <a:solidFill>
+                  <a:srgbClr val="DDEBFF"/>
+                </a:solidFill>
+                <a:latin typeface="Arial"/>
+                <a:ea typeface="Microsoft YaHei"/>
+                <a:cs typeface="Arial"/>
+              </a:rPr>
+              <a:t>最短时间 / 最少换乘</a:t>
+            </a:r>
+          </a:p>
+        </p:txBody>
+      </p:sp>
+      <p:sp>
+        <p:nvSpPr>
+          <p:cNvPr id="9" name="TextBox 9"/>
+          <p:cNvSpPr txBox="1"/>
+          <p:nvPr/>
+        </p:nvSpPr>
+        <p:spPr>
+          <a:xfrm>
+            <a:off x="944880" y="2886075"/>
+            <a:ext cx="1615440" cy="293370"/>
+          </a:xfrm>
+          <a:prstGeom prst="rect">
+            <a:avLst/>
+          </a:prstGeom>
+          <a:noFill/>
+          <a:ln>
+            <a:noFill/>
+          </a:ln>
+        </p:spPr>
+        <p:txBody>
+          <a:bodyPr wrap="none" lIns="0" tIns="0" rIns="0" bIns="0" anchor="t" anchorCtr="0">
+            <a:spAutoFit/>
+          </a:bodyPr>
+          <a:lstStyle/>
+          <a:p>
+            <a:pPr algn="l"/>
+            <a:r>
+              <a:rPr lang="zh-CN" sz="1500" dirty="0">
+                <a:solidFill>
+                  <a:srgbClr val="DDEBFF"/>
+                </a:solidFill>
+                <a:latin typeface="Arial"/>
+                <a:ea typeface="Microsoft YaHei"/>
+                <a:cs typeface="Arial"/>
+              </a:rPr>
+              <a:t>K 优路径（K=3）</a:t>
+            </a:r>
+          </a:p>
+        </p:txBody>
+      </p:sp>
+      <p:sp>
+        <p:nvSpPr>
+          <p:cNvPr id="10" name="TextBox 10"/>
+          <p:cNvSpPr txBox="1"/>
+          <p:nvPr/>
+        </p:nvSpPr>
+        <p:spPr>
+          <a:xfrm>
+            <a:off x="944880" y="3267075"/>
+            <a:ext cx="1226820" cy="293370"/>
+          </a:xfrm>
+          <a:prstGeom prst="rect">
+            <a:avLst/>
+          </a:prstGeom>
+          <a:noFill/>
+          <a:ln>
+            <a:noFill/>
+          </a:ln>
+        </p:spPr>
+        <p:txBody>
+          <a:bodyPr wrap="none" lIns="0" tIns="0" rIns="0" bIns="0" anchor="t" anchorCtr="0">
+            <a:spAutoFit/>
+          </a:bodyPr>
+          <a:lstStyle/>
+          <a:p>
+            <a:pPr algn="l"/>
+            <a:r>
+              <a:rPr lang="zh-CN" sz="1500" dirty="0">
+                <a:solidFill>
+                  <a:srgbClr val="DDEBFF"/>
+                </a:solidFill>
+                <a:latin typeface="Arial"/>
+                <a:ea typeface="Microsoft YaHei"/>
+                <a:cs typeface="Arial"/>
+              </a:rPr>
+              <a:t>换乘节点拆分</a:t>
+            </a:r>
+          </a:p>
+        </p:txBody>
+      </p:sp>
+      <p:sp>
+        <p:nvSpPr>
+          <p:cNvPr id="11" name="TextBox 11"/>
+          <p:cNvSpPr txBox="1"/>
+          <p:nvPr/>
+        </p:nvSpPr>
+        <p:spPr>
+          <a:xfrm>
+            <a:off x="944880" y="3648075"/>
+            <a:ext cx="1382095" cy="293370"/>
+          </a:xfrm>
+          <a:prstGeom prst="rect">
+            <a:avLst/>
+          </a:prstGeom>
+          <a:noFill/>
+          <a:ln>
+            <a:noFill/>
+          </a:ln>
+        </p:spPr>
+        <p:txBody>
+          <a:bodyPr wrap="none" lIns="0" tIns="0" rIns="0" bIns="0" anchor="t" anchorCtr="0">
+            <a:spAutoFit/>
+          </a:bodyPr>
+          <a:lstStyle/>
+          <a:p>
+            <a:pPr algn="l"/>
+            <a:r>
+              <a:rPr lang="en-US" sz="1500" dirty="0">
+                <a:solidFill>
+                  <a:srgbClr val="DDEBFF"/>
+                </a:solidFill>
+                <a:latin typeface="Arial"/>
+                <a:ea typeface="Arial"/>
+                <a:cs typeface="Arial"/>
+              </a:rPr>
+              <a:t>Dijkstra + Yen</a:t>
+            </a:r>
+          </a:p>
+        </p:txBody>
+      </p:sp>
+      <p:sp>
+        <p:nvSpPr>
+          <p:cNvPr id="12" name="Rectangle 12"/>
+          <p:cNvSpPr/>
+          <p:nvPr/>
+        </p:nvSpPr>
+        <p:spPr>
+          <a:xfrm>
+            <a:off x="4476750" y="1714500"/>
+            <a:ext cx="3619500" cy="2476500"/>
+          </a:xfrm>
+          <a:prstGeom prst="roundRect">
+            <a:avLst>
+              <a:gd name="adj" fmla="val 4615"/>
+            </a:avLst>
+          </a:prstGeom>
+          <a:solidFill>
+            <a:srgbClr val="132846"/>
+          </a:solidFill>
+          <a:ln w="19050">
+            <a:solidFill>
+              <a:srgbClr val="1E3A5F"/>
+            </a:solidFill>
+          </a:ln>
+        </p:spPr>
+      </p:sp>
+      <p:sp>
+        <p:nvSpPr>
+          <p:cNvPr id="13" name="TextBox 13"/>
+          <p:cNvSpPr txBox="1"/>
+          <p:nvPr/>
+        </p:nvSpPr>
+        <p:spPr>
+          <a:xfrm>
+            <a:off x="4656582" y="1868805"/>
+            <a:ext cx="1624256" cy="410718"/>
+          </a:xfrm>
+          <a:prstGeom prst="rect">
+            <a:avLst/>
+          </a:prstGeom>
+          <a:noFill/>
+          <a:ln>
+            <a:noFill/>
+          </a:ln>
+        </p:spPr>
+        <p:txBody>
+          <a:bodyPr wrap="none" lIns="0" tIns="0" rIns="0" bIns="0" anchor="t" anchorCtr="0">
+            <a:spAutoFit/>
+          </a:bodyPr>
+          <a:lstStyle/>
+          <a:p>
+            <a:pPr algn="l"/>
+            <a:r>
+              <a:rPr lang="zh-CN" sz="2100" b="1" dirty="0">
+                <a:solidFill>
+                  <a:srgbClr val="FFD54F"/>
+                </a:solidFill>
+                <a:latin typeface="Arial"/>
+                <a:ea typeface="Microsoft YaHei"/>
+                <a:cs typeface="Arial"/>
+              </a:rPr>
+              <a:t>⚙️ 运营管理</a:t>
+            </a:r>
+          </a:p>
+        </p:txBody>
+      </p:sp>
+      <p:sp>
+        <p:nvSpPr>
+          <p:cNvPr id="14" name="TextBox 14"/>
+          <p:cNvSpPr txBox="1"/>
+          <p:nvPr/>
+        </p:nvSpPr>
+        <p:spPr>
+          <a:xfrm>
+            <a:off x="4659630" y="2505075"/>
+            <a:ext cx="1337882" cy="293370"/>
+          </a:xfrm>
+          <a:prstGeom prst="rect">
+            <a:avLst/>
+          </a:prstGeom>
+          <a:noFill/>
+          <a:ln>
+            <a:noFill/>
+          </a:ln>
+        </p:spPr>
+        <p:txBody>
+          <a:bodyPr wrap="none" lIns="0" tIns="0" rIns="0" bIns="0" anchor="t" anchorCtr="0">
+            <a:spAutoFit/>
+          </a:bodyPr>
+          <a:lstStyle/>
+          <a:p>
+            <a:pPr algn="l"/>
+            <a:r>
+              <a:rPr lang="zh-CN" sz="1500" dirty="0">
+                <a:solidFill>
+                  <a:srgbClr val="DDEBFF"/>
+                </a:solidFill>
+                <a:latin typeface="Arial"/>
+                <a:ea typeface="Microsoft YaHei"/>
+                <a:cs typeface="Arial"/>
+              </a:rPr>
+              <a:t>单站关闭/开启</a:t>
+            </a:r>
+          </a:p>
+        </p:txBody>
+      </p:sp>
+      <p:sp>
+        <p:nvSpPr>
+          <p:cNvPr id="15" name="TextBox 15"/>
+          <p:cNvSpPr txBox="1"/>
+          <p:nvPr/>
+        </p:nvSpPr>
+        <p:spPr>
+          <a:xfrm>
+            <a:off x="4659630" y="2886075"/>
+            <a:ext cx="1348740" cy="293370"/>
+          </a:xfrm>
+          <a:prstGeom prst="rect">
+            <a:avLst/>
+          </a:prstGeom>
+          <a:noFill/>
+          <a:ln>
+            <a:noFill/>
+          </a:ln>
+        </p:spPr>
+        <p:txBody>
+          <a:bodyPr wrap="none" lIns="0" tIns="0" rIns="0" bIns="0" anchor="t" anchorCtr="0">
+            <a:spAutoFit/>
+          </a:bodyPr>
+          <a:lstStyle/>
+          <a:p>
+            <a:pPr algn="l"/>
+            <a:r>
+              <a:rPr lang="zh-CN" sz="1500" dirty="0">
+                <a:solidFill>
+                  <a:srgbClr val="DDEBFF"/>
+                </a:solidFill>
+                <a:latin typeface="Arial"/>
+                <a:ea typeface="Microsoft YaHei"/>
+                <a:cs typeface="Arial"/>
+              </a:rPr>
+              <a:t>批量 CSV 更新</a:t>
+            </a:r>
+          </a:p>
+        </p:txBody>
+      </p:sp>
+      <p:sp>
+        <p:nvSpPr>
+          <p:cNvPr id="16" name="TextBox 16"/>
+          <p:cNvSpPr txBox="1"/>
+          <p:nvPr/>
+        </p:nvSpPr>
+        <p:spPr>
+          <a:xfrm>
+            <a:off x="4659630" y="3267075"/>
+            <a:ext cx="1226820" cy="293370"/>
+          </a:xfrm>
+          <a:prstGeom prst="rect">
+            <a:avLst/>
+          </a:prstGeom>
+          <a:noFill/>
+          <a:ln>
+            <a:noFill/>
+          </a:ln>
+        </p:spPr>
+        <p:txBody>
+          <a:bodyPr wrap="none" lIns="0" tIns="0" rIns="0" bIns="0" anchor="t" anchorCtr="0">
+            <a:spAutoFit/>
+          </a:bodyPr>
+          <a:lstStyle/>
+          <a:p>
+            <a:pPr algn="l"/>
+            <a:r>
+              <a:rPr lang="zh-CN" sz="1500" dirty="0">
+                <a:solidFill>
+                  <a:srgbClr val="DDEBFF"/>
+                </a:solidFill>
+                <a:latin typeface="Arial"/>
+                <a:ea typeface="Microsoft YaHei"/>
+                <a:cs typeface="Arial"/>
+              </a:rPr>
+              <a:t>恢复初始状态</a:t>
+            </a:r>
+          </a:p>
+        </p:txBody>
+      </p:sp>
+      <p:sp>
+        <p:nvSpPr>
+          <p:cNvPr id="17" name="TextBox 17"/>
+          <p:cNvSpPr txBox="1"/>
+          <p:nvPr/>
+        </p:nvSpPr>
+        <p:spPr>
+          <a:xfrm>
+            <a:off x="4659630" y="3648075"/>
+            <a:ext cx="1226820" cy="293370"/>
+          </a:xfrm>
+          <a:prstGeom prst="rect">
+            <a:avLst/>
+          </a:prstGeom>
+          <a:noFill/>
+          <a:ln>
+            <a:noFill/>
+          </a:ln>
+        </p:spPr>
+        <p:txBody>
+          <a:bodyPr wrap="none" lIns="0" tIns="0" rIns="0" bIns="0" anchor="t" anchorCtr="0">
+            <a:spAutoFit/>
+          </a:bodyPr>
+          <a:lstStyle/>
+          <a:p>
+            <a:pPr algn="l"/>
+            <a:r>
+              <a:rPr lang="zh-CN" sz="1500" dirty="0">
+                <a:solidFill>
+                  <a:srgbClr val="DDEBFF"/>
+                </a:solidFill>
+                <a:latin typeface="Arial"/>
+                <a:ea typeface="Microsoft YaHei"/>
+                <a:cs typeface="Arial"/>
+              </a:rPr>
+              <a:t>闭站路径过滤</a:t>
+            </a:r>
+          </a:p>
+        </p:txBody>
+      </p:sp>
+      <p:sp>
+        <p:nvSpPr>
+          <p:cNvPr id="18" name="Rectangle 18"/>
+          <p:cNvSpPr/>
+          <p:nvPr/>
+        </p:nvSpPr>
+        <p:spPr>
+          <a:xfrm>
+            <a:off x="8191500" y="1714500"/>
+            <a:ext cx="3619500" cy="2476500"/>
+          </a:xfrm>
+          <a:prstGeom prst="roundRect">
+            <a:avLst>
+              <a:gd name="adj" fmla="val 4615"/>
+            </a:avLst>
+          </a:prstGeom>
+          <a:solidFill>
+            <a:srgbClr val="132846"/>
+          </a:solidFill>
+          <a:ln w="19050">
+            <a:solidFill>
+              <a:srgbClr val="1E3A5F"/>
+            </a:solidFill>
+          </a:ln>
+        </p:spPr>
+      </p:sp>
+      <p:sp>
+        <p:nvSpPr>
+          <p:cNvPr id="19" name="TextBox 19"/>
+          <p:cNvSpPr txBox="1"/>
+          <p:nvPr/>
+        </p:nvSpPr>
+        <p:spPr>
+          <a:xfrm>
+            <a:off x="8371332" y="1868805"/>
+            <a:ext cx="1460996" cy="410718"/>
+          </a:xfrm>
+          <a:prstGeom prst="rect">
+            <a:avLst/>
+          </a:prstGeom>
+          <a:noFill/>
+          <a:ln>
+            <a:noFill/>
+          </a:ln>
+        </p:spPr>
+        <p:txBody>
+          <a:bodyPr wrap="none" lIns="0" tIns="0" rIns="0" bIns="0" anchor="t" anchorCtr="0">
+            <a:spAutoFit/>
+          </a:bodyPr>
+          <a:lstStyle/>
+          <a:p>
+            <a:pPr algn="l"/>
+            <a:r>
+              <a:rPr lang="zh-CN" sz="2100" b="1" dirty="0">
+                <a:solidFill>
+                  <a:srgbClr val="FFD54F"/>
+                </a:solidFill>
+                <a:latin typeface="Arial"/>
+                <a:ea typeface="Microsoft YaHei"/>
+                <a:cs typeface="Arial"/>
+              </a:rPr>
+              <a:t>📊 网络分析</a:t>
+            </a:r>
+          </a:p>
+        </p:txBody>
+      </p:sp>
+      <p:sp>
+        <p:nvSpPr>
+          <p:cNvPr id="20" name="TextBox 20"/>
+          <p:cNvSpPr txBox="1"/>
+          <p:nvPr/>
+        </p:nvSpPr>
+        <p:spPr>
+          <a:xfrm>
+            <a:off x="8374380" y="2505075"/>
+            <a:ext cx="1284732" cy="293370"/>
+          </a:xfrm>
+          <a:prstGeom prst="rect">
+            <a:avLst/>
+          </a:prstGeom>
+          <a:noFill/>
+          <a:ln>
+            <a:noFill/>
+          </a:ln>
+        </p:spPr>
+        <p:txBody>
+          <a:bodyPr wrap="none" lIns="0" tIns="0" rIns="0" bIns="0" anchor="t" anchorCtr="0">
+            <a:spAutoFit/>
+          </a:bodyPr>
+          <a:lstStyle/>
+          <a:p>
+            <a:pPr algn="l"/>
+            <a:r>
+              <a:rPr lang="zh-CN" sz="1500" dirty="0">
+                <a:solidFill>
+                  <a:srgbClr val="DDEBFF"/>
+                </a:solidFill>
+                <a:latin typeface="Arial"/>
+                <a:ea typeface="Microsoft YaHei"/>
+                <a:cs typeface="Arial"/>
+              </a:rPr>
+              <a:t>BFS 影响范围</a:t>
+            </a:r>
+          </a:p>
+        </p:txBody>
+      </p:sp>
+      <p:sp>
+        <p:nvSpPr>
+          <p:cNvPr id="21" name="TextBox 21"/>
+          <p:cNvSpPr txBox="1"/>
+          <p:nvPr/>
+        </p:nvSpPr>
+        <p:spPr>
+          <a:xfrm>
+            <a:off x="8374380" y="2886075"/>
+            <a:ext cx="1284732" cy="293370"/>
+          </a:xfrm>
+          <a:prstGeom prst="rect">
+            <a:avLst/>
+          </a:prstGeom>
+          <a:noFill/>
+          <a:ln>
+            <a:noFill/>
+          </a:ln>
+        </p:spPr>
+        <p:txBody>
+          <a:bodyPr wrap="none" lIns="0" tIns="0" rIns="0" bIns="0" anchor="t" anchorCtr="0">
+            <a:spAutoFit/>
+          </a:bodyPr>
+          <a:lstStyle/>
+          <a:p>
+            <a:pPr algn="l"/>
+            <a:r>
+              <a:rPr lang="zh-CN" sz="1500" dirty="0">
+                <a:solidFill>
+                  <a:srgbClr val="DDEBFF"/>
+                </a:solidFill>
+                <a:latin typeface="Arial"/>
+                <a:ea typeface="Microsoft YaHei"/>
+                <a:cs typeface="Arial"/>
+              </a:rPr>
+              <a:t>DFS 连通分量</a:t>
+            </a:r>
+          </a:p>
+        </p:txBody>
+      </p:sp>
+      <p:sp>
+        <p:nvSpPr>
+          <p:cNvPr id="22" name="TextBox 22"/>
+          <p:cNvSpPr txBox="1"/>
+          <p:nvPr/>
+        </p:nvSpPr>
+        <p:spPr>
+          <a:xfrm>
+            <a:off x="8374380" y="3267075"/>
+            <a:ext cx="836676" cy="293370"/>
+          </a:xfrm>
+          <a:prstGeom prst="rect">
+            <a:avLst/>
+          </a:prstGeom>
+          <a:noFill/>
+          <a:ln>
+            <a:noFill/>
+          </a:ln>
+        </p:spPr>
+        <p:txBody>
+          <a:bodyPr wrap="none" lIns="0" tIns="0" rIns="0" bIns="0" anchor="t" anchorCtr="0">
+            <a:spAutoFit/>
+          </a:bodyPr>
+          <a:lstStyle/>
+          <a:p>
+            <a:pPr algn="l"/>
+            <a:r>
+              <a:rPr lang="zh-CN" sz="1500" dirty="0">
+                <a:solidFill>
+                  <a:srgbClr val="DDEBFF"/>
+                </a:solidFill>
+                <a:latin typeface="Arial"/>
+                <a:ea typeface="Microsoft YaHei"/>
+                <a:cs typeface="Arial"/>
+              </a:rPr>
+              <a:t>K 阶邻居</a:t>
+            </a:r>
+          </a:p>
+        </p:txBody>
+      </p:sp>
+      <p:sp>
+        <p:nvSpPr>
+          <p:cNvPr id="23" name="TextBox 23"/>
+          <p:cNvSpPr txBox="1"/>
+          <p:nvPr/>
+        </p:nvSpPr>
+        <p:spPr>
+          <a:xfrm>
+            <a:off x="8374380" y="3648075"/>
+            <a:ext cx="1428750" cy="293370"/>
+          </a:xfrm>
+          <a:prstGeom prst="rect">
+            <a:avLst/>
+          </a:prstGeom>
+          <a:noFill/>
+          <a:ln>
+            <a:noFill/>
+          </a:ln>
+        </p:spPr>
+        <p:txBody>
+          <a:bodyPr wrap="none" lIns="0" tIns="0" rIns="0" bIns="0" anchor="t" anchorCtr="0">
+            <a:spAutoFit/>
+          </a:bodyPr>
+          <a:lstStyle/>
+          <a:p>
+            <a:pPr algn="l"/>
+            <a:r>
+              <a:rPr lang="zh-CN" sz="1500" dirty="0">
+                <a:solidFill>
+                  <a:srgbClr val="DDEBFF"/>
+                </a:solidFill>
+                <a:latin typeface="Arial"/>
+                <a:ea typeface="Microsoft YaHei"/>
+                <a:cs typeface="Arial"/>
+              </a:rPr>
+              <a:t>分量数变化检测</a:t>
+            </a:r>
+          </a:p>
+        </p:txBody>
+      </p:sp>
+      <p:sp>
+        <p:nvSpPr>
+          <p:cNvPr id="24" name="Rectangle 24"/>
+          <p:cNvSpPr/>
+          <p:nvPr/>
+        </p:nvSpPr>
+        <p:spPr>
+          <a:xfrm>
+            <a:off x="571500" y="4667250"/>
+            <a:ext cx="1714500" cy="1238250"/>
+          </a:xfrm>
+          <a:prstGeom prst="roundRect">
+            <a:avLst>
+              <a:gd name="adj" fmla="val 6154"/>
+            </a:avLst>
+          </a:prstGeom>
+          <a:solidFill>
+            <a:srgbClr val="132846"/>
+          </a:solidFill>
+          <a:ln w="19050">
+            <a:solidFill>
+              <a:srgbClr val="1E3A5F"/>
+            </a:solidFill>
+          </a:ln>
+        </p:spPr>
+      </p:sp>
+      <p:sp>
+        <p:nvSpPr>
+          <p:cNvPr id="25" name="TextBox 25"/>
+          <p:cNvSpPr txBox="1"/>
+          <p:nvPr/>
+        </p:nvSpPr>
+        <p:spPr>
+          <a:xfrm>
+            <a:off x="1229975" y="4932045"/>
+            <a:ext cx="397551" cy="469392"/>
+          </a:xfrm>
+          <a:prstGeom prst="rect">
+            <a:avLst/>
+          </a:prstGeom>
+          <a:noFill/>
+          <a:ln>
+            <a:noFill/>
+          </a:ln>
+        </p:spPr>
+        <p:txBody>
+          <a:bodyPr wrap="none" lIns="0" tIns="0" rIns="0" bIns="0" anchor="t" anchorCtr="0">
+            <a:spAutoFit/>
+          </a:bodyPr>
+          <a:lstStyle/>
+          <a:p>
+            <a:pPr algn="ctr"/>
+            <a:r>
+              <a:rPr lang="en-US" sz="2400" b="1" dirty="0">
+                <a:solidFill>
+                  <a:srgbClr val="FFD54F"/>
+                </a:solidFill>
+                <a:latin typeface="Arial"/>
+                <a:ea typeface="Arial"/>
+                <a:cs typeface="Arial"/>
+              </a:rPr>
+              <a:t>20</a:t>
+            </a:r>
+          </a:p>
+        </p:txBody>
+      </p:sp>
+      <p:sp>
+        <p:nvSpPr>
+          <p:cNvPr id="26" name="TextBox 26"/>
+          <p:cNvSpPr txBox="1"/>
+          <p:nvPr/>
+        </p:nvSpPr>
+        <p:spPr>
+          <a:xfrm>
+            <a:off x="1261110" y="5442585"/>
+            <a:ext cx="335280" cy="234696"/>
+          </a:xfrm>
+          <a:prstGeom prst="rect">
+            <a:avLst/>
+          </a:prstGeom>
+          <a:noFill/>
+          <a:ln>
+            <a:noFill/>
+          </a:ln>
+        </p:spPr>
+        <p:txBody>
+          <a:bodyPr wrap="none" lIns="0" tIns="0" rIns="0" bIns="0" anchor="t" anchorCtr="0">
+            <a:spAutoFit/>
+          </a:bodyPr>
+          <a:lstStyle/>
+          <a:p>
+            <a:pPr algn="ctr"/>
+            <a:r>
+              <a:rPr lang="zh-CN" sz="1200" dirty="0">
+                <a:solidFill>
+                  <a:srgbClr val="DDEBFF"/>
+                </a:solidFill>
+                <a:latin typeface="Arial"/>
+                <a:ea typeface="Microsoft YaHei"/>
+                <a:cs typeface="Arial"/>
+              </a:rPr>
+              <a:t>线路</a:t>
+            </a:r>
+          </a:p>
+        </p:txBody>
+      </p:sp>
+      <p:sp>
+        <p:nvSpPr>
+          <p:cNvPr id="27" name="Rectangle 27"/>
+          <p:cNvSpPr/>
+          <p:nvPr/>
+        </p:nvSpPr>
+        <p:spPr>
+          <a:xfrm>
+            <a:off x="2428875" y="4667250"/>
+            <a:ext cx="1714500" cy="1238250"/>
+          </a:xfrm>
+          <a:prstGeom prst="roundRect">
+            <a:avLst>
+              <a:gd name="adj" fmla="val 6154"/>
+            </a:avLst>
+          </a:prstGeom>
+          <a:solidFill>
+            <a:srgbClr val="132846"/>
+          </a:solidFill>
+          <a:ln w="19050">
+            <a:solidFill>
+              <a:srgbClr val="1E3A5F"/>
+            </a:solidFill>
+          </a:ln>
+        </p:spPr>
+      </p:sp>
+      <p:sp>
+        <p:nvSpPr>
+          <p:cNvPr id="28" name="TextBox 28"/>
+          <p:cNvSpPr txBox="1"/>
+          <p:nvPr/>
+        </p:nvSpPr>
+        <p:spPr>
+          <a:xfrm>
+            <a:off x="2900766" y="4932045"/>
+            <a:ext cx="770717" cy="469392"/>
+          </a:xfrm>
+          <a:prstGeom prst="rect">
+            <a:avLst/>
+          </a:prstGeom>
+          <a:noFill/>
+          <a:ln>
+            <a:noFill/>
+          </a:ln>
+        </p:spPr>
+        <p:txBody>
+          <a:bodyPr wrap="none" lIns="0" tIns="0" rIns="0" bIns="0" anchor="t" anchorCtr="0">
+            <a:spAutoFit/>
+          </a:bodyPr>
+          <a:lstStyle/>
+          <a:p>
+            <a:pPr algn="ctr"/>
+            <a:r>
+              <a:rPr lang="en-US" sz="2400" b="1" dirty="0">
+                <a:solidFill>
+                  <a:srgbClr val="FFD54F"/>
+                </a:solidFill>
+                <a:latin typeface="Arial"/>
+                <a:ea typeface="Arial"/>
+                <a:cs typeface="Arial"/>
+              </a:rPr>
+              <a:t>530+</a:t>
+            </a:r>
+          </a:p>
+        </p:txBody>
+      </p:sp>
+      <p:sp>
+        <p:nvSpPr>
+          <p:cNvPr id="29" name="TextBox 29"/>
+          <p:cNvSpPr txBox="1"/>
+          <p:nvPr/>
+        </p:nvSpPr>
+        <p:spPr>
+          <a:xfrm>
+            <a:off x="3037713" y="5442585"/>
+            <a:ext cx="496824" cy="234696"/>
+          </a:xfrm>
+          <a:prstGeom prst="rect">
+            <a:avLst/>
+          </a:prstGeom>
+          <a:noFill/>
+          <a:ln>
+            <a:noFill/>
+          </a:ln>
+        </p:spPr>
+        <p:txBody>
+          <a:bodyPr wrap="none" lIns="0" tIns="0" rIns="0" bIns="0" anchor="t" anchorCtr="0">
+            <a:spAutoFit/>
+          </a:bodyPr>
+          <a:lstStyle/>
+          <a:p>
+            <a:pPr algn="ctr"/>
+            <a:r>
+              <a:rPr lang="zh-CN" sz="1200" dirty="0">
+                <a:solidFill>
+                  <a:srgbClr val="DDEBFF"/>
+                </a:solidFill>
+                <a:latin typeface="Arial"/>
+                <a:ea typeface="Microsoft YaHei"/>
+                <a:cs typeface="Arial"/>
+              </a:rPr>
+              <a:t>物理站</a:t>
+            </a:r>
+          </a:p>
+        </p:txBody>
+      </p:sp>
+      <p:sp>
+        <p:nvSpPr>
+          <p:cNvPr id="30" name="Rectangle 30"/>
+          <p:cNvSpPr/>
+          <p:nvPr/>
+        </p:nvSpPr>
+        <p:spPr>
+          <a:xfrm>
+            <a:off x="4286250" y="4667250"/>
+            <a:ext cx="1714500" cy="1238250"/>
+          </a:xfrm>
+          <a:prstGeom prst="roundRect">
+            <a:avLst>
+              <a:gd name="adj" fmla="val 6154"/>
+            </a:avLst>
+          </a:prstGeom>
+          <a:solidFill>
+            <a:srgbClr val="132846"/>
+          </a:solidFill>
+          <a:ln w="19050">
+            <a:solidFill>
+              <a:srgbClr val="1E3A5F"/>
+            </a:solidFill>
+          </a:ln>
+        </p:spPr>
+      </p:sp>
+      <p:sp>
+        <p:nvSpPr>
+          <p:cNvPr id="31" name="TextBox 31"/>
+          <p:cNvSpPr txBox="1"/>
+          <p:nvPr/>
+        </p:nvSpPr>
+        <p:spPr>
+          <a:xfrm>
+            <a:off x="4758141" y="4932045"/>
+            <a:ext cx="770717" cy="469392"/>
+          </a:xfrm>
+          <a:prstGeom prst="rect">
+            <a:avLst/>
+          </a:prstGeom>
+          <a:noFill/>
+          <a:ln>
+            <a:noFill/>
+          </a:ln>
+        </p:spPr>
+        <p:txBody>
+          <a:bodyPr wrap="none" lIns="0" tIns="0" rIns="0" bIns="0" anchor="t" anchorCtr="0">
+            <a:spAutoFit/>
+          </a:bodyPr>
+          <a:lstStyle/>
+          <a:p>
+            <a:pPr algn="ctr"/>
+            <a:r>
+              <a:rPr lang="en-US" sz="2400" b="1" dirty="0">
+                <a:solidFill>
+                  <a:srgbClr val="FFD54F"/>
+                </a:solidFill>
+                <a:latin typeface="Arial"/>
+                <a:ea typeface="Arial"/>
+                <a:cs typeface="Arial"/>
+              </a:rPr>
+              <a:t>800+</a:t>
+            </a:r>
+          </a:p>
+        </p:txBody>
+      </p:sp>
+      <p:sp>
+        <p:nvSpPr>
+          <p:cNvPr id="32" name="TextBox 32"/>
+          <p:cNvSpPr txBox="1"/>
+          <p:nvPr/>
+        </p:nvSpPr>
+        <p:spPr>
+          <a:xfrm>
+            <a:off x="4895088" y="5442585"/>
+            <a:ext cx="496824" cy="234696"/>
+          </a:xfrm>
+          <a:prstGeom prst="rect">
+            <a:avLst/>
+          </a:prstGeom>
+          <a:noFill/>
+          <a:ln>
+            <a:noFill/>
+          </a:ln>
+        </p:spPr>
+        <p:txBody>
+          <a:bodyPr wrap="none" lIns="0" tIns="0" rIns="0" bIns="0" anchor="t" anchorCtr="0">
+            <a:spAutoFit/>
+          </a:bodyPr>
+          <a:lstStyle/>
+          <a:p>
+            <a:pPr algn="ctr"/>
+            <a:r>
+              <a:rPr lang="zh-CN" sz="1200" dirty="0">
+                <a:solidFill>
+                  <a:srgbClr val="DDEBFF"/>
+                </a:solidFill>
+                <a:latin typeface="Arial"/>
+                <a:ea typeface="Microsoft YaHei"/>
+                <a:cs typeface="Arial"/>
+              </a:rPr>
+              <a:t>图节点</a:t>
+            </a:r>
+          </a:p>
+        </p:txBody>
+      </p:sp>
+      <p:sp>
+        <p:nvSpPr>
+          <p:cNvPr id="33" name="Rectangle 33"/>
+          <p:cNvSpPr/>
+          <p:nvPr/>
+        </p:nvSpPr>
+        <p:spPr>
+          <a:xfrm>
+            <a:off x="6143625" y="4667250"/>
+            <a:ext cx="1714500" cy="1238250"/>
+          </a:xfrm>
+          <a:prstGeom prst="roundRect">
+            <a:avLst>
+              <a:gd name="adj" fmla="val 6154"/>
+            </a:avLst>
+          </a:prstGeom>
+          <a:solidFill>
+            <a:srgbClr val="132846"/>
+          </a:solidFill>
+          <a:ln w="19050">
+            <a:solidFill>
+              <a:srgbClr val="1E3A5F"/>
+            </a:solidFill>
+          </a:ln>
+        </p:spPr>
+      </p:sp>
+      <p:sp>
+        <p:nvSpPr>
+          <p:cNvPr id="34" name="TextBox 34"/>
+          <p:cNvSpPr txBox="1"/>
+          <p:nvPr/>
+        </p:nvSpPr>
+        <p:spPr>
+          <a:xfrm>
+            <a:off x="6522225" y="4932045"/>
+            <a:ext cx="957301" cy="469392"/>
+          </a:xfrm>
+          <a:prstGeom prst="rect">
+            <a:avLst/>
+          </a:prstGeom>
+          <a:noFill/>
+          <a:ln>
+            <a:noFill/>
+          </a:ln>
+        </p:spPr>
+        <p:txBody>
+          <a:bodyPr wrap="none" lIns="0" tIns="0" rIns="0" bIns="0" anchor="t" anchorCtr="0">
+            <a:spAutoFit/>
+          </a:bodyPr>
+          <a:lstStyle/>
+          <a:p>
+            <a:pPr algn="ctr"/>
+            <a:r>
+              <a:rPr lang="en-US" sz="2400" b="1" dirty="0">
+                <a:solidFill>
+                  <a:srgbClr val="FFD54F"/>
+                </a:solidFill>
+                <a:latin typeface="Arial"/>
+                <a:ea typeface="Arial"/>
+                <a:cs typeface="Arial"/>
+              </a:rPr>
+              <a:t>1300+</a:t>
+            </a:r>
+          </a:p>
+        </p:txBody>
+      </p:sp>
+      <p:sp>
+        <p:nvSpPr>
+          <p:cNvPr id="35" name="TextBox 35"/>
+          <p:cNvSpPr txBox="1"/>
+          <p:nvPr/>
+        </p:nvSpPr>
+        <p:spPr>
+          <a:xfrm>
+            <a:off x="6752463" y="5442585"/>
+            <a:ext cx="496824" cy="234696"/>
+          </a:xfrm>
+          <a:prstGeom prst="rect">
+            <a:avLst/>
+          </a:prstGeom>
+          <a:noFill/>
+          <a:ln>
+            <a:noFill/>
+          </a:ln>
+        </p:spPr>
+        <p:txBody>
+          <a:bodyPr wrap="none" lIns="0" tIns="0" rIns="0" bIns="0" anchor="t" anchorCtr="0">
+            <a:spAutoFit/>
+          </a:bodyPr>
+          <a:lstStyle/>
+          <a:p>
+            <a:pPr algn="ctr"/>
+            <a:r>
+              <a:rPr lang="zh-CN" sz="1200" dirty="0">
+                <a:solidFill>
+                  <a:srgbClr val="DDEBFF"/>
+                </a:solidFill>
+                <a:latin typeface="Arial"/>
+                <a:ea typeface="Microsoft YaHei"/>
+                <a:cs typeface="Arial"/>
+              </a:rPr>
+              <a:t>有向边</a:t>
+            </a:r>
+          </a:p>
+        </p:txBody>
+      </p:sp>
+      <p:sp>
+        <p:nvSpPr>
+          <p:cNvPr id="36" name="Rectangle 36"/>
+          <p:cNvSpPr/>
+          <p:nvPr/>
+        </p:nvSpPr>
+        <p:spPr>
+          <a:xfrm>
+            <a:off x="8001000" y="4667250"/>
+            <a:ext cx="1714500" cy="1238250"/>
+          </a:xfrm>
+          <a:prstGeom prst="roundRect">
+            <a:avLst>
+              <a:gd name="adj" fmla="val 6154"/>
+            </a:avLst>
+          </a:prstGeom>
+          <a:solidFill>
+            <a:srgbClr val="132846"/>
+          </a:solidFill>
+          <a:ln w="19050">
+            <a:solidFill>
+              <a:srgbClr val="1E3A5F"/>
+            </a:solidFill>
+          </a:ln>
+        </p:spPr>
+      </p:sp>
+      <p:sp>
+        <p:nvSpPr>
+          <p:cNvPr id="37" name="TextBox 37"/>
+          <p:cNvSpPr txBox="1"/>
+          <p:nvPr/>
+        </p:nvSpPr>
+        <p:spPr>
+          <a:xfrm>
+            <a:off x="8566183" y="4932045"/>
+            <a:ext cx="584134" cy="469392"/>
+          </a:xfrm>
+          <a:prstGeom prst="rect">
+            <a:avLst/>
+          </a:prstGeom>
+          <a:noFill/>
+          <a:ln>
+            <a:noFill/>
+          </a:ln>
+        </p:spPr>
+        <p:txBody>
+          <a:bodyPr wrap="none" lIns="0" tIns="0" rIns="0" bIns="0" anchor="t" anchorCtr="0">
+            <a:spAutoFit/>
+          </a:bodyPr>
+          <a:lstStyle/>
+          <a:p>
+            <a:pPr algn="ctr"/>
+            <a:r>
+              <a:rPr lang="en-US" sz="2400" b="1" dirty="0">
+                <a:solidFill>
+                  <a:srgbClr val="FFD54F"/>
+                </a:solidFill>
+                <a:latin typeface="Arial"/>
+                <a:ea typeface="Arial"/>
+                <a:cs typeface="Arial"/>
+              </a:rPr>
+              <a:t>278</a:t>
+            </a:r>
+          </a:p>
+        </p:txBody>
+      </p:sp>
+      <p:sp>
+        <p:nvSpPr>
+          <p:cNvPr id="38" name="TextBox 38"/>
+          <p:cNvSpPr txBox="1"/>
+          <p:nvPr/>
+        </p:nvSpPr>
+        <p:spPr>
+          <a:xfrm>
+            <a:off x="8609838" y="5442585"/>
+            <a:ext cx="496824" cy="234696"/>
+          </a:xfrm>
+          <a:prstGeom prst="rect">
+            <a:avLst/>
+          </a:prstGeom>
+          <a:noFill/>
+          <a:ln>
+            <a:noFill/>
+          </a:ln>
+        </p:spPr>
+        <p:txBody>
+          <a:bodyPr wrap="none" lIns="0" tIns="0" rIns="0" bIns="0" anchor="t" anchorCtr="0">
+            <a:spAutoFit/>
+          </a:bodyPr>
+          <a:lstStyle/>
+          <a:p>
+            <a:pPr algn="ctr"/>
+            <a:r>
+              <a:rPr lang="zh-CN" sz="1200" dirty="0">
+                <a:solidFill>
+                  <a:srgbClr val="DDEBFF"/>
+                </a:solidFill>
+                <a:latin typeface="Arial"/>
+                <a:ea typeface="Microsoft YaHei"/>
+                <a:cs typeface="Arial"/>
+              </a:rPr>
+              <a:t>换乘边</a:t>
+            </a:r>
+          </a:p>
+        </p:txBody>
+      </p:sp>
+      <p:sp>
+        <p:nvSpPr>
+          <p:cNvPr id="39" name="Rectangle 39"/>
+          <p:cNvSpPr/>
+          <p:nvPr/>
+        </p:nvSpPr>
+        <p:spPr>
+          <a:xfrm>
+            <a:off x="9858375" y="4667250"/>
+            <a:ext cx="1714500" cy="1238250"/>
+          </a:xfrm>
+          <a:prstGeom prst="roundRect">
+            <a:avLst>
+              <a:gd name="adj" fmla="val 6154"/>
+            </a:avLst>
+          </a:prstGeom>
+          <a:solidFill>
+            <a:srgbClr val="132846"/>
+          </a:solidFill>
+          <a:ln w="19050">
+            <a:solidFill>
+              <a:srgbClr val="1E3A5F"/>
+            </a:solidFill>
+          </a:ln>
+        </p:spPr>
+      </p:sp>
+      <p:sp>
+        <p:nvSpPr>
+          <p:cNvPr id="40" name="TextBox 40"/>
+          <p:cNvSpPr txBox="1"/>
+          <p:nvPr/>
+        </p:nvSpPr>
+        <p:spPr>
+          <a:xfrm>
+            <a:off x="10516850" y="4932045"/>
+            <a:ext cx="397551" cy="469392"/>
+          </a:xfrm>
+          <a:prstGeom prst="rect">
+            <a:avLst/>
+          </a:prstGeom>
+          <a:noFill/>
+          <a:ln>
+            <a:noFill/>
+          </a:ln>
+        </p:spPr>
+        <p:txBody>
+          <a:bodyPr wrap="none" lIns="0" tIns="0" rIns="0" bIns="0" anchor="t" anchorCtr="0">
+            <a:spAutoFit/>
+          </a:bodyPr>
+          <a:lstStyle/>
+          <a:p>
+            <a:pPr algn="ctr"/>
+            <a:r>
+              <a:rPr lang="en-US" sz="2400" b="1" dirty="0">
+                <a:solidFill>
+                  <a:srgbClr val="FFD54F"/>
+                </a:solidFill>
+                <a:latin typeface="Arial"/>
+                <a:ea typeface="Arial"/>
+                <a:cs typeface="Arial"/>
+              </a:rPr>
+              <a:t>41</a:t>
+            </a:r>
+          </a:p>
+        </p:txBody>
+      </p:sp>
+      <p:sp>
+        <p:nvSpPr>
+          <p:cNvPr id="41" name="TextBox 41"/>
+          <p:cNvSpPr txBox="1"/>
+          <p:nvPr/>
+        </p:nvSpPr>
+        <p:spPr>
+          <a:xfrm>
+            <a:off x="10386441" y="5442585"/>
+            <a:ext cx="658368" cy="234696"/>
+          </a:xfrm>
+          <a:prstGeom prst="rect">
+            <a:avLst/>
+          </a:prstGeom>
+          <a:noFill/>
+          <a:ln>
+            <a:noFill/>
+          </a:ln>
+        </p:spPr>
+        <p:txBody>
+          <a:bodyPr wrap="none" lIns="0" tIns="0" rIns="0" bIns="0" anchor="t" anchorCtr="0">
+            <a:spAutoFit/>
+          </a:bodyPr>
+          <a:lstStyle/>
+          <a:p>
+            <a:pPr algn="ctr"/>
+            <a:r>
+              <a:rPr lang="zh-CN" sz="1200" dirty="0">
+                <a:solidFill>
+                  <a:srgbClr val="DDEBFF"/>
+                </a:solidFill>
+                <a:latin typeface="Arial"/>
+                <a:ea typeface="Microsoft YaHei"/>
+                <a:cs typeface="Arial"/>
+              </a:rPr>
+              <a:t>测试通过</a:t>
+            </a:r>
+          </a:p>
+        </p:txBody>
+      </p:sp>
+      <p:sp>
+        <p:nvSpPr>
+          <p:cNvPr id="42" name="TextBox 42"/>
+          <p:cNvSpPr txBox="1"/>
+          <p:nvPr/>
+        </p:nvSpPr>
+        <p:spPr>
+          <a:xfrm>
+            <a:off x="755904" y="6442710"/>
+            <a:ext cx="2538374" cy="234696"/>
+          </a:xfrm>
+          <a:prstGeom prst="rect">
+            <a:avLst/>
+          </a:prstGeom>
+          <a:noFill/>
+          <a:ln>
+            <a:noFill/>
+          </a:ln>
+        </p:spPr>
+        <p:txBody>
+          <a:bodyPr wrap="none" lIns="0" tIns="0" rIns="0" bIns="0" anchor="t" anchorCtr="0">
+            <a:spAutoFit/>
+          </a:bodyPr>
+          <a:lstStyle/>
+          <a:p>
+            <a:pPr algn="l"/>
+            <a:r>
+              <a:rPr lang="zh-CN" sz="1200" dirty="0">
+                <a:solidFill>
+                  <a:srgbClr val="91A9C8"/>
+                </a:solidFill>
+                <a:latin typeface="Arial"/>
+                <a:ea typeface="Microsoft YaHei"/>
+                <a:cs typeface="Arial"/>
+              </a:rPr>
+              <a:t>~3,100 行 C++17 · 无第三方图库</a:t>
+            </a:r>
+          </a:p>
+        </p:txBody>
+      </p:sp>
+    </p:spTree>
+  </p:cSld>
+  <p:clrMapOvr>
+    <a:masterClrMapping/>
+  </p:clrMapOvr>
+  <p:transition xmlns:p14="http://schemas.microsoft.com/office/powerpoint/2010/main" p14:dur="400">
+    <p:fade/>
+  </p:transition>
+</p:sld>
+</file>
+
+<file path=ppt/slides/slide3.xml><?xml version="1.0" encoding="utf-8"?>
+<p:sld xmlns:a="http://schemas.openxmlformats.org/drawingml/2006/main" xmlns:r="http://schemas.openxmlformats.org/officeDocument/2006/relationships" xmlns:p="http://schemas.openxmlformats.org/presentationml/2006/main">
+  <p:cSld>
+    <p:spTree>
+      <p:nvGrpSpPr>
+        <p:cNvPr id="1" name=""/>
+        <p:cNvGrpSpPr/>
+        <p:nvPr/>
+      </p:nvGrpSpPr>
+      <p:grpSpPr>
+        <a:xfrm>
+          <a:off x="0" y="0"/>
+          <a:ext cx="0" cy="0"/>
+          <a:chOff x="0" y="0"/>
+          <a:chExt cx="0" cy="0"/>
+        </a:xfrm>
+      </p:grpSpPr>
+      <p:sp>
+        <p:nvSpPr>
+          <p:cNvPr id="2" name="Rectangle 2"/>
+          <p:cNvSpPr/>
+          <p:nvPr/>
+        </p:nvSpPr>
+        <p:spPr>
+          <a:xfrm>
+            <a:off x="0" y="0"/>
+            <a:ext cx="12192000" cy="6858000"/>
+          </a:xfrm>
+          <a:prstGeom prst="rect">
+            <a:avLst/>
+          </a:prstGeom>
+          <a:solidFill>
+            <a:srgbClr val="0B1F3A"/>
+          </a:solidFill>
+          <a:ln>
+            <a:noFill/>
+          </a:ln>
+        </p:spPr>
+      </p:sp>
+      <p:sp>
+        <p:nvSpPr>
+          <p:cNvPr id="3" name="TextBox 3"/>
+          <p:cNvSpPr txBox="1"/>
+          <p:nvPr/>
+        </p:nvSpPr>
+        <p:spPr>
+          <a:xfrm>
+            <a:off x="745236" y="501015"/>
+            <a:ext cx="4301621" cy="645414"/>
+          </a:xfrm>
+          <a:prstGeom prst="rect">
+            <a:avLst/>
+          </a:prstGeom>
+          <a:noFill/>
+          <a:ln>
+            <a:noFill/>
+          </a:ln>
+        </p:spPr>
+        <p:txBody>
+          <a:bodyPr wrap="none" lIns="0" tIns="0" rIns="0" bIns="0" anchor="t" anchorCtr="0">
+            <a:spAutoFit/>
+          </a:bodyPr>
+          <a:lstStyle/>
+          <a:p>
+            <a:pPr algn="l"/>
+            <a:r>
+              <a:rPr lang="zh-CN" sz="3300" b="1" dirty="0">
+                <a:solidFill>
+                  <a:srgbClr val="FFFFFF"/>
+                </a:solidFill>
+                <a:latin typeface="Arial"/>
+                <a:ea typeface="Microsoft YaHei"/>
+                <a:cs typeface="Arial"/>
+              </a:rPr>
+              <a:t>数据集建设 &amp; 图建模</a:t>
+            </a:r>
+          </a:p>
+        </p:txBody>
+      </p:sp>
+      <p:sp>
+        <p:nvSpPr>
+          <p:cNvPr id="4" name="Line 4"/>
+          <p:cNvSpPr/>
+          <p:nvPr/>
+        </p:nvSpPr>
+        <p:spPr>
+          <a:xfrm>
+            <a:off x="762000" y="1047750"/>
+            <a:ext cx="10668000" cy="9525"/>
+          </a:xfrm>
+          <a:custGeom>
+            <a:avLst/>
+            <a:gdLst/>
+            <a:ahLst/>
+            <a:cxnLst/>
+            <a:rect l="l" t="t" r="r" b="b"/>
+            <a:pathLst>
+              <a:path w="10668000" h="9525">
+                <a:moveTo>
+                  <a:pt x="0" y="0"/>
+                </a:moveTo>
+                <a:lnTo>
+                  <a:pt x="10668000" y="0"/>
+                </a:lnTo>
+              </a:path>
+            </a:pathLst>
+          </a:custGeom>
+          <a:noFill/>
+          <a:ln w="28575" cap="rnd">
+            <a:solidFill>
+              <a:srgbClr val="E4002B"/>
+            </a:solidFill>
+          </a:ln>
+        </p:spPr>
+      </p:sp>
+      <p:sp>
+        <p:nvSpPr>
+          <p:cNvPr id="5" name="TextBox 5"/>
+          <p:cNvSpPr txBox="1"/>
+          <p:nvPr/>
+        </p:nvSpPr>
+        <p:spPr>
+          <a:xfrm>
+            <a:off x="755142" y="1187768"/>
+            <a:ext cx="3375850" cy="264033"/>
+          </a:xfrm>
+          <a:prstGeom prst="rect">
+            <a:avLst/>
+          </a:prstGeom>
+          <a:noFill/>
+          <a:ln>
+            <a:noFill/>
+          </a:ln>
+        </p:spPr>
+        <p:txBody>
+          <a:bodyPr wrap="none" lIns="0" tIns="0" rIns="0" bIns="0" anchor="t" anchorCtr="0">
+            <a:spAutoFit/>
+          </a:bodyPr>
+          <a:lstStyle/>
+          <a:p>
+            <a:pPr algn="l"/>
+            <a:r>
+              <a:rPr lang="zh-CN" sz="1350" dirty="0">
+                <a:solidFill>
+                  <a:srgbClr val="FFD54F"/>
+                </a:solidFill>
+                <a:latin typeface="Arial"/>
+                <a:ea typeface="Microsoft YaHei"/>
+                <a:cs typeface="Arial"/>
+              </a:rPr>
+              <a:t>对应课设：数据集 10 + 图拓扑 10 = 20 分</a:t>
+            </a:r>
+          </a:p>
+        </p:txBody>
+      </p:sp>
+      <p:sp>
+        <p:nvSpPr>
+          <p:cNvPr id="6" name="Rectangle 6"/>
+          <p:cNvSpPr/>
+          <p:nvPr/>
+        </p:nvSpPr>
+        <p:spPr>
+          <a:xfrm>
+            <a:off x="571500" y="1666875"/>
+            <a:ext cx="3238500" cy="1238250"/>
+          </a:xfrm>
+          <a:prstGeom prst="roundRect">
+            <a:avLst>
+              <a:gd name="adj" fmla="val 7692"/>
+            </a:avLst>
+          </a:prstGeom>
+          <a:solidFill>
+            <a:srgbClr val="132846"/>
+          </a:solidFill>
+          <a:ln w="19050">
+            <a:solidFill>
+              <a:srgbClr val="1E3A5F"/>
+            </a:solidFill>
+          </a:ln>
+        </p:spPr>
+      </p:sp>
+      <p:sp>
+        <p:nvSpPr>
+          <p:cNvPr id="7" name="TextBox 7"/>
+          <p:cNvSpPr txBox="1"/>
+          <p:nvPr/>
+        </p:nvSpPr>
+        <p:spPr>
+          <a:xfrm>
+            <a:off x="753618" y="1822132"/>
+            <a:ext cx="865894" cy="322707"/>
+          </a:xfrm>
+          <a:prstGeom prst="rect">
+            <a:avLst/>
+          </a:prstGeom>
+          <a:noFill/>
+          <a:ln>
+            <a:noFill/>
+          </a:ln>
+        </p:spPr>
+        <p:txBody>
+          <a:bodyPr wrap="none" lIns="0" tIns="0" rIns="0" bIns="0" anchor="t" anchorCtr="0">
+            <a:spAutoFit/>
+          </a:bodyPr>
+          <a:lstStyle/>
+          <a:p>
+            <a:pPr algn="l"/>
+            <a:r>
+              <a:rPr lang="en-US" sz="1650" b="1" dirty="0">
+                <a:solidFill>
+                  <a:srgbClr val="FFD54F"/>
+                </a:solidFill>
+                <a:latin typeface="Arial"/>
+                <a:ea typeface="Arial"/>
+                <a:cs typeface="Arial"/>
+              </a:rPr>
+              <a:t>① Fetch</a:t>
+            </a:r>
+          </a:p>
+        </p:txBody>
+      </p:sp>
+      <p:sp>
+        <p:nvSpPr>
+          <p:cNvPr id="8" name="TextBox 8"/>
+          <p:cNvSpPr txBox="1"/>
+          <p:nvPr/>
+        </p:nvSpPr>
+        <p:spPr>
+          <a:xfrm>
+            <a:off x="755904" y="2204085"/>
+            <a:ext cx="1579169" cy="234696"/>
+          </a:xfrm>
+          <a:prstGeom prst="rect">
+            <a:avLst/>
+          </a:prstGeom>
+          <a:noFill/>
+          <a:ln>
+            <a:noFill/>
+          </a:ln>
+        </p:spPr>
+        <p:txBody>
+          <a:bodyPr wrap="none" lIns="0" tIns="0" rIns="0" bIns="0" anchor="t" anchorCtr="0">
+            <a:spAutoFit/>
+          </a:bodyPr>
+          <a:lstStyle/>
+          <a:p>
+            <a:pPr algn="l"/>
+            <a:r>
+              <a:rPr lang="en-US" sz="1200" dirty="0">
+                <a:solidFill>
+                  <a:srgbClr val="DDEBFF"/>
+                </a:solidFill>
+                <a:latin typeface="Consolas"/>
+                <a:ea typeface="Consolas"/>
+                <a:cs typeface="Consolas"/>
+              </a:rPr>
+              <a:t>python fetch_all.py</a:t>
+            </a:r>
+          </a:p>
+        </p:txBody>
+      </p:sp>
+      <p:sp>
+        <p:nvSpPr>
+          <p:cNvPr id="9" name="TextBox 9"/>
+          <p:cNvSpPr txBox="1"/>
+          <p:nvPr/>
+        </p:nvSpPr>
+        <p:spPr>
+          <a:xfrm>
+            <a:off x="755904" y="2442210"/>
+            <a:ext cx="1508246" cy="234696"/>
+          </a:xfrm>
+          <a:prstGeom prst="rect">
+            <a:avLst/>
+          </a:prstGeom>
+          <a:noFill/>
+          <a:ln>
+            <a:noFill/>
+          </a:ln>
+        </p:spPr>
+        <p:txBody>
+          <a:bodyPr wrap="none" lIns="0" tIns="0" rIns="0" bIns="0" anchor="t" anchorCtr="0">
+            <a:spAutoFit/>
+          </a:bodyPr>
+          <a:lstStyle/>
+          <a:p>
+            <a:pPr algn="l"/>
+            <a:r>
+              <a:rPr lang="en-US" sz="1200" dirty="0">
+                <a:solidFill>
+                  <a:srgbClr val="B7C7DE"/>
+                </a:solidFill>
+                <a:latin typeface="Arial"/>
+                <a:ea typeface="Arial"/>
+                <a:cs typeface="Arial"/>
+              </a:rPr>
+              <a:t>Shanghai Metro API</a:t>
+            </a:r>
+          </a:p>
+        </p:txBody>
+      </p:sp>
+      <p:sp>
+        <p:nvSpPr>
+          <p:cNvPr id="10" name="TextBox 10"/>
+          <p:cNvSpPr txBox="1"/>
+          <p:nvPr/>
+        </p:nvSpPr>
+        <p:spPr>
+          <a:xfrm>
+            <a:off x="756666" y="2696528"/>
+            <a:ext cx="1810004" cy="205359"/>
+          </a:xfrm>
+          <a:prstGeom prst="rect">
+            <a:avLst/>
+          </a:prstGeom>
+          <a:noFill/>
+          <a:ln>
+            <a:noFill/>
+          </a:ln>
+        </p:spPr>
+        <p:txBody>
+          <a:bodyPr wrap="none" lIns="0" tIns="0" rIns="0" bIns="0" anchor="t" anchorCtr="0">
+            <a:spAutoFit/>
+          </a:bodyPr>
+          <a:lstStyle/>
+          <a:p>
+            <a:pPr algn="l"/>
+            <a:r>
+              <a:rPr lang="en-US" sz="1050" dirty="0">
+                <a:solidFill>
+                  <a:srgbClr val="B7C7DE"/>
+                </a:solidFill>
+                <a:latin typeface="Arial"/>
+                <a:ea typeface="Arial"/>
+                <a:cs typeface="Arial"/>
+              </a:rPr>
+              <a:t>→ metro_data/line-XX.csv</a:t>
+            </a:r>
+          </a:p>
+        </p:txBody>
+      </p:sp>
+      <p:sp>
+        <p:nvSpPr>
+          <p:cNvPr id="11" name="Rectangle 11"/>
+          <p:cNvSpPr/>
+          <p:nvPr/>
+        </p:nvSpPr>
+        <p:spPr>
+          <a:xfrm>
+            <a:off x="4381500" y="1666875"/>
+            <a:ext cx="3238500" cy="1238250"/>
+          </a:xfrm>
+          <a:prstGeom prst="roundRect">
+            <a:avLst>
+              <a:gd name="adj" fmla="val 7692"/>
+            </a:avLst>
+          </a:prstGeom>
+          <a:solidFill>
+            <a:srgbClr val="132846"/>
+          </a:solidFill>
+          <a:ln w="19050">
+            <a:solidFill>
+              <a:srgbClr val="1E3A5F"/>
+            </a:solidFill>
+          </a:ln>
+        </p:spPr>
+      </p:sp>
+      <p:sp>
+        <p:nvSpPr>
+          <p:cNvPr id="12" name="TextBox 12"/>
+          <p:cNvSpPr txBox="1"/>
+          <p:nvPr/>
+        </p:nvSpPr>
+        <p:spPr>
+          <a:xfrm>
+            <a:off x="4563618" y="1822132"/>
+            <a:ext cx="747959" cy="322707"/>
+          </a:xfrm>
+          <a:prstGeom prst="rect">
+            <a:avLst/>
+          </a:prstGeom>
+          <a:noFill/>
+          <a:ln>
+            <a:noFill/>
+          </a:ln>
+        </p:spPr>
+        <p:txBody>
+          <a:bodyPr wrap="none" lIns="0" tIns="0" rIns="0" bIns="0" anchor="t" anchorCtr="0">
+            <a:spAutoFit/>
+          </a:bodyPr>
+          <a:lstStyle/>
+          <a:p>
+            <a:pPr algn="l"/>
+            <a:r>
+              <a:rPr lang="en-US" sz="1650" b="1" dirty="0">
+                <a:solidFill>
+                  <a:srgbClr val="FFD54F"/>
+                </a:solidFill>
+                <a:latin typeface="Arial"/>
+                <a:ea typeface="Arial"/>
+                <a:cs typeface="Arial"/>
+              </a:rPr>
+              <a:t>② Build</a:t>
+            </a:r>
+          </a:p>
+        </p:txBody>
+      </p:sp>
+      <p:sp>
+        <p:nvSpPr>
+          <p:cNvPr id="13" name="TextBox 13"/>
+          <p:cNvSpPr txBox="1"/>
+          <p:nvPr/>
+        </p:nvSpPr>
+        <p:spPr>
+          <a:xfrm>
+            <a:off x="4565904" y="2204085"/>
+            <a:ext cx="1585992" cy="234696"/>
+          </a:xfrm>
+          <a:prstGeom prst="rect">
+            <a:avLst/>
+          </a:prstGeom>
+          <a:noFill/>
+          <a:ln>
+            <a:noFill/>
+          </a:ln>
+        </p:spPr>
+        <p:txBody>
+          <a:bodyPr wrap="none" lIns="0" tIns="0" rIns="0" bIns="0" anchor="t" anchorCtr="0">
+            <a:spAutoFit/>
+          </a:bodyPr>
+          <a:lstStyle/>
+          <a:p>
+            <a:pPr algn="l"/>
+            <a:r>
+              <a:rPr lang="en-US" sz="1200" dirty="0">
+                <a:solidFill>
+                  <a:srgbClr val="DDEBFF"/>
+                </a:solidFill>
+                <a:latin typeface="Consolas"/>
+                <a:ea typeface="Consolas"/>
+                <a:cs typeface="Consolas"/>
+              </a:rPr>
+              <a:t>build_dataset (C++)</a:t>
+            </a:r>
+          </a:p>
+        </p:txBody>
+      </p:sp>
+      <p:sp>
+        <p:nvSpPr>
+          <p:cNvPr id="14" name="TextBox 14"/>
+          <p:cNvSpPr txBox="1"/>
+          <p:nvPr/>
+        </p:nvSpPr>
+        <p:spPr>
+          <a:xfrm>
+            <a:off x="4565904" y="2442210"/>
+            <a:ext cx="2160727" cy="234696"/>
+          </a:xfrm>
+          <a:prstGeom prst="rect">
+            <a:avLst/>
+          </a:prstGeom>
+          <a:noFill/>
+          <a:ln>
+            <a:noFill/>
+          </a:ln>
+        </p:spPr>
+        <p:txBody>
+          <a:bodyPr wrap="none" lIns="0" tIns="0" rIns="0" bIns="0" anchor="t" anchorCtr="0">
+            <a:spAutoFit/>
+          </a:bodyPr>
+          <a:lstStyle/>
+          <a:p>
+            <a:pPr algn="l"/>
+            <a:r>
+              <a:rPr lang="zh-CN" sz="1200" dirty="0">
+                <a:solidFill>
+                  <a:srgbClr val="B7C7DE"/>
+                </a:solidFill>
+                <a:latin typeface="Arial"/>
+                <a:ea typeface="Microsoft YaHei"/>
+                <a:cs typeface="Arial"/>
+              </a:rPr>
+              <a:t>换乘拆分 · 边填补 · 环线去伪</a:t>
+            </a:r>
+          </a:p>
+        </p:txBody>
+      </p:sp>
+      <p:sp>
+        <p:nvSpPr>
+          <p:cNvPr id="15" name="TextBox 15"/>
+          <p:cNvSpPr txBox="1"/>
+          <p:nvPr/>
+        </p:nvSpPr>
+        <p:spPr>
+          <a:xfrm>
+            <a:off x="4566666" y="2696528"/>
+            <a:ext cx="1703946" cy="205359"/>
+          </a:xfrm>
+          <a:prstGeom prst="rect">
+            <a:avLst/>
+          </a:prstGeom>
+          <a:noFill/>
+          <a:ln>
+            <a:noFill/>
+          </a:ln>
+        </p:spPr>
+        <p:txBody>
+          <a:bodyPr wrap="none" lIns="0" tIns="0" rIns="0" bIns="0" anchor="t" anchorCtr="0">
+            <a:spAutoFit/>
+          </a:bodyPr>
+          <a:lstStyle/>
+          <a:p>
+            <a:pPr algn="l"/>
+            <a:r>
+              <a:rPr lang="en-US" sz="1050" dirty="0">
+                <a:solidFill>
+                  <a:srgbClr val="B7C7DE"/>
+                </a:solidFill>
+                <a:latin typeface="Arial"/>
+                <a:ea typeface="Arial"/>
+                <a:cs typeface="Arial"/>
+              </a:rPr>
+              <a:t>→ Station.csv, Edge.csv</a:t>
+            </a:r>
+          </a:p>
+        </p:txBody>
+      </p:sp>
+      <p:sp>
+        <p:nvSpPr>
+          <p:cNvPr id="16" name="Rectangle 16"/>
+          <p:cNvSpPr/>
+          <p:nvPr/>
+        </p:nvSpPr>
+        <p:spPr>
+          <a:xfrm>
+            <a:off x="8191500" y="1666875"/>
+            <a:ext cx="3238500" cy="1238250"/>
+          </a:xfrm>
+          <a:prstGeom prst="roundRect">
+            <a:avLst>
+              <a:gd name="adj" fmla="val 7692"/>
+            </a:avLst>
+          </a:prstGeom>
+          <a:solidFill>
+            <a:srgbClr val="132846"/>
+          </a:solidFill>
+          <a:ln w="19050">
+            <a:solidFill>
+              <a:srgbClr val="1E3A5F"/>
+            </a:solidFill>
+          </a:ln>
+        </p:spPr>
+      </p:sp>
+      <p:sp>
+        <p:nvSpPr>
+          <p:cNvPr id="17" name="TextBox 17"/>
+          <p:cNvSpPr txBox="1"/>
+          <p:nvPr/>
+        </p:nvSpPr>
+        <p:spPr>
+          <a:xfrm>
+            <a:off x="8373618" y="1822132"/>
+            <a:ext cx="1201979" cy="322707"/>
+          </a:xfrm>
+          <a:prstGeom prst="rect">
+            <a:avLst/>
+          </a:prstGeom>
+          <a:noFill/>
+          <a:ln>
+            <a:noFill/>
+          </a:ln>
+        </p:spPr>
+        <p:txBody>
+          <a:bodyPr wrap="none" lIns="0" tIns="0" rIns="0" bIns="0" anchor="t" anchorCtr="0">
+            <a:spAutoFit/>
+          </a:bodyPr>
+          <a:lstStyle/>
+          <a:p>
+            <a:pPr algn="l"/>
+            <a:r>
+              <a:rPr lang="en-US" sz="1650" b="1" dirty="0">
+                <a:solidFill>
+                  <a:srgbClr val="FFD54F"/>
+                </a:solidFill>
+                <a:latin typeface="Arial"/>
+                <a:ea typeface="Arial"/>
+                <a:cs typeface="Arial"/>
+              </a:rPr>
+              <a:t>③ Visualize</a:t>
+            </a:r>
+          </a:p>
+        </p:txBody>
+      </p:sp>
+      <p:sp>
+        <p:nvSpPr>
+          <p:cNvPr id="18" name="TextBox 18"/>
+          <p:cNvSpPr txBox="1"/>
+          <p:nvPr/>
+        </p:nvSpPr>
+        <p:spPr>
+          <a:xfrm>
+            <a:off x="8375904" y="2204085"/>
+            <a:ext cx="2015338" cy="234696"/>
+          </a:xfrm>
+          <a:prstGeom prst="rect">
+            <a:avLst/>
+          </a:prstGeom>
+          <a:noFill/>
+          <a:ln>
+            <a:noFill/>
+          </a:ln>
+        </p:spPr>
+        <p:txBody>
+          <a:bodyPr wrap="none" lIns="0" tIns="0" rIns="0" bIns="0" anchor="t" anchorCtr="0">
+            <a:spAutoFit/>
+          </a:bodyPr>
+          <a:lstStyle/>
+          <a:p>
+            <a:pPr algn="l"/>
+            <a:r>
+              <a:rPr lang="en-US" sz="1200" dirty="0">
+                <a:solidFill>
+                  <a:srgbClr val="DDEBFF"/>
+                </a:solidFill>
+                <a:latin typeface="Consolas"/>
+                <a:ea typeface="Consolas"/>
+                <a:cs typeface="Consolas"/>
+              </a:rPr>
+              <a:t>fetch_station_coords.py</a:t>
+            </a:r>
+          </a:p>
+        </p:txBody>
+      </p:sp>
+      <p:sp>
+        <p:nvSpPr>
+          <p:cNvPr id="19" name="TextBox 19"/>
+          <p:cNvSpPr txBox="1"/>
+          <p:nvPr/>
+        </p:nvSpPr>
+        <p:spPr>
+          <a:xfrm>
+            <a:off x="8375904" y="2442210"/>
+            <a:ext cx="1537231" cy="234696"/>
+          </a:xfrm>
+          <a:prstGeom prst="rect">
+            <a:avLst/>
+          </a:prstGeom>
+          <a:noFill/>
+          <a:ln>
+            <a:noFill/>
+          </a:ln>
+        </p:spPr>
+        <p:txBody>
+          <a:bodyPr wrap="none" lIns="0" tIns="0" rIns="0" bIns="0" anchor="t" anchorCtr="0">
+            <a:spAutoFit/>
+          </a:bodyPr>
+          <a:lstStyle/>
+          <a:p>
+            <a:pPr algn="l"/>
+            <a:r>
+              <a:rPr lang="zh-CN" sz="1200" dirty="0">
+                <a:solidFill>
+                  <a:srgbClr val="B7C7DE"/>
+                </a:solidFill>
+                <a:latin typeface="Arial"/>
+                <a:ea typeface="Microsoft YaHei"/>
+                <a:cs typeface="Arial"/>
+              </a:rPr>
+              <a:t>OSM Overpass 投影</a:t>
+            </a:r>
+          </a:p>
+        </p:txBody>
+      </p:sp>
+      <p:sp>
+        <p:nvSpPr>
+          <p:cNvPr id="20" name="TextBox 20"/>
+          <p:cNvSpPr txBox="1"/>
+          <p:nvPr/>
+        </p:nvSpPr>
+        <p:spPr>
+          <a:xfrm>
+            <a:off x="8376666" y="2696528"/>
+            <a:ext cx="915314" cy="205359"/>
+          </a:xfrm>
+          <a:prstGeom prst="rect">
+            <a:avLst/>
+          </a:prstGeom>
+          <a:noFill/>
+          <a:ln>
+            <a:noFill/>
+          </a:ln>
+        </p:spPr>
+        <p:txBody>
+          <a:bodyPr wrap="none" lIns="0" tIns="0" rIns="0" bIns="0" anchor="t" anchorCtr="0">
+            <a:spAutoFit/>
+          </a:bodyPr>
+          <a:lstStyle/>
+          <a:p>
+            <a:pPr algn="l"/>
+            <a:r>
+              <a:rPr lang="en-US" sz="1050" dirty="0">
+                <a:solidFill>
+                  <a:srgbClr val="B7C7DE"/>
+                </a:solidFill>
+                <a:latin typeface="Arial"/>
+                <a:ea typeface="Arial"/>
+                <a:cs typeface="Arial"/>
+              </a:rPr>
+              <a:t>→ layout.json</a:t>
+            </a:r>
+          </a:p>
+        </p:txBody>
+      </p:sp>
+      <p:sp>
+        <p:nvSpPr>
+          <p:cNvPr id="21" name="Line 21"/>
+          <p:cNvSpPr/>
+          <p:nvPr/>
+        </p:nvSpPr>
+        <p:spPr>
+          <a:xfrm>
+            <a:off x="3810000" y="2286000"/>
+            <a:ext cx="571500" cy="9525"/>
+          </a:xfrm>
+          <a:custGeom>
+            <a:avLst/>
+            <a:gdLst/>
+            <a:ahLst/>
+            <a:cxnLst/>
+            <a:rect l="l" t="t" r="r" b="b"/>
+            <a:pathLst>
+              <a:path w="571500" h="9525">
+                <a:moveTo>
+                  <a:pt x="0" y="0"/>
+                </a:moveTo>
+                <a:lnTo>
+                  <a:pt x="571500" y="0"/>
+                </a:lnTo>
+              </a:path>
+            </a:pathLst>
+          </a:custGeom>
+          <a:noFill/>
+          <a:ln w="28575" cap="rnd">
+            <a:solidFill>
+              <a:srgbClr val="E4002B"/>
+            </a:solidFill>
+          </a:ln>
+        </p:spPr>
+      </p:sp>
+      <p:sp>
+        <p:nvSpPr>
+          <p:cNvPr id="22" name="Polygon 22"/>
+          <p:cNvSpPr/>
+          <p:nvPr/>
+        </p:nvSpPr>
+        <p:spPr>
+          <a:xfrm>
+            <a:off x="4333875" y="2219325"/>
+            <a:ext cx="95250" cy="133350"/>
+          </a:xfrm>
+          <a:custGeom>
+            <a:avLst/>
+            <a:gdLst/>
+            <a:ahLst/>
+            <a:cxnLst/>
+            <a:rect l="l" t="t" r="r" b="b"/>
+            <a:pathLst>
+              <a:path w="95250" h="133350">
+                <a:moveTo>
+                  <a:pt x="0" y="0"/>
+                </a:moveTo>
+                <a:lnTo>
+                  <a:pt x="95250" y="66675"/>
+                </a:lnTo>
+                <a:lnTo>
+                  <a:pt x="0" y="133350"/>
+                </a:lnTo>
+                <a:close/>
+              </a:path>
+            </a:pathLst>
+          </a:custGeom>
+          <a:solidFill>
+            <a:srgbClr val="E4002B"/>
+          </a:solidFill>
+          <a:ln>
+            <a:noFill/>
+          </a:ln>
+        </p:spPr>
+      </p:sp>
+      <p:sp>
+        <p:nvSpPr>
+          <p:cNvPr id="23" name="Line 23"/>
+          <p:cNvSpPr/>
+          <p:nvPr/>
+        </p:nvSpPr>
+        <p:spPr>
+          <a:xfrm>
+            <a:off x="7620000" y="2286000"/>
+            <a:ext cx="571500" cy="9525"/>
+          </a:xfrm>
+          <a:custGeom>
+            <a:avLst/>
+            <a:gdLst/>
+            <a:ahLst/>
+            <a:cxnLst/>
+            <a:rect l="l" t="t" r="r" b="b"/>
+            <a:pathLst>
+              <a:path w="571500" h="9525">
+                <a:moveTo>
+                  <a:pt x="0" y="0"/>
+                </a:moveTo>
+                <a:lnTo>
+                  <a:pt x="571500" y="0"/>
+                </a:lnTo>
+              </a:path>
+            </a:pathLst>
+          </a:custGeom>
+          <a:noFill/>
+          <a:ln w="28575" cap="rnd">
+            <a:solidFill>
+              <a:srgbClr val="E4002B"/>
+            </a:solidFill>
+          </a:ln>
+        </p:spPr>
+      </p:sp>
+      <p:sp>
+        <p:nvSpPr>
+          <p:cNvPr id="24" name="Polygon 24"/>
+          <p:cNvSpPr/>
+          <p:nvPr/>
+        </p:nvSpPr>
+        <p:spPr>
+          <a:xfrm>
+            <a:off x="8143875" y="2219325"/>
+            <a:ext cx="95250" cy="133350"/>
+          </a:xfrm>
+          <a:custGeom>
+            <a:avLst/>
+            <a:gdLst/>
+            <a:ahLst/>
+            <a:cxnLst/>
+            <a:rect l="l" t="t" r="r" b="b"/>
+            <a:pathLst>
+              <a:path w="95250" h="133350">
+                <a:moveTo>
+                  <a:pt x="0" y="0"/>
+                </a:moveTo>
+                <a:lnTo>
+                  <a:pt x="95250" y="66675"/>
+                </a:lnTo>
+                <a:lnTo>
+                  <a:pt x="0" y="133350"/>
+                </a:lnTo>
+                <a:close/>
+              </a:path>
+            </a:pathLst>
+          </a:custGeom>
+          <a:solidFill>
+            <a:srgbClr val="E4002B"/>
+          </a:solidFill>
+          <a:ln>
+            <a:noFill/>
+          </a:ln>
+        </p:spPr>
+      </p:sp>
+      <p:sp>
+        <p:nvSpPr>
+          <p:cNvPr id="25" name="Rectangle 25"/>
+          <p:cNvSpPr/>
+          <p:nvPr/>
+        </p:nvSpPr>
+        <p:spPr>
+          <a:xfrm>
+            <a:off x="571500" y="3429000"/>
+            <a:ext cx="4762500" cy="2190750"/>
+          </a:xfrm>
+          <a:prstGeom prst="roundRect">
+            <a:avLst>
+              <a:gd name="adj" fmla="val 4348"/>
+            </a:avLst>
+          </a:prstGeom>
+          <a:solidFill>
+            <a:srgbClr val="132846"/>
+          </a:solidFill>
+          <a:ln w="19050">
+            <a:solidFill>
+              <a:srgbClr val="1E3A5F"/>
+            </a:solidFill>
+          </a:ln>
+        </p:spPr>
+      </p:sp>
+      <p:sp>
+        <p:nvSpPr>
+          <p:cNvPr id="26" name="TextBox 26"/>
+          <p:cNvSpPr txBox="1"/>
+          <p:nvPr/>
+        </p:nvSpPr>
+        <p:spPr>
+          <a:xfrm>
+            <a:off x="753618" y="3584258"/>
+            <a:ext cx="3281972" cy="322707"/>
+          </a:xfrm>
+          <a:prstGeom prst="rect">
+            <a:avLst/>
+          </a:prstGeom>
+          <a:noFill/>
+          <a:ln>
+            <a:noFill/>
+          </a:ln>
+        </p:spPr>
+        <p:txBody>
+          <a:bodyPr wrap="none" lIns="0" tIns="0" rIns="0" bIns="0" anchor="t" anchorCtr="0">
+            <a:spAutoFit/>
+          </a:bodyPr>
+          <a:lstStyle/>
+          <a:p>
+            <a:pPr algn="l"/>
+            <a:r>
+              <a:rPr lang="zh-CN" sz="1650" b="1" dirty="0">
+                <a:solidFill>
+                  <a:srgbClr val="FFD54F"/>
+                </a:solidFill>
+                <a:latin typeface="Arial"/>
+                <a:ea typeface="Microsoft YaHei"/>
+                <a:cs typeface="Arial"/>
+              </a:rPr>
+              <a:t>换乘节点拆分（例：人民广场）</a:t>
+            </a:r>
+          </a:p>
+        </p:txBody>
+      </p:sp>
+      <p:sp>
+        <p:nvSpPr>
+          <p:cNvPr id="27" name="Ellipse 27"/>
+          <p:cNvSpPr/>
+          <p:nvPr/>
+        </p:nvSpPr>
+        <p:spPr>
+          <a:xfrm>
+            <a:off x="1257300" y="4257675"/>
+            <a:ext cx="533400" cy="533400"/>
+          </a:xfrm>
+          <a:prstGeom prst="ellipse">
+            <a:avLst/>
+          </a:prstGeom>
+          <a:solidFill>
+            <a:srgbClr val="E4002B"/>
+          </a:solidFill>
+          <a:ln>
+            <a:noFill/>
+          </a:ln>
+        </p:spPr>
+      </p:sp>
+      <p:sp>
+        <p:nvSpPr>
+          <p:cNvPr id="28" name="TextBox 28"/>
+          <p:cNvSpPr txBox="1"/>
+          <p:nvPr/>
+        </p:nvSpPr>
+        <p:spPr>
+          <a:xfrm>
+            <a:off x="1331321" y="4471035"/>
+            <a:ext cx="385359" cy="234696"/>
+          </a:xfrm>
+          <a:prstGeom prst="rect">
+            <a:avLst/>
+          </a:prstGeom>
+          <a:noFill/>
+          <a:ln>
+            <a:noFill/>
+          </a:ln>
+        </p:spPr>
+        <p:txBody>
+          <a:bodyPr wrap="none" lIns="0" tIns="0" rIns="0" bIns="0" anchor="t" anchorCtr="0">
+            <a:spAutoFit/>
+          </a:bodyPr>
+          <a:lstStyle/>
+          <a:p>
+            <a:pPr algn="ctr"/>
+            <a:r>
+              <a:rPr lang="en-US" sz="1200" b="1" dirty="0">
+                <a:solidFill>
+                  <a:srgbClr val="FFFFFF"/>
+                </a:solidFill>
+                <a:latin typeface="Consolas"/>
+                <a:ea typeface="Consolas"/>
+                <a:cs typeface="Consolas"/>
+              </a:rPr>
+              <a:t>0113</a:t>
+            </a:r>
+          </a:p>
+        </p:txBody>
+      </p:sp>
+      <p:sp>
+        <p:nvSpPr>
+          <p:cNvPr id="29" name="TextBox 29"/>
+          <p:cNvSpPr txBox="1"/>
+          <p:nvPr/>
+        </p:nvSpPr>
+        <p:spPr>
+          <a:xfrm>
+            <a:off x="1338443" y="4934902"/>
+            <a:ext cx="371113" cy="205359"/>
+          </a:xfrm>
+          <a:prstGeom prst="rect">
+            <a:avLst/>
+          </a:prstGeom>
+          <a:noFill/>
+          <a:ln>
+            <a:noFill/>
+          </a:ln>
+        </p:spPr>
+        <p:txBody>
+          <a:bodyPr wrap="none" lIns="0" tIns="0" rIns="0" bIns="0" anchor="t" anchorCtr="0">
+            <a:spAutoFit/>
+          </a:bodyPr>
+          <a:lstStyle/>
+          <a:p>
+            <a:pPr algn="ctr"/>
+            <a:r>
+              <a:rPr lang="zh-CN" sz="1050" dirty="0">
+                <a:solidFill>
+                  <a:srgbClr val="B7C7DE"/>
+                </a:solidFill>
+                <a:latin typeface="Arial"/>
+                <a:ea typeface="Microsoft YaHei"/>
+                <a:cs typeface="Arial"/>
+              </a:rPr>
+              <a:t>1号线</a:t>
+            </a:r>
+          </a:p>
+        </p:txBody>
+      </p:sp>
+      <p:sp>
+        <p:nvSpPr>
+          <p:cNvPr id="30" name="Ellipse 30"/>
+          <p:cNvSpPr/>
+          <p:nvPr/>
+        </p:nvSpPr>
+        <p:spPr>
+          <a:xfrm>
+            <a:off x="2686050" y="4257675"/>
+            <a:ext cx="533400" cy="533400"/>
+          </a:xfrm>
+          <a:prstGeom prst="ellipse">
+            <a:avLst/>
+          </a:prstGeom>
+          <a:solidFill>
+            <a:srgbClr val="97D700"/>
+          </a:solidFill>
+          <a:ln>
+            <a:noFill/>
+          </a:ln>
+        </p:spPr>
+      </p:sp>
+      <p:sp>
+        <p:nvSpPr>
+          <p:cNvPr id="31" name="TextBox 31"/>
+          <p:cNvSpPr txBox="1"/>
+          <p:nvPr/>
+        </p:nvSpPr>
+        <p:spPr>
+          <a:xfrm>
+            <a:off x="2760071" y="4471035"/>
+            <a:ext cx="385359" cy="234696"/>
+          </a:xfrm>
+          <a:prstGeom prst="rect">
+            <a:avLst/>
+          </a:prstGeom>
+          <a:noFill/>
+          <a:ln>
+            <a:noFill/>
+          </a:ln>
+        </p:spPr>
+        <p:txBody>
+          <a:bodyPr wrap="none" lIns="0" tIns="0" rIns="0" bIns="0" anchor="t" anchorCtr="0">
+            <a:spAutoFit/>
+          </a:bodyPr>
+          <a:lstStyle/>
+          <a:p>
+            <a:pPr algn="ctr"/>
+            <a:r>
+              <a:rPr lang="en-US" sz="1200" b="1" dirty="0">
+                <a:solidFill>
+                  <a:srgbClr val="FFFFFF"/>
+                </a:solidFill>
+                <a:latin typeface="Consolas"/>
+                <a:ea typeface="Consolas"/>
+                <a:cs typeface="Consolas"/>
+              </a:rPr>
+              <a:t>0213</a:t>
+            </a:r>
+          </a:p>
+        </p:txBody>
+      </p:sp>
+      <p:sp>
+        <p:nvSpPr>
+          <p:cNvPr id="32" name="TextBox 32"/>
+          <p:cNvSpPr txBox="1"/>
+          <p:nvPr/>
+        </p:nvSpPr>
+        <p:spPr>
+          <a:xfrm>
+            <a:off x="2767193" y="4934902"/>
+            <a:ext cx="371113" cy="205359"/>
+          </a:xfrm>
+          <a:prstGeom prst="rect">
+            <a:avLst/>
+          </a:prstGeom>
+          <a:noFill/>
+          <a:ln>
+            <a:noFill/>
+          </a:ln>
+        </p:spPr>
+        <p:txBody>
+          <a:bodyPr wrap="none" lIns="0" tIns="0" rIns="0" bIns="0" anchor="t" anchorCtr="0">
+            <a:spAutoFit/>
+          </a:bodyPr>
+          <a:lstStyle/>
+          <a:p>
+            <a:pPr algn="ctr"/>
+            <a:r>
+              <a:rPr lang="zh-CN" sz="1050" dirty="0">
+                <a:solidFill>
+                  <a:srgbClr val="B7C7DE"/>
+                </a:solidFill>
+                <a:latin typeface="Arial"/>
+                <a:ea typeface="Microsoft YaHei"/>
+                <a:cs typeface="Arial"/>
+              </a:rPr>
+              <a:t>2号线</a:t>
+            </a:r>
+          </a:p>
+        </p:txBody>
+      </p:sp>
+      <p:sp>
+        <p:nvSpPr>
+          <p:cNvPr id="33" name="Ellipse 33"/>
+          <p:cNvSpPr/>
+          <p:nvPr/>
+        </p:nvSpPr>
+        <p:spPr>
+          <a:xfrm>
+            <a:off x="4114800" y="4257675"/>
+            <a:ext cx="533400" cy="533400"/>
+          </a:xfrm>
+          <a:prstGeom prst="ellipse">
+            <a:avLst/>
+          </a:prstGeom>
+          <a:solidFill>
+            <a:srgbClr val="001E62"/>
+          </a:solidFill>
+          <a:ln>
+            <a:noFill/>
+          </a:ln>
+        </p:spPr>
+      </p:sp>
+      <p:sp>
+        <p:nvSpPr>
+          <p:cNvPr id="34" name="TextBox 34"/>
+          <p:cNvSpPr txBox="1"/>
+          <p:nvPr/>
+        </p:nvSpPr>
+        <p:spPr>
+          <a:xfrm>
+            <a:off x="4188821" y="4471035"/>
+            <a:ext cx="385359" cy="234696"/>
+          </a:xfrm>
+          <a:prstGeom prst="rect">
+            <a:avLst/>
+          </a:prstGeom>
+          <a:noFill/>
+          <a:ln>
+            <a:noFill/>
+          </a:ln>
+        </p:spPr>
+        <p:txBody>
+          <a:bodyPr wrap="none" lIns="0" tIns="0" rIns="0" bIns="0" anchor="t" anchorCtr="0">
+            <a:spAutoFit/>
+          </a:bodyPr>
+          <a:lstStyle/>
+          <a:p>
+            <a:pPr algn="ctr"/>
+            <a:r>
+              <a:rPr lang="en-US" sz="1200" b="1" dirty="0">
+                <a:solidFill>
+                  <a:srgbClr val="FFFFFF"/>
+                </a:solidFill>
+                <a:latin typeface="Consolas"/>
+                <a:ea typeface="Consolas"/>
+                <a:cs typeface="Consolas"/>
+              </a:rPr>
+              <a:t>0816</a:t>
+            </a:r>
+          </a:p>
+        </p:txBody>
+      </p:sp>
+      <p:sp>
+        <p:nvSpPr>
+          <p:cNvPr id="35" name="TextBox 35"/>
+          <p:cNvSpPr txBox="1"/>
+          <p:nvPr/>
+        </p:nvSpPr>
+        <p:spPr>
+          <a:xfrm>
+            <a:off x="4195943" y="4934902"/>
+            <a:ext cx="371113" cy="205359"/>
+          </a:xfrm>
+          <a:prstGeom prst="rect">
+            <a:avLst/>
+          </a:prstGeom>
+          <a:noFill/>
+          <a:ln>
+            <a:noFill/>
+          </a:ln>
+        </p:spPr>
+        <p:txBody>
+          <a:bodyPr wrap="none" lIns="0" tIns="0" rIns="0" bIns="0" anchor="t" anchorCtr="0">
+            <a:spAutoFit/>
+          </a:bodyPr>
+          <a:lstStyle/>
+          <a:p>
+            <a:pPr algn="ctr"/>
+            <a:r>
+              <a:rPr lang="zh-CN" sz="1050" dirty="0">
+                <a:solidFill>
+                  <a:srgbClr val="B7C7DE"/>
+                </a:solidFill>
+                <a:latin typeface="Arial"/>
+                <a:ea typeface="Microsoft YaHei"/>
+                <a:cs typeface="Arial"/>
+              </a:rPr>
+              <a:t>8号线</a:t>
+            </a:r>
+          </a:p>
+        </p:txBody>
+      </p:sp>
+      <p:sp>
+        <p:nvSpPr>
+          <p:cNvPr id="36" name="Line 36"/>
+          <p:cNvSpPr/>
+          <p:nvPr/>
+        </p:nvSpPr>
+        <p:spPr>
+          <a:xfrm>
+            <a:off x="1790700" y="4524375"/>
+            <a:ext cx="895350" cy="9525"/>
+          </a:xfrm>
+          <a:custGeom>
+            <a:avLst/>
+            <a:gdLst/>
+            <a:ahLst/>
+            <a:cxnLst/>
+            <a:rect l="l" t="t" r="r" b="b"/>
+            <a:pathLst>
+              <a:path w="895350" h="9525">
+                <a:moveTo>
+                  <a:pt x="0" y="0"/>
+                </a:moveTo>
+                <a:lnTo>
+                  <a:pt x="895350" y="0"/>
+                </a:lnTo>
+              </a:path>
+            </a:pathLst>
+          </a:custGeom>
+          <a:noFill/>
+          <a:ln w="19050" cap="rnd">
+            <a:solidFill>
+              <a:srgbClr val="B7C7DE"/>
+            </a:solidFill>
+            <a:custDash>
+              <a:ds d="300000" sp="200000"/>
+            </a:custDash>
+          </a:ln>
+        </p:spPr>
+      </p:sp>
+      <p:sp>
+        <p:nvSpPr>
+          <p:cNvPr id="37" name="Line 37"/>
+          <p:cNvSpPr/>
+          <p:nvPr/>
+        </p:nvSpPr>
+        <p:spPr>
+          <a:xfrm>
+            <a:off x="3219450" y="4524375"/>
+            <a:ext cx="895350" cy="9525"/>
+          </a:xfrm>
+          <a:custGeom>
+            <a:avLst/>
+            <a:gdLst/>
+            <a:ahLst/>
+            <a:cxnLst/>
+            <a:rect l="l" t="t" r="r" b="b"/>
+            <a:pathLst>
+              <a:path w="895350" h="9525">
+                <a:moveTo>
+                  <a:pt x="0" y="0"/>
+                </a:moveTo>
+                <a:lnTo>
+                  <a:pt x="895350" y="0"/>
+                </a:lnTo>
+              </a:path>
+            </a:pathLst>
+          </a:custGeom>
+          <a:noFill/>
+          <a:ln w="19050" cap="rnd">
+            <a:solidFill>
+              <a:srgbClr val="B7C7DE"/>
+            </a:solidFill>
+            <a:custDash>
+              <a:ds d="300000" sp="200000"/>
+            </a:custDash>
+          </a:ln>
+        </p:spPr>
+      </p:sp>
+      <p:sp>
+        <p:nvSpPr>
+          <p:cNvPr id="38" name="Freeform 38"/>
+          <p:cNvSpPr/>
+          <p:nvPr/>
+        </p:nvSpPr>
+        <p:spPr>
+          <a:xfrm>
+            <a:off x="1524000" y="3990975"/>
+            <a:ext cx="2857500" cy="266700"/>
+          </a:xfrm>
+          <a:custGeom>
+            <a:avLst/>
+            <a:gdLst/>
+            <a:ahLst/>
+            <a:cxnLst/>
+            <a:rect l="l" t="t" r="r" b="b"/>
+            <a:pathLst>
+              <a:path w="2857500" h="266700">
+                <a:moveTo>
+                  <a:pt x="0" y="266700"/>
+                </a:moveTo>
+                <a:cubicBezTo>
+                  <a:pt x="952500" y="0"/>
+                  <a:pt x="1905000" y="0"/>
+                  <a:pt x="2857500" y="266700"/>
+                </a:cubicBezTo>
+              </a:path>
+            </a:pathLst>
+          </a:custGeom>
+          <a:noFill/>
+          <a:ln w="19050">
+            <a:solidFill>
+              <a:srgbClr val="B7C7DE"/>
+            </a:solidFill>
+          </a:ln>
+        </p:spPr>
+      </p:sp>
+      <p:sp>
+        <p:nvSpPr>
+          <p:cNvPr id="39" name="TextBox 39"/>
+          <p:cNvSpPr txBox="1"/>
+          <p:nvPr/>
+        </p:nvSpPr>
+        <p:spPr>
+          <a:xfrm>
+            <a:off x="2668248" y="3963352"/>
+            <a:ext cx="569004" cy="205359"/>
+          </a:xfrm>
+          <a:prstGeom prst="rect">
+            <a:avLst/>
+          </a:prstGeom>
+          <a:noFill/>
+          <a:ln>
+            <a:noFill/>
+          </a:ln>
+        </p:spPr>
+        <p:txBody>
+          <a:bodyPr wrap="none" lIns="0" tIns="0" rIns="0" bIns="0" anchor="t" anchorCtr="0">
+            <a:spAutoFit/>
+          </a:bodyPr>
+          <a:lstStyle/>
+          <a:p>
+            <a:pPr algn="ctr"/>
+            <a:r>
+              <a:rPr lang="zh-CN" sz="1050" dirty="0">
+                <a:solidFill>
+                  <a:srgbClr val="B7C7DE"/>
+                </a:solidFill>
+                <a:latin typeface="Arial"/>
+                <a:ea typeface="Microsoft YaHei"/>
+                <a:cs typeface="Arial"/>
+              </a:rPr>
+              <a:t>换乘 t=5</a:t>
+            </a:r>
+          </a:p>
+        </p:txBody>
+      </p:sp>
+      <p:sp>
+        <p:nvSpPr>
+          <p:cNvPr id="40" name="TextBox 40"/>
+          <p:cNvSpPr txBox="1"/>
+          <p:nvPr/>
+        </p:nvSpPr>
+        <p:spPr>
+          <a:xfrm>
+            <a:off x="756666" y="5315902"/>
+            <a:ext cx="4046239" cy="205359"/>
+          </a:xfrm>
+          <a:prstGeom prst="rect">
+            <a:avLst/>
+          </a:prstGeom>
+          <a:noFill/>
+          <a:ln>
+            <a:noFill/>
+          </a:ln>
+        </p:spPr>
+        <p:txBody>
+          <a:bodyPr wrap="none" lIns="0" tIns="0" rIns="0" bIns="0" anchor="t" anchorCtr="0">
+            <a:spAutoFit/>
+          </a:bodyPr>
+          <a:lstStyle/>
+          <a:p>
+            <a:pPr algn="l"/>
+            <a:r>
+              <a:rPr lang="zh-CN" sz="1050" dirty="0">
+                <a:solidFill>
+                  <a:srgbClr val="B7C7DE"/>
+                </a:solidFill>
+                <a:latin typeface="Arial"/>
+                <a:ea typeface="Microsoft YaHei"/>
+                <a:cs typeface="Arial"/>
+              </a:rPr>
+              <a:t>同名站按线路拆成 3 节点 · 换乘边双向 · 边权=5min · line=换乘</a:t>
+            </a:r>
+          </a:p>
+        </p:txBody>
+      </p:sp>
+      <p:sp>
+        <p:nvSpPr>
+          <p:cNvPr id="41" name="Rectangle 41"/>
+          <p:cNvSpPr/>
+          <p:nvPr/>
+        </p:nvSpPr>
+        <p:spPr>
+          <a:xfrm>
+            <a:off x="5715000" y="3429000"/>
+            <a:ext cx="5905500" cy="2190750"/>
+          </a:xfrm>
+          <a:prstGeom prst="roundRect">
+            <a:avLst>
+              <a:gd name="adj" fmla="val 4348"/>
+            </a:avLst>
+          </a:prstGeom>
+          <a:solidFill>
+            <a:srgbClr val="132846"/>
+          </a:solidFill>
+          <a:ln w="19050">
+            <a:solidFill>
+              <a:srgbClr val="1E3A5F"/>
+            </a:solidFill>
+          </a:ln>
+        </p:spPr>
+      </p:sp>
+      <p:sp>
+        <p:nvSpPr>
+          <p:cNvPr id="42" name="TextBox 42"/>
+          <p:cNvSpPr txBox="1"/>
+          <p:nvPr/>
+        </p:nvSpPr>
+        <p:spPr>
+          <a:xfrm>
+            <a:off x="5897118" y="3584258"/>
+            <a:ext cx="949681" cy="322707"/>
+          </a:xfrm>
+          <a:prstGeom prst="rect">
+            <a:avLst/>
+          </a:prstGeom>
+          <a:noFill/>
+          <a:ln>
+            <a:noFill/>
+          </a:ln>
+        </p:spPr>
+        <p:txBody>
+          <a:bodyPr wrap="none" lIns="0" tIns="0" rIns="0" bIns="0" anchor="t" anchorCtr="0">
+            <a:spAutoFit/>
+          </a:bodyPr>
+          <a:lstStyle/>
+          <a:p>
+            <a:pPr algn="l"/>
+            <a:r>
+              <a:rPr lang="zh-CN" sz="1650" b="1" dirty="0">
+                <a:solidFill>
+                  <a:srgbClr val="FFD54F"/>
+                </a:solidFill>
+                <a:latin typeface="Arial"/>
+                <a:ea typeface="Microsoft YaHei"/>
+                <a:cs typeface="Arial"/>
+              </a:rPr>
+              <a:t>特殊处理</a:t>
+            </a:r>
+          </a:p>
+        </p:txBody>
+      </p:sp>
+      <p:sp>
+        <p:nvSpPr>
+          <p:cNvPr id="43" name="TextBox 43"/>
+          <p:cNvSpPr txBox="1"/>
+          <p:nvPr/>
+        </p:nvSpPr>
+        <p:spPr>
+          <a:xfrm>
+            <a:off x="5898642" y="3950018"/>
+            <a:ext cx="3919616" cy="264033"/>
+          </a:xfrm>
+          <a:prstGeom prst="rect">
+            <a:avLst/>
+          </a:prstGeom>
+          <a:noFill/>
+          <a:ln>
+            <a:noFill/>
+          </a:ln>
+        </p:spPr>
+        <p:txBody>
+          <a:bodyPr wrap="none" lIns="0" tIns="0" rIns="0" bIns="0" anchor="t" anchorCtr="0">
+            <a:spAutoFit/>
+          </a:bodyPr>
+          <a:lstStyle/>
+          <a:p>
+            <a:pPr algn="l"/>
+            <a:r>
+              <a:rPr lang="zh-CN" sz="1350" dirty="0">
+                <a:solidFill>
+                  <a:srgbClr val="DDEBFF"/>
+                </a:solidFill>
+                <a:latin typeface="Arial"/>
+                <a:ea typeface="Microsoft YaHei"/>
+                <a:cs typeface="Arial"/>
+              </a:rPr>
+              <a:t>▸ 4 号线环状：内圈/外圈方向标记（Line4Dir）</a:t>
+            </a:r>
+          </a:p>
+        </p:txBody>
+      </p:sp>
+      <p:sp>
+        <p:nvSpPr>
+          <p:cNvPr id="44" name="TextBox 44"/>
+          <p:cNvSpPr txBox="1"/>
+          <p:nvPr/>
+        </p:nvSpPr>
+        <p:spPr>
+          <a:xfrm>
+            <a:off x="5898642" y="4254818"/>
+            <a:ext cx="3626168" cy="264033"/>
+          </a:xfrm>
+          <a:prstGeom prst="rect">
+            <a:avLst/>
+          </a:prstGeom>
+          <a:noFill/>
+          <a:ln>
+            <a:noFill/>
+          </a:ln>
+        </p:spPr>
+        <p:txBody>
+          <a:bodyPr wrap="none" lIns="0" tIns="0" rIns="0" bIns="0" anchor="t" anchorCtr="0">
+            <a:spAutoFit/>
+          </a:bodyPr>
+          <a:lstStyle/>
+          <a:p>
+            <a:pPr algn="l"/>
+            <a:r>
+              <a:rPr lang="zh-CN" sz="1350" dirty="0">
+                <a:solidFill>
+                  <a:srgbClr val="DDEBFF"/>
+                </a:solidFill>
+                <a:latin typeface="Arial"/>
+                <a:ea typeface="Microsoft YaHei"/>
+                <a:cs typeface="Arial"/>
+              </a:rPr>
+              <a:t>▸ 5/10/11 支线：3min 默认补边填补 Y 分叉</a:t>
+            </a:r>
+          </a:p>
+        </p:txBody>
+      </p:sp>
+      <p:sp>
+        <p:nvSpPr>
+          <p:cNvPr id="45" name="TextBox 45"/>
+          <p:cNvSpPr txBox="1"/>
+          <p:nvPr/>
+        </p:nvSpPr>
+        <p:spPr>
+          <a:xfrm>
+            <a:off x="5898642" y="4559618"/>
+            <a:ext cx="3957409" cy="264033"/>
+          </a:xfrm>
+          <a:prstGeom prst="rect">
+            <a:avLst/>
+          </a:prstGeom>
+          <a:noFill/>
+          <a:ln>
+            <a:noFill/>
+          </a:ln>
+        </p:spPr>
+        <p:txBody>
+          <a:bodyPr wrap="none" lIns="0" tIns="0" rIns="0" bIns="0" anchor="t" anchorCtr="0">
+            <a:spAutoFit/>
+          </a:bodyPr>
+          <a:lstStyle/>
+          <a:p>
+            <a:pPr algn="l"/>
+            <a:r>
+              <a:rPr lang="zh-CN" sz="1350" dirty="0">
+                <a:solidFill>
+                  <a:srgbClr val="DDEBFF"/>
+                </a:solidFill>
+                <a:latin typeface="Arial"/>
+                <a:ea typeface="Microsoft YaHei"/>
+                <a:cs typeface="Arial"/>
+              </a:rPr>
+              <a:t>▸ remove_loop_closure_edges() 移除环线伪边</a:t>
+            </a:r>
+          </a:p>
+        </p:txBody>
+      </p:sp>
+      <p:sp>
+        <p:nvSpPr>
+          <p:cNvPr id="46" name="TextBox 46"/>
+          <p:cNvSpPr txBox="1"/>
+          <p:nvPr/>
+        </p:nvSpPr>
+        <p:spPr>
+          <a:xfrm>
+            <a:off x="5898642" y="4864418"/>
+            <a:ext cx="3686679" cy="264033"/>
+          </a:xfrm>
+          <a:prstGeom prst="rect">
+            <a:avLst/>
+          </a:prstGeom>
+          <a:noFill/>
+          <a:ln>
+            <a:noFill/>
+          </a:ln>
+        </p:spPr>
+        <p:txBody>
+          <a:bodyPr wrap="none" lIns="0" tIns="0" rIns="0" bIns="0" anchor="t" anchorCtr="0">
+            <a:spAutoFit/>
+          </a:bodyPr>
+          <a:lstStyle/>
+          <a:p>
+            <a:pPr algn="l"/>
+            <a:r>
+              <a:rPr lang="zh-CN" sz="1350" dirty="0">
+                <a:solidFill>
+                  <a:srgbClr val="DDEBFF"/>
+                </a:solidFill>
+                <a:latin typeface="Arial"/>
+                <a:ea typeface="Microsoft YaHei"/>
+                <a:cs typeface="Arial"/>
+              </a:rPr>
+              <a:t>▸ UTF-8 BOM：utf-8-sig，中文 Excel 兼容</a:t>
+            </a:r>
+          </a:p>
+        </p:txBody>
+      </p:sp>
+      <p:sp>
+        <p:nvSpPr>
+          <p:cNvPr id="47" name="TextBox 47"/>
+          <p:cNvSpPr txBox="1"/>
+          <p:nvPr/>
+        </p:nvSpPr>
+        <p:spPr>
+          <a:xfrm>
+            <a:off x="5898642" y="5169218"/>
+            <a:ext cx="3322058" cy="264033"/>
+          </a:xfrm>
+          <a:prstGeom prst="rect">
+            <a:avLst/>
+          </a:prstGeom>
+          <a:noFill/>
+          <a:ln>
+            <a:noFill/>
+          </a:ln>
+        </p:spPr>
+        <p:txBody>
+          <a:bodyPr wrap="none" lIns="0" tIns="0" rIns="0" bIns="0" anchor="t" anchorCtr="0">
+            <a:spAutoFit/>
+          </a:bodyPr>
+          <a:lstStyle/>
+          <a:p>
+            <a:pPr algn="l"/>
+            <a:r>
+              <a:rPr lang="zh-CN" sz="1350" dirty="0">
+                <a:solidFill>
+                  <a:srgbClr val="DDEBFF"/>
+                </a:solidFill>
+                <a:latin typeface="Arial"/>
+                <a:ea typeface="Microsoft YaHei"/>
+                <a:cs typeface="Arial"/>
+              </a:rPr>
+              <a:t>▸ StationManager 拆分同名站为独立 ID</a:t>
+            </a:r>
+          </a:p>
+        </p:txBody>
+      </p:sp>
+      <p:sp>
+        <p:nvSpPr>
+          <p:cNvPr id="48" name="TextBox 48"/>
+          <p:cNvSpPr txBox="1"/>
+          <p:nvPr/>
+        </p:nvSpPr>
+        <p:spPr>
+          <a:xfrm>
+            <a:off x="2849675" y="6124575"/>
+            <a:ext cx="6492650" cy="293370"/>
+          </a:xfrm>
+          <a:prstGeom prst="rect">
+            <a:avLst/>
+          </a:prstGeom>
+          <a:noFill/>
+          <a:ln>
+            <a:noFill/>
+          </a:ln>
+        </p:spPr>
+        <p:txBody>
+          <a:bodyPr wrap="none" lIns="0" tIns="0" rIns="0" bIns="0" anchor="t" anchorCtr="0">
+            <a:spAutoFit/>
+          </a:bodyPr>
+          <a:lstStyle/>
+          <a:p>
+            <a:pPr algn="ctr"/>
+            <a:r>
+              <a:rPr lang="zh-CN" sz="1500" b="1" dirty="0">
+                <a:solidFill>
+                  <a:srgbClr val="FFD54F"/>
+                </a:solidFill>
+                <a:latin typeface="Arial"/>
+                <a:ea typeface="Microsoft YaHei"/>
+                <a:cs typeface="Arial"/>
+              </a:rPr>
+              <a:t>530 物理站 → 800+ 图节点 · 1044 边段 → 1300+ 有向边 · 278 换乘边</a:t>
+            </a:r>
+          </a:p>
+        </p:txBody>
+      </p:sp>
+    </p:spTree>
+  </p:cSld>
+  <p:clrMapOvr>
+    <a:masterClrMapping/>
+  </p:clrMapOvr>
+  <p:transition xmlns:p14="http://schemas.microsoft.com/office/powerpoint/2010/main" p14:dur="400">
+    <p:fade/>
+  </p:transition>
+</p:sld>
+</file>
+
+<file path=ppt/slides/slide4.xml><?xml version="1.0" encoding="utf-8"?>
+<p:sld xmlns:a="http://schemas.openxmlformats.org/drawingml/2006/main" xmlns:r="http://schemas.openxmlformats.org/officeDocument/2006/relationships" xmlns:p="http://schemas.openxmlformats.org/presentationml/2006/main">
+  <p:cSld>
+    <p:spTree>
+      <p:nvGrpSpPr>
+        <p:cNvPr id="1" name=""/>
+        <p:cNvGrpSpPr/>
+        <p:nvPr/>
+      </p:nvGrpSpPr>
+      <p:grpSpPr>
+        <a:xfrm>
+          <a:off x="0" y="0"/>
+          <a:ext cx="0" cy="0"/>
+          <a:chOff x="0" y="0"/>
+          <a:chExt cx="0" cy="0"/>
+        </a:xfrm>
+      </p:grpSpPr>
+      <p:sp>
+        <p:nvSpPr>
+          <p:cNvPr id="2" name="Rectangle 2"/>
+          <p:cNvSpPr/>
+          <p:nvPr/>
+        </p:nvSpPr>
+        <p:spPr>
+          <a:xfrm>
+            <a:off x="0" y="0"/>
+            <a:ext cx="12192000" cy="6858000"/>
+          </a:xfrm>
+          <a:prstGeom prst="rect">
+            <a:avLst/>
+          </a:prstGeom>
+          <a:solidFill>
+            <a:srgbClr val="0B1F3A"/>
+          </a:solidFill>
+          <a:ln>
+            <a:noFill/>
+          </a:ln>
+        </p:spPr>
+      </p:sp>
+      <p:sp>
+        <p:nvSpPr>
+          <p:cNvPr id="3" name="TextBox 3"/>
+          <p:cNvSpPr txBox="1"/>
+          <p:nvPr/>
+        </p:nvSpPr>
+        <p:spPr>
+          <a:xfrm>
+            <a:off x="745236" y="501015"/>
+            <a:ext cx="1899361" cy="645414"/>
+          </a:xfrm>
+          <a:prstGeom prst="rect">
+            <a:avLst/>
+          </a:prstGeom>
+          <a:noFill/>
+          <a:ln>
+            <a:noFill/>
+          </a:ln>
+        </p:spPr>
+        <p:txBody>
+          <a:bodyPr wrap="none" lIns="0" tIns="0" rIns="0" bIns="0" anchor="t" anchorCtr="0">
+            <a:spAutoFit/>
+          </a:bodyPr>
+          <a:lstStyle/>
+          <a:p>
+            <a:pPr algn="l"/>
+            <a:r>
+              <a:rPr lang="zh-CN" sz="3300" b="1" dirty="0">
+                <a:solidFill>
+                  <a:srgbClr val="FFFFFF"/>
+                </a:solidFill>
+                <a:latin typeface="Arial"/>
+                <a:ea typeface="Microsoft YaHei"/>
+                <a:cs typeface="Arial"/>
+              </a:rPr>
+              <a:t>路径算法</a:t>
+            </a:r>
+          </a:p>
+        </p:txBody>
+      </p:sp>
+      <p:sp>
+        <p:nvSpPr>
+          <p:cNvPr id="4" name="Line 4"/>
+          <p:cNvSpPr/>
+          <p:nvPr/>
+        </p:nvSpPr>
+        <p:spPr>
+          <a:xfrm>
+            <a:off x="762000" y="1047750"/>
+            <a:ext cx="10668000" cy="9525"/>
+          </a:xfrm>
+          <a:custGeom>
+            <a:avLst/>
+            <a:gdLst/>
+            <a:ahLst/>
+            <a:cxnLst/>
+            <a:rect l="l" t="t" r="r" b="b"/>
+            <a:pathLst>
+              <a:path w="10668000" h="9525">
+                <a:moveTo>
+                  <a:pt x="0" y="0"/>
+                </a:moveTo>
+                <a:lnTo>
+                  <a:pt x="10668000" y="0"/>
+                </a:lnTo>
+              </a:path>
+            </a:pathLst>
+          </a:custGeom>
+          <a:noFill/>
+          <a:ln w="28575" cap="rnd">
+            <a:solidFill>
+              <a:srgbClr val="E4002B"/>
+            </a:solidFill>
+          </a:ln>
+        </p:spPr>
+      </p:sp>
+      <p:sp>
+        <p:nvSpPr>
+          <p:cNvPr id="5" name="TextBox 5"/>
+          <p:cNvSpPr txBox="1"/>
+          <p:nvPr/>
+        </p:nvSpPr>
+        <p:spPr>
+          <a:xfrm>
+            <a:off x="755142" y="1187768"/>
+            <a:ext cx="2140039" cy="264033"/>
+          </a:xfrm>
+          <a:prstGeom prst="rect">
+            <a:avLst/>
+          </a:prstGeom>
+          <a:noFill/>
+          <a:ln>
+            <a:noFill/>
+          </a:ln>
+        </p:spPr>
+        <p:txBody>
+          <a:bodyPr wrap="none" lIns="0" tIns="0" rIns="0" bIns="0" anchor="t" anchorCtr="0">
+            <a:spAutoFit/>
+          </a:bodyPr>
+          <a:lstStyle/>
+          <a:p>
+            <a:pPr algn="l"/>
+            <a:r>
+              <a:rPr lang="zh-CN" sz="1350" dirty="0">
+                <a:solidFill>
+                  <a:srgbClr val="FFD54F"/>
+                </a:solidFill>
+                <a:latin typeface="Arial"/>
+                <a:ea typeface="Microsoft YaHei"/>
+                <a:cs typeface="Arial"/>
+              </a:rPr>
+              <a:t>对应课设：路径算法 15 分</a:t>
+            </a:r>
+          </a:p>
+        </p:txBody>
+      </p:sp>
+      <p:sp>
+        <p:nvSpPr>
+          <p:cNvPr id="6" name="Rectangle 6"/>
+          <p:cNvSpPr/>
+          <p:nvPr/>
+        </p:nvSpPr>
+        <p:spPr>
+          <a:xfrm>
+            <a:off x="571500" y="1666875"/>
+            <a:ext cx="2667000" cy="1762125"/>
+          </a:xfrm>
+          <a:prstGeom prst="roundRect">
+            <a:avLst>
+              <a:gd name="adj" fmla="val 5405"/>
+            </a:avLst>
+          </a:prstGeom>
+          <a:solidFill>
+            <a:srgbClr val="132846"/>
+          </a:solidFill>
+          <a:ln w="19050">
+            <a:solidFill>
+              <a:srgbClr val="1E3A5F"/>
+            </a:solidFill>
+          </a:ln>
+        </p:spPr>
+      </p:sp>
+      <p:sp>
+        <p:nvSpPr>
+          <p:cNvPr id="7" name="TextBox 7"/>
+          <p:cNvSpPr txBox="1"/>
+          <p:nvPr/>
+        </p:nvSpPr>
+        <p:spPr>
+          <a:xfrm>
+            <a:off x="705993" y="1822132"/>
+            <a:ext cx="2036726" cy="322707"/>
+          </a:xfrm>
+          <a:prstGeom prst="rect">
+            <a:avLst/>
+          </a:prstGeom>
+          <a:noFill/>
+          <a:ln>
+            <a:noFill/>
+          </a:ln>
+        </p:spPr>
+        <p:txBody>
+          <a:bodyPr wrap="none" lIns="0" tIns="0" rIns="0" bIns="0" anchor="t" anchorCtr="0">
+            <a:spAutoFit/>
+          </a:bodyPr>
+          <a:lstStyle/>
+          <a:p>
+            <a:pPr algn="l"/>
+            <a:r>
+              <a:rPr lang="en-US" sz="1650" b="1" dirty="0">
+                <a:solidFill>
+                  <a:srgbClr val="FFD54F"/>
+                </a:solidFill>
+                <a:latin typeface="Arial"/>
+                <a:ea typeface="Arial"/>
+                <a:cs typeface="Arial"/>
+              </a:rPr>
+              <a:t>Dijkstra Shortest</a:t>
+            </a:r>
+          </a:p>
+        </p:txBody>
+      </p:sp>
+      <p:sp>
+        <p:nvSpPr>
+          <p:cNvPr id="8" name="TextBox 8"/>
+          <p:cNvSpPr txBox="1"/>
+          <p:nvPr/>
+        </p:nvSpPr>
+        <p:spPr>
+          <a:xfrm>
+            <a:off x="708279" y="2251710"/>
+            <a:ext cx="1360018" cy="234696"/>
+          </a:xfrm>
+          <a:prstGeom prst="rect">
+            <a:avLst/>
+          </a:prstGeom>
+          <a:noFill/>
+          <a:ln>
+            <a:noFill/>
+          </a:ln>
+        </p:spPr>
+        <p:txBody>
+          <a:bodyPr wrap="none" lIns="0" tIns="0" rIns="0" bIns="0" anchor="t" anchorCtr="0">
+            <a:spAutoFit/>
+          </a:bodyPr>
+          <a:lstStyle/>
+          <a:p>
+            <a:pPr algn="l"/>
+            <a:r>
+              <a:rPr lang="zh-CN" sz="1200" dirty="0">
+                <a:solidFill>
+                  <a:srgbClr val="DDEBFF"/>
+                </a:solidFill>
+                <a:latin typeface="Consolas"/>
+                <a:ea typeface="Microsoft YaHei"/>
+                <a:cs typeface="Consolas"/>
+              </a:rPr>
+              <a:t>权重: TimeWeight</a:t>
+            </a:r>
+          </a:p>
+        </p:txBody>
+      </p:sp>
+      <p:sp>
+        <p:nvSpPr>
+          <p:cNvPr id="9" name="TextBox 9"/>
+          <p:cNvSpPr txBox="1"/>
+          <p:nvPr/>
+        </p:nvSpPr>
+        <p:spPr>
+          <a:xfrm>
+            <a:off x="709041" y="2553652"/>
+            <a:ext cx="1834096" cy="205359"/>
+          </a:xfrm>
+          <a:prstGeom prst="rect">
+            <a:avLst/>
+          </a:prstGeom>
+          <a:noFill/>
+          <a:ln>
+            <a:noFill/>
+          </a:ln>
+        </p:spPr>
+        <p:txBody>
+          <a:bodyPr wrap="none" lIns="0" tIns="0" rIns="0" bIns="0" anchor="t" anchorCtr="0">
+            <a:spAutoFit/>
+          </a:bodyPr>
+          <a:lstStyle/>
+          <a:p>
+            <a:pPr algn="l"/>
+            <a:r>
+              <a:rPr lang="en-US" sz="1050" dirty="0">
+                <a:solidFill>
+                  <a:srgbClr val="DDEBFF"/>
+                </a:solidFill>
+                <a:latin typeface="Consolas"/>
+                <a:ea typeface="Consolas"/>
+                <a:cs typeface="Consolas"/>
+              </a:rPr>
+              <a:t>min-heap: std::greater&lt;&gt;</a:t>
+            </a:r>
+          </a:p>
+        </p:txBody>
+      </p:sp>
+      <p:sp>
+        <p:nvSpPr>
+          <p:cNvPr id="10" name="TextBox 10"/>
+          <p:cNvSpPr txBox="1"/>
+          <p:nvPr/>
+        </p:nvSpPr>
+        <p:spPr>
+          <a:xfrm>
+            <a:off x="708279" y="2918460"/>
+            <a:ext cx="1441856" cy="234696"/>
+          </a:xfrm>
+          <a:prstGeom prst="rect">
+            <a:avLst/>
+          </a:prstGeom>
+          <a:noFill/>
+          <a:ln>
+            <a:noFill/>
+          </a:ln>
+        </p:spPr>
+        <p:txBody>
+          <a:bodyPr wrap="none" lIns="0" tIns="0" rIns="0" bIns="0" anchor="t" anchorCtr="0">
+            <a:spAutoFit/>
+          </a:bodyPr>
+          <a:lstStyle/>
+          <a:p>
+            <a:pPr algn="l"/>
+            <a:r>
+              <a:rPr lang="zh-CN" sz="1200" dirty="0">
+                <a:solidFill>
+                  <a:srgbClr val="B7C7DE"/>
+                </a:solidFill>
+                <a:latin typeface="Arial"/>
+                <a:ea typeface="Microsoft YaHei"/>
+                <a:cs typeface="Arial"/>
+              </a:rPr>
+              <a:t>用途: 单源最短时间</a:t>
+            </a:r>
+          </a:p>
+        </p:txBody>
+      </p:sp>
+      <p:sp>
+        <p:nvSpPr>
+          <p:cNvPr id="11" name="Rectangle 11"/>
+          <p:cNvSpPr/>
+          <p:nvPr/>
+        </p:nvSpPr>
+        <p:spPr>
+          <a:xfrm>
+            <a:off x="3429000" y="1666875"/>
+            <a:ext cx="2667000" cy="1762125"/>
+          </a:xfrm>
+          <a:prstGeom prst="roundRect">
+            <a:avLst>
+              <a:gd name="adj" fmla="val 5405"/>
+            </a:avLst>
+          </a:prstGeom>
+          <a:solidFill>
+            <a:srgbClr val="132846"/>
+          </a:solidFill>
+          <a:ln w="19050">
+            <a:solidFill>
+              <a:srgbClr val="1E3A5F"/>
+            </a:solidFill>
+          </a:ln>
+        </p:spPr>
+      </p:sp>
+      <p:sp>
+        <p:nvSpPr>
+          <p:cNvPr id="12" name="TextBox 12"/>
+          <p:cNvSpPr txBox="1"/>
+          <p:nvPr/>
+        </p:nvSpPr>
+        <p:spPr>
+          <a:xfrm>
+            <a:off x="3563493" y="1822132"/>
+            <a:ext cx="1778909" cy="322707"/>
+          </a:xfrm>
+          <a:prstGeom prst="rect">
+            <a:avLst/>
+          </a:prstGeom>
+          <a:noFill/>
+          <a:ln>
+            <a:noFill/>
+          </a:ln>
+        </p:spPr>
+        <p:txBody>
+          <a:bodyPr wrap="none" lIns="0" tIns="0" rIns="0" bIns="0" anchor="t" anchorCtr="0">
+            <a:spAutoFit/>
+          </a:bodyPr>
+          <a:lstStyle/>
+          <a:p>
+            <a:pPr algn="l"/>
+            <a:r>
+              <a:rPr lang="en-US" sz="1650" b="1" dirty="0">
+                <a:solidFill>
+                  <a:srgbClr val="FFD54F"/>
+                </a:solidFill>
+                <a:latin typeface="Arial"/>
+                <a:ea typeface="Arial"/>
+                <a:cs typeface="Arial"/>
+              </a:rPr>
+              <a:t>Yen K-Shortest</a:t>
+            </a:r>
+          </a:p>
+        </p:txBody>
+      </p:sp>
+      <p:sp>
+        <p:nvSpPr>
+          <p:cNvPr id="13" name="TextBox 13"/>
+          <p:cNvSpPr txBox="1"/>
+          <p:nvPr/>
+        </p:nvSpPr>
+        <p:spPr>
+          <a:xfrm>
+            <a:off x="3565779" y="2251710"/>
+            <a:ext cx="1272235" cy="234696"/>
+          </a:xfrm>
+          <a:prstGeom prst="rect">
+            <a:avLst/>
+          </a:prstGeom>
+          <a:noFill/>
+          <a:ln>
+            <a:noFill/>
+          </a:ln>
+        </p:spPr>
+        <p:txBody>
+          <a:bodyPr wrap="none" lIns="0" tIns="0" rIns="0" bIns="0" anchor="t" anchorCtr="0">
+            <a:spAutoFit/>
+          </a:bodyPr>
+          <a:lstStyle/>
+          <a:p>
+            <a:pPr algn="l"/>
+            <a:r>
+              <a:rPr lang="zh-CN" sz="1200" dirty="0">
+                <a:solidFill>
+                  <a:srgbClr val="DDEBFF"/>
+                </a:solidFill>
+                <a:latin typeface="Consolas"/>
+                <a:ea typeface="Microsoft YaHei"/>
+                <a:cs typeface="Consolas"/>
+              </a:rPr>
+              <a:t>算法: spur-path</a:t>
+            </a:r>
+          </a:p>
+        </p:txBody>
+      </p:sp>
+      <p:sp>
+        <p:nvSpPr>
+          <p:cNvPr id="14" name="TextBox 14"/>
+          <p:cNvSpPr txBox="1"/>
+          <p:nvPr/>
+        </p:nvSpPr>
+        <p:spPr>
+          <a:xfrm>
+            <a:off x="3566541" y="2553652"/>
+            <a:ext cx="346710" cy="205359"/>
+          </a:xfrm>
+          <a:prstGeom prst="rect">
+            <a:avLst/>
+          </a:prstGeom>
+          <a:noFill/>
+          <a:ln>
+            <a:noFill/>
+          </a:ln>
+        </p:spPr>
+        <p:txBody>
+          <a:bodyPr wrap="none" lIns="0" tIns="0" rIns="0" bIns="0" anchor="t" anchorCtr="0">
+            <a:spAutoFit/>
+          </a:bodyPr>
+          <a:lstStyle/>
+          <a:p>
+            <a:pPr algn="l"/>
+            <a:r>
+              <a:rPr lang="en-US" sz="1050" dirty="0">
+                <a:solidFill>
+                  <a:srgbClr val="DDEBFF"/>
+                </a:solidFill>
+                <a:latin typeface="Consolas"/>
+                <a:ea typeface="Consolas"/>
+                <a:cs typeface="Consolas"/>
+              </a:rPr>
+              <a:t>K = 3</a:t>
+            </a:r>
+          </a:p>
+        </p:txBody>
+      </p:sp>
+      <p:sp>
+        <p:nvSpPr>
+          <p:cNvPr id="15" name="TextBox 15"/>
+          <p:cNvSpPr txBox="1"/>
+          <p:nvPr/>
+        </p:nvSpPr>
+        <p:spPr>
+          <a:xfrm>
+            <a:off x="3565779" y="2918460"/>
+            <a:ext cx="1656740" cy="234696"/>
+          </a:xfrm>
+          <a:prstGeom prst="rect">
+            <a:avLst/>
+          </a:prstGeom>
+          <a:noFill/>
+          <a:ln>
+            <a:noFill/>
+          </a:ln>
+        </p:spPr>
+        <p:txBody>
+          <a:bodyPr wrap="none" lIns="0" tIns="0" rIns="0" bIns="0" anchor="t" anchorCtr="0">
+            <a:spAutoFit/>
+          </a:bodyPr>
+          <a:lstStyle/>
+          <a:p>
+            <a:pPr algn="l"/>
+            <a:r>
+              <a:rPr lang="zh-CN" sz="1200" dirty="0">
+                <a:solidFill>
+                  <a:srgbClr val="B7C7DE"/>
+                </a:solidFill>
+                <a:latin typeface="Arial"/>
+                <a:ea typeface="Microsoft YaHei"/>
+                <a:cs typeface="Arial"/>
+              </a:rPr>
+              <a:t>用途: Top-K 最短路径</a:t>
+            </a:r>
+          </a:p>
+        </p:txBody>
+      </p:sp>
+      <p:sp>
+        <p:nvSpPr>
+          <p:cNvPr id="16" name="Rectangle 16"/>
+          <p:cNvSpPr/>
+          <p:nvPr/>
+        </p:nvSpPr>
+        <p:spPr>
+          <a:xfrm>
+            <a:off x="6286500" y="1666875"/>
+            <a:ext cx="2667000" cy="1762125"/>
+          </a:xfrm>
+          <a:prstGeom prst="roundRect">
+            <a:avLst>
+              <a:gd name="adj" fmla="val 5405"/>
+            </a:avLst>
+          </a:prstGeom>
+          <a:solidFill>
+            <a:srgbClr val="132846"/>
+          </a:solidFill>
+          <a:ln w="19050">
+            <a:solidFill>
+              <a:srgbClr val="1E3A5F"/>
+            </a:solidFill>
+          </a:ln>
+        </p:spPr>
+      </p:sp>
+      <p:sp>
+        <p:nvSpPr>
+          <p:cNvPr id="17" name="TextBox 17"/>
+          <p:cNvSpPr txBox="1"/>
+          <p:nvPr/>
+        </p:nvSpPr>
+        <p:spPr>
+          <a:xfrm>
+            <a:off x="6420993" y="1822132"/>
+            <a:ext cx="1974481" cy="322707"/>
+          </a:xfrm>
+          <a:prstGeom prst="rect">
+            <a:avLst/>
+          </a:prstGeom>
+          <a:noFill/>
+          <a:ln>
+            <a:noFill/>
+          </a:ln>
+        </p:spPr>
+        <p:txBody>
+          <a:bodyPr wrap="none" lIns="0" tIns="0" rIns="0" bIns="0" anchor="t" anchorCtr="0">
+            <a:spAutoFit/>
+          </a:bodyPr>
+          <a:lstStyle/>
+          <a:p>
+            <a:pPr algn="l"/>
+            <a:r>
+              <a:rPr lang="en-US" sz="1650" b="1" dirty="0">
+                <a:solidFill>
+                  <a:srgbClr val="FFD54F"/>
+                </a:solidFill>
+                <a:latin typeface="Arial"/>
+                <a:ea typeface="Arial"/>
+                <a:cs typeface="Arial"/>
+              </a:rPr>
+              <a:t>Dijkstra Min Xfer</a:t>
+            </a:r>
+          </a:p>
+        </p:txBody>
+      </p:sp>
+      <p:sp>
+        <p:nvSpPr>
+          <p:cNvPr id="18" name="TextBox 18"/>
+          <p:cNvSpPr txBox="1"/>
+          <p:nvPr/>
+        </p:nvSpPr>
+        <p:spPr>
+          <a:xfrm>
+            <a:off x="6423279" y="2251710"/>
+            <a:ext cx="1934566" cy="234696"/>
+          </a:xfrm>
+          <a:prstGeom prst="rect">
+            <a:avLst/>
+          </a:prstGeom>
+          <a:noFill/>
+          <a:ln>
+            <a:noFill/>
+          </a:ln>
+        </p:spPr>
+        <p:txBody>
+          <a:bodyPr wrap="none" lIns="0" tIns="0" rIns="0" bIns="0" anchor="t" anchorCtr="0">
+            <a:spAutoFit/>
+          </a:bodyPr>
+          <a:lstStyle/>
+          <a:p>
+            <a:pPr algn="l"/>
+            <a:r>
+              <a:rPr lang="zh-CN" sz="1200" dirty="0">
+                <a:solidFill>
+                  <a:srgbClr val="DDEBFF"/>
+                </a:solidFill>
+                <a:latin typeface="Consolas"/>
+                <a:ea typeface="Microsoft YaHei"/>
+                <a:cs typeface="Consolas"/>
+              </a:rPr>
+              <a:t>权重: (transfers, time)</a:t>
+            </a:r>
+          </a:p>
+        </p:txBody>
+      </p:sp>
+      <p:sp>
+        <p:nvSpPr>
+          <p:cNvPr id="19" name="TextBox 19"/>
+          <p:cNvSpPr txBox="1"/>
+          <p:nvPr/>
+        </p:nvSpPr>
+        <p:spPr>
+          <a:xfrm>
+            <a:off x="6424041" y="2553652"/>
+            <a:ext cx="717423" cy="205359"/>
+          </a:xfrm>
+          <a:prstGeom prst="rect">
+            <a:avLst/>
+          </a:prstGeom>
+          <a:noFill/>
+          <a:ln>
+            <a:noFill/>
+          </a:ln>
+        </p:spPr>
+        <p:txBody>
+          <a:bodyPr wrap="none" lIns="0" tIns="0" rIns="0" bIns="0" anchor="t" anchorCtr="0">
+            <a:spAutoFit/>
+          </a:bodyPr>
+          <a:lstStyle/>
+          <a:p>
+            <a:pPr algn="l"/>
+            <a:r>
+              <a:rPr lang="zh-CN" sz="1050" dirty="0">
+                <a:solidFill>
+                  <a:srgbClr val="DDEBFF"/>
+                </a:solidFill>
+                <a:latin typeface="Consolas"/>
+                <a:ea typeface="Microsoft YaHei"/>
+                <a:cs typeface="Consolas"/>
+              </a:rPr>
+              <a:t>字典序比较</a:t>
+            </a:r>
+          </a:p>
+        </p:txBody>
+      </p:sp>
+      <p:sp>
+        <p:nvSpPr>
+          <p:cNvPr id="20" name="TextBox 20"/>
+          <p:cNvSpPr txBox="1"/>
+          <p:nvPr/>
+        </p:nvSpPr>
+        <p:spPr>
+          <a:xfrm>
+            <a:off x="6423279" y="2918460"/>
+            <a:ext cx="1118768" cy="234696"/>
+          </a:xfrm>
+          <a:prstGeom prst="rect">
+            <a:avLst/>
+          </a:prstGeom>
+          <a:noFill/>
+          <a:ln>
+            <a:noFill/>
+          </a:ln>
+        </p:spPr>
+        <p:txBody>
+          <a:bodyPr wrap="none" lIns="0" tIns="0" rIns="0" bIns="0" anchor="t" anchorCtr="0">
+            <a:spAutoFit/>
+          </a:bodyPr>
+          <a:lstStyle/>
+          <a:p>
+            <a:pPr algn="l"/>
+            <a:r>
+              <a:rPr lang="zh-CN" sz="1200" dirty="0">
+                <a:solidFill>
+                  <a:srgbClr val="B7C7DE"/>
+                </a:solidFill>
+                <a:latin typeface="Arial"/>
+                <a:ea typeface="Microsoft YaHei"/>
+                <a:cs typeface="Arial"/>
+              </a:rPr>
+              <a:t>用途: 最少换乘</a:t>
+            </a:r>
+          </a:p>
+        </p:txBody>
+      </p:sp>
+      <p:sp>
+        <p:nvSpPr>
+          <p:cNvPr id="21" name="Rectangle 21"/>
+          <p:cNvSpPr/>
+          <p:nvPr/>
+        </p:nvSpPr>
+        <p:spPr>
+          <a:xfrm>
+            <a:off x="9144000" y="1666875"/>
+            <a:ext cx="2667000" cy="1762125"/>
+          </a:xfrm>
+          <a:prstGeom prst="roundRect">
+            <a:avLst>
+              <a:gd name="adj" fmla="val 5405"/>
+            </a:avLst>
+          </a:prstGeom>
+          <a:solidFill>
+            <a:srgbClr val="132846"/>
+          </a:solidFill>
+          <a:ln w="19050">
+            <a:solidFill>
+              <a:srgbClr val="1E3A5F"/>
+            </a:solidFill>
+          </a:ln>
+        </p:spPr>
+      </p:sp>
+      <p:sp>
+        <p:nvSpPr>
+          <p:cNvPr id="22" name="TextBox 22"/>
+          <p:cNvSpPr txBox="1"/>
+          <p:nvPr/>
+        </p:nvSpPr>
+        <p:spPr>
+          <a:xfrm>
+            <a:off x="9278493" y="1822132"/>
+            <a:ext cx="1718677" cy="322707"/>
+          </a:xfrm>
+          <a:prstGeom prst="rect">
+            <a:avLst/>
+          </a:prstGeom>
+          <a:noFill/>
+          <a:ln>
+            <a:noFill/>
+          </a:ln>
+        </p:spPr>
+        <p:txBody>
+          <a:bodyPr wrap="none" lIns="0" tIns="0" rIns="0" bIns="0" anchor="t" anchorCtr="0">
+            <a:spAutoFit/>
+          </a:bodyPr>
+          <a:lstStyle/>
+          <a:p>
+            <a:pPr algn="l"/>
+            <a:r>
+              <a:rPr lang="en-US" sz="1650" b="1" dirty="0">
+                <a:solidFill>
+                  <a:srgbClr val="FFD54F"/>
+                </a:solidFill>
+                <a:latin typeface="Arial"/>
+                <a:ea typeface="Arial"/>
+                <a:cs typeface="Arial"/>
+              </a:rPr>
+              <a:t>Yen K-Min Xfer</a:t>
+            </a:r>
+          </a:p>
+        </p:txBody>
+      </p:sp>
+      <p:sp>
+        <p:nvSpPr>
+          <p:cNvPr id="23" name="TextBox 23"/>
+          <p:cNvSpPr txBox="1"/>
+          <p:nvPr/>
+        </p:nvSpPr>
+        <p:spPr>
+          <a:xfrm>
+            <a:off x="9280779" y="2251710"/>
+            <a:ext cx="1717189" cy="234696"/>
+          </a:xfrm>
+          <a:prstGeom prst="rect">
+            <a:avLst/>
+          </a:prstGeom>
+          <a:noFill/>
+          <a:ln>
+            <a:noFill/>
+          </a:ln>
+        </p:spPr>
+        <p:txBody>
+          <a:bodyPr wrap="none" lIns="0" tIns="0" rIns="0" bIns="0" anchor="t" anchorCtr="0">
+            <a:spAutoFit/>
+          </a:bodyPr>
+          <a:lstStyle/>
+          <a:p>
+            <a:pPr algn="l"/>
+            <a:r>
+              <a:rPr lang="en-US" sz="1200" dirty="0">
+                <a:solidFill>
+                  <a:srgbClr val="DDEBFF"/>
+                </a:solidFill>
+                <a:latin typeface="Consolas"/>
+                <a:ea typeface="Consolas"/>
+                <a:cs typeface="Consolas"/>
+              </a:rPr>
+              <a:t>Yen + TransferWeight</a:t>
+            </a:r>
+          </a:p>
+        </p:txBody>
+      </p:sp>
+      <p:sp>
+        <p:nvSpPr>
+          <p:cNvPr id="24" name="TextBox 24"/>
+          <p:cNvSpPr txBox="1"/>
+          <p:nvPr/>
+        </p:nvSpPr>
+        <p:spPr>
+          <a:xfrm>
+            <a:off x="9281541" y="2553652"/>
+            <a:ext cx="346710" cy="205359"/>
+          </a:xfrm>
+          <a:prstGeom prst="rect">
+            <a:avLst/>
+          </a:prstGeom>
+          <a:noFill/>
+          <a:ln>
+            <a:noFill/>
+          </a:ln>
+        </p:spPr>
+        <p:txBody>
+          <a:bodyPr wrap="none" lIns="0" tIns="0" rIns="0" bIns="0" anchor="t" anchorCtr="0">
+            <a:spAutoFit/>
+          </a:bodyPr>
+          <a:lstStyle/>
+          <a:p>
+            <a:pPr algn="l"/>
+            <a:r>
+              <a:rPr lang="en-US" sz="1050" dirty="0">
+                <a:solidFill>
+                  <a:srgbClr val="DDEBFF"/>
+                </a:solidFill>
+                <a:latin typeface="Consolas"/>
+                <a:ea typeface="Consolas"/>
+                <a:cs typeface="Consolas"/>
+              </a:rPr>
+              <a:t>K = 3</a:t>
+            </a:r>
+          </a:p>
+        </p:txBody>
+      </p:sp>
+      <p:sp>
+        <p:nvSpPr>
+          <p:cNvPr id="25" name="TextBox 25"/>
+          <p:cNvSpPr txBox="1"/>
+          <p:nvPr/>
+        </p:nvSpPr>
+        <p:spPr>
+          <a:xfrm>
+            <a:off x="9280779" y="2918460"/>
+            <a:ext cx="1656740" cy="234696"/>
+          </a:xfrm>
+          <a:prstGeom prst="rect">
+            <a:avLst/>
+          </a:prstGeom>
+          <a:noFill/>
+          <a:ln>
+            <a:noFill/>
+          </a:ln>
+        </p:spPr>
+        <p:txBody>
+          <a:bodyPr wrap="none" lIns="0" tIns="0" rIns="0" bIns="0" anchor="t" anchorCtr="0">
+            <a:spAutoFit/>
+          </a:bodyPr>
+          <a:lstStyle/>
+          <a:p>
+            <a:pPr algn="l"/>
+            <a:r>
+              <a:rPr lang="zh-CN" sz="1200" dirty="0">
+                <a:solidFill>
+                  <a:srgbClr val="B7C7DE"/>
+                </a:solidFill>
+                <a:latin typeface="Arial"/>
+                <a:ea typeface="Microsoft YaHei"/>
+                <a:cs typeface="Arial"/>
+              </a:rPr>
+              <a:t>用途: Top-K 最少换乘</a:t>
+            </a:r>
+          </a:p>
+        </p:txBody>
+      </p:sp>
+      <p:sp>
+        <p:nvSpPr>
+          <p:cNvPr id="26" name="Rectangle 26"/>
+          <p:cNvSpPr/>
+          <p:nvPr/>
+        </p:nvSpPr>
+        <p:spPr>
+          <a:xfrm>
+            <a:off x="571500" y="3714750"/>
+            <a:ext cx="5905500" cy="2381250"/>
+          </a:xfrm>
+          <a:prstGeom prst="roundRect">
+            <a:avLst>
+              <a:gd name="adj" fmla="val 4000"/>
+            </a:avLst>
+          </a:prstGeom>
+          <a:solidFill>
+            <a:srgbClr val="132846"/>
+          </a:solidFill>
+          <a:ln w="19050">
+            <a:solidFill>
+              <a:srgbClr val="1E3A5F"/>
+            </a:solidFill>
+          </a:ln>
+        </p:spPr>
+      </p:sp>
+      <p:sp>
+        <p:nvSpPr>
+          <p:cNvPr id="27" name="TextBox 27"/>
+          <p:cNvSpPr txBox="1"/>
+          <p:nvPr/>
+        </p:nvSpPr>
+        <p:spPr>
+          <a:xfrm>
+            <a:off x="753618" y="3822382"/>
+            <a:ext cx="2647413" cy="322707"/>
+          </a:xfrm>
+          <a:prstGeom prst="rect">
+            <a:avLst/>
+          </a:prstGeom>
+          <a:noFill/>
+          <a:ln>
+            <a:noFill/>
+          </a:ln>
+        </p:spPr>
+        <p:txBody>
+          <a:bodyPr wrap="none" lIns="0" tIns="0" rIns="0" bIns="0" anchor="t" anchorCtr="0">
+            <a:spAutoFit/>
+          </a:bodyPr>
+          <a:lstStyle/>
+          <a:p>
+            <a:pPr algn="l"/>
+            <a:r>
+              <a:rPr lang="zh-CN" sz="1650" b="1" dirty="0">
+                <a:solidFill>
+                  <a:srgbClr val="FFD54F"/>
+                </a:solidFill>
+                <a:latin typeface="Arial"/>
+                <a:ea typeface="Microsoft YaHei"/>
+                <a:cs typeface="Arial"/>
+              </a:rPr>
+              <a:t>Dijkstra 主循环（简化）</a:t>
+            </a:r>
+          </a:p>
+        </p:txBody>
+      </p:sp>
+      <p:sp>
+        <p:nvSpPr>
+          <p:cNvPr id="28" name="TextBox 28"/>
+          <p:cNvSpPr txBox="1"/>
+          <p:nvPr/>
+        </p:nvSpPr>
+        <p:spPr>
+          <a:xfrm>
+            <a:off x="756285" y="4069556"/>
+            <a:ext cx="2932688" cy="220028"/>
+          </a:xfrm>
+          <a:prstGeom prst="rect">
+            <a:avLst/>
+          </a:prstGeom>
+          <a:noFill/>
+          <a:ln>
+            <a:noFill/>
+          </a:ln>
+        </p:spPr>
+        <p:txBody>
+          <a:bodyPr wrap="none" lIns="0" tIns="0" rIns="0" bIns="0" anchor="t" anchorCtr="0">
+            <a:spAutoFit/>
+          </a:bodyPr>
+          <a:lstStyle/>
+          <a:p>
+            <a:pPr algn="l"/>
+            <a:r>
+              <a:rPr lang="en-US" sz="1120" dirty="0">
+                <a:solidFill>
+                  <a:srgbClr val="DDEBFF"/>
+                </a:solidFill>
+                <a:latin typeface="Consolas"/>
+                <a:ea typeface="Consolas"/>
+                <a:cs typeface="Consolas"/>
+              </a:rPr>
+              <a:t>pq: priority_queue&lt;Weight&gt; (min-heap)</a:t>
+            </a:r>
+          </a:p>
+        </p:txBody>
+      </p:sp>
+      <p:sp>
+        <p:nvSpPr>
+          <p:cNvPr id="29" name="TextBox 29"/>
+          <p:cNvSpPr txBox="1"/>
+          <p:nvPr/>
+        </p:nvSpPr>
+        <p:spPr>
+          <a:xfrm>
+            <a:off x="756285" y="4279106"/>
+            <a:ext cx="1556194" cy="220028"/>
+          </a:xfrm>
+          <a:prstGeom prst="rect">
+            <a:avLst/>
+          </a:prstGeom>
+          <a:noFill/>
+          <a:ln>
+            <a:noFill/>
+          </a:ln>
+        </p:spPr>
+        <p:txBody>
+          <a:bodyPr wrap="none" lIns="0" tIns="0" rIns="0" bIns="0" anchor="t" anchorCtr="0">
+            <a:spAutoFit/>
+          </a:bodyPr>
+          <a:lstStyle/>
+          <a:p>
+            <a:pPr algn="l"/>
+            <a:r>
+              <a:rPr lang="en-US" sz="1120" dirty="0">
+                <a:solidFill>
+                  <a:srgbClr val="DDEBFF"/>
+                </a:solidFill>
+                <a:latin typeface="Consolas"/>
+                <a:ea typeface="Consolas"/>
+                <a:cs typeface="Consolas"/>
+              </a:rPr>
+              <a:t>pq.push({start, 0})</a:t>
+            </a:r>
+          </a:p>
+        </p:txBody>
+      </p:sp>
+      <p:sp>
+        <p:nvSpPr>
+          <p:cNvPr id="30" name="TextBox 30"/>
+          <p:cNvSpPr txBox="1"/>
+          <p:nvPr/>
+        </p:nvSpPr>
+        <p:spPr>
+          <a:xfrm>
+            <a:off x="756285" y="4488656"/>
+            <a:ext cx="1147286" cy="220028"/>
+          </a:xfrm>
+          <a:prstGeom prst="rect">
+            <a:avLst/>
+          </a:prstGeom>
+          <a:noFill/>
+          <a:ln>
+            <a:noFill/>
+          </a:ln>
+        </p:spPr>
+        <p:txBody>
+          <a:bodyPr wrap="none" lIns="0" tIns="0" rIns="0" bIns="0" anchor="t" anchorCtr="0">
+            <a:spAutoFit/>
+          </a:bodyPr>
+          <a:lstStyle/>
+          <a:p>
+            <a:pPr algn="l"/>
+            <a:r>
+              <a:rPr lang="en-US" sz="1120" dirty="0">
+                <a:solidFill>
+                  <a:srgbClr val="DDEBFF"/>
+                </a:solidFill>
+                <a:latin typeface="Consolas"/>
+                <a:ea typeface="Consolas"/>
+                <a:cs typeface="Consolas"/>
+              </a:rPr>
+              <a:t>dist[start] = 0</a:t>
+            </a:r>
+          </a:p>
+        </p:txBody>
+      </p:sp>
+      <p:sp>
+        <p:nvSpPr>
+          <p:cNvPr id="31" name="TextBox 31"/>
+          <p:cNvSpPr txBox="1"/>
+          <p:nvPr/>
+        </p:nvSpPr>
+        <p:spPr>
+          <a:xfrm>
+            <a:off x="756285" y="4698206"/>
+            <a:ext cx="1631918" cy="220028"/>
+          </a:xfrm>
+          <a:prstGeom prst="rect">
+            <a:avLst/>
+          </a:prstGeom>
+          <a:noFill/>
+          <a:ln>
+            <a:noFill/>
+          </a:ln>
+        </p:spPr>
+        <p:txBody>
+          <a:bodyPr wrap="none" lIns="0" tIns="0" rIns="0" bIns="0" anchor="t" anchorCtr="0">
+            <a:spAutoFit/>
+          </a:bodyPr>
+          <a:lstStyle/>
+          <a:p>
+            <a:pPr algn="l"/>
+            <a:r>
+              <a:rPr lang="en-US" sz="1120" dirty="0">
+                <a:solidFill>
+                  <a:srgbClr val="DDEBFF"/>
+                </a:solidFill>
+                <a:latin typeface="Consolas"/>
+                <a:ea typeface="Consolas"/>
+                <a:cs typeface="Consolas"/>
+              </a:rPr>
+              <a:t>while (!pq.empty()) {</a:t>
+            </a:r>
+          </a:p>
+        </p:txBody>
+      </p:sp>
+      <p:sp>
+        <p:nvSpPr>
+          <p:cNvPr id="32" name="TextBox 32"/>
+          <p:cNvSpPr txBox="1"/>
+          <p:nvPr/>
+        </p:nvSpPr>
+        <p:spPr>
+          <a:xfrm>
+            <a:off x="756285" y="4907756"/>
+            <a:ext cx="2654189" cy="220028"/>
+          </a:xfrm>
+          <a:prstGeom prst="rect">
+            <a:avLst/>
+          </a:prstGeom>
+          <a:noFill/>
+          <a:ln>
+            <a:noFill/>
+          </a:ln>
+        </p:spPr>
+        <p:txBody>
+          <a:bodyPr wrap="none" lIns="0" tIns="0" rIns="0" bIns="0" anchor="t" anchorCtr="0">
+            <a:spAutoFit/>
+          </a:bodyPr>
+          <a:lstStyle/>
+          <a:p>
+            <a:pPr algn="l"/>
+            <a:r>
+              <a:rPr lang="en-US" sz="1120" dirty="0">
+                <a:solidFill>
+                  <a:srgbClr val="DDEBFF"/>
+                </a:solidFill>
+                <a:latin typeface="Consolas"/>
+                <a:ea typeface="Consolas"/>
+                <a:cs typeface="Consolas"/>
+              </a:rPr>
+              <a:t>auto [u, du] = pq.top(); pq.pop();</a:t>
+            </a:r>
+          </a:p>
+        </p:txBody>
+      </p:sp>
+      <p:sp>
+        <p:nvSpPr>
+          <p:cNvPr id="33" name="TextBox 33"/>
+          <p:cNvSpPr txBox="1"/>
+          <p:nvPr/>
+        </p:nvSpPr>
+        <p:spPr>
+          <a:xfrm>
+            <a:off x="756285" y="5117306"/>
+            <a:ext cx="1866662" cy="220028"/>
+          </a:xfrm>
+          <a:prstGeom prst="rect">
+            <a:avLst/>
+          </a:prstGeom>
+          <a:noFill/>
+          <a:ln>
+            <a:noFill/>
+          </a:ln>
+        </p:spPr>
+        <p:txBody>
+          <a:bodyPr wrap="none" lIns="0" tIns="0" rIns="0" bIns="0" anchor="t" anchorCtr="0">
+            <a:spAutoFit/>
+          </a:bodyPr>
+          <a:lstStyle/>
+          <a:p>
+            <a:pPr algn="l"/>
+            <a:r>
+              <a:rPr lang="en-US" sz="1120" dirty="0">
+                <a:solidFill>
+                  <a:srgbClr val="DDEBFF"/>
+                </a:solidFill>
+                <a:latin typeface="Consolas"/>
+                <a:ea typeface="Consolas"/>
+                <a:cs typeface="Consolas"/>
+              </a:rPr>
+              <a:t>if (visited[u]) continue;</a:t>
+            </a:r>
+          </a:p>
+        </p:txBody>
+      </p:sp>
+      <p:sp>
+        <p:nvSpPr>
+          <p:cNvPr id="34" name="TextBox 34"/>
+          <p:cNvSpPr txBox="1"/>
+          <p:nvPr/>
+        </p:nvSpPr>
+        <p:spPr>
+          <a:xfrm>
+            <a:off x="756285" y="5326856"/>
+            <a:ext cx="1359313" cy="220028"/>
+          </a:xfrm>
+          <a:prstGeom prst="rect">
+            <a:avLst/>
+          </a:prstGeom>
+          <a:noFill/>
+          <a:ln>
+            <a:noFill/>
+          </a:ln>
+        </p:spPr>
+        <p:txBody>
+          <a:bodyPr wrap="none" lIns="0" tIns="0" rIns="0" bIns="0" anchor="t" anchorCtr="0">
+            <a:spAutoFit/>
+          </a:bodyPr>
+          <a:lstStyle/>
+          <a:p>
+            <a:pPr algn="l"/>
+            <a:r>
+              <a:rPr lang="en-US" sz="1120" dirty="0">
+                <a:solidFill>
+                  <a:srgbClr val="DDEBFF"/>
+                </a:solidFill>
+                <a:latin typeface="Consolas"/>
+                <a:ea typeface="Consolas"/>
+                <a:cs typeface="Consolas"/>
+              </a:rPr>
+              <a:t>visited[u] = true;</a:t>
+            </a:r>
+          </a:p>
+        </p:txBody>
+      </p:sp>
+      <p:sp>
+        <p:nvSpPr>
+          <p:cNvPr id="35" name="TextBox 35"/>
+          <p:cNvSpPr txBox="1"/>
+          <p:nvPr/>
+        </p:nvSpPr>
+        <p:spPr>
+          <a:xfrm>
+            <a:off x="756285" y="5536406"/>
+            <a:ext cx="2646616" cy="220028"/>
+          </a:xfrm>
+          <a:prstGeom prst="rect">
+            <a:avLst/>
+          </a:prstGeom>
+          <a:noFill/>
+          <a:ln>
+            <a:noFill/>
+          </a:ln>
+        </p:spPr>
+        <p:txBody>
+          <a:bodyPr wrap="none" lIns="0" tIns="0" rIns="0" bIns="0" anchor="t" anchorCtr="0">
+            <a:spAutoFit/>
+          </a:bodyPr>
+          <a:lstStyle/>
+          <a:p>
+            <a:pPr algn="l"/>
+            <a:r>
+              <a:rPr lang="en-US" sz="1120" dirty="0">
+                <a:solidFill>
+                  <a:srgbClr val="DDEBFF"/>
+                </a:solidFill>
+                <a:latin typeface="Consolas"/>
+                <a:ea typeface="Consolas"/>
+                <a:cs typeface="Consolas"/>
+              </a:rPr>
+              <a:t>for (edge : g.neighbors(u, mgr)) {</a:t>
+            </a:r>
+          </a:p>
+        </p:txBody>
+      </p:sp>
+      <p:sp>
+        <p:nvSpPr>
+          <p:cNvPr id="36" name="TextBox 36"/>
+          <p:cNvSpPr txBox="1"/>
+          <p:nvPr/>
+        </p:nvSpPr>
+        <p:spPr>
+          <a:xfrm>
+            <a:off x="756285" y="5745956"/>
+            <a:ext cx="2759095" cy="220028"/>
+          </a:xfrm>
+          <a:prstGeom prst="rect">
+            <a:avLst/>
+          </a:prstGeom>
+          <a:noFill/>
+          <a:ln>
+            <a:noFill/>
+          </a:ln>
+        </p:spPr>
+        <p:txBody>
+          <a:bodyPr wrap="none" lIns="0" tIns="0" rIns="0" bIns="0" anchor="t" anchorCtr="0">
+            <a:spAutoFit/>
+          </a:bodyPr>
+          <a:lstStyle/>
+          <a:p>
+            <a:pPr algn="l"/>
+            <a:r>
+              <a:rPr lang="en-US" sz="1120" dirty="0">
+                <a:solidFill>
+                  <a:srgbClr val="DDEBFF"/>
+                </a:solidFill>
+                <a:latin typeface="Consolas"/>
+                <a:ea typeface="Consolas"/>
+                <a:cs typeface="Consolas"/>
+              </a:rPr>
+              <a:t>Weight nw = du + edge_weight(edge);</a:t>
+            </a:r>
+          </a:p>
+        </p:txBody>
+      </p:sp>
+      <p:sp>
+        <p:nvSpPr>
+          <p:cNvPr id="37" name="Rectangle 37"/>
+          <p:cNvSpPr/>
+          <p:nvPr/>
+        </p:nvSpPr>
+        <p:spPr>
+          <a:xfrm>
+            <a:off x="6667500" y="3714750"/>
+            <a:ext cx="5334000" cy="2381250"/>
+          </a:xfrm>
+          <a:prstGeom prst="roundRect">
+            <a:avLst>
+              <a:gd name="adj" fmla="val 4000"/>
+            </a:avLst>
+          </a:prstGeom>
+          <a:solidFill>
+            <a:srgbClr val="132846"/>
+          </a:solidFill>
+          <a:ln w="19050">
+            <a:solidFill>
+              <a:srgbClr val="1E3A5F"/>
+            </a:solidFill>
+          </a:ln>
+        </p:spPr>
+      </p:sp>
+      <p:sp>
+        <p:nvSpPr>
+          <p:cNvPr id="38" name="TextBox 38"/>
+          <p:cNvSpPr txBox="1"/>
+          <p:nvPr/>
+        </p:nvSpPr>
+        <p:spPr>
+          <a:xfrm>
+            <a:off x="6849618" y="3822382"/>
+            <a:ext cx="3888368" cy="322707"/>
+          </a:xfrm>
+          <a:prstGeom prst="rect">
+            <a:avLst/>
+          </a:prstGeom>
+          <a:noFill/>
+          <a:ln>
+            <a:noFill/>
+          </a:ln>
+        </p:spPr>
+        <p:txBody>
+          <a:bodyPr wrap="none" lIns="0" tIns="0" rIns="0" bIns="0" anchor="t" anchorCtr="0">
+            <a:spAutoFit/>
+          </a:bodyPr>
+          <a:lstStyle/>
+          <a:p>
+            <a:pPr algn="l"/>
+            <a:r>
+              <a:rPr lang="zh-CN" sz="1650" b="1" dirty="0">
+                <a:solidFill>
+                  <a:srgbClr val="FFD54F"/>
+                </a:solidFill>
+                <a:latin typeface="Arial"/>
+                <a:ea typeface="Microsoft YaHei"/>
+                <a:cs typeface="Arial"/>
+              </a:rPr>
+              <a:t>换乘计数三规则（v1.0.0 核心修复）</a:t>
+            </a:r>
+          </a:p>
+        </p:txBody>
+      </p:sp>
+      <p:sp>
+        <p:nvSpPr>
+          <p:cNvPr id="39" name="TextBox 39"/>
+          <p:cNvSpPr txBox="1"/>
+          <p:nvPr/>
+        </p:nvSpPr>
+        <p:spPr>
+          <a:xfrm>
+            <a:off x="6851904" y="4232910"/>
+            <a:ext cx="4236568" cy="234696"/>
+          </a:xfrm>
+          <a:prstGeom prst="rect">
+            <a:avLst/>
+          </a:prstGeom>
+          <a:noFill/>
+          <a:ln>
+            <a:noFill/>
+          </a:ln>
+        </p:spPr>
+        <p:txBody>
+          <a:bodyPr wrap="none" lIns="0" tIns="0" rIns="0" bIns="0" anchor="t" anchorCtr="0">
+            <a:spAutoFit/>
+          </a:bodyPr>
+          <a:lstStyle/>
+          <a:p>
+            <a:pPr algn="l"/>
+            <a:r>
+              <a:rPr lang="zh-CN" sz="1200" dirty="0">
+                <a:solidFill>
+                  <a:srgbClr val="DDEBFF"/>
+                </a:solidFill>
+                <a:latin typeface="Arial"/>
+                <a:ea typeface="Microsoft YaHei"/>
+                <a:cs typeface="Arial"/>
+              </a:rPr>
+              <a:t>① 起点上第一条线不算换乘（line_trace 不预置起点线路）</a:t>
+            </a:r>
+          </a:p>
+        </p:txBody>
+      </p:sp>
+      <p:sp>
+        <p:nvSpPr>
+          <p:cNvPr id="40" name="TextBox 40"/>
+          <p:cNvSpPr txBox="1"/>
+          <p:nvPr/>
+        </p:nvSpPr>
+        <p:spPr>
+          <a:xfrm>
+            <a:off x="6851904" y="4499610"/>
+            <a:ext cx="3844138" cy="234696"/>
+          </a:xfrm>
+          <a:prstGeom prst="rect">
+            <a:avLst/>
+          </a:prstGeom>
+          <a:noFill/>
+          <a:ln>
+            <a:noFill/>
+          </a:ln>
+        </p:spPr>
+        <p:txBody>
+          <a:bodyPr wrap="none" lIns="0" tIns="0" rIns="0" bIns="0" anchor="t" anchorCtr="0">
+            <a:spAutoFit/>
+          </a:bodyPr>
+          <a:lstStyle/>
+          <a:p>
+            <a:pPr algn="l"/>
+            <a:r>
+              <a:rPr lang="zh-CN" sz="1200" dirty="0">
+                <a:solidFill>
+                  <a:srgbClr val="DDEBFF"/>
+                </a:solidFill>
+                <a:latin typeface="Arial"/>
+                <a:ea typeface="Microsoft YaHei"/>
+                <a:cs typeface="Arial"/>
+              </a:rPr>
+              <a:t>② 沿途换乘计一次（新线路 ID 不等于当前线路 ID）</a:t>
+            </a:r>
+          </a:p>
+        </p:txBody>
+      </p:sp>
+      <p:sp>
+        <p:nvSpPr>
+          <p:cNvPr id="41" name="TextBox 41"/>
+          <p:cNvSpPr txBox="1"/>
+          <p:nvPr/>
+        </p:nvSpPr>
+        <p:spPr>
+          <a:xfrm>
+            <a:off x="6851904" y="4766310"/>
+            <a:ext cx="4147718" cy="234696"/>
+          </a:xfrm>
+          <a:prstGeom prst="rect">
+            <a:avLst/>
+          </a:prstGeom>
+          <a:noFill/>
+          <a:ln>
+            <a:noFill/>
+          </a:ln>
+        </p:spPr>
+        <p:txBody>
+          <a:bodyPr wrap="none" lIns="0" tIns="0" rIns="0" bIns="0" anchor="t" anchorCtr="0">
+            <a:spAutoFit/>
+          </a:bodyPr>
+          <a:lstStyle/>
+          <a:p>
+            <a:pPr algn="l"/>
+            <a:r>
+              <a:rPr lang="zh-CN" sz="1200" dirty="0">
+                <a:solidFill>
+                  <a:srgbClr val="DDEBFF"/>
+                </a:solidFill>
+                <a:latin typeface="Arial"/>
+                <a:ea typeface="Microsoft YaHei"/>
+                <a:cs typeface="Arial"/>
+              </a:rPr>
+              <a:t>③ 终点前最后一段换乘边不算换乘（i+1==size 特殊处理）</a:t>
+            </a:r>
+          </a:p>
+        </p:txBody>
+      </p:sp>
+      <p:sp>
+        <p:nvSpPr>
+          <p:cNvPr id="42" name="Line 42"/>
+          <p:cNvSpPr/>
+          <p:nvPr/>
+        </p:nvSpPr>
+        <p:spPr>
+          <a:xfrm>
+            <a:off x="6858000" y="5143500"/>
+            <a:ext cx="4953000" cy="9525"/>
+          </a:xfrm>
+          <a:custGeom>
+            <a:avLst/>
+            <a:gdLst/>
+            <a:ahLst/>
+            <a:cxnLst/>
+            <a:rect l="l" t="t" r="r" b="b"/>
+            <a:pathLst>
+              <a:path w="4953000" h="9525">
+                <a:moveTo>
+                  <a:pt x="0" y="0"/>
+                </a:moveTo>
+                <a:lnTo>
+                  <a:pt x="4953000" y="0"/>
+                </a:lnTo>
+              </a:path>
+            </a:pathLst>
+          </a:custGeom>
+          <a:noFill/>
+          <a:ln w="9525" cap="rnd">
+            <a:solidFill>
+              <a:srgbClr val="1E3A5F"/>
+            </a:solidFill>
+          </a:ln>
+        </p:spPr>
+      </p:sp>
+      <p:sp>
+        <p:nvSpPr>
+          <p:cNvPr id="43" name="TextBox 43"/>
+          <p:cNvSpPr txBox="1"/>
+          <p:nvPr/>
+        </p:nvSpPr>
+        <p:spPr>
+          <a:xfrm>
+            <a:off x="6849618" y="5232082"/>
+            <a:ext cx="483222" cy="322707"/>
+          </a:xfrm>
+          <a:prstGeom prst="rect">
+            <a:avLst/>
+          </a:prstGeom>
+          <a:noFill/>
+          <a:ln>
+            <a:noFill/>
+          </a:ln>
+        </p:spPr>
+        <p:txBody>
+          <a:bodyPr wrap="none" lIns="0" tIns="0" rIns="0" bIns="0" anchor="t" anchorCtr="0">
+            <a:spAutoFit/>
+          </a:bodyPr>
+          <a:lstStyle/>
+          <a:p>
+            <a:pPr algn="l"/>
+            <a:r>
+              <a:rPr lang="zh-CN" sz="1650" b="1" dirty="0">
+                <a:solidFill>
+                  <a:srgbClr val="FFD54F"/>
+                </a:solidFill>
+                <a:latin typeface="Arial"/>
+                <a:ea typeface="Microsoft YaHei"/>
+                <a:cs typeface="Arial"/>
+              </a:rPr>
+              <a:t>示例</a:t>
+            </a:r>
+          </a:p>
+        </p:txBody>
+      </p:sp>
+      <p:sp>
+        <p:nvSpPr>
+          <p:cNvPr id="44" name="TextBox 44"/>
+          <p:cNvSpPr txBox="1"/>
+          <p:nvPr/>
+        </p:nvSpPr>
+        <p:spPr>
+          <a:xfrm>
+            <a:off x="6852285" y="5555456"/>
+            <a:ext cx="2669334" cy="220028"/>
+          </a:xfrm>
+          <a:prstGeom prst="rect">
+            <a:avLst/>
+          </a:prstGeom>
+          <a:noFill/>
+          <a:ln>
+            <a:noFill/>
+          </a:ln>
+        </p:spPr>
+        <p:txBody>
+          <a:bodyPr wrap="none" lIns="0" tIns="0" rIns="0" bIns="0" anchor="t" anchorCtr="0">
+            <a:spAutoFit/>
+          </a:bodyPr>
+          <a:lstStyle/>
+          <a:p>
+            <a:pPr algn="l"/>
+            <a:r>
+              <a:rPr lang="zh-CN" sz="1120" dirty="0">
+                <a:solidFill>
+                  <a:srgbClr val="B7C7DE"/>
+                </a:solidFill>
+                <a:latin typeface="Arial"/>
+                <a:ea typeface="Microsoft YaHei"/>
+                <a:cs typeface="Arial"/>
+              </a:rPr>
+              <a:t>莘庄→陆家嘴 1 换乘（1 号线 → 2 号线）</a:t>
+            </a:r>
+          </a:p>
+        </p:txBody>
+      </p:sp>
+      <p:sp>
+        <p:nvSpPr>
+          <p:cNvPr id="45" name="TextBox 45"/>
+          <p:cNvSpPr txBox="1"/>
+          <p:nvPr/>
+        </p:nvSpPr>
+        <p:spPr>
+          <a:xfrm>
+            <a:off x="6852285" y="5784056"/>
+            <a:ext cx="2866215" cy="220028"/>
+          </a:xfrm>
+          <a:prstGeom prst="rect">
+            <a:avLst/>
+          </a:prstGeom>
+          <a:noFill/>
+          <a:ln>
+            <a:noFill/>
+          </a:ln>
+        </p:spPr>
+        <p:txBody>
+          <a:bodyPr wrap="none" lIns="0" tIns="0" rIns="0" bIns="0" anchor="t" anchorCtr="0">
+            <a:spAutoFit/>
+          </a:bodyPr>
+          <a:lstStyle/>
+          <a:p>
+            <a:pPr algn="l"/>
+            <a:r>
+              <a:rPr lang="zh-CN" sz="1120" dirty="0">
+                <a:solidFill>
+                  <a:srgbClr val="B7C7DE"/>
+                </a:solidFill>
+                <a:latin typeface="Arial"/>
+                <a:ea typeface="Microsoft YaHei"/>
+                <a:cs typeface="Arial"/>
+              </a:rPr>
+              <a:t>人民广场→陆家嘴 0 换乘（直接乘 2 号线）</a:t>
             </a:r>
           </a:p>
         </p:txBody>

</xml_diff>

<commit_message>
feat(ppt-v2.0.0): operations + network-analysis slides (Task 3)
Co-Authored-By: Claude Fable 5 <noreply@anthropic.com>
</commit_message>
<xml_diff>
--- a/docs/ppt-v2.0.0/答辩PPT-v2.0.0.pptx
+++ b/docs/ppt-v2.0.0/答辩PPT-v2.0.0.pptx
@@ -9,6 +9,8 @@
     <p:sldId id="257" r:id="rId8"/>
     <p:sldId id="258" r:id="rId9"/>
     <p:sldId id="259" r:id="rId10"/>
+    <p:sldId id="260" r:id="rId11"/>
+    <p:sldId id="261" r:id="rId12"/>
   </p:sldIdLst>
   <p:sldSz cx="12192000" cy="6858000" type="screen4x3"/>
   <p:notesSz cx="6858000" cy="9144000"/>
@@ -8670,6 +8672,3291 @@
                 <a:cs typeface="Arial"/>
               </a:rPr>
               <a:t>人民广场→陆家嘴 0 换乘（直接乘 2 号线）</a:t>
+            </a:r>
+          </a:p>
+        </p:txBody>
+      </p:sp>
+    </p:spTree>
+  </p:cSld>
+  <p:clrMapOvr>
+    <a:masterClrMapping/>
+  </p:clrMapOvr>
+  <p:transition xmlns:p14="http://schemas.microsoft.com/office/powerpoint/2010/main" p14:dur="400">
+    <p:fade/>
+  </p:transition>
+</p:sld>
+</file>
+
+<file path=ppt/slides/slide5.xml><?xml version="1.0" encoding="utf-8"?>
+<p:sld xmlns:a="http://schemas.openxmlformats.org/drawingml/2006/main" xmlns:r="http://schemas.openxmlformats.org/officeDocument/2006/relationships" xmlns:p="http://schemas.openxmlformats.org/presentationml/2006/main">
+  <p:cSld>
+    <p:spTree>
+      <p:nvGrpSpPr>
+        <p:cNvPr id="1" name=""/>
+        <p:cNvGrpSpPr/>
+        <p:nvPr/>
+      </p:nvGrpSpPr>
+      <p:grpSpPr>
+        <a:xfrm>
+          <a:off x="0" y="0"/>
+          <a:ext cx="0" cy="0"/>
+          <a:chOff x="0" y="0"/>
+          <a:chExt cx="0" cy="0"/>
+        </a:xfrm>
+      </p:grpSpPr>
+      <p:sp>
+        <p:nvSpPr>
+          <p:cNvPr id="2" name="Rectangle 2"/>
+          <p:cNvSpPr/>
+          <p:nvPr/>
+        </p:nvSpPr>
+        <p:spPr>
+          <a:xfrm>
+            <a:off x="0" y="0"/>
+            <a:ext cx="12192000" cy="6858000"/>
+          </a:xfrm>
+          <a:prstGeom prst="rect">
+            <a:avLst/>
+          </a:prstGeom>
+          <a:solidFill>
+            <a:srgbClr val="0B1F3A"/>
+          </a:solidFill>
+          <a:ln>
+            <a:noFill/>
+          </a:ln>
+        </p:spPr>
+      </p:sp>
+      <p:sp>
+        <p:nvSpPr>
+          <p:cNvPr id="3" name="TextBox 3"/>
+          <p:cNvSpPr txBox="1"/>
+          <p:nvPr/>
+        </p:nvSpPr>
+        <p:spPr>
+          <a:xfrm>
+            <a:off x="745236" y="501015"/>
+            <a:ext cx="3631418" cy="645414"/>
+          </a:xfrm>
+          <a:prstGeom prst="rect">
+            <a:avLst/>
+          </a:prstGeom>
+          <a:noFill/>
+          <a:ln>
+            <a:noFill/>
+          </a:ln>
+        </p:spPr>
+        <p:txBody>
+          <a:bodyPr wrap="none" lIns="0" tIns="0" rIns="0" bIns="0" anchor="t" anchorCtr="0">
+            <a:spAutoFit/>
+          </a:bodyPr>
+          <a:lstStyle/>
+          <a:p>
+            <a:pPr algn="l"/>
+            <a:r>
+              <a:rPr lang="zh-CN" sz="3300" b="1" dirty="0">
+                <a:solidFill>
+                  <a:srgbClr val="FFFFFF"/>
+                </a:solidFill>
+                <a:latin typeface="Arial"/>
+                <a:ea typeface="Microsoft YaHei"/>
+                <a:cs typeface="Arial"/>
+              </a:rPr>
+              <a:t>运营管理（M2）</a:t>
+            </a:r>
+          </a:p>
+        </p:txBody>
+      </p:sp>
+      <p:sp>
+        <p:nvSpPr>
+          <p:cNvPr id="4" name="Line 4"/>
+          <p:cNvSpPr/>
+          <p:nvPr/>
+        </p:nvSpPr>
+        <p:spPr>
+          <a:xfrm>
+            <a:off x="762000" y="1047750"/>
+            <a:ext cx="10668000" cy="9525"/>
+          </a:xfrm>
+          <a:custGeom>
+            <a:avLst/>
+            <a:gdLst/>
+            <a:ahLst/>
+            <a:cxnLst/>
+            <a:rect l="l" t="t" r="r" b="b"/>
+            <a:pathLst>
+              <a:path w="10668000" h="9525">
+                <a:moveTo>
+                  <a:pt x="0" y="0"/>
+                </a:moveTo>
+                <a:lnTo>
+                  <a:pt x="10668000" y="0"/>
+                </a:lnTo>
+              </a:path>
+            </a:pathLst>
+          </a:custGeom>
+          <a:noFill/>
+          <a:ln w="28575" cap="rnd">
+            <a:solidFill>
+              <a:srgbClr val="E4002B"/>
+            </a:solidFill>
+          </a:ln>
+        </p:spPr>
+      </p:sp>
+      <p:sp>
+        <p:nvSpPr>
+          <p:cNvPr id="5" name="TextBox 5"/>
+          <p:cNvSpPr txBox="1"/>
+          <p:nvPr/>
+        </p:nvSpPr>
+        <p:spPr>
+          <a:xfrm>
+            <a:off x="755142" y="1187768"/>
+            <a:ext cx="2140039" cy="264033"/>
+          </a:xfrm>
+          <a:prstGeom prst="rect">
+            <a:avLst/>
+          </a:prstGeom>
+          <a:noFill/>
+          <a:ln>
+            <a:noFill/>
+          </a:ln>
+        </p:spPr>
+        <p:txBody>
+          <a:bodyPr wrap="none" lIns="0" tIns="0" rIns="0" bIns="0" anchor="t" anchorCtr="0">
+            <a:spAutoFit/>
+          </a:bodyPr>
+          <a:lstStyle/>
+          <a:p>
+            <a:pPr algn="l"/>
+            <a:r>
+              <a:rPr lang="zh-CN" sz="1350" dirty="0">
+                <a:solidFill>
+                  <a:srgbClr val="FFD54F"/>
+                </a:solidFill>
+                <a:latin typeface="Arial"/>
+                <a:ea typeface="Microsoft YaHei"/>
+                <a:cs typeface="Arial"/>
+              </a:rPr>
+              <a:t>对应课设：运营管理 15 分</a:t>
+            </a:r>
+          </a:p>
+        </p:txBody>
+      </p:sp>
+      <p:sp>
+        <p:nvSpPr>
+          <p:cNvPr id="6" name="Rectangle 6"/>
+          <p:cNvSpPr/>
+          <p:nvPr/>
+        </p:nvSpPr>
+        <p:spPr>
+          <a:xfrm>
+            <a:off x="571500" y="1666875"/>
+            <a:ext cx="3619500" cy="1952625"/>
+          </a:xfrm>
+          <a:prstGeom prst="roundRect">
+            <a:avLst>
+              <a:gd name="adj" fmla="val 4878"/>
+            </a:avLst>
+          </a:prstGeom>
+          <a:solidFill>
+            <a:srgbClr val="132846"/>
+          </a:solidFill>
+          <a:ln w="19050">
+            <a:solidFill>
+              <a:srgbClr val="1E3A5F"/>
+            </a:solidFill>
+          </a:ln>
+        </p:spPr>
+      </p:sp>
+      <p:sp>
+        <p:nvSpPr>
+          <p:cNvPr id="7" name="TextBox 7"/>
+          <p:cNvSpPr txBox="1"/>
+          <p:nvPr/>
+        </p:nvSpPr>
+        <p:spPr>
+          <a:xfrm>
+            <a:off x="752856" y="1853565"/>
+            <a:ext cx="1901083" cy="352044"/>
+          </a:xfrm>
+          <a:prstGeom prst="rect">
+            <a:avLst/>
+          </a:prstGeom>
+          <a:noFill/>
+          <a:ln>
+            <a:noFill/>
+          </a:ln>
+        </p:spPr>
+        <p:txBody>
+          <a:bodyPr wrap="none" lIns="0" tIns="0" rIns="0" bIns="0" anchor="t" anchorCtr="0">
+            <a:spAutoFit/>
+          </a:bodyPr>
+          <a:lstStyle/>
+          <a:p>
+            <a:pPr algn="l"/>
+            <a:r>
+              <a:rPr lang="zh-CN" sz="1800" b="1" dirty="0">
+                <a:solidFill>
+                  <a:srgbClr val="FFD54F"/>
+                </a:solidFill>
+                <a:latin typeface="Arial"/>
+                <a:ea typeface="Microsoft YaHei"/>
+                <a:cs typeface="Arial"/>
+              </a:rPr>
+              <a:t>🔒 单站关闭/开启</a:t>
+            </a:r>
+          </a:p>
+        </p:txBody>
+      </p:sp>
+      <p:sp>
+        <p:nvSpPr>
+          <p:cNvPr id="8" name="TextBox 8"/>
+          <p:cNvSpPr txBox="1"/>
+          <p:nvPr/>
+        </p:nvSpPr>
+        <p:spPr>
+          <a:xfrm>
+            <a:off x="756285" y="2355056"/>
+            <a:ext cx="2291221" cy="220028"/>
+          </a:xfrm>
+          <a:prstGeom prst="rect">
+            <a:avLst/>
+          </a:prstGeom>
+          <a:noFill/>
+          <a:ln>
+            <a:noFill/>
+          </a:ln>
+        </p:spPr>
+        <p:txBody>
+          <a:bodyPr wrap="none" lIns="0" tIns="0" rIns="0" bIns="0" anchor="t" anchorCtr="0">
+            <a:spAutoFit/>
+          </a:bodyPr>
+          <a:lstStyle/>
+          <a:p>
+            <a:pPr algn="l"/>
+            <a:r>
+              <a:rPr lang="en-US" sz="1120" dirty="0">
+                <a:solidFill>
+                  <a:srgbClr val="DDEBFF"/>
+                </a:solidFill>
+                <a:latin typeface="Consolas"/>
+                <a:ea typeface="Consolas"/>
+                <a:cs typeface="Consolas"/>
+              </a:rPr>
+              <a:t>POST /api/stations/&lt;id&gt;/close</a:t>
+            </a:r>
+          </a:p>
+        </p:txBody>
+      </p:sp>
+      <p:sp>
+        <p:nvSpPr>
+          <p:cNvPr id="9" name="TextBox 9"/>
+          <p:cNvSpPr txBox="1"/>
+          <p:nvPr/>
+        </p:nvSpPr>
+        <p:spPr>
+          <a:xfrm>
+            <a:off x="756285" y="2659856"/>
+            <a:ext cx="2246403" cy="220028"/>
+          </a:xfrm>
+          <a:prstGeom prst="rect">
+            <a:avLst/>
+          </a:prstGeom>
+          <a:noFill/>
+          <a:ln>
+            <a:noFill/>
+          </a:ln>
+        </p:spPr>
+        <p:txBody>
+          <a:bodyPr wrap="none" lIns="0" tIns="0" rIns="0" bIns="0" anchor="t" anchorCtr="0">
+            <a:spAutoFit/>
+          </a:bodyPr>
+          <a:lstStyle/>
+          <a:p>
+            <a:pPr algn="l"/>
+            <a:r>
+              <a:rPr lang="en-US" sz="1120" dirty="0">
+                <a:solidFill>
+                  <a:srgbClr val="DDEBFF"/>
+                </a:solidFill>
+                <a:latin typeface="Consolas"/>
+                <a:ea typeface="Consolas"/>
+                <a:cs typeface="Consolas"/>
+              </a:rPr>
+              <a:t>POST /api/stations/&lt;id&gt;/open</a:t>
+            </a:r>
+          </a:p>
+        </p:txBody>
+      </p:sp>
+      <p:sp>
+        <p:nvSpPr>
+          <p:cNvPr id="10" name="TextBox 10"/>
+          <p:cNvSpPr txBox="1"/>
+          <p:nvPr/>
+        </p:nvSpPr>
+        <p:spPr>
+          <a:xfrm>
+            <a:off x="755904" y="2956560"/>
+            <a:ext cx="2552799" cy="234696"/>
+          </a:xfrm>
+          <a:prstGeom prst="rect">
+            <a:avLst/>
+          </a:prstGeom>
+          <a:noFill/>
+          <a:ln>
+            <a:noFill/>
+          </a:ln>
+        </p:spPr>
+        <p:txBody>
+          <a:bodyPr wrap="none" lIns="0" tIns="0" rIns="0" bIns="0" anchor="t" anchorCtr="0">
+            <a:spAutoFit/>
+          </a:bodyPr>
+          <a:lstStyle/>
+          <a:p>
+            <a:pPr algn="l"/>
+            <a:r>
+              <a:rPr lang="en-US" sz="1200" dirty="0">
+                <a:solidFill>
+                  <a:srgbClr val="B7C7DE"/>
+                </a:solidFill>
+                <a:latin typeface="Arial"/>
+                <a:ea typeface="Arial"/>
+                <a:cs typeface="Arial"/>
+              </a:rPr>
+              <a:t>→ StationManager.set_status()</a:t>
+            </a:r>
+          </a:p>
+        </p:txBody>
+      </p:sp>
+      <p:sp>
+        <p:nvSpPr>
+          <p:cNvPr id="11" name="TextBox 11"/>
+          <p:cNvSpPr txBox="1"/>
+          <p:nvPr/>
+        </p:nvSpPr>
+        <p:spPr>
+          <a:xfrm>
+            <a:off x="755904" y="3261360"/>
+            <a:ext cx="1595323" cy="234696"/>
+          </a:xfrm>
+          <a:prstGeom prst="rect">
+            <a:avLst/>
+          </a:prstGeom>
+          <a:noFill/>
+          <a:ln>
+            <a:noFill/>
+          </a:ln>
+        </p:spPr>
+        <p:txBody>
+          <a:bodyPr wrap="none" lIns="0" tIns="0" rIns="0" bIns="0" anchor="t" anchorCtr="0">
+            <a:spAutoFit/>
+          </a:bodyPr>
+          <a:lstStyle/>
+          <a:p>
+            <a:pPr algn="l"/>
+            <a:r>
+              <a:rPr lang="zh-CN" sz="1200" dirty="0">
+                <a:solidFill>
+                  <a:srgbClr val="B7C7DE"/>
+                </a:solidFill>
+                <a:latin typeface="Arial"/>
+                <a:ea typeface="Microsoft YaHei"/>
+                <a:cs typeface="Arial"/>
+              </a:rPr>
+              <a:t>锁: unique_lock (写)</a:t>
+            </a:r>
+          </a:p>
+        </p:txBody>
+      </p:sp>
+      <p:sp>
+        <p:nvSpPr>
+          <p:cNvPr id="12" name="Rectangle 12"/>
+          <p:cNvSpPr/>
+          <p:nvPr/>
+        </p:nvSpPr>
+        <p:spPr>
+          <a:xfrm>
+            <a:off x="4381500" y="1666875"/>
+            <a:ext cx="3619500" cy="1952625"/>
+          </a:xfrm>
+          <a:prstGeom prst="roundRect">
+            <a:avLst>
+              <a:gd name="adj" fmla="val 4878"/>
+            </a:avLst>
+          </a:prstGeom>
+          <a:solidFill>
+            <a:srgbClr val="132846"/>
+          </a:solidFill>
+          <a:ln w="19050">
+            <a:solidFill>
+              <a:srgbClr val="1E3A5F"/>
+            </a:solidFill>
+          </a:ln>
+        </p:spPr>
+      </p:sp>
+      <p:sp>
+        <p:nvSpPr>
+          <p:cNvPr id="13" name="TextBox 13"/>
+          <p:cNvSpPr txBox="1"/>
+          <p:nvPr/>
+        </p:nvSpPr>
+        <p:spPr>
+          <a:xfrm>
+            <a:off x="4562856" y="1853565"/>
+            <a:ext cx="1927007" cy="352044"/>
+          </a:xfrm>
+          <a:prstGeom prst="rect">
+            <a:avLst/>
+          </a:prstGeom>
+          <a:noFill/>
+          <a:ln>
+            <a:noFill/>
+          </a:ln>
+        </p:spPr>
+        <p:txBody>
+          <a:bodyPr wrap="none" lIns="0" tIns="0" rIns="0" bIns="0" anchor="t" anchorCtr="0">
+            <a:spAutoFit/>
+          </a:bodyPr>
+          <a:lstStyle/>
+          <a:p>
+            <a:pPr algn="l"/>
+            <a:r>
+              <a:rPr lang="zh-CN" sz="1800" b="1" dirty="0">
+                <a:solidFill>
+                  <a:srgbClr val="FFD54F"/>
+                </a:solidFill>
+                <a:latin typeface="Arial"/>
+                <a:ea typeface="Microsoft YaHei"/>
+                <a:cs typeface="Arial"/>
+              </a:rPr>
+              <a:t>📦 批量 CSV 更新</a:t>
+            </a:r>
+          </a:p>
+        </p:txBody>
+      </p:sp>
+      <p:sp>
+        <p:nvSpPr>
+          <p:cNvPr id="14" name="TextBox 14"/>
+          <p:cNvSpPr txBox="1"/>
+          <p:nvPr/>
+        </p:nvSpPr>
+        <p:spPr>
+          <a:xfrm>
+            <a:off x="4566285" y="2355056"/>
+            <a:ext cx="2532075" cy="220028"/>
+          </a:xfrm>
+          <a:prstGeom prst="rect">
+            <a:avLst/>
+          </a:prstGeom>
+          <a:noFill/>
+          <a:ln>
+            <a:noFill/>
+          </a:ln>
+        </p:spPr>
+        <p:txBody>
+          <a:bodyPr wrap="none" lIns="0" tIns="0" rIns="0" bIns="0" anchor="t" anchorCtr="0">
+            <a:spAutoFit/>
+          </a:bodyPr>
+          <a:lstStyle/>
+          <a:p>
+            <a:pPr algn="l"/>
+            <a:r>
+              <a:rPr lang="en-US" sz="1120" dirty="0">
+                <a:solidFill>
+                  <a:srgbClr val="DDEBFF"/>
+                </a:solidFill>
+                <a:latin typeface="Consolas"/>
+                <a:ea typeface="Consolas"/>
+                <a:cs typeface="Consolas"/>
+              </a:rPr>
+              <a:t>POST /api/stations/batch-update</a:t>
+            </a:r>
+          </a:p>
+        </p:txBody>
+      </p:sp>
+      <p:sp>
+        <p:nvSpPr>
+          <p:cNvPr id="15" name="TextBox 15"/>
+          <p:cNvSpPr txBox="1"/>
+          <p:nvPr/>
+        </p:nvSpPr>
+        <p:spPr>
+          <a:xfrm>
+            <a:off x="4565904" y="2651760"/>
+            <a:ext cx="2055724" cy="234696"/>
+          </a:xfrm>
+          <a:prstGeom prst="rect">
+            <a:avLst/>
+          </a:prstGeom>
+          <a:noFill/>
+          <a:ln>
+            <a:noFill/>
+          </a:ln>
+        </p:spPr>
+        <p:txBody>
+          <a:bodyPr wrap="none" lIns="0" tIns="0" rIns="0" bIns="0" anchor="t" anchorCtr="0">
+            <a:spAutoFit/>
+          </a:bodyPr>
+          <a:lstStyle/>
+          <a:p>
+            <a:pPr algn="l"/>
+            <a:r>
+              <a:rPr lang="zh-CN" sz="1200" dirty="0">
+                <a:solidFill>
+                  <a:srgbClr val="B7C7DE"/>
+                </a:solidFill>
+                <a:latin typeface="Arial"/>
+                <a:ea typeface="Microsoft YaHei"/>
+                <a:cs typeface="Arial"/>
+              </a:rPr>
+              <a:t>multipart/form-data 上传</a:t>
+            </a:r>
+          </a:p>
+        </p:txBody>
+      </p:sp>
+      <p:sp>
+        <p:nvSpPr>
+          <p:cNvPr id="16" name="TextBox 16"/>
+          <p:cNvSpPr txBox="1"/>
+          <p:nvPr/>
+        </p:nvSpPr>
+        <p:spPr>
+          <a:xfrm>
+            <a:off x="4565904" y="2956560"/>
+            <a:ext cx="2564587" cy="234696"/>
+          </a:xfrm>
+          <a:prstGeom prst="rect">
+            <a:avLst/>
+          </a:prstGeom>
+          <a:noFill/>
+          <a:ln>
+            <a:noFill/>
+          </a:ln>
+        </p:spPr>
+        <p:txBody>
+          <a:bodyPr wrap="none" lIns="0" tIns="0" rIns="0" bIns="0" anchor="t" anchorCtr="0">
+            <a:spAutoFit/>
+          </a:bodyPr>
+          <a:lstStyle/>
+          <a:p>
+            <a:pPr algn="l"/>
+            <a:r>
+              <a:rPr lang="zh-CN" sz="1200" dirty="0">
+                <a:solidFill>
+                  <a:srgbClr val="B7C7DE"/>
+                </a:solidFill>
+                <a:latin typeface="Arial"/>
+                <a:ea typeface="Microsoft YaHei"/>
+                <a:cs typeface="Arial"/>
+              </a:rPr>
+              <a:t>处理 update_station_status.csv</a:t>
+            </a:r>
+          </a:p>
+        </p:txBody>
+      </p:sp>
+      <p:sp>
+        <p:nvSpPr>
+          <p:cNvPr id="17" name="TextBox 17"/>
+          <p:cNvSpPr txBox="1"/>
+          <p:nvPr/>
+        </p:nvSpPr>
+        <p:spPr>
+          <a:xfrm>
+            <a:off x="4565904" y="3261360"/>
+            <a:ext cx="1304544" cy="234696"/>
+          </a:xfrm>
+          <a:prstGeom prst="rect">
+            <a:avLst/>
+          </a:prstGeom>
+          <a:noFill/>
+          <a:ln>
+            <a:noFill/>
+          </a:ln>
+        </p:spPr>
+        <p:txBody>
+          <a:bodyPr wrap="none" lIns="0" tIns="0" rIns="0" bIns="0" anchor="t" anchorCtr="0">
+            <a:spAutoFit/>
+          </a:bodyPr>
+          <a:lstStyle/>
+          <a:p>
+            <a:pPr algn="l"/>
+            <a:r>
+              <a:rPr lang="zh-CN" sz="1200" dirty="0">
+                <a:solidFill>
+                  <a:srgbClr val="B7C7DE"/>
+                </a:solidFill>
+                <a:latin typeface="Arial"/>
+                <a:ea typeface="Microsoft YaHei"/>
+                <a:cs typeface="Arial"/>
+              </a:rPr>
+              <a:t>返回逐行诊断报告</a:t>
+            </a:r>
+          </a:p>
+        </p:txBody>
+      </p:sp>
+      <p:sp>
+        <p:nvSpPr>
+          <p:cNvPr id="18" name="Rectangle 18"/>
+          <p:cNvSpPr/>
+          <p:nvPr/>
+        </p:nvSpPr>
+        <p:spPr>
+          <a:xfrm>
+            <a:off x="8191500" y="1666875"/>
+            <a:ext cx="3619500" cy="1952625"/>
+          </a:xfrm>
+          <a:prstGeom prst="roundRect">
+            <a:avLst>
+              <a:gd name="adj" fmla="val 4878"/>
+            </a:avLst>
+          </a:prstGeom>
+          <a:solidFill>
+            <a:srgbClr val="132846"/>
+          </a:solidFill>
+          <a:ln w="19050">
+            <a:solidFill>
+              <a:srgbClr val="1E3A5F"/>
+            </a:solidFill>
+          </a:ln>
+        </p:spPr>
+      </p:sp>
+      <p:sp>
+        <p:nvSpPr>
+          <p:cNvPr id="19" name="TextBox 19"/>
+          <p:cNvSpPr txBox="1"/>
+          <p:nvPr/>
+        </p:nvSpPr>
+        <p:spPr>
+          <a:xfrm>
+            <a:off x="8372856" y="1853565"/>
+            <a:ext cx="1392220" cy="352044"/>
+          </a:xfrm>
+          <a:prstGeom prst="rect">
+            <a:avLst/>
+          </a:prstGeom>
+          <a:noFill/>
+          <a:ln>
+            <a:noFill/>
+          </a:ln>
+        </p:spPr>
+        <p:txBody>
+          <a:bodyPr wrap="none" lIns="0" tIns="0" rIns="0" bIns="0" anchor="t" anchorCtr="0">
+            <a:spAutoFit/>
+          </a:bodyPr>
+          <a:lstStyle/>
+          <a:p>
+            <a:pPr algn="l"/>
+            <a:r>
+              <a:rPr lang="zh-CN" sz="1800" b="1" dirty="0">
+                <a:solidFill>
+                  <a:srgbClr val="FFD54F"/>
+                </a:solidFill>
+                <a:latin typeface="Arial"/>
+                <a:ea typeface="Microsoft YaHei"/>
+                <a:cs typeface="Arial"/>
+              </a:rPr>
+              <a:t>↩️ 恢复初始</a:t>
+            </a:r>
+          </a:p>
+        </p:txBody>
+      </p:sp>
+      <p:sp>
+        <p:nvSpPr>
+          <p:cNvPr id="20" name="TextBox 20"/>
+          <p:cNvSpPr txBox="1"/>
+          <p:nvPr/>
+        </p:nvSpPr>
+        <p:spPr>
+          <a:xfrm>
+            <a:off x="8376285" y="2355056"/>
+            <a:ext cx="2115264" cy="220028"/>
+          </a:xfrm>
+          <a:prstGeom prst="rect">
+            <a:avLst/>
+          </a:prstGeom>
+          <a:noFill/>
+          <a:ln>
+            <a:noFill/>
+          </a:ln>
+        </p:spPr>
+        <p:txBody>
+          <a:bodyPr wrap="none" lIns="0" tIns="0" rIns="0" bIns="0" anchor="t" anchorCtr="0">
+            <a:spAutoFit/>
+          </a:bodyPr>
+          <a:lstStyle/>
+          <a:p>
+            <a:pPr algn="l"/>
+            <a:r>
+              <a:rPr lang="en-US" sz="1120" dirty="0">
+                <a:solidFill>
+                  <a:srgbClr val="DDEBFF"/>
+                </a:solidFill>
+                <a:latin typeface="Consolas"/>
+                <a:ea typeface="Consolas"/>
+                <a:cs typeface="Consolas"/>
+              </a:rPr>
+              <a:t>POST /api/stations/restore</a:t>
+            </a:r>
+          </a:p>
+        </p:txBody>
+      </p:sp>
+      <p:sp>
+        <p:nvSpPr>
+          <p:cNvPr id="21" name="TextBox 21"/>
+          <p:cNvSpPr txBox="1"/>
+          <p:nvPr/>
+        </p:nvSpPr>
+        <p:spPr>
+          <a:xfrm>
+            <a:off x="8375904" y="2651760"/>
+            <a:ext cx="1828800" cy="234696"/>
+          </a:xfrm>
+          <a:prstGeom prst="rect">
+            <a:avLst/>
+          </a:prstGeom>
+          <a:noFill/>
+          <a:ln>
+            <a:noFill/>
+          </a:ln>
+        </p:spPr>
+        <p:txBody>
+          <a:bodyPr wrap="none" lIns="0" tIns="0" rIns="0" bIns="0" anchor="t" anchorCtr="0">
+            <a:spAutoFit/>
+          </a:bodyPr>
+          <a:lstStyle/>
+          <a:p>
+            <a:pPr algn="l"/>
+            <a:r>
+              <a:rPr lang="zh-CN" sz="1200" dirty="0">
+                <a:solidFill>
+                  <a:srgbClr val="B7C7DE"/>
+                </a:solidFill>
+                <a:latin typeface="Arial"/>
+                <a:ea typeface="Microsoft YaHei"/>
+                <a:cs typeface="Arial"/>
+              </a:rPr>
+              <a:t>→ Station_init.csv 快照</a:t>
+            </a:r>
+          </a:p>
+        </p:txBody>
+      </p:sp>
+      <p:sp>
+        <p:nvSpPr>
+          <p:cNvPr id="22" name="TextBox 22"/>
+          <p:cNvSpPr txBox="1"/>
+          <p:nvPr/>
+        </p:nvSpPr>
+        <p:spPr>
+          <a:xfrm>
+            <a:off x="8375904" y="2956560"/>
+            <a:ext cx="1942643" cy="234696"/>
+          </a:xfrm>
+          <a:prstGeom prst="rect">
+            <a:avLst/>
+          </a:prstGeom>
+          <a:noFill/>
+          <a:ln>
+            <a:noFill/>
+          </a:ln>
+        </p:spPr>
+        <p:txBody>
+          <a:bodyPr wrap="none" lIns="0" tIns="0" rIns="0" bIns="0" anchor="t" anchorCtr="0">
+            <a:spAutoFit/>
+          </a:bodyPr>
+          <a:lstStyle/>
+          <a:p>
+            <a:pPr algn="l"/>
+            <a:r>
+              <a:rPr lang="zh-CN" sz="1200" dirty="0">
+                <a:solidFill>
+                  <a:srgbClr val="B7C7DE"/>
+                </a:solidFill>
+                <a:latin typeface="Arial"/>
+                <a:ea typeface="Microsoft YaHei"/>
+                <a:cs typeface="Arial"/>
+              </a:rPr>
+              <a:t>build_dataset 生成时留存</a:t>
+            </a:r>
+          </a:p>
+        </p:txBody>
+      </p:sp>
+      <p:sp>
+        <p:nvSpPr>
+          <p:cNvPr id="23" name="TextBox 23"/>
+          <p:cNvSpPr txBox="1"/>
+          <p:nvPr/>
+        </p:nvSpPr>
+        <p:spPr>
+          <a:xfrm>
+            <a:off x="8375904" y="3261360"/>
+            <a:ext cx="981456" cy="234696"/>
+          </a:xfrm>
+          <a:prstGeom prst="rect">
+            <a:avLst/>
+          </a:prstGeom>
+          <a:noFill/>
+          <a:ln>
+            <a:noFill/>
+          </a:ln>
+        </p:spPr>
+        <p:txBody>
+          <a:bodyPr wrap="none" lIns="0" tIns="0" rIns="0" bIns="0" anchor="t" anchorCtr="0">
+            <a:spAutoFit/>
+          </a:bodyPr>
+          <a:lstStyle/>
+          <a:p>
+            <a:pPr algn="l"/>
+            <a:r>
+              <a:rPr lang="zh-CN" sz="1200" dirty="0">
+                <a:solidFill>
+                  <a:srgbClr val="B7C7DE"/>
+                </a:solidFill>
+                <a:latin typeface="Arial"/>
+                <a:ea typeface="Microsoft YaHei"/>
+                <a:cs typeface="Arial"/>
+              </a:rPr>
+              <a:t>一键完全复原</a:t>
+            </a:r>
+          </a:p>
+        </p:txBody>
+      </p:sp>
+      <p:sp>
+        <p:nvSpPr>
+          <p:cNvPr id="24" name="Rectangle 24"/>
+          <p:cNvSpPr/>
+          <p:nvPr/>
+        </p:nvSpPr>
+        <p:spPr>
+          <a:xfrm>
+            <a:off x="571500" y="3810000"/>
+            <a:ext cx="7429500" cy="1905000"/>
+          </a:xfrm>
+          <a:prstGeom prst="roundRect">
+            <a:avLst>
+              <a:gd name="adj" fmla="val 5000"/>
+            </a:avLst>
+          </a:prstGeom>
+          <a:solidFill>
+            <a:srgbClr val="132846"/>
+          </a:solidFill>
+          <a:ln w="19050">
+            <a:solidFill>
+              <a:srgbClr val="1E3A5F"/>
+            </a:solidFill>
+          </a:ln>
+        </p:spPr>
+      </p:sp>
+      <p:sp>
+        <p:nvSpPr>
+          <p:cNvPr id="25" name="TextBox 25"/>
+          <p:cNvSpPr txBox="1"/>
+          <p:nvPr/>
+        </p:nvSpPr>
+        <p:spPr>
+          <a:xfrm>
+            <a:off x="753618" y="3917632"/>
+            <a:ext cx="4899253" cy="322707"/>
+          </a:xfrm>
+          <a:prstGeom prst="rect">
+            <a:avLst/>
+          </a:prstGeom>
+          <a:noFill/>
+          <a:ln>
+            <a:noFill/>
+          </a:ln>
+        </p:spPr>
+        <p:txBody>
+          <a:bodyPr wrap="none" lIns="0" tIns="0" rIns="0" bIns="0" anchor="t" anchorCtr="0">
+            <a:spAutoFit/>
+          </a:bodyPr>
+          <a:lstStyle/>
+          <a:p>
+            <a:pPr algn="l"/>
+            <a:r>
+              <a:rPr lang="zh-CN" sz="1650" b="1" dirty="0">
+                <a:solidFill>
+                  <a:srgbClr val="FFD54F"/>
+                </a:solidFill>
+                <a:latin typeface="Arial"/>
+                <a:ea typeface="Microsoft YaHei"/>
+                <a:cs typeface="Arial"/>
+              </a:rPr>
+              <a:t>闭站路径过滤（Graph::neighbors 内部逻辑）</a:t>
+            </a:r>
+          </a:p>
+        </p:txBody>
+      </p:sp>
+      <p:sp>
+        <p:nvSpPr>
+          <p:cNvPr id="26" name="Line 26"/>
+          <p:cNvSpPr/>
+          <p:nvPr/>
+        </p:nvSpPr>
+        <p:spPr>
+          <a:xfrm>
+            <a:off x="1714500" y="4857750"/>
+            <a:ext cx="2095500" cy="9525"/>
+          </a:xfrm>
+          <a:custGeom>
+            <a:avLst/>
+            <a:gdLst/>
+            <a:ahLst/>
+            <a:cxnLst/>
+            <a:rect l="l" t="t" r="r" b="b"/>
+            <a:pathLst>
+              <a:path w="2095500" h="9525">
+                <a:moveTo>
+                  <a:pt x="0" y="0"/>
+                </a:moveTo>
+                <a:lnTo>
+                  <a:pt x="2095500" y="0"/>
+                </a:lnTo>
+              </a:path>
+            </a:pathLst>
+          </a:custGeom>
+          <a:noFill/>
+          <a:ln w="19050" cap="rnd">
+            <a:solidFill>
+              <a:srgbClr val="4A6280"/>
+            </a:solidFill>
+          </a:ln>
+        </p:spPr>
+      </p:sp>
+      <p:sp>
+        <p:nvSpPr>
+          <p:cNvPr id="27" name="Line 27"/>
+          <p:cNvSpPr/>
+          <p:nvPr/>
+        </p:nvSpPr>
+        <p:spPr>
+          <a:xfrm>
+            <a:off x="2667000" y="4762500"/>
+            <a:ext cx="190500" cy="190500"/>
+          </a:xfrm>
+          <a:custGeom>
+            <a:avLst/>
+            <a:gdLst/>
+            <a:ahLst/>
+            <a:cxnLst/>
+            <a:rect l="l" t="t" r="r" b="b"/>
+            <a:pathLst>
+              <a:path w="190500" h="190500">
+                <a:moveTo>
+                  <a:pt x="0" y="0"/>
+                </a:moveTo>
+                <a:lnTo>
+                  <a:pt x="190500" y="190500"/>
+                </a:lnTo>
+              </a:path>
+            </a:pathLst>
+          </a:custGeom>
+          <a:noFill/>
+          <a:ln w="28575" cap="rnd">
+            <a:solidFill>
+              <a:srgbClr val="E4002B"/>
+            </a:solidFill>
+          </a:ln>
+        </p:spPr>
+      </p:sp>
+      <p:sp>
+        <p:nvSpPr>
+          <p:cNvPr id="28" name="Line 28"/>
+          <p:cNvSpPr/>
+          <p:nvPr/>
+        </p:nvSpPr>
+        <p:spPr>
+          <a:xfrm>
+            <a:off x="2667000" y="4762500"/>
+            <a:ext cx="190500" cy="190500"/>
+          </a:xfrm>
+          <a:custGeom>
+            <a:avLst/>
+            <a:gdLst/>
+            <a:ahLst/>
+            <a:cxnLst/>
+            <a:rect l="l" t="t" r="r" b="b"/>
+            <a:pathLst>
+              <a:path w="190500" h="190500">
+                <a:moveTo>
+                  <a:pt x="0" y="190500"/>
+                </a:moveTo>
+                <a:lnTo>
+                  <a:pt x="190500" y="0"/>
+                </a:lnTo>
+              </a:path>
+            </a:pathLst>
+          </a:custGeom>
+          <a:noFill/>
+          <a:ln w="28575" cap="rnd">
+            <a:solidFill>
+              <a:srgbClr val="E4002B"/>
+            </a:solidFill>
+          </a:ln>
+        </p:spPr>
+      </p:sp>
+      <p:sp>
+        <p:nvSpPr>
+          <p:cNvPr id="29" name="Freeform 29"/>
+          <p:cNvSpPr/>
+          <p:nvPr/>
+        </p:nvSpPr>
+        <p:spPr>
+          <a:xfrm>
+            <a:off x="1714500" y="4476750"/>
+            <a:ext cx="4191000" cy="381000"/>
+          </a:xfrm>
+          <a:custGeom>
+            <a:avLst/>
+            <a:gdLst/>
+            <a:ahLst/>
+            <a:cxnLst/>
+            <a:rect l="l" t="t" r="r" b="b"/>
+            <a:pathLst>
+              <a:path w="4191000" h="381000">
+                <a:moveTo>
+                  <a:pt x="0" y="381000"/>
+                </a:moveTo>
+                <a:cubicBezTo>
+                  <a:pt x="1397000" y="0"/>
+                  <a:pt x="2794000" y="0"/>
+                  <a:pt x="4191000" y="381000"/>
+                </a:cubicBezTo>
+              </a:path>
+            </a:pathLst>
+          </a:custGeom>
+          <a:noFill/>
+          <a:ln w="28575">
+            <a:solidFill>
+              <a:srgbClr val="97D700"/>
+            </a:solidFill>
+          </a:ln>
+        </p:spPr>
+      </p:sp>
+      <p:sp>
+        <p:nvSpPr>
+          <p:cNvPr id="30" name="Line 30"/>
+          <p:cNvSpPr/>
+          <p:nvPr/>
+        </p:nvSpPr>
+        <p:spPr>
+          <a:xfrm>
+            <a:off x="3810000" y="4857750"/>
+            <a:ext cx="2095500" cy="9525"/>
+          </a:xfrm>
+          <a:custGeom>
+            <a:avLst/>
+            <a:gdLst/>
+            <a:ahLst/>
+            <a:cxnLst/>
+            <a:rect l="l" t="t" r="r" b="b"/>
+            <a:pathLst>
+              <a:path w="2095500" h="9525">
+                <a:moveTo>
+                  <a:pt x="2095500" y="0"/>
+                </a:moveTo>
+                <a:lnTo>
+                  <a:pt x="0" y="0"/>
+                </a:lnTo>
+              </a:path>
+            </a:pathLst>
+          </a:custGeom>
+          <a:noFill/>
+          <a:ln w="19050" cap="rnd">
+            <a:solidFill>
+              <a:srgbClr val="4A6280"/>
+            </a:solidFill>
+          </a:ln>
+        </p:spPr>
+      </p:sp>
+      <p:sp>
+        <p:nvSpPr>
+          <p:cNvPr id="31" name="Line 31"/>
+          <p:cNvSpPr/>
+          <p:nvPr/>
+        </p:nvSpPr>
+        <p:spPr>
+          <a:xfrm>
+            <a:off x="4762500" y="4762500"/>
+            <a:ext cx="190500" cy="190500"/>
+          </a:xfrm>
+          <a:custGeom>
+            <a:avLst/>
+            <a:gdLst/>
+            <a:ahLst/>
+            <a:cxnLst/>
+            <a:rect l="l" t="t" r="r" b="b"/>
+            <a:pathLst>
+              <a:path w="190500" h="190500">
+                <a:moveTo>
+                  <a:pt x="0" y="0"/>
+                </a:moveTo>
+                <a:lnTo>
+                  <a:pt x="190500" y="190500"/>
+                </a:lnTo>
+              </a:path>
+            </a:pathLst>
+          </a:custGeom>
+          <a:noFill/>
+          <a:ln w="28575" cap="rnd">
+            <a:solidFill>
+              <a:srgbClr val="E4002B"/>
+            </a:solidFill>
+          </a:ln>
+        </p:spPr>
+      </p:sp>
+      <p:sp>
+        <p:nvSpPr>
+          <p:cNvPr id="32" name="Line 32"/>
+          <p:cNvSpPr/>
+          <p:nvPr/>
+        </p:nvSpPr>
+        <p:spPr>
+          <a:xfrm>
+            <a:off x="4762500" y="4762500"/>
+            <a:ext cx="190500" cy="190500"/>
+          </a:xfrm>
+          <a:custGeom>
+            <a:avLst/>
+            <a:gdLst/>
+            <a:ahLst/>
+            <a:cxnLst/>
+            <a:rect l="l" t="t" r="r" b="b"/>
+            <a:pathLst>
+              <a:path w="190500" h="190500">
+                <a:moveTo>
+                  <a:pt x="0" y="190500"/>
+                </a:moveTo>
+                <a:lnTo>
+                  <a:pt x="190500" y="0"/>
+                </a:lnTo>
+              </a:path>
+            </a:pathLst>
+          </a:custGeom>
+          <a:noFill/>
+          <a:ln w="28575" cap="rnd">
+            <a:solidFill>
+              <a:srgbClr val="E4002B"/>
+            </a:solidFill>
+          </a:ln>
+        </p:spPr>
+      </p:sp>
+      <p:sp>
+        <p:nvSpPr>
+          <p:cNvPr id="33" name="Ellipse 33"/>
+          <p:cNvSpPr/>
+          <p:nvPr/>
+        </p:nvSpPr>
+        <p:spPr>
+          <a:xfrm>
+            <a:off x="1409700" y="4552950"/>
+            <a:ext cx="609600" cy="609600"/>
+          </a:xfrm>
+          <a:prstGeom prst="ellipse">
+            <a:avLst/>
+          </a:prstGeom>
+          <a:solidFill>
+            <a:srgbClr val="97D700"/>
+          </a:solidFill>
+          <a:ln>
+            <a:noFill/>
+          </a:ln>
+        </p:spPr>
+      </p:sp>
+      <p:sp>
+        <p:nvSpPr>
+          <p:cNvPr id="34" name="TextBox 34"/>
+          <p:cNvSpPr txBox="1"/>
+          <p:nvPr/>
+        </p:nvSpPr>
+        <p:spPr>
+          <a:xfrm>
+            <a:off x="1638350" y="4746308"/>
+            <a:ext cx="152301" cy="322707"/>
+          </a:xfrm>
+          <a:prstGeom prst="rect">
+            <a:avLst/>
+          </a:prstGeom>
+          <a:noFill/>
+          <a:ln>
+            <a:noFill/>
+          </a:ln>
+        </p:spPr>
+        <p:txBody>
+          <a:bodyPr wrap="none" lIns="0" tIns="0" rIns="0" bIns="0" anchor="t" anchorCtr="0">
+            <a:spAutoFit/>
+          </a:bodyPr>
+          <a:lstStyle/>
+          <a:p>
+            <a:pPr algn="ctr"/>
+            <a:r>
+              <a:rPr lang="en-US" sz="1650" b="1" dirty="0">
+                <a:solidFill>
+                  <a:srgbClr val="FFFFFF"/>
+                </a:solidFill>
+                <a:latin typeface="Arial"/>
+                <a:ea typeface="Arial"/>
+                <a:cs typeface="Arial"/>
+              </a:rPr>
+              <a:t>A</a:t>
+            </a:r>
+          </a:p>
+        </p:txBody>
+      </p:sp>
+      <p:sp>
+        <p:nvSpPr>
+          <p:cNvPr id="35" name="TextBox 35"/>
+          <p:cNvSpPr txBox="1"/>
+          <p:nvPr/>
+        </p:nvSpPr>
+        <p:spPr>
+          <a:xfrm>
+            <a:off x="1355788" y="5315902"/>
+            <a:ext cx="717423" cy="205359"/>
+          </a:xfrm>
+          <a:prstGeom prst="rect">
+            <a:avLst/>
+          </a:prstGeom>
+          <a:noFill/>
+          <a:ln>
+            <a:noFill/>
+          </a:ln>
+        </p:spPr>
+        <p:txBody>
+          <a:bodyPr wrap="none" lIns="0" tIns="0" rIns="0" bIns="0" anchor="t" anchorCtr="0">
+            <a:spAutoFit/>
+          </a:bodyPr>
+          <a:lstStyle/>
+          <a:p>
+            <a:pPr algn="ctr"/>
+            <a:r>
+              <a:rPr lang="zh-CN" sz="1050" dirty="0">
+                <a:solidFill>
+                  <a:srgbClr val="B7C7DE"/>
+                </a:solidFill>
+                <a:latin typeface="Arial"/>
+                <a:ea typeface="Microsoft YaHei"/>
+                <a:cs typeface="Arial"/>
+              </a:rPr>
+              <a:t>起点（开）</a:t>
+            </a:r>
+          </a:p>
+        </p:txBody>
+      </p:sp>
+      <p:sp>
+        <p:nvSpPr>
+          <p:cNvPr id="36" name="Ellipse 36"/>
+          <p:cNvSpPr/>
+          <p:nvPr/>
+        </p:nvSpPr>
+        <p:spPr>
+          <a:xfrm>
+            <a:off x="3505200" y="4552950"/>
+            <a:ext cx="609600" cy="609600"/>
+          </a:xfrm>
+          <a:prstGeom prst="ellipse">
+            <a:avLst/>
+          </a:prstGeom>
+          <a:solidFill>
+            <a:srgbClr val="3A0F14"/>
+          </a:solidFill>
+          <a:ln w="28575">
+            <a:solidFill>
+              <a:srgbClr val="E4002B"/>
+            </a:solidFill>
+          </a:ln>
+        </p:spPr>
+      </p:sp>
+      <p:sp>
+        <p:nvSpPr>
+          <p:cNvPr id="37" name="TextBox 37"/>
+          <p:cNvSpPr txBox="1"/>
+          <p:nvPr/>
+        </p:nvSpPr>
+        <p:spPr>
+          <a:xfrm>
+            <a:off x="3733850" y="4746308"/>
+            <a:ext cx="152301" cy="322707"/>
+          </a:xfrm>
+          <a:prstGeom prst="rect">
+            <a:avLst/>
+          </a:prstGeom>
+          <a:noFill/>
+          <a:ln>
+            <a:noFill/>
+          </a:ln>
+        </p:spPr>
+        <p:txBody>
+          <a:bodyPr wrap="none" lIns="0" tIns="0" rIns="0" bIns="0" anchor="t" anchorCtr="0">
+            <a:spAutoFit/>
+          </a:bodyPr>
+          <a:lstStyle/>
+          <a:p>
+            <a:pPr algn="ctr"/>
+            <a:r>
+              <a:rPr lang="en-US" sz="1650" b="1" dirty="0">
+                <a:solidFill>
+                  <a:srgbClr val="E4002B"/>
+                </a:solidFill>
+                <a:latin typeface="Arial"/>
+                <a:ea typeface="Arial"/>
+                <a:cs typeface="Arial"/>
+              </a:rPr>
+              <a:t>B</a:t>
+            </a:r>
+          </a:p>
+        </p:txBody>
+      </p:sp>
+      <p:sp>
+        <p:nvSpPr>
+          <p:cNvPr id="38" name="TextBox 38"/>
+          <p:cNvSpPr txBox="1"/>
+          <p:nvPr/>
+        </p:nvSpPr>
+        <p:spPr>
+          <a:xfrm>
+            <a:off x="3663315" y="5315902"/>
+            <a:ext cx="293370" cy="205359"/>
+          </a:xfrm>
+          <a:prstGeom prst="rect">
+            <a:avLst/>
+          </a:prstGeom>
+          <a:noFill/>
+          <a:ln>
+            <a:noFill/>
+          </a:ln>
+        </p:spPr>
+        <p:txBody>
+          <a:bodyPr wrap="none" lIns="0" tIns="0" rIns="0" bIns="0" anchor="t" anchorCtr="0">
+            <a:spAutoFit/>
+          </a:bodyPr>
+          <a:lstStyle/>
+          <a:p>
+            <a:pPr algn="ctr"/>
+            <a:r>
+              <a:rPr lang="zh-CN" sz="1050" dirty="0">
+                <a:solidFill>
+                  <a:srgbClr val="E4002B"/>
+                </a:solidFill>
+                <a:latin typeface="Arial"/>
+                <a:ea typeface="Microsoft YaHei"/>
+                <a:cs typeface="Arial"/>
+              </a:rPr>
+              <a:t>闭站</a:t>
+            </a:r>
+          </a:p>
+        </p:txBody>
+      </p:sp>
+      <p:sp>
+        <p:nvSpPr>
+          <p:cNvPr id="39" name="Ellipse 39"/>
+          <p:cNvSpPr/>
+          <p:nvPr/>
+        </p:nvSpPr>
+        <p:spPr>
+          <a:xfrm>
+            <a:off x="5600700" y="4552950"/>
+            <a:ext cx="609600" cy="609600"/>
+          </a:xfrm>
+          <a:prstGeom prst="ellipse">
+            <a:avLst/>
+          </a:prstGeom>
+          <a:solidFill>
+            <a:srgbClr val="97D700"/>
+          </a:solidFill>
+          <a:ln>
+            <a:noFill/>
+          </a:ln>
+        </p:spPr>
+      </p:sp>
+      <p:sp>
+        <p:nvSpPr>
+          <p:cNvPr id="40" name="TextBox 40"/>
+          <p:cNvSpPr txBox="1"/>
+          <p:nvPr/>
+        </p:nvSpPr>
+        <p:spPr>
+          <a:xfrm>
+            <a:off x="5829350" y="4746308"/>
+            <a:ext cx="152301" cy="322707"/>
+          </a:xfrm>
+          <a:prstGeom prst="rect">
+            <a:avLst/>
+          </a:prstGeom>
+          <a:noFill/>
+          <a:ln>
+            <a:noFill/>
+          </a:ln>
+        </p:spPr>
+        <p:txBody>
+          <a:bodyPr wrap="none" lIns="0" tIns="0" rIns="0" bIns="0" anchor="t" anchorCtr="0">
+            <a:spAutoFit/>
+          </a:bodyPr>
+          <a:lstStyle/>
+          <a:p>
+            <a:pPr algn="ctr"/>
+            <a:r>
+              <a:rPr lang="en-US" sz="1650" b="1" dirty="0">
+                <a:solidFill>
+                  <a:srgbClr val="FFFFFF"/>
+                </a:solidFill>
+                <a:latin typeface="Arial"/>
+                <a:ea typeface="Arial"/>
+                <a:cs typeface="Arial"/>
+              </a:rPr>
+              <a:t>C</a:t>
+            </a:r>
+          </a:p>
+        </p:txBody>
+      </p:sp>
+      <p:sp>
+        <p:nvSpPr>
+          <p:cNvPr id="41" name="TextBox 41"/>
+          <p:cNvSpPr txBox="1"/>
+          <p:nvPr/>
+        </p:nvSpPr>
+        <p:spPr>
+          <a:xfrm>
+            <a:off x="5546788" y="5315902"/>
+            <a:ext cx="717423" cy="205359"/>
+          </a:xfrm>
+          <a:prstGeom prst="rect">
+            <a:avLst/>
+          </a:prstGeom>
+          <a:noFill/>
+          <a:ln>
+            <a:noFill/>
+          </a:ln>
+        </p:spPr>
+        <p:txBody>
+          <a:bodyPr wrap="none" lIns="0" tIns="0" rIns="0" bIns="0" anchor="t" anchorCtr="0">
+            <a:spAutoFit/>
+          </a:bodyPr>
+          <a:lstStyle/>
+          <a:p>
+            <a:pPr algn="ctr"/>
+            <a:r>
+              <a:rPr lang="zh-CN" sz="1050" dirty="0">
+                <a:solidFill>
+                  <a:srgbClr val="B7C7DE"/>
+                </a:solidFill>
+                <a:latin typeface="Arial"/>
+                <a:ea typeface="Microsoft YaHei"/>
+                <a:cs typeface="Arial"/>
+              </a:rPr>
+              <a:t>邻站（开）</a:t>
+            </a:r>
+          </a:p>
+        </p:txBody>
+      </p:sp>
+      <p:sp>
+        <p:nvSpPr>
+          <p:cNvPr id="42" name="TextBox 42"/>
+          <p:cNvSpPr txBox="1"/>
+          <p:nvPr/>
+        </p:nvSpPr>
+        <p:spPr>
+          <a:xfrm>
+            <a:off x="6851904" y="4632960"/>
+            <a:ext cx="881421" cy="234696"/>
+          </a:xfrm>
+          <a:prstGeom prst="rect">
+            <a:avLst/>
+          </a:prstGeom>
+          <a:noFill/>
+          <a:ln>
+            <a:noFill/>
+          </a:ln>
+        </p:spPr>
+        <p:txBody>
+          <a:bodyPr wrap="none" lIns="0" tIns="0" rIns="0" bIns="0" anchor="t" anchorCtr="0">
+            <a:spAutoFit/>
+          </a:bodyPr>
+          <a:lstStyle/>
+          <a:p>
+            <a:pPr algn="l"/>
+            <a:r>
+              <a:rPr lang="zh-CN" sz="1200" b="1" dirty="0">
+                <a:solidFill>
+                  <a:srgbClr val="E4002B"/>
+                </a:solidFill>
+                <a:latin typeface="Arial"/>
+                <a:ea typeface="Microsoft YaHei"/>
+                <a:cs typeface="Arial"/>
+              </a:rPr>
+              <a:t>闭站节点 B</a:t>
+            </a:r>
+          </a:p>
+        </p:txBody>
+      </p:sp>
+      <p:sp>
+        <p:nvSpPr>
+          <p:cNvPr id="43" name="TextBox 43"/>
+          <p:cNvSpPr txBox="1"/>
+          <p:nvPr/>
+        </p:nvSpPr>
+        <p:spPr>
+          <a:xfrm>
+            <a:off x="6851904" y="4842510"/>
+            <a:ext cx="521056" cy="234696"/>
+          </a:xfrm>
+          <a:prstGeom prst="rect">
+            <a:avLst/>
+          </a:prstGeom>
+          <a:noFill/>
+          <a:ln>
+            <a:noFill/>
+          </a:ln>
+        </p:spPr>
+        <p:txBody>
+          <a:bodyPr wrap="none" lIns="0" tIns="0" rIns="0" bIns="0" anchor="t" anchorCtr="0">
+            <a:spAutoFit/>
+          </a:bodyPr>
+          <a:lstStyle/>
+          <a:p>
+            <a:pPr algn="l"/>
+            <a:r>
+              <a:rPr lang="zh-CN" sz="1200" b="1" dirty="0">
+                <a:solidFill>
+                  <a:srgbClr val="E4002B"/>
+                </a:solidFill>
+                <a:latin typeface="Arial"/>
+                <a:ea typeface="Microsoft YaHei"/>
+                <a:cs typeface="Arial"/>
+              </a:rPr>
+              <a:t>被过滤</a:t>
+            </a:r>
+          </a:p>
+        </p:txBody>
+      </p:sp>
+      <p:sp>
+        <p:nvSpPr>
+          <p:cNvPr id="44" name="Rectangle 44"/>
+          <p:cNvSpPr/>
+          <p:nvPr/>
+        </p:nvSpPr>
+        <p:spPr>
+          <a:xfrm>
+            <a:off x="8382000" y="3810000"/>
+            <a:ext cx="3238500" cy="1905000"/>
+          </a:xfrm>
+          <a:prstGeom prst="roundRect">
+            <a:avLst>
+              <a:gd name="adj" fmla="val 5000"/>
+            </a:avLst>
+          </a:prstGeom>
+          <a:solidFill>
+            <a:srgbClr val="132846"/>
+          </a:solidFill>
+          <a:ln w="19050">
+            <a:solidFill>
+              <a:srgbClr val="1E3A5F"/>
+            </a:solidFill>
+          </a:ln>
+        </p:spPr>
+      </p:sp>
+      <p:sp>
+        <p:nvSpPr>
+          <p:cNvPr id="45" name="TextBox 45"/>
+          <p:cNvSpPr txBox="1"/>
+          <p:nvPr/>
+        </p:nvSpPr>
+        <p:spPr>
+          <a:xfrm>
+            <a:off x="8564880" y="3933825"/>
+            <a:ext cx="1177145" cy="293370"/>
+          </a:xfrm>
+          <a:prstGeom prst="rect">
+            <a:avLst/>
+          </a:prstGeom>
+          <a:noFill/>
+          <a:ln>
+            <a:noFill/>
+          </a:ln>
+        </p:spPr>
+        <p:txBody>
+          <a:bodyPr wrap="none" lIns="0" tIns="0" rIns="0" bIns="0" anchor="t" anchorCtr="0">
+            <a:spAutoFit/>
+          </a:bodyPr>
+          <a:lstStyle/>
+          <a:p>
+            <a:pPr algn="l"/>
+            <a:r>
+              <a:rPr lang="zh-CN" sz="1500" b="1" dirty="0">
+                <a:solidFill>
+                  <a:srgbClr val="FFD54F"/>
+                </a:solidFill>
+                <a:latin typeface="Arial"/>
+                <a:ea typeface="Microsoft YaHei"/>
+                <a:cs typeface="Arial"/>
+              </a:rPr>
+              <a:t>Web 管理 UI</a:t>
+            </a:r>
+          </a:p>
+        </p:txBody>
+      </p:sp>
+      <p:sp>
+        <p:nvSpPr>
+          <p:cNvPr id="46" name="Rectangle 46"/>
+          <p:cNvSpPr/>
+          <p:nvPr/>
+        </p:nvSpPr>
+        <p:spPr>
+          <a:xfrm>
+            <a:off x="8572500" y="4238625"/>
+            <a:ext cx="2857500" cy="1333500"/>
+          </a:xfrm>
+          <a:prstGeom prst="rect">
+            <a:avLst/>
+          </a:prstGeom>
+          <a:solidFill>
+            <a:srgbClr val="0F2A45"/>
+          </a:solidFill>
+          <a:ln w="9525">
+            <a:solidFill>
+              <a:srgbClr val="1E3A5F"/>
+            </a:solidFill>
+          </a:ln>
+        </p:spPr>
+      </p:sp>
+      <p:sp>
+        <p:nvSpPr>
+          <p:cNvPr id="47" name="Rectangle 47"/>
+          <p:cNvSpPr/>
+          <p:nvPr/>
+        </p:nvSpPr>
+        <p:spPr>
+          <a:xfrm>
+            <a:off x="8572500" y="4238625"/>
+            <a:ext cx="2857500" cy="1333500"/>
+          </a:xfrm>
+          <a:prstGeom prst="rect">
+            <a:avLst/>
+          </a:prstGeom>
+          <a:noFill/>
+          <a:ln w="14288">
+            <a:solidFill>
+              <a:srgbClr val="1E3A5F"/>
+            </a:solidFill>
+            <a:custDash>
+              <a:ds d="400000" sp="266666"/>
+            </a:custDash>
+          </a:ln>
+        </p:spPr>
+      </p:sp>
+      <p:sp>
+        <p:nvSpPr>
+          <p:cNvPr id="48" name="TextBox 48"/>
+          <p:cNvSpPr txBox="1"/>
+          <p:nvPr/>
+        </p:nvSpPr>
+        <p:spPr>
+          <a:xfrm>
+            <a:off x="8931783" y="4839652"/>
+            <a:ext cx="2138934" cy="205359"/>
+          </a:xfrm>
+          <a:prstGeom prst="rect">
+            <a:avLst/>
+          </a:prstGeom>
+          <a:noFill/>
+          <a:ln>
+            <a:noFill/>
+          </a:ln>
+        </p:spPr>
+        <p:txBody>
+          <a:bodyPr wrap="none" lIns="0" tIns="0" rIns="0" bIns="0" anchor="t" anchorCtr="0">
+            <a:spAutoFit/>
+          </a:bodyPr>
+          <a:lstStyle/>
+          <a:p>
+            <a:pPr algn="ctr"/>
+            <a:r>
+              <a:rPr lang="zh-CN" sz="1050" dirty="0">
+                <a:solidFill>
+                  <a:srgbClr val="B7C7DE"/>
+                </a:solidFill>
+                <a:latin typeface="Arial"/>
+                <a:ea typeface="Microsoft YaHei"/>
+                <a:cs typeface="Arial"/>
+              </a:rPr>
+              <a:t>线路筛选 + 状态切换 + CSV 上传</a:t>
+            </a:r>
+          </a:p>
+        </p:txBody>
+      </p:sp>
+      <p:sp>
+        <p:nvSpPr>
+          <p:cNvPr id="49" name="TextBox 49"/>
+          <p:cNvSpPr txBox="1"/>
+          <p:nvPr/>
+        </p:nvSpPr>
+        <p:spPr>
+          <a:xfrm>
+            <a:off x="564642" y="6236018"/>
+            <a:ext cx="1821999" cy="264033"/>
+          </a:xfrm>
+          <a:prstGeom prst="rect">
+            <a:avLst/>
+          </a:prstGeom>
+          <a:noFill/>
+          <a:ln>
+            <a:noFill/>
+          </a:ln>
+        </p:spPr>
+        <p:txBody>
+          <a:bodyPr wrap="none" lIns="0" tIns="0" rIns="0" bIns="0" anchor="t" anchorCtr="0">
+            <a:spAutoFit/>
+          </a:bodyPr>
+          <a:lstStyle/>
+          <a:p>
+            <a:pPr algn="l"/>
+            <a:r>
+              <a:rPr lang="zh-CN" sz="1350" dirty="0">
+                <a:solidFill>
+                  <a:srgbClr val="DDEBFF"/>
+                </a:solidFill>
+                <a:latin typeface="Arial"/>
+                <a:ea typeface="Microsoft YaHei"/>
+                <a:cs typeface="Arial"/>
+              </a:rPr>
+              <a:t>批量更新 41 站 &lt;10ms</a:t>
+            </a:r>
+          </a:p>
+        </p:txBody>
+      </p:sp>
+      <p:sp>
+        <p:nvSpPr>
+          <p:cNvPr id="50" name="TextBox 50"/>
+          <p:cNvSpPr txBox="1"/>
+          <p:nvPr/>
+        </p:nvSpPr>
+        <p:spPr>
+          <a:xfrm>
+            <a:off x="4755642" y="6236018"/>
+            <a:ext cx="1649349" cy="264033"/>
+          </a:xfrm>
+          <a:prstGeom prst="rect">
+            <a:avLst/>
+          </a:prstGeom>
+          <a:noFill/>
+          <a:ln>
+            <a:noFill/>
+          </a:ln>
+        </p:spPr>
+        <p:txBody>
+          <a:bodyPr wrap="none" lIns="0" tIns="0" rIns="0" bIns="0" anchor="t" anchorCtr="0">
+            <a:spAutoFit/>
+          </a:bodyPr>
+          <a:lstStyle/>
+          <a:p>
+            <a:pPr algn="l"/>
+            <a:r>
+              <a:rPr lang="zh-CN" sz="1350" dirty="0">
+                <a:solidFill>
+                  <a:srgbClr val="DDEBFF"/>
+                </a:solidFill>
+                <a:latin typeface="Arial"/>
+                <a:ea typeface="Microsoft YaHei"/>
+                <a:cs typeface="Arial"/>
+              </a:rPr>
+              <a:t>受影响路径实时重算</a:t>
+            </a:r>
+          </a:p>
+        </p:txBody>
+      </p:sp>
+      <p:sp>
+        <p:nvSpPr>
+          <p:cNvPr id="51" name="TextBox 51"/>
+          <p:cNvSpPr txBox="1"/>
+          <p:nvPr/>
+        </p:nvSpPr>
+        <p:spPr>
+          <a:xfrm>
+            <a:off x="8565642" y="6236018"/>
+            <a:ext cx="2339950" cy="264033"/>
+          </a:xfrm>
+          <a:prstGeom prst="rect">
+            <a:avLst/>
+          </a:prstGeom>
+          <a:noFill/>
+          <a:ln>
+            <a:noFill/>
+          </a:ln>
+        </p:spPr>
+        <p:txBody>
+          <a:bodyPr wrap="none" lIns="0" tIns="0" rIns="0" bIns="0" anchor="t" anchorCtr="0">
+            <a:spAutoFit/>
+          </a:bodyPr>
+          <a:lstStyle/>
+          <a:p>
+            <a:pPr algn="l"/>
+            <a:r>
+              <a:rPr lang="zh-CN" sz="1350" dirty="0">
+                <a:solidFill>
+                  <a:srgbClr val="DDEBFF"/>
+                </a:solidFill>
+                <a:latin typeface="Arial"/>
+                <a:ea typeface="Microsoft YaHei"/>
+                <a:cs typeface="Arial"/>
+              </a:rPr>
+              <a:t>线程安全（shared_mutex）</a:t>
+            </a:r>
+          </a:p>
+        </p:txBody>
+      </p:sp>
+      <p:sp>
+        <p:nvSpPr>
+          <p:cNvPr id="52" name="TextBox 52"/>
+          <p:cNvSpPr txBox="1"/>
+          <p:nvPr/>
+        </p:nvSpPr>
+        <p:spPr>
+          <a:xfrm>
+            <a:off x="755904" y="5756910"/>
+            <a:ext cx="4002329" cy="234696"/>
+          </a:xfrm>
+          <a:prstGeom prst="rect">
+            <a:avLst/>
+          </a:prstGeom>
+          <a:noFill/>
+          <a:ln>
+            <a:noFill/>
+          </a:ln>
+        </p:spPr>
+        <p:txBody>
+          <a:bodyPr wrap="none" lIns="0" tIns="0" rIns="0" bIns="0" anchor="t" anchorCtr="0">
+            <a:spAutoFit/>
+          </a:bodyPr>
+          <a:lstStyle/>
+          <a:p>
+            <a:pPr algn="l"/>
+            <a:r>
+              <a:rPr lang="zh-CN" sz="1200" dirty="0">
+                <a:solidFill>
+                  <a:srgbClr val="B7C7DE"/>
+                </a:solidFill>
+                <a:latin typeface="Arial"/>
+                <a:ea typeface="Microsoft YaHei"/>
+                <a:cs typeface="Arial"/>
+              </a:rPr>
+              <a:t>但换乘边永不封锁 —— 换乘节点属同一物理站的不同平台</a:t>
+            </a:r>
+          </a:p>
+        </p:txBody>
+      </p:sp>
+    </p:spTree>
+  </p:cSld>
+  <p:clrMapOvr>
+    <a:masterClrMapping/>
+  </p:clrMapOvr>
+  <p:transition xmlns:p14="http://schemas.microsoft.com/office/powerpoint/2010/main" p14:dur="400">
+    <p:fade/>
+  </p:transition>
+</p:sld>
+</file>
+
+<file path=ppt/slides/slide6.xml><?xml version="1.0" encoding="utf-8"?>
+<p:sld xmlns:a="http://schemas.openxmlformats.org/drawingml/2006/main" xmlns:r="http://schemas.openxmlformats.org/officeDocument/2006/relationships" xmlns:p="http://schemas.openxmlformats.org/presentationml/2006/main">
+  <p:cSld>
+    <p:spTree>
+      <p:nvGrpSpPr>
+        <p:cNvPr id="1" name=""/>
+        <p:cNvGrpSpPr/>
+        <p:nvPr/>
+      </p:nvGrpSpPr>
+      <p:grpSpPr>
+        <a:xfrm>
+          <a:off x="0" y="0"/>
+          <a:ext cx="0" cy="0"/>
+          <a:chOff x="0" y="0"/>
+          <a:chExt cx="0" cy="0"/>
+        </a:xfrm>
+      </p:grpSpPr>
+      <p:sp>
+        <p:nvSpPr>
+          <p:cNvPr id="2" name="Rectangle 2"/>
+          <p:cNvSpPr/>
+          <p:nvPr/>
+        </p:nvSpPr>
+        <p:spPr>
+          <a:xfrm>
+            <a:off x="0" y="0"/>
+            <a:ext cx="12192000" cy="6858000"/>
+          </a:xfrm>
+          <a:prstGeom prst="rect">
+            <a:avLst/>
+          </a:prstGeom>
+          <a:solidFill>
+            <a:srgbClr val="0B1F3A"/>
+          </a:solidFill>
+          <a:ln>
+            <a:noFill/>
+          </a:ln>
+        </p:spPr>
+      </p:sp>
+      <p:sp>
+        <p:nvSpPr>
+          <p:cNvPr id="3" name="TextBox 3"/>
+          <p:cNvSpPr txBox="1"/>
+          <p:nvPr/>
+        </p:nvSpPr>
+        <p:spPr>
+          <a:xfrm>
+            <a:off x="745236" y="501015"/>
+            <a:ext cx="1899361" cy="645414"/>
+          </a:xfrm>
+          <a:prstGeom prst="rect">
+            <a:avLst/>
+          </a:prstGeom>
+          <a:noFill/>
+          <a:ln>
+            <a:noFill/>
+          </a:ln>
+        </p:spPr>
+        <p:txBody>
+          <a:bodyPr wrap="none" lIns="0" tIns="0" rIns="0" bIns="0" anchor="t" anchorCtr="0">
+            <a:spAutoFit/>
+          </a:bodyPr>
+          <a:lstStyle/>
+          <a:p>
+            <a:pPr algn="l"/>
+            <a:r>
+              <a:rPr lang="zh-CN" sz="3300" b="1" dirty="0">
+                <a:solidFill>
+                  <a:srgbClr val="FFFFFF"/>
+                </a:solidFill>
+                <a:latin typeface="Arial"/>
+                <a:ea typeface="Microsoft YaHei"/>
+                <a:cs typeface="Arial"/>
+              </a:rPr>
+              <a:t>网络分析</a:t>
+            </a:r>
+          </a:p>
+        </p:txBody>
+      </p:sp>
+      <p:sp>
+        <p:nvSpPr>
+          <p:cNvPr id="4" name="Line 4"/>
+          <p:cNvSpPr/>
+          <p:nvPr/>
+        </p:nvSpPr>
+        <p:spPr>
+          <a:xfrm>
+            <a:off x="762000" y="1047750"/>
+            <a:ext cx="10668000" cy="9525"/>
+          </a:xfrm>
+          <a:custGeom>
+            <a:avLst/>
+            <a:gdLst/>
+            <a:ahLst/>
+            <a:cxnLst/>
+            <a:rect l="l" t="t" r="r" b="b"/>
+            <a:pathLst>
+              <a:path w="10668000" h="9525">
+                <a:moveTo>
+                  <a:pt x="0" y="0"/>
+                </a:moveTo>
+                <a:lnTo>
+                  <a:pt x="10668000" y="0"/>
+                </a:lnTo>
+              </a:path>
+            </a:pathLst>
+          </a:custGeom>
+          <a:noFill/>
+          <a:ln w="28575" cap="rnd">
+            <a:solidFill>
+              <a:srgbClr val="E4002B"/>
+            </a:solidFill>
+          </a:ln>
+        </p:spPr>
+      </p:sp>
+      <p:sp>
+        <p:nvSpPr>
+          <p:cNvPr id="5" name="TextBox 5"/>
+          <p:cNvSpPr txBox="1"/>
+          <p:nvPr/>
+        </p:nvSpPr>
+        <p:spPr>
+          <a:xfrm>
+            <a:off x="755142" y="1187768"/>
+            <a:ext cx="2040084" cy="264033"/>
+          </a:xfrm>
+          <a:prstGeom prst="rect">
+            <a:avLst/>
+          </a:prstGeom>
+          <a:noFill/>
+          <a:ln>
+            <a:noFill/>
+          </a:ln>
+        </p:spPr>
+        <p:txBody>
+          <a:bodyPr wrap="none" lIns="0" tIns="0" rIns="0" bIns="0" anchor="t" anchorCtr="0">
+            <a:spAutoFit/>
+          </a:bodyPr>
+          <a:lstStyle/>
+          <a:p>
+            <a:pPr algn="l"/>
+            <a:r>
+              <a:rPr lang="zh-CN" sz="1350" dirty="0">
+                <a:solidFill>
+                  <a:srgbClr val="FFD54F"/>
+                </a:solidFill>
+                <a:latin typeface="Arial"/>
+                <a:ea typeface="Microsoft YaHei"/>
+                <a:cs typeface="Arial"/>
+              </a:rPr>
+              <a:t>对应课设：网络分析 5 分</a:t>
+            </a:r>
+          </a:p>
+        </p:txBody>
+      </p:sp>
+      <p:sp>
+        <p:nvSpPr>
+          <p:cNvPr id="6" name="Rectangle 6"/>
+          <p:cNvSpPr/>
+          <p:nvPr/>
+        </p:nvSpPr>
+        <p:spPr>
+          <a:xfrm>
+            <a:off x="571500" y="1666875"/>
+            <a:ext cx="5238750" cy="4429125"/>
+          </a:xfrm>
+          <a:prstGeom prst="roundRect">
+            <a:avLst>
+              <a:gd name="adj" fmla="val 2581"/>
+            </a:avLst>
+          </a:prstGeom>
+          <a:solidFill>
+            <a:srgbClr val="132846"/>
+          </a:solidFill>
+          <a:ln w="19050">
+            <a:solidFill>
+              <a:srgbClr val="1E3A5F"/>
+            </a:solidFill>
+          </a:ln>
+        </p:spPr>
+      </p:sp>
+      <p:sp>
+        <p:nvSpPr>
+          <p:cNvPr id="7" name="TextBox 7"/>
+          <p:cNvSpPr txBox="1"/>
+          <p:nvPr/>
+        </p:nvSpPr>
+        <p:spPr>
+          <a:xfrm>
+            <a:off x="751332" y="1821180"/>
+            <a:ext cx="2154083" cy="410718"/>
+          </a:xfrm>
+          <a:prstGeom prst="rect">
+            <a:avLst/>
+          </a:prstGeom>
+          <a:noFill/>
+          <a:ln>
+            <a:noFill/>
+          </a:ln>
+        </p:spPr>
+        <p:txBody>
+          <a:bodyPr wrap="none" lIns="0" tIns="0" rIns="0" bIns="0" anchor="t" anchorCtr="0">
+            <a:spAutoFit/>
+          </a:bodyPr>
+          <a:lstStyle/>
+          <a:p>
+            <a:pPr algn="l"/>
+            <a:r>
+              <a:rPr lang="zh-CN" sz="2100" b="1" dirty="0">
+                <a:solidFill>
+                  <a:srgbClr val="FFD54F"/>
+                </a:solidFill>
+                <a:latin typeface="Arial"/>
+                <a:ea typeface="Microsoft YaHei"/>
+                <a:cs typeface="Arial"/>
+              </a:rPr>
+              <a:t>🌐 BFS 影响范围</a:t>
+            </a:r>
+          </a:p>
+        </p:txBody>
+      </p:sp>
+      <p:sp>
+        <p:nvSpPr>
+          <p:cNvPr id="8" name="TextBox 8"/>
+          <p:cNvSpPr txBox="1"/>
+          <p:nvPr/>
+        </p:nvSpPr>
+        <p:spPr>
+          <a:xfrm>
+            <a:off x="755904" y="2251710"/>
+            <a:ext cx="2748890" cy="234696"/>
+          </a:xfrm>
+          <a:prstGeom prst="rect">
+            <a:avLst/>
+          </a:prstGeom>
+          <a:noFill/>
+          <a:ln>
+            <a:noFill/>
+          </a:ln>
+        </p:spPr>
+        <p:txBody>
+          <a:bodyPr wrap="none" lIns="0" tIns="0" rIns="0" bIns="0" anchor="t" anchorCtr="0">
+            <a:spAutoFit/>
+          </a:bodyPr>
+          <a:lstStyle/>
+          <a:p>
+            <a:pPr algn="l"/>
+            <a:r>
+              <a:rPr lang="en-US" sz="1200" dirty="0">
+                <a:solidFill>
+                  <a:srgbClr val="FFD54F"/>
+                </a:solidFill>
+                <a:latin typeface="Consolas"/>
+                <a:ea typeface="Consolas"/>
+                <a:cs typeface="Consolas"/>
+              </a:rPr>
+              <a:t>POST /api/analysis/affected-area</a:t>
+            </a:r>
+          </a:p>
+        </p:txBody>
+      </p:sp>
+      <p:sp>
+        <p:nvSpPr>
+          <p:cNvPr id="9" name="TextBox 9"/>
+          <p:cNvSpPr txBox="1"/>
+          <p:nvPr/>
+        </p:nvSpPr>
+        <p:spPr>
+          <a:xfrm>
+            <a:off x="756666" y="2706052"/>
+            <a:ext cx="2279352" cy="205359"/>
+          </a:xfrm>
+          <a:prstGeom prst="rect">
+            <a:avLst/>
+          </a:prstGeom>
+          <a:noFill/>
+          <a:ln>
+            <a:noFill/>
+          </a:ln>
+        </p:spPr>
+        <p:txBody>
+          <a:bodyPr wrap="none" lIns="0" tIns="0" rIns="0" bIns="0" anchor="t" anchorCtr="0">
+            <a:spAutoFit/>
+          </a:bodyPr>
+          <a:lstStyle/>
+          <a:p>
+            <a:pPr algn="l"/>
+            <a:r>
+              <a:rPr lang="en-US" sz="1050" dirty="0">
+                <a:solidFill>
+                  <a:srgbClr val="DDEBFF"/>
+                </a:solidFill>
+                <a:latin typeface="Consolas"/>
+                <a:ea typeface="Consolas"/>
+                <a:cs typeface="Consolas"/>
+              </a:rPr>
+              <a:t>std::queue&lt;pair&lt;string,int&gt;&gt; q;</a:t>
+            </a:r>
+          </a:p>
+        </p:txBody>
+      </p:sp>
+      <p:sp>
+        <p:nvSpPr>
+          <p:cNvPr id="10" name="TextBox 10"/>
+          <p:cNvSpPr txBox="1"/>
+          <p:nvPr/>
+        </p:nvSpPr>
+        <p:spPr>
+          <a:xfrm>
+            <a:off x="756666" y="2877502"/>
+            <a:ext cx="1452448" cy="205359"/>
+          </a:xfrm>
+          <a:prstGeom prst="rect">
+            <a:avLst/>
+          </a:prstGeom>
+          <a:noFill/>
+          <a:ln>
+            <a:noFill/>
+          </a:ln>
+        </p:spPr>
+        <p:txBody>
+          <a:bodyPr wrap="none" lIns="0" tIns="0" rIns="0" bIns="0" anchor="t" anchorCtr="0">
+            <a:spAutoFit/>
+          </a:bodyPr>
+          <a:lstStyle/>
+          <a:p>
+            <a:pPr algn="l"/>
+            <a:r>
+              <a:rPr lang="en-US" sz="1050" dirty="0">
+                <a:solidFill>
+                  <a:srgbClr val="DDEBFF"/>
+                </a:solidFill>
+                <a:latin typeface="Consolas"/>
+                <a:ea typeface="Consolas"/>
+                <a:cs typeface="Consolas"/>
+              </a:rPr>
+              <a:t>q.push({start, 0});</a:t>
+            </a:r>
+          </a:p>
+        </p:txBody>
+      </p:sp>
+      <p:sp>
+        <p:nvSpPr>
+          <p:cNvPr id="11" name="TextBox 11"/>
+          <p:cNvSpPr txBox="1"/>
+          <p:nvPr/>
+        </p:nvSpPr>
+        <p:spPr>
+          <a:xfrm>
+            <a:off x="756666" y="3048952"/>
+            <a:ext cx="1615002" cy="205359"/>
+          </a:xfrm>
+          <a:prstGeom prst="rect">
+            <a:avLst/>
+          </a:prstGeom>
+          <a:noFill/>
+          <a:ln>
+            <a:noFill/>
+          </a:ln>
+        </p:spPr>
+        <p:txBody>
+          <a:bodyPr wrap="none" lIns="0" tIns="0" rIns="0" bIns="0" anchor="t" anchorCtr="0">
+            <a:spAutoFit/>
+          </a:bodyPr>
+          <a:lstStyle/>
+          <a:p>
+            <a:pPr algn="l"/>
+            <a:r>
+              <a:rPr lang="en-US" sz="1050" dirty="0">
+                <a:solidFill>
+                  <a:srgbClr val="DDEBFF"/>
+                </a:solidFill>
+                <a:latin typeface="Consolas"/>
+                <a:ea typeface="Consolas"/>
+                <a:cs typeface="Consolas"/>
+              </a:rPr>
+              <a:t>visited.insert(start);</a:t>
+            </a:r>
+          </a:p>
+        </p:txBody>
+      </p:sp>
+      <p:sp>
+        <p:nvSpPr>
+          <p:cNvPr id="12" name="TextBox 12"/>
+          <p:cNvSpPr txBox="1"/>
+          <p:nvPr/>
+        </p:nvSpPr>
+        <p:spPr>
+          <a:xfrm>
+            <a:off x="756666" y="3220402"/>
+            <a:ext cx="1445381" cy="205359"/>
+          </a:xfrm>
+          <a:prstGeom prst="rect">
+            <a:avLst/>
+          </a:prstGeom>
+          <a:noFill/>
+          <a:ln>
+            <a:noFill/>
+          </a:ln>
+        </p:spPr>
+        <p:txBody>
+          <a:bodyPr wrap="none" lIns="0" tIns="0" rIns="0" bIns="0" anchor="t" anchorCtr="0">
+            <a:spAutoFit/>
+          </a:bodyPr>
+          <a:lstStyle/>
+          <a:p>
+            <a:pPr algn="l"/>
+            <a:r>
+              <a:rPr lang="en-US" sz="1050" dirty="0">
+                <a:solidFill>
+                  <a:srgbClr val="DDEBFF"/>
+                </a:solidFill>
+                <a:latin typeface="Consolas"/>
+                <a:ea typeface="Consolas"/>
+                <a:cs typeface="Consolas"/>
+              </a:rPr>
+              <a:t>while (!q.empty()) {</a:t>
+            </a:r>
+          </a:p>
+        </p:txBody>
+      </p:sp>
+      <p:sp>
+        <p:nvSpPr>
+          <p:cNvPr id="13" name="TextBox 13"/>
+          <p:cNvSpPr txBox="1"/>
+          <p:nvPr/>
+        </p:nvSpPr>
+        <p:spPr>
+          <a:xfrm>
+            <a:off x="756666" y="3391852"/>
+            <a:ext cx="2399500" cy="205359"/>
+          </a:xfrm>
+          <a:prstGeom prst="rect">
+            <a:avLst/>
+          </a:prstGeom>
+          <a:noFill/>
+          <a:ln>
+            <a:noFill/>
+          </a:ln>
+        </p:spPr>
+        <p:txBody>
+          <a:bodyPr wrap="none" lIns="0" tIns="0" rIns="0" bIns="0" anchor="t" anchorCtr="0">
+            <a:spAutoFit/>
+          </a:bodyPr>
+          <a:lstStyle/>
+          <a:p>
+            <a:pPr algn="l"/>
+            <a:r>
+              <a:rPr lang="en-US" sz="1050" dirty="0">
+                <a:solidFill>
+                  <a:srgbClr val="DDEBFF"/>
+                </a:solidFill>
+                <a:latin typeface="Consolas"/>
+                <a:ea typeface="Consolas"/>
+                <a:cs typeface="Consolas"/>
+              </a:rPr>
+              <a:t>auto [u, d] = q.front(); q.pop();</a:t>
+            </a:r>
+          </a:p>
+        </p:txBody>
+      </p:sp>
+      <p:sp>
+        <p:nvSpPr>
+          <p:cNvPr id="14" name="TextBox 14"/>
+          <p:cNvSpPr txBox="1"/>
+          <p:nvPr/>
+        </p:nvSpPr>
+        <p:spPr>
+          <a:xfrm>
+            <a:off x="756666" y="3563302"/>
+            <a:ext cx="1431246" cy="205359"/>
+          </a:xfrm>
+          <a:prstGeom prst="rect">
+            <a:avLst/>
+          </a:prstGeom>
+          <a:noFill/>
+          <a:ln>
+            <a:noFill/>
+          </a:ln>
+        </p:spPr>
+        <p:txBody>
+          <a:bodyPr wrap="none" lIns="0" tIns="0" rIns="0" bIns="0" anchor="t" anchorCtr="0">
+            <a:spAutoFit/>
+          </a:bodyPr>
+          <a:lstStyle/>
+          <a:p>
+            <a:pPr algn="l"/>
+            <a:r>
+              <a:rPr lang="en-US" sz="1050" dirty="0">
+                <a:solidFill>
+                  <a:srgbClr val="DDEBFF"/>
+                </a:solidFill>
+                <a:latin typeface="Consolas"/>
+                <a:ea typeface="Consolas"/>
+                <a:cs typeface="Consolas"/>
+              </a:rPr>
+              <a:t>if (d == k) continue;</a:t>
+            </a:r>
+          </a:p>
+        </p:txBody>
+      </p:sp>
+      <p:sp>
+        <p:nvSpPr>
+          <p:cNvPr id="15" name="TextBox 15"/>
+          <p:cNvSpPr txBox="1"/>
+          <p:nvPr/>
+        </p:nvSpPr>
+        <p:spPr>
+          <a:xfrm>
+            <a:off x="756666" y="3734752"/>
+            <a:ext cx="2116798" cy="205359"/>
+          </a:xfrm>
+          <a:prstGeom prst="rect">
+            <a:avLst/>
+          </a:prstGeom>
+          <a:noFill/>
+          <a:ln>
+            <a:noFill/>
+          </a:ln>
+        </p:spPr>
+        <p:txBody>
+          <a:bodyPr wrap="none" lIns="0" tIns="0" rIns="0" bIns="0" anchor="t" anchorCtr="0">
+            <a:spAutoFit/>
+          </a:bodyPr>
+          <a:lstStyle/>
+          <a:p>
+            <a:pPr algn="l"/>
+            <a:r>
+              <a:rPr lang="en-US" sz="1050" dirty="0">
+                <a:solidFill>
+                  <a:srgbClr val="DDEBFF"/>
+                </a:solidFill>
+                <a:latin typeface="Consolas"/>
+                <a:ea typeface="Consolas"/>
+                <a:cs typeface="Consolas"/>
+              </a:rPr>
+              <a:t>for (e : g.neighbors(u, mgr))</a:t>
+            </a:r>
+          </a:p>
+        </p:txBody>
+      </p:sp>
+      <p:sp>
+        <p:nvSpPr>
+          <p:cNvPr id="16" name="TextBox 16"/>
+          <p:cNvSpPr txBox="1"/>
+          <p:nvPr/>
+        </p:nvSpPr>
+        <p:spPr>
+          <a:xfrm>
+            <a:off x="756666" y="3906202"/>
+            <a:ext cx="2321757" cy="205359"/>
+          </a:xfrm>
+          <a:prstGeom prst="rect">
+            <a:avLst/>
+          </a:prstGeom>
+          <a:noFill/>
+          <a:ln>
+            <a:noFill/>
+          </a:ln>
+        </p:spPr>
+        <p:txBody>
+          <a:bodyPr wrap="none" lIns="0" tIns="0" rIns="0" bIns="0" anchor="t" anchorCtr="0">
+            <a:spAutoFit/>
+          </a:bodyPr>
+          <a:lstStyle/>
+          <a:p>
+            <a:pPr algn="l"/>
+            <a:r>
+              <a:rPr lang="en-US" sz="1050" dirty="0">
+                <a:solidFill>
+                  <a:srgbClr val="DDEBFF"/>
+                </a:solidFill>
+                <a:latin typeface="Consolas"/>
+                <a:ea typeface="Consolas"/>
+                <a:cs typeface="Consolas"/>
+              </a:rPr>
+              <a:t>if (visited.insert(e.to).second)</a:t>
+            </a:r>
+          </a:p>
+        </p:txBody>
+      </p:sp>
+      <p:sp>
+        <p:nvSpPr>
+          <p:cNvPr id="17" name="TextBox 17"/>
+          <p:cNvSpPr txBox="1"/>
+          <p:nvPr/>
+        </p:nvSpPr>
+        <p:spPr>
+          <a:xfrm>
+            <a:off x="756666" y="4077652"/>
+            <a:ext cx="1530191" cy="205359"/>
+          </a:xfrm>
+          <a:prstGeom prst="rect">
+            <a:avLst/>
+          </a:prstGeom>
+          <a:noFill/>
+          <a:ln>
+            <a:noFill/>
+          </a:ln>
+        </p:spPr>
+        <p:txBody>
+          <a:bodyPr wrap="none" lIns="0" tIns="0" rIns="0" bIns="0" anchor="t" anchorCtr="0">
+            <a:spAutoFit/>
+          </a:bodyPr>
+          <a:lstStyle/>
+          <a:p>
+            <a:pPr algn="l"/>
+            <a:r>
+              <a:rPr lang="en-US" sz="1050" dirty="0">
+                <a:solidFill>
+                  <a:srgbClr val="DDEBFF"/>
+                </a:solidFill>
+                <a:latin typeface="Consolas"/>
+                <a:ea typeface="Consolas"/>
+                <a:cs typeface="Consolas"/>
+              </a:rPr>
+              <a:t>q.push({e.to, d+1});</a:t>
+            </a:r>
+          </a:p>
+        </p:txBody>
+      </p:sp>
+      <p:sp>
+        <p:nvSpPr>
+          <p:cNvPr id="18" name="TextBox 18"/>
+          <p:cNvSpPr txBox="1"/>
+          <p:nvPr/>
+        </p:nvSpPr>
+        <p:spPr>
+          <a:xfrm>
+            <a:off x="756666" y="4249102"/>
+            <a:ext cx="88411" cy="205359"/>
+          </a:xfrm>
+          <a:prstGeom prst="rect">
+            <a:avLst/>
+          </a:prstGeom>
+          <a:noFill/>
+          <a:ln>
+            <a:noFill/>
+          </a:ln>
+        </p:spPr>
+        <p:txBody>
+          <a:bodyPr wrap="none" lIns="0" tIns="0" rIns="0" bIns="0" anchor="t" anchorCtr="0">
+            <a:spAutoFit/>
+          </a:bodyPr>
+          <a:lstStyle/>
+          <a:p>
+            <a:pPr algn="l"/>
+            <a:r>
+              <a:rPr lang="en-US" sz="1050" dirty="0">
+                <a:solidFill>
+                  <a:srgbClr val="DDEBFF"/>
+                </a:solidFill>
+                <a:latin typeface="Consolas"/>
+                <a:ea typeface="Consolas"/>
+                <a:cs typeface="Consolas"/>
+              </a:rPr>
+              <a:t>}</a:t>
+            </a:r>
+          </a:p>
+        </p:txBody>
+      </p:sp>
+      <p:sp>
+        <p:nvSpPr>
+          <p:cNvPr id="19" name="TextBox 19"/>
+          <p:cNvSpPr txBox="1"/>
+          <p:nvPr/>
+        </p:nvSpPr>
+        <p:spPr>
+          <a:xfrm>
+            <a:off x="754380" y="4314825"/>
+            <a:ext cx="2564892" cy="293370"/>
+          </a:xfrm>
+          <a:prstGeom prst="rect">
+            <a:avLst/>
+          </a:prstGeom>
+          <a:noFill/>
+          <a:ln>
+            <a:noFill/>
+          </a:ln>
+        </p:spPr>
+        <p:txBody>
+          <a:bodyPr wrap="none" lIns="0" tIns="0" rIns="0" bIns="0" anchor="t" anchorCtr="0">
+            <a:spAutoFit/>
+          </a:bodyPr>
+          <a:lstStyle/>
+          <a:p>
+            <a:pPr algn="l"/>
+            <a:r>
+              <a:rPr lang="zh-CN" sz="1500" dirty="0">
+                <a:solidFill>
+                  <a:srgbClr val="FFFFFF"/>
+                </a:solidFill>
+                <a:latin typeface="Arial"/>
+                <a:ea typeface="Microsoft YaHei"/>
+                <a:cs typeface="Arial"/>
+              </a:rPr>
+              <a:t>示例：关闭人民广场后 K=2</a:t>
+            </a:r>
+          </a:p>
+        </p:txBody>
+      </p:sp>
+      <p:sp>
+        <p:nvSpPr>
+          <p:cNvPr id="20" name="TextBox 20"/>
+          <p:cNvSpPr txBox="1"/>
+          <p:nvPr/>
+        </p:nvSpPr>
+        <p:spPr>
+          <a:xfrm>
+            <a:off x="755904" y="4632960"/>
+            <a:ext cx="1878025" cy="234696"/>
+          </a:xfrm>
+          <a:prstGeom prst="rect">
+            <a:avLst/>
+          </a:prstGeom>
+          <a:noFill/>
+          <a:ln>
+            <a:noFill/>
+          </a:ln>
+        </p:spPr>
+        <p:txBody>
+          <a:bodyPr wrap="none" lIns="0" tIns="0" rIns="0" bIns="0" anchor="t" anchorCtr="0">
+            <a:spAutoFit/>
+          </a:bodyPr>
+          <a:lstStyle/>
+          <a:p>
+            <a:pPr algn="l"/>
+            <a:r>
+              <a:rPr lang="zh-CN" sz="1200" dirty="0">
+                <a:solidFill>
+                  <a:srgbClr val="B7C7DE"/>
+                </a:solidFill>
+                <a:latin typeface="Arial"/>
+                <a:ea typeface="Microsoft YaHei"/>
+                <a:cs typeface="Arial"/>
+              </a:rPr>
+              <a:t>→ 影响范围包含相邻 12 站</a:t>
+            </a:r>
+          </a:p>
+        </p:txBody>
+      </p:sp>
+      <p:sp>
+        <p:nvSpPr>
+          <p:cNvPr id="21" name="TextBox 21"/>
+          <p:cNvSpPr txBox="1"/>
+          <p:nvPr/>
+        </p:nvSpPr>
+        <p:spPr>
+          <a:xfrm>
+            <a:off x="755142" y="4997768"/>
+            <a:ext cx="2856631" cy="264033"/>
+          </a:xfrm>
+          <a:prstGeom prst="rect">
+            <a:avLst/>
+          </a:prstGeom>
+          <a:noFill/>
+          <a:ln>
+            <a:noFill/>
+          </a:ln>
+        </p:spPr>
+        <p:txBody>
+          <a:bodyPr wrap="none" lIns="0" tIns="0" rIns="0" bIns="0" anchor="t" anchorCtr="0">
+            <a:spAutoFit/>
+          </a:bodyPr>
+          <a:lstStyle/>
+          <a:p>
+            <a:pPr algn="l"/>
+            <a:r>
+              <a:rPr lang="zh-CN" sz="1350" b="1" dirty="0">
+                <a:solidFill>
+                  <a:srgbClr val="FFD54F"/>
+                </a:solidFill>
+                <a:latin typeface="Arial"/>
+                <a:ea typeface="Microsoft YaHei"/>
+                <a:cs typeface="Arial"/>
+              </a:rPr>
+              <a:t>复杂度 O(V+E) · 访问 K 阶邻居</a:t>
+            </a:r>
+          </a:p>
+        </p:txBody>
+      </p:sp>
+      <p:sp>
+        <p:nvSpPr>
+          <p:cNvPr id="22" name="Rectangle 22"/>
+          <p:cNvSpPr/>
+          <p:nvPr/>
+        </p:nvSpPr>
+        <p:spPr>
+          <a:xfrm>
+            <a:off x="6381750" y="1666875"/>
+            <a:ext cx="5238750" cy="4429125"/>
+          </a:xfrm>
+          <a:prstGeom prst="roundRect">
+            <a:avLst>
+              <a:gd name="adj" fmla="val 2581"/>
+            </a:avLst>
+          </a:prstGeom>
+          <a:solidFill>
+            <a:srgbClr val="132846"/>
+          </a:solidFill>
+          <a:ln w="19050">
+            <a:solidFill>
+              <a:srgbClr val="1E3A5F"/>
+            </a:solidFill>
+          </a:ln>
+        </p:spPr>
+      </p:sp>
+      <p:sp>
+        <p:nvSpPr>
+          <p:cNvPr id="23" name="TextBox 23"/>
+          <p:cNvSpPr txBox="1"/>
+          <p:nvPr/>
+        </p:nvSpPr>
+        <p:spPr>
+          <a:xfrm>
+            <a:off x="6561582" y="1821180"/>
+            <a:ext cx="2154083" cy="410718"/>
+          </a:xfrm>
+          <a:prstGeom prst="rect">
+            <a:avLst/>
+          </a:prstGeom>
+          <a:noFill/>
+          <a:ln>
+            <a:noFill/>
+          </a:ln>
+        </p:spPr>
+        <p:txBody>
+          <a:bodyPr wrap="none" lIns="0" tIns="0" rIns="0" bIns="0" anchor="t" anchorCtr="0">
+            <a:spAutoFit/>
+          </a:bodyPr>
+          <a:lstStyle/>
+          <a:p>
+            <a:pPr algn="l"/>
+            <a:r>
+              <a:rPr lang="zh-CN" sz="2100" b="1" dirty="0">
+                <a:solidFill>
+                  <a:srgbClr val="FFD54F"/>
+                </a:solidFill>
+                <a:latin typeface="Arial"/>
+                <a:ea typeface="Microsoft YaHei"/>
+                <a:cs typeface="Arial"/>
+              </a:rPr>
+              <a:t>🔗 DFS 连通分量</a:t>
+            </a:r>
+          </a:p>
+        </p:txBody>
+      </p:sp>
+      <p:sp>
+        <p:nvSpPr>
+          <p:cNvPr id="24" name="TextBox 24"/>
+          <p:cNvSpPr txBox="1"/>
+          <p:nvPr/>
+        </p:nvSpPr>
+        <p:spPr>
+          <a:xfrm>
+            <a:off x="6566154" y="2251710"/>
+            <a:ext cx="2387422" cy="234696"/>
+          </a:xfrm>
+          <a:prstGeom prst="rect">
+            <a:avLst/>
+          </a:prstGeom>
+          <a:noFill/>
+          <a:ln>
+            <a:noFill/>
+          </a:ln>
+        </p:spPr>
+        <p:txBody>
+          <a:bodyPr wrap="none" lIns="0" tIns="0" rIns="0" bIns="0" anchor="t" anchorCtr="0">
+            <a:spAutoFit/>
+          </a:bodyPr>
+          <a:lstStyle/>
+          <a:p>
+            <a:pPr algn="l"/>
+            <a:r>
+              <a:rPr lang="en-US" sz="1200" dirty="0">
+                <a:solidFill>
+                  <a:srgbClr val="FFD54F"/>
+                </a:solidFill>
+                <a:latin typeface="Consolas"/>
+                <a:ea typeface="Consolas"/>
+                <a:cs typeface="Consolas"/>
+              </a:rPr>
+              <a:t>GET /api/analysis/components</a:t>
+            </a:r>
+          </a:p>
+        </p:txBody>
+      </p:sp>
+      <p:sp>
+        <p:nvSpPr>
+          <p:cNvPr id="25" name="TextBox 25"/>
+          <p:cNvSpPr txBox="1"/>
+          <p:nvPr/>
+        </p:nvSpPr>
+        <p:spPr>
+          <a:xfrm>
+            <a:off x="6566916" y="2706052"/>
+            <a:ext cx="2258149" cy="205359"/>
+          </a:xfrm>
+          <a:prstGeom prst="rect">
+            <a:avLst/>
+          </a:prstGeom>
+          <a:noFill/>
+          <a:ln>
+            <a:noFill/>
+          </a:ln>
+        </p:spPr>
+        <p:txBody>
+          <a:bodyPr wrap="none" lIns="0" tIns="0" rIns="0" bIns="0" anchor="t" anchorCtr="0">
+            <a:spAutoFit/>
+          </a:bodyPr>
+          <a:lstStyle/>
+          <a:p>
+            <a:pPr algn="l"/>
+            <a:r>
+              <a:rPr lang="en-US" sz="1050" dirty="0">
+                <a:solidFill>
+                  <a:srgbClr val="DDEBFF"/>
+                </a:solidFill>
+                <a:latin typeface="Consolas"/>
+                <a:ea typeface="Consolas"/>
+                <a:cs typeface="Consolas"/>
+              </a:rPr>
+              <a:t>int count_components(g, mgr) {</a:t>
+            </a:r>
+          </a:p>
+        </p:txBody>
+      </p:sp>
+      <p:sp>
+        <p:nvSpPr>
+          <p:cNvPr id="26" name="TextBox 26"/>
+          <p:cNvSpPr txBox="1"/>
+          <p:nvPr/>
+        </p:nvSpPr>
+        <p:spPr>
+          <a:xfrm>
+            <a:off x="6566916" y="2877502"/>
+            <a:ext cx="802234" cy="205359"/>
+          </a:xfrm>
+          <a:prstGeom prst="rect">
+            <a:avLst/>
+          </a:prstGeom>
+          <a:noFill/>
+          <a:ln>
+            <a:noFill/>
+          </a:ln>
+        </p:spPr>
+        <p:txBody>
+          <a:bodyPr wrap="none" lIns="0" tIns="0" rIns="0" bIns="0" anchor="t" anchorCtr="0">
+            <a:spAutoFit/>
+          </a:bodyPr>
+          <a:lstStyle/>
+          <a:p>
+            <a:pPr algn="l"/>
+            <a:r>
+              <a:rPr lang="en-US" sz="1050" dirty="0">
+                <a:solidFill>
+                  <a:srgbClr val="DDEBFF"/>
+                </a:solidFill>
+                <a:latin typeface="Consolas"/>
+                <a:ea typeface="Consolas"/>
+                <a:cs typeface="Consolas"/>
+              </a:rPr>
+              <a:t>int cnt = 0;</a:t>
+            </a:r>
+          </a:p>
+        </p:txBody>
+      </p:sp>
+      <p:sp>
+        <p:nvSpPr>
+          <p:cNvPr id="27" name="TextBox 27"/>
+          <p:cNvSpPr txBox="1"/>
+          <p:nvPr/>
+        </p:nvSpPr>
+        <p:spPr>
+          <a:xfrm>
+            <a:off x="6566916" y="3048952"/>
+            <a:ext cx="1473651" cy="205359"/>
+          </a:xfrm>
+          <a:prstGeom prst="rect">
+            <a:avLst/>
+          </a:prstGeom>
+          <a:noFill/>
+          <a:ln>
+            <a:noFill/>
+          </a:ln>
+        </p:spPr>
+        <p:txBody>
+          <a:bodyPr wrap="none" lIns="0" tIns="0" rIns="0" bIns="0" anchor="t" anchorCtr="0">
+            <a:spAutoFit/>
+          </a:bodyPr>
+          <a:lstStyle/>
+          <a:p>
+            <a:pPr algn="l"/>
+            <a:r>
+              <a:rPr lang="en-US" sz="1050" dirty="0">
+                <a:solidFill>
+                  <a:srgbClr val="DDEBFF"/>
+                </a:solidFill>
+                <a:latin typeface="Consolas"/>
+                <a:ea typeface="Consolas"/>
+                <a:cs typeface="Consolas"/>
+              </a:rPr>
+              <a:t>for (id : g.all_ids())</a:t>
+            </a:r>
+          </a:p>
+        </p:txBody>
+      </p:sp>
+      <p:sp>
+        <p:nvSpPr>
+          <p:cNvPr id="28" name="TextBox 28"/>
+          <p:cNvSpPr txBox="1"/>
+          <p:nvPr/>
+        </p:nvSpPr>
+        <p:spPr>
+          <a:xfrm>
+            <a:off x="6566916" y="3220402"/>
+            <a:ext cx="2067325" cy="205359"/>
+          </a:xfrm>
+          <a:prstGeom prst="rect">
+            <a:avLst/>
+          </a:prstGeom>
+          <a:noFill/>
+          <a:ln>
+            <a:noFill/>
+          </a:ln>
+        </p:spPr>
+        <p:txBody>
+          <a:bodyPr wrap="none" lIns="0" tIns="0" rIns="0" bIns="0" anchor="t" anchorCtr="0">
+            <a:spAutoFit/>
+          </a:bodyPr>
+          <a:lstStyle/>
+          <a:p>
+            <a:pPr algn="l"/>
+            <a:r>
+              <a:rPr lang="en-US" sz="1050" dirty="0">
+                <a:solidFill>
+                  <a:srgbClr val="DDEBFF"/>
+                </a:solidFill>
+                <a:latin typeface="Consolas"/>
+                <a:ea typeface="Consolas"/>
+                <a:cs typeface="Consolas"/>
+              </a:rPr>
+              <a:t>if (open(id) &amp;&amp; !visited[id]) {</a:t>
+            </a:r>
+          </a:p>
+        </p:txBody>
+      </p:sp>
+      <p:sp>
+        <p:nvSpPr>
+          <p:cNvPr id="29" name="TextBox 29"/>
+          <p:cNvSpPr txBox="1"/>
+          <p:nvPr/>
+        </p:nvSpPr>
+        <p:spPr>
+          <a:xfrm>
+            <a:off x="6566916" y="3391852"/>
+            <a:ext cx="1770488" cy="205359"/>
+          </a:xfrm>
+          <a:prstGeom prst="rect">
+            <a:avLst/>
+          </a:prstGeom>
+          <a:noFill/>
+          <a:ln>
+            <a:noFill/>
+          </a:ln>
+        </p:spPr>
+        <p:txBody>
+          <a:bodyPr wrap="none" lIns="0" tIns="0" rIns="0" bIns="0" anchor="t" anchorCtr="0">
+            <a:spAutoFit/>
+          </a:bodyPr>
+          <a:lstStyle/>
+          <a:p>
+            <a:pPr algn="l"/>
+            <a:r>
+              <a:rPr lang="en-US" sz="1050" dirty="0">
+                <a:solidFill>
+                  <a:srgbClr val="DDEBFF"/>
+                </a:solidFill>
+                <a:latin typeface="Consolas"/>
+                <a:ea typeface="Consolas"/>
+                <a:cs typeface="Consolas"/>
+              </a:rPr>
+              <a:t>dfs(id, visited, g, mgr);</a:t>
+            </a:r>
+          </a:p>
+        </p:txBody>
+      </p:sp>
+      <p:sp>
+        <p:nvSpPr>
+          <p:cNvPr id="30" name="TextBox 30"/>
+          <p:cNvSpPr txBox="1"/>
+          <p:nvPr/>
+        </p:nvSpPr>
+        <p:spPr>
+          <a:xfrm>
+            <a:off x="6566916" y="3563302"/>
+            <a:ext cx="477126" cy="205359"/>
+          </a:xfrm>
+          <a:prstGeom prst="rect">
+            <a:avLst/>
+          </a:prstGeom>
+          <a:noFill/>
+          <a:ln>
+            <a:noFill/>
+          </a:ln>
+        </p:spPr>
+        <p:txBody>
+          <a:bodyPr wrap="none" lIns="0" tIns="0" rIns="0" bIns="0" anchor="t" anchorCtr="0">
+            <a:spAutoFit/>
+          </a:bodyPr>
+          <a:lstStyle/>
+          <a:p>
+            <a:pPr algn="l"/>
+            <a:r>
+              <a:rPr lang="en-US" sz="1050" dirty="0">
+                <a:solidFill>
+                  <a:srgbClr val="DDEBFF"/>
+                </a:solidFill>
+                <a:latin typeface="Consolas"/>
+                <a:ea typeface="Consolas"/>
+                <a:cs typeface="Consolas"/>
+              </a:rPr>
+              <a:t>cnt++;</a:t>
+            </a:r>
+          </a:p>
+        </p:txBody>
+      </p:sp>
+      <p:sp>
+        <p:nvSpPr>
+          <p:cNvPr id="31" name="TextBox 31"/>
+          <p:cNvSpPr txBox="1"/>
+          <p:nvPr/>
+        </p:nvSpPr>
+        <p:spPr>
+          <a:xfrm>
+            <a:off x="6566916" y="3734752"/>
+            <a:ext cx="88411" cy="205359"/>
+          </a:xfrm>
+          <a:prstGeom prst="rect">
+            <a:avLst/>
+          </a:prstGeom>
+          <a:noFill/>
+          <a:ln>
+            <a:noFill/>
+          </a:ln>
+        </p:spPr>
+        <p:txBody>
+          <a:bodyPr wrap="none" lIns="0" tIns="0" rIns="0" bIns="0" anchor="t" anchorCtr="0">
+            <a:spAutoFit/>
+          </a:bodyPr>
+          <a:lstStyle/>
+          <a:p>
+            <a:pPr algn="l"/>
+            <a:r>
+              <a:rPr lang="en-US" sz="1050" dirty="0">
+                <a:solidFill>
+                  <a:srgbClr val="DDEBFF"/>
+                </a:solidFill>
+                <a:latin typeface="Consolas"/>
+                <a:ea typeface="Consolas"/>
+                <a:cs typeface="Consolas"/>
+              </a:rPr>
+              <a:t>}</a:t>
+            </a:r>
+          </a:p>
+        </p:txBody>
+      </p:sp>
+      <p:sp>
+        <p:nvSpPr>
+          <p:cNvPr id="32" name="TextBox 32"/>
+          <p:cNvSpPr txBox="1"/>
+          <p:nvPr/>
+        </p:nvSpPr>
+        <p:spPr>
+          <a:xfrm>
+            <a:off x="6566916" y="3906202"/>
+            <a:ext cx="830504" cy="205359"/>
+          </a:xfrm>
+          <a:prstGeom prst="rect">
+            <a:avLst/>
+          </a:prstGeom>
+          <a:noFill/>
+          <a:ln>
+            <a:noFill/>
+          </a:ln>
+        </p:spPr>
+        <p:txBody>
+          <a:bodyPr wrap="none" lIns="0" tIns="0" rIns="0" bIns="0" anchor="t" anchorCtr="0">
+            <a:spAutoFit/>
+          </a:bodyPr>
+          <a:lstStyle/>
+          <a:p>
+            <a:pPr algn="l"/>
+            <a:r>
+              <a:rPr lang="en-US" sz="1050" dirty="0">
+                <a:solidFill>
+                  <a:srgbClr val="DDEBFF"/>
+                </a:solidFill>
+                <a:latin typeface="Consolas"/>
+                <a:ea typeface="Consolas"/>
+                <a:cs typeface="Consolas"/>
+              </a:rPr>
+              <a:t>return cnt;</a:t>
+            </a:r>
+          </a:p>
+        </p:txBody>
+      </p:sp>
+      <p:sp>
+        <p:nvSpPr>
+          <p:cNvPr id="33" name="TextBox 33"/>
+          <p:cNvSpPr txBox="1"/>
+          <p:nvPr/>
+        </p:nvSpPr>
+        <p:spPr>
+          <a:xfrm>
+            <a:off x="6566916" y="4077652"/>
+            <a:ext cx="88411" cy="205359"/>
+          </a:xfrm>
+          <a:prstGeom prst="rect">
+            <a:avLst/>
+          </a:prstGeom>
+          <a:noFill/>
+          <a:ln>
+            <a:noFill/>
+          </a:ln>
+        </p:spPr>
+        <p:txBody>
+          <a:bodyPr wrap="none" lIns="0" tIns="0" rIns="0" bIns="0" anchor="t" anchorCtr="0">
+            <a:spAutoFit/>
+          </a:bodyPr>
+          <a:lstStyle/>
+          <a:p>
+            <a:pPr algn="l"/>
+            <a:r>
+              <a:rPr lang="en-US" sz="1050" dirty="0">
+                <a:solidFill>
+                  <a:srgbClr val="DDEBFF"/>
+                </a:solidFill>
+                <a:latin typeface="Consolas"/>
+                <a:ea typeface="Consolas"/>
+                <a:cs typeface="Consolas"/>
+              </a:rPr>
+              <a:t>}</a:t>
+            </a:r>
+          </a:p>
+        </p:txBody>
+      </p:sp>
+      <p:sp>
+        <p:nvSpPr>
+          <p:cNvPr id="34" name="TextBox 34"/>
+          <p:cNvSpPr txBox="1"/>
+          <p:nvPr/>
+        </p:nvSpPr>
+        <p:spPr>
+          <a:xfrm>
+            <a:off x="6564630" y="4314825"/>
+            <a:ext cx="2408110" cy="293370"/>
+          </a:xfrm>
+          <a:prstGeom prst="rect">
+            <a:avLst/>
+          </a:prstGeom>
+          <a:noFill/>
+          <a:ln>
+            <a:noFill/>
+          </a:ln>
+        </p:spPr>
+        <p:txBody>
+          <a:bodyPr wrap="none" lIns="0" tIns="0" rIns="0" bIns="0" anchor="t" anchorCtr="0">
+            <a:spAutoFit/>
+          </a:bodyPr>
+          <a:lstStyle/>
+          <a:p>
+            <a:pPr algn="l"/>
+            <a:r>
+              <a:rPr lang="zh-CN" sz="1500" dirty="0">
+                <a:solidFill>
+                  <a:srgbClr val="FFFFFF"/>
+                </a:solidFill>
+                <a:latin typeface="Arial"/>
+                <a:ea typeface="Microsoft YaHei"/>
+                <a:cs typeface="Arial"/>
+              </a:rPr>
+              <a:t>示例：正常运营 → 分量 = 1</a:t>
+            </a:r>
+          </a:p>
+        </p:txBody>
+      </p:sp>
+      <p:sp>
+        <p:nvSpPr>
+          <p:cNvPr id="35" name="TextBox 35"/>
+          <p:cNvSpPr txBox="1"/>
+          <p:nvPr/>
+        </p:nvSpPr>
+        <p:spPr>
+          <a:xfrm>
+            <a:off x="6566154" y="4632960"/>
+            <a:ext cx="2338426" cy="234696"/>
+          </a:xfrm>
+          <a:prstGeom prst="rect">
+            <a:avLst/>
+          </a:prstGeom>
+          <a:noFill/>
+          <a:ln>
+            <a:noFill/>
+          </a:ln>
+        </p:spPr>
+        <p:txBody>
+          <a:bodyPr wrap="none" lIns="0" tIns="0" rIns="0" bIns="0" anchor="t" anchorCtr="0">
+            <a:spAutoFit/>
+          </a:bodyPr>
+          <a:lstStyle/>
+          <a:p>
+            <a:pPr algn="l"/>
+            <a:r>
+              <a:rPr lang="zh-CN" sz="1200" dirty="0">
+                <a:solidFill>
+                  <a:srgbClr val="B7C7DE"/>
+                </a:solidFill>
+                <a:latin typeface="Arial"/>
+                <a:ea typeface="Microsoft YaHei"/>
+                <a:cs typeface="Arial"/>
+              </a:rPr>
+              <a:t>→ 关闭 4 号线所有站 → 分量 = 2+</a:t>
+            </a:r>
+          </a:p>
+        </p:txBody>
+      </p:sp>
+      <p:sp>
+        <p:nvSpPr>
+          <p:cNvPr id="36" name="TextBox 36"/>
+          <p:cNvSpPr txBox="1"/>
+          <p:nvPr/>
+        </p:nvSpPr>
+        <p:spPr>
+          <a:xfrm>
+            <a:off x="6565392" y="4997768"/>
+            <a:ext cx="2624762" cy="264033"/>
+          </a:xfrm>
+          <a:prstGeom prst="rect">
+            <a:avLst/>
+          </a:prstGeom>
+          <a:noFill/>
+          <a:ln>
+            <a:noFill/>
+          </a:ln>
+        </p:spPr>
+        <p:txBody>
+          <a:bodyPr wrap="none" lIns="0" tIns="0" rIns="0" bIns="0" anchor="t" anchorCtr="0">
+            <a:spAutoFit/>
+          </a:bodyPr>
+          <a:lstStyle/>
+          <a:p>
+            <a:pPr algn="l"/>
+            <a:r>
+              <a:rPr lang="zh-CN" sz="1350" b="1" dirty="0">
+                <a:solidFill>
+                  <a:srgbClr val="FFD54F"/>
+                </a:solidFill>
+                <a:latin typeface="Arial"/>
+                <a:ea typeface="Microsoft YaHei"/>
+                <a:cs typeface="Arial"/>
+              </a:rPr>
+              <a:t>复杂度 O(V+E) · 检测图分裂</a:t>
+            </a:r>
+          </a:p>
+        </p:txBody>
+      </p:sp>
+      <p:sp>
+        <p:nvSpPr>
+          <p:cNvPr id="37" name="TextBox 37"/>
+          <p:cNvSpPr txBox="1"/>
+          <p:nvPr/>
+        </p:nvSpPr>
+        <p:spPr>
+          <a:xfrm>
+            <a:off x="4288688" y="6347460"/>
+            <a:ext cx="3614623" cy="234696"/>
+          </a:xfrm>
+          <a:prstGeom prst="rect">
+            <a:avLst/>
+          </a:prstGeom>
+          <a:noFill/>
+          <a:ln>
+            <a:noFill/>
+          </a:ln>
+        </p:spPr>
+        <p:txBody>
+          <a:bodyPr wrap="none" lIns="0" tIns="0" rIns="0" bIns="0" anchor="t" anchorCtr="0">
+            <a:spAutoFit/>
+          </a:bodyPr>
+          <a:lstStyle/>
+          <a:p>
+            <a:pPr algn="ctr"/>
+            <a:r>
+              <a:rPr lang="zh-CN" sz="1200" dirty="0">
+                <a:solidFill>
+                  <a:srgbClr val="91A9C8"/>
+                </a:solidFill>
+                <a:latin typeface="Arial"/>
+                <a:ea typeface="Microsoft YaHei"/>
+                <a:cs typeface="Arial"/>
+              </a:rPr>
+              <a:t>两算法均在 metro_core 中实现，前端可视化调用</a:t>
             </a:r>
           </a:p>
         </p:txBody>

</xml_diff>

<commit_message>
feat(ppt-v2.0.0): visualization + tests-summary slides (Task 4)
Co-Authored-By: Claude Fable 5 <noreply@anthropic.com>
</commit_message>
<xml_diff>
--- a/docs/ppt-v2.0.0/答辩PPT-v2.0.0.pptx
+++ b/docs/ppt-v2.0.0/答辩PPT-v2.0.0.pptx
@@ -11,6 +11,8 @@
     <p:sldId id="259" r:id="rId10"/>
     <p:sldId id="260" r:id="rId11"/>
     <p:sldId id="261" r:id="rId12"/>
+    <p:sldId id="262" r:id="rId13"/>
+    <p:sldId id="263" r:id="rId14"/>
   </p:sldIdLst>
   <p:sldSz cx="12192000" cy="6858000" type="screen4x3"/>
   <p:notesSz cx="6858000" cy="9144000"/>
@@ -11957,6 +11959,3394 @@
                 <a:cs typeface="Arial"/>
               </a:rPr>
               <a:t>两算法均在 metro_core 中实现，前端可视化调用</a:t>
+            </a:r>
+          </a:p>
+        </p:txBody>
+      </p:sp>
+    </p:spTree>
+  </p:cSld>
+  <p:clrMapOvr>
+    <a:masterClrMapping/>
+  </p:clrMapOvr>
+  <p:transition xmlns:p14="http://schemas.microsoft.com/office/powerpoint/2010/main" p14:dur="400">
+    <p:fade/>
+  </p:transition>
+</p:sld>
+</file>
+
+<file path=ppt/slides/slide7.xml><?xml version="1.0" encoding="utf-8"?>
+<p:sld xmlns:a="http://schemas.openxmlformats.org/drawingml/2006/main" xmlns:r="http://schemas.openxmlformats.org/officeDocument/2006/relationships" xmlns:p="http://schemas.openxmlformats.org/presentationml/2006/main">
+  <p:cSld>
+    <p:spTree>
+      <p:nvGrpSpPr>
+        <p:cNvPr id="1" name=""/>
+        <p:cNvGrpSpPr/>
+        <p:nvPr/>
+      </p:nvGrpSpPr>
+      <p:grpSpPr>
+        <a:xfrm>
+          <a:off x="0" y="0"/>
+          <a:ext cx="0" cy="0"/>
+          <a:chOff x="0" y="0"/>
+          <a:chExt cx="0" cy="0"/>
+        </a:xfrm>
+      </p:grpSpPr>
+      <p:sp>
+        <p:nvSpPr>
+          <p:cNvPr id="2" name="Rectangle 2"/>
+          <p:cNvSpPr/>
+          <p:nvPr/>
+        </p:nvSpPr>
+        <p:spPr>
+          <a:xfrm>
+            <a:off x="0" y="0"/>
+            <a:ext cx="12192000" cy="6858000"/>
+          </a:xfrm>
+          <a:prstGeom prst="rect">
+            <a:avLst/>
+          </a:prstGeom>
+          <a:solidFill>
+            <a:srgbClr val="0B1F3A"/>
+          </a:solidFill>
+          <a:ln>
+            <a:noFill/>
+          </a:ln>
+        </p:spPr>
+      </p:sp>
+      <p:sp>
+        <p:nvSpPr>
+          <p:cNvPr id="3" name="TextBox 3"/>
+          <p:cNvSpPr txBox="1"/>
+          <p:nvPr/>
+        </p:nvSpPr>
+        <p:spPr>
+          <a:xfrm>
+            <a:off x="745236" y="501015"/>
+            <a:ext cx="2832278" cy="645414"/>
+          </a:xfrm>
+          <a:prstGeom prst="rect">
+            <a:avLst/>
+          </a:prstGeom>
+          <a:noFill/>
+          <a:ln>
+            <a:noFill/>
+          </a:ln>
+        </p:spPr>
+        <p:txBody>
+          <a:bodyPr wrap="none" lIns="0" tIns="0" rIns="0" bIns="0" anchor="t" anchorCtr="0">
+            <a:spAutoFit/>
+          </a:bodyPr>
+          <a:lstStyle/>
+          <a:p>
+            <a:pPr algn="l"/>
+            <a:r>
+              <a:rPr lang="zh-CN" sz="3300" b="1" dirty="0">
+                <a:solidFill>
+                  <a:srgbClr val="FFFFFF"/>
+                </a:solidFill>
+                <a:latin typeface="Arial"/>
+                <a:ea typeface="Microsoft YaHei"/>
+                <a:cs typeface="Arial"/>
+              </a:rPr>
+              <a:t>可视化与工程</a:t>
+            </a:r>
+          </a:p>
+        </p:txBody>
+      </p:sp>
+      <p:sp>
+        <p:nvSpPr>
+          <p:cNvPr id="4" name="Line 4"/>
+          <p:cNvSpPr/>
+          <p:nvPr/>
+        </p:nvSpPr>
+        <p:spPr>
+          <a:xfrm>
+            <a:off x="762000" y="1047750"/>
+            <a:ext cx="10668000" cy="9525"/>
+          </a:xfrm>
+          <a:custGeom>
+            <a:avLst/>
+            <a:gdLst/>
+            <a:ahLst/>
+            <a:cxnLst/>
+            <a:rect l="l" t="t" r="r" b="b"/>
+            <a:pathLst>
+              <a:path w="10668000" h="9525">
+                <a:moveTo>
+                  <a:pt x="0" y="0"/>
+                </a:moveTo>
+                <a:lnTo>
+                  <a:pt x="10668000" y="0"/>
+                </a:lnTo>
+              </a:path>
+            </a:pathLst>
+          </a:custGeom>
+          <a:noFill/>
+          <a:ln w="28575" cap="rnd">
+            <a:solidFill>
+              <a:srgbClr val="E4002B"/>
+            </a:solidFill>
+          </a:ln>
+        </p:spPr>
+      </p:sp>
+      <p:sp>
+        <p:nvSpPr>
+          <p:cNvPr id="5" name="TextBox 5"/>
+          <p:cNvSpPr txBox="1"/>
+          <p:nvPr/>
+        </p:nvSpPr>
+        <p:spPr>
+          <a:xfrm>
+            <a:off x="755142" y="1187768"/>
+            <a:ext cx="2585295" cy="264033"/>
+          </a:xfrm>
+          <a:prstGeom prst="rect">
+            <a:avLst/>
+          </a:prstGeom>
+          <a:noFill/>
+          <a:ln>
+            <a:noFill/>
+          </a:ln>
+        </p:spPr>
+        <p:txBody>
+          <a:bodyPr wrap="none" lIns="0" tIns="0" rIns="0" bIns="0" anchor="t" anchorCtr="0">
+            <a:spAutoFit/>
+          </a:bodyPr>
+          <a:lstStyle/>
+          <a:p>
+            <a:pPr algn="l"/>
+            <a:r>
+              <a:rPr lang="zh-CN" sz="1350" dirty="0">
+                <a:solidFill>
+                  <a:srgbClr val="FFD54F"/>
+                </a:solidFill>
+                <a:latin typeface="Arial"/>
+                <a:ea typeface="Microsoft YaHei"/>
+                <a:cs typeface="Arial"/>
+              </a:rPr>
+              <a:t>对应课设：可视化 · 端到端集成</a:t>
+            </a:r>
+          </a:p>
+        </p:txBody>
+      </p:sp>
+      <p:sp>
+        <p:nvSpPr>
+          <p:cNvPr id="6" name="Rectangle 6"/>
+          <p:cNvSpPr/>
+          <p:nvPr/>
+        </p:nvSpPr>
+        <p:spPr>
+          <a:xfrm>
+            <a:off x="571500" y="1666875"/>
+            <a:ext cx="11049000" cy="1857375"/>
+          </a:xfrm>
+          <a:prstGeom prst="roundRect">
+            <a:avLst>
+              <a:gd name="adj" fmla="val 5128"/>
+            </a:avLst>
+          </a:prstGeom>
+          <a:solidFill>
+            <a:srgbClr val="132846"/>
+          </a:solidFill>
+          <a:ln w="19050">
+            <a:solidFill>
+              <a:srgbClr val="1E3A5F"/>
+            </a:solidFill>
+          </a:ln>
+        </p:spPr>
+      </p:sp>
+      <p:sp>
+        <p:nvSpPr>
+          <p:cNvPr id="7" name="TextBox 7"/>
+          <p:cNvSpPr txBox="1"/>
+          <p:nvPr/>
+        </p:nvSpPr>
+        <p:spPr>
+          <a:xfrm>
+            <a:off x="753618" y="1774508"/>
+            <a:ext cx="949681" cy="322707"/>
+          </a:xfrm>
+          <a:prstGeom prst="rect">
+            <a:avLst/>
+          </a:prstGeom>
+          <a:noFill/>
+          <a:ln>
+            <a:noFill/>
+          </a:ln>
+        </p:spPr>
+        <p:txBody>
+          <a:bodyPr wrap="none" lIns="0" tIns="0" rIns="0" bIns="0" anchor="t" anchorCtr="0">
+            <a:spAutoFit/>
+          </a:bodyPr>
+          <a:lstStyle/>
+          <a:p>
+            <a:pPr algn="l"/>
+            <a:r>
+              <a:rPr lang="zh-CN" sz="1650" b="1" dirty="0">
+                <a:solidFill>
+                  <a:srgbClr val="FFD54F"/>
+                </a:solidFill>
+                <a:latin typeface="Arial"/>
+                <a:ea typeface="Microsoft YaHei"/>
+                <a:cs typeface="Arial"/>
+              </a:rPr>
+              <a:t>系统分层</a:t>
+            </a:r>
+          </a:p>
+        </p:txBody>
+      </p:sp>
+      <p:sp>
+        <p:nvSpPr>
+          <p:cNvPr id="8" name="Rectangle 8"/>
+          <p:cNvSpPr/>
+          <p:nvPr/>
+        </p:nvSpPr>
+        <p:spPr>
+          <a:xfrm>
+            <a:off x="1619250" y="2238375"/>
+            <a:ext cx="8572500" cy="304800"/>
+          </a:xfrm>
+          <a:prstGeom prst="roundRect">
+            <a:avLst>
+              <a:gd name="adj" fmla="val 12500"/>
+            </a:avLst>
+          </a:prstGeom>
+          <a:solidFill>
+            <a:srgbClr val="2A4A7A"/>
+          </a:solidFill>
+          <a:ln w="9525">
+            <a:solidFill>
+              <a:srgbClr val="1E3A5F"/>
+            </a:solidFill>
+          </a:ln>
+        </p:spPr>
+      </p:sp>
+      <p:sp>
+        <p:nvSpPr>
+          <p:cNvPr id="9" name="TextBox 9"/>
+          <p:cNvSpPr txBox="1"/>
+          <p:nvPr/>
+        </p:nvSpPr>
+        <p:spPr>
+          <a:xfrm>
+            <a:off x="1756029" y="2318385"/>
+            <a:ext cx="3451270" cy="234696"/>
+          </a:xfrm>
+          <a:prstGeom prst="rect">
+            <a:avLst/>
+          </a:prstGeom>
+          <a:noFill/>
+          <a:ln>
+            <a:noFill/>
+          </a:ln>
+        </p:spPr>
+        <p:txBody>
+          <a:bodyPr wrap="none" lIns="0" tIns="0" rIns="0" bIns="0" anchor="t" anchorCtr="0">
+            <a:spAutoFit/>
+          </a:bodyPr>
+          <a:lstStyle/>
+          <a:p>
+            <a:pPr algn="l"/>
+            <a:r>
+              <a:rPr lang="en-US" sz="1200" dirty="0">
+                <a:solidFill>
+                  <a:srgbClr val="FFFFFF"/>
+                </a:solidFill>
+                <a:latin typeface="Arial"/>
+                <a:ea typeface="Arial"/>
+                <a:cs typeface="Arial"/>
+              </a:rPr>
+              <a:t>Browser (index.html + app.js + tailwind.js)</a:t>
+            </a:r>
+          </a:p>
+        </p:txBody>
+      </p:sp>
+      <p:sp>
+        <p:nvSpPr>
+          <p:cNvPr id="10" name="Rectangle 10"/>
+          <p:cNvSpPr/>
+          <p:nvPr/>
+        </p:nvSpPr>
+        <p:spPr>
+          <a:xfrm>
+            <a:off x="1619250" y="2619375"/>
+            <a:ext cx="8572500" cy="304800"/>
+          </a:xfrm>
+          <a:prstGeom prst="roundRect">
+            <a:avLst>
+              <a:gd name="adj" fmla="val 12500"/>
+            </a:avLst>
+          </a:prstGeom>
+          <a:solidFill>
+            <a:srgbClr val="1E3A5F"/>
+          </a:solidFill>
+          <a:ln w="9525">
+            <a:solidFill>
+              <a:srgbClr val="1E3A5F"/>
+            </a:solidFill>
+          </a:ln>
+        </p:spPr>
+      </p:sp>
+      <p:sp>
+        <p:nvSpPr>
+          <p:cNvPr id="11" name="TextBox 11"/>
+          <p:cNvSpPr txBox="1"/>
+          <p:nvPr/>
+        </p:nvSpPr>
+        <p:spPr>
+          <a:xfrm>
+            <a:off x="1756029" y="2699385"/>
+            <a:ext cx="4212336" cy="234696"/>
+          </a:xfrm>
+          <a:prstGeom prst="rect">
+            <a:avLst/>
+          </a:prstGeom>
+          <a:noFill/>
+          <a:ln>
+            <a:noFill/>
+          </a:ln>
+        </p:spPr>
+        <p:txBody>
+          <a:bodyPr wrap="none" lIns="0" tIns="0" rIns="0" bIns="0" anchor="t" anchorCtr="0">
+            <a:spAutoFit/>
+          </a:bodyPr>
+          <a:lstStyle/>
+          <a:p>
+            <a:pPr algn="l"/>
+            <a:r>
+              <a:rPr lang="zh-CN" sz="1200" dirty="0">
+                <a:solidFill>
+                  <a:srgbClr val="FFFFFF"/>
+                </a:solidFill>
+                <a:latin typeface="Arial"/>
+                <a:ea typeface="Microsoft YaHei"/>
+                <a:cs typeface="Arial"/>
+              </a:rPr>
+              <a:t>metro_server (cpp-httplib + nlohmann/json, 18 端点)</a:t>
+            </a:r>
+          </a:p>
+        </p:txBody>
+      </p:sp>
+      <p:sp>
+        <p:nvSpPr>
+          <p:cNvPr id="12" name="Rectangle 12"/>
+          <p:cNvSpPr/>
+          <p:nvPr/>
+        </p:nvSpPr>
+        <p:spPr>
+          <a:xfrm>
+            <a:off x="1619250" y="3000375"/>
+            <a:ext cx="8572500" cy="304800"/>
+          </a:xfrm>
+          <a:prstGeom prst="roundRect">
+            <a:avLst>
+              <a:gd name="adj" fmla="val 12500"/>
+            </a:avLst>
+          </a:prstGeom>
+          <a:solidFill>
+            <a:srgbClr val="152D4A"/>
+          </a:solidFill>
+          <a:ln w="9525">
+            <a:solidFill>
+              <a:srgbClr val="1E3A5F"/>
+            </a:solidFill>
+          </a:ln>
+        </p:spPr>
+      </p:sp>
+      <p:sp>
+        <p:nvSpPr>
+          <p:cNvPr id="13" name="TextBox 13"/>
+          <p:cNvSpPr txBox="1"/>
+          <p:nvPr/>
+        </p:nvSpPr>
+        <p:spPr>
+          <a:xfrm>
+            <a:off x="1756029" y="3080385"/>
+            <a:ext cx="5521646" cy="234696"/>
+          </a:xfrm>
+          <a:prstGeom prst="rect">
+            <a:avLst/>
+          </a:prstGeom>
+          <a:noFill/>
+          <a:ln>
+            <a:noFill/>
+          </a:ln>
+        </p:spPr>
+        <p:txBody>
+          <a:bodyPr wrap="none" lIns="0" tIns="0" rIns="0" bIns="0" anchor="t" anchorCtr="0">
+            <a:spAutoFit/>
+          </a:bodyPr>
+          <a:lstStyle/>
+          <a:p>
+            <a:pPr algn="l"/>
+            <a:r>
+              <a:rPr lang="en-US" sz="1200" dirty="0">
+                <a:solidFill>
+                  <a:srgbClr val="FFFFFF"/>
+                </a:solidFill>
+                <a:latin typeface="Arial"/>
+                <a:ea typeface="Arial"/>
+                <a:cs typeface="Arial"/>
+              </a:rPr>
+              <a:t>metro_core static lib (Graph, StationManager, pathfinder, analysis)</a:t>
+            </a:r>
+          </a:p>
+        </p:txBody>
+      </p:sp>
+      <p:sp>
+        <p:nvSpPr>
+          <p:cNvPr id="14" name="Rectangle 14"/>
+          <p:cNvSpPr/>
+          <p:nvPr/>
+        </p:nvSpPr>
+        <p:spPr>
+          <a:xfrm>
+            <a:off x="1619250" y="3381375"/>
+            <a:ext cx="8572500" cy="304800"/>
+          </a:xfrm>
+          <a:prstGeom prst="roundRect">
+            <a:avLst>
+              <a:gd name="adj" fmla="val 12500"/>
+            </a:avLst>
+          </a:prstGeom>
+          <a:solidFill>
+            <a:srgbClr val="0F2440"/>
+          </a:solidFill>
+          <a:ln w="9525">
+            <a:solidFill>
+              <a:srgbClr val="1E3A5F"/>
+            </a:solidFill>
+          </a:ln>
+        </p:spPr>
+      </p:sp>
+      <p:sp>
+        <p:nvSpPr>
+          <p:cNvPr id="15" name="TextBox 15"/>
+          <p:cNvSpPr txBox="1"/>
+          <p:nvPr/>
+        </p:nvSpPr>
+        <p:spPr>
+          <a:xfrm>
+            <a:off x="1756029" y="3461385"/>
+            <a:ext cx="4643375" cy="234696"/>
+          </a:xfrm>
+          <a:prstGeom prst="rect">
+            <a:avLst/>
+          </a:prstGeom>
+          <a:noFill/>
+          <a:ln>
+            <a:noFill/>
+          </a:ln>
+        </p:spPr>
+        <p:txBody>
+          <a:bodyPr wrap="none" lIns="0" tIns="0" rIns="0" bIns="0" anchor="t" anchorCtr="0">
+            <a:spAutoFit/>
+          </a:bodyPr>
+          <a:lstStyle/>
+          <a:p>
+            <a:pPr algn="l"/>
+            <a:r>
+              <a:rPr lang="en-US" sz="1200" dirty="0">
+                <a:solidFill>
+                  <a:srgbClr val="FFFFFF"/>
+                </a:solidFill>
+                <a:latin typeface="Arial"/>
+                <a:ea typeface="Arial"/>
+                <a:cs typeface="Arial"/>
+              </a:rPr>
+              <a:t>python/data/ (Station.csv · Edge.csv · Station_init.csv)</a:t>
+            </a:r>
+          </a:p>
+        </p:txBody>
+      </p:sp>
+      <p:sp>
+        <p:nvSpPr>
+          <p:cNvPr id="16" name="TextBox 16"/>
+          <p:cNvSpPr txBox="1"/>
+          <p:nvPr/>
+        </p:nvSpPr>
+        <p:spPr>
+          <a:xfrm>
+            <a:off x="5452110" y="2477452"/>
+            <a:ext cx="906780" cy="205359"/>
+          </a:xfrm>
+          <a:prstGeom prst="rect">
+            <a:avLst/>
+          </a:prstGeom>
+          <a:noFill/>
+          <a:ln>
+            <a:noFill/>
+          </a:ln>
+        </p:spPr>
+        <p:txBody>
+          <a:bodyPr wrap="none" lIns="0" tIns="0" rIns="0" bIns="0" anchor="t" anchorCtr="0">
+            <a:spAutoFit/>
+          </a:bodyPr>
+          <a:lstStyle/>
+          <a:p>
+            <a:pPr algn="ctr"/>
+            <a:r>
+              <a:rPr lang="en-US" sz="1050" dirty="0">
+                <a:solidFill>
+                  <a:srgbClr val="B7C7DE"/>
+                </a:solidFill>
+                <a:latin typeface="Arial"/>
+                <a:ea typeface="Arial"/>
+                <a:cs typeface="Arial"/>
+              </a:rPr>
+              <a:t>↓ HTTP/JSON</a:t>
+            </a:r>
+          </a:p>
+        </p:txBody>
+      </p:sp>
+      <p:sp>
+        <p:nvSpPr>
+          <p:cNvPr id="17" name="TextBox 17"/>
+          <p:cNvSpPr txBox="1"/>
+          <p:nvPr/>
+        </p:nvSpPr>
+        <p:spPr>
+          <a:xfrm>
+            <a:off x="5698741" y="2858452"/>
+            <a:ext cx="413518" cy="205359"/>
+          </a:xfrm>
+          <a:prstGeom prst="rect">
+            <a:avLst/>
+          </a:prstGeom>
+          <a:noFill/>
+          <a:ln>
+            <a:noFill/>
+          </a:ln>
+        </p:spPr>
+        <p:txBody>
+          <a:bodyPr wrap="none" lIns="0" tIns="0" rIns="0" bIns="0" anchor="t" anchorCtr="0">
+            <a:spAutoFit/>
+          </a:bodyPr>
+          <a:lstStyle/>
+          <a:p>
+            <a:pPr algn="ctr"/>
+            <a:r>
+              <a:rPr lang="zh-CN" sz="1050" dirty="0">
+                <a:solidFill>
+                  <a:srgbClr val="B7C7DE"/>
+                </a:solidFill>
+                <a:latin typeface="Arial"/>
+                <a:ea typeface="Microsoft YaHei"/>
+                <a:cs typeface="Arial"/>
+              </a:rPr>
+              <a:t>↓ 共享</a:t>
+            </a:r>
+          </a:p>
+        </p:txBody>
+      </p:sp>
+      <p:sp>
+        <p:nvSpPr>
+          <p:cNvPr id="18" name="TextBox 18"/>
+          <p:cNvSpPr txBox="1"/>
+          <p:nvPr/>
+        </p:nvSpPr>
+        <p:spPr>
+          <a:xfrm>
+            <a:off x="5861294" y="3239452"/>
+            <a:ext cx="88411" cy="205359"/>
+          </a:xfrm>
+          <a:prstGeom prst="rect">
+            <a:avLst/>
+          </a:prstGeom>
+          <a:noFill/>
+          <a:ln>
+            <a:noFill/>
+          </a:ln>
+        </p:spPr>
+        <p:txBody>
+          <a:bodyPr wrap="none" lIns="0" tIns="0" rIns="0" bIns="0" anchor="t" anchorCtr="0">
+            <a:spAutoFit/>
+          </a:bodyPr>
+          <a:lstStyle/>
+          <a:p>
+            <a:pPr algn="ctr"/>
+            <a:r>
+              <a:rPr lang="en-US" sz="1050" dirty="0">
+                <a:solidFill>
+                  <a:srgbClr val="B7C7DE"/>
+                </a:solidFill>
+                <a:latin typeface="Arial"/>
+                <a:ea typeface="Arial"/>
+                <a:cs typeface="Arial"/>
+              </a:rPr>
+              <a:t>↓</a:t>
+            </a:r>
+          </a:p>
+        </p:txBody>
+      </p:sp>
+      <p:sp>
+        <p:nvSpPr>
+          <p:cNvPr id="19" name="Rectangle 19"/>
+          <p:cNvSpPr/>
+          <p:nvPr/>
+        </p:nvSpPr>
+        <p:spPr>
+          <a:xfrm>
+            <a:off x="571500" y="3762375"/>
+            <a:ext cx="4762500" cy="2333625"/>
+          </a:xfrm>
+          <a:prstGeom prst="roundRect">
+            <a:avLst>
+              <a:gd name="adj" fmla="val 4082"/>
+            </a:avLst>
+          </a:prstGeom>
+          <a:solidFill>
+            <a:srgbClr val="132846"/>
+          </a:solidFill>
+          <a:ln w="19050">
+            <a:solidFill>
+              <a:srgbClr val="1E3A5F"/>
+            </a:solidFill>
+          </a:ln>
+        </p:spPr>
+      </p:sp>
+      <p:sp>
+        <p:nvSpPr>
+          <p:cNvPr id="20" name="TextBox 20"/>
+          <p:cNvSpPr txBox="1"/>
+          <p:nvPr/>
+        </p:nvSpPr>
+        <p:spPr>
+          <a:xfrm>
+            <a:off x="754380" y="3886200"/>
+            <a:ext cx="3670343" cy="293370"/>
+          </a:xfrm>
+          <a:prstGeom prst="rect">
+            <a:avLst/>
+          </a:prstGeom>
+          <a:noFill/>
+          <a:ln>
+            <a:noFill/>
+          </a:ln>
+        </p:spPr>
+        <p:txBody>
+          <a:bodyPr wrap="none" lIns="0" tIns="0" rIns="0" bIns="0" anchor="t" anchorCtr="0">
+            <a:spAutoFit/>
+          </a:bodyPr>
+          <a:lstStyle/>
+          <a:p>
+            <a:pPr algn="l"/>
+            <a:r>
+              <a:rPr lang="zh-CN" sz="1500" b="1" dirty="0">
+                <a:solidFill>
+                  <a:srgbClr val="FFD54F"/>
+                </a:solidFill>
+                <a:latin typeface="Arial"/>
+                <a:ea typeface="Microsoft YaHei"/>
+                <a:cs typeface="Arial"/>
+              </a:rPr>
+              <a:t>前端极简 UI（Tailwind CDN, 全离线）</a:t>
+            </a:r>
+          </a:p>
+        </p:txBody>
+      </p:sp>
+      <p:pic>
+        <p:nvPicPr>
+          <p:cNvPr id="21" name="Image 21"/>
+          <p:cNvPicPr>
+            <a:picLocks noChangeAspect="1"/>
+          </p:cNvPicPr>
+          <p:nvPr/>
+        </p:nvPicPr>
+        <p:blipFill>
+          <a:blip r:embed="rId2"/>
+          <a:stretch>
+            <a:fillRect/>
+          </a:stretch>
+        </p:blipFill>
+        <p:spPr>
+          <a:xfrm>
+            <a:off x="2340285" y="4238625"/>
+            <a:ext cx="1224930" cy="1714500"/>
+          </a:xfrm>
+          <a:prstGeom prst="rect">
+            <a:avLst/>
+          </a:prstGeom>
+        </p:spPr>
+      </p:pic>
+      <p:sp>
+        <p:nvSpPr>
+          <p:cNvPr id="22" name="TextBox 22"/>
+          <p:cNvSpPr txBox="1"/>
+          <p:nvPr/>
+        </p:nvSpPr>
+        <p:spPr>
+          <a:xfrm>
+            <a:off x="756666" y="5935028"/>
+            <a:ext cx="2894228" cy="205359"/>
+          </a:xfrm>
+          <a:prstGeom prst="rect">
+            <a:avLst/>
+          </a:prstGeom>
+          <a:noFill/>
+          <a:ln>
+            <a:noFill/>
+          </a:ln>
+        </p:spPr>
+        <p:txBody>
+          <a:bodyPr wrap="none" lIns="0" tIns="0" rIns="0" bIns="0" anchor="t" anchorCtr="0">
+            <a:spAutoFit/>
+          </a:bodyPr>
+          <a:lstStyle/>
+          <a:p>
+            <a:pPr algn="l"/>
+            <a:r>
+              <a:rPr lang="zh-CN" sz="1050" dirty="0">
+                <a:solidFill>
+                  <a:srgbClr val="91A9C8"/>
+                </a:solidFill>
+                <a:latin typeface="Arial"/>
+                <a:ea typeface="Microsoft YaHei"/>
+                <a:cs typeface="Arial"/>
+              </a:rPr>
+              <a:t>顶部标签 · 卡片式结果 · 路径规划/运营/分析</a:t>
+            </a:r>
+          </a:p>
+        </p:txBody>
+      </p:sp>
+      <p:sp>
+        <p:nvSpPr>
+          <p:cNvPr id="23" name="Rectangle 23"/>
+          <p:cNvSpPr/>
+          <p:nvPr/>
+        </p:nvSpPr>
+        <p:spPr>
+          <a:xfrm>
+            <a:off x="5524500" y="3762375"/>
+            <a:ext cx="3048000" cy="2333625"/>
+          </a:xfrm>
+          <a:prstGeom prst="roundRect">
+            <a:avLst>
+              <a:gd name="adj" fmla="val 4082"/>
+            </a:avLst>
+          </a:prstGeom>
+          <a:solidFill>
+            <a:srgbClr val="132846"/>
+          </a:solidFill>
+          <a:ln w="19050">
+            <a:solidFill>
+              <a:srgbClr val="1E3A5F"/>
+            </a:solidFill>
+          </a:ln>
+        </p:spPr>
+      </p:sp>
+      <p:sp>
+        <p:nvSpPr>
+          <p:cNvPr id="24" name="TextBox 24"/>
+          <p:cNvSpPr txBox="1"/>
+          <p:nvPr/>
+        </p:nvSpPr>
+        <p:spPr>
+          <a:xfrm>
+            <a:off x="5707380" y="3886200"/>
+            <a:ext cx="1337005" cy="293370"/>
+          </a:xfrm>
+          <a:prstGeom prst="rect">
+            <a:avLst/>
+          </a:prstGeom>
+          <a:noFill/>
+          <a:ln>
+            <a:noFill/>
+          </a:ln>
+        </p:spPr>
+        <p:txBody>
+          <a:bodyPr wrap="none" lIns="0" tIns="0" rIns="0" bIns="0" anchor="t" anchorCtr="0">
+            <a:spAutoFit/>
+          </a:bodyPr>
+          <a:lstStyle/>
+          <a:p>
+            <a:pPr algn="l"/>
+            <a:r>
+              <a:rPr lang="zh-CN" sz="1500" b="1" dirty="0">
+                <a:solidFill>
+                  <a:srgbClr val="FFD54F"/>
+                </a:solidFill>
+                <a:latin typeface="Arial"/>
+                <a:ea typeface="Microsoft YaHei"/>
+                <a:cs typeface="Arial"/>
+              </a:rPr>
+              <a:t>18 REST 端点</a:t>
+            </a:r>
+          </a:p>
+        </p:txBody>
+      </p:sp>
+      <p:sp>
+        <p:nvSpPr>
+          <p:cNvPr id="25" name="TextBox 25"/>
+          <p:cNvSpPr txBox="1"/>
+          <p:nvPr/>
+        </p:nvSpPr>
+        <p:spPr>
+          <a:xfrm>
+            <a:off x="5708904" y="4251960"/>
+            <a:ext cx="932993" cy="234696"/>
+          </a:xfrm>
+          <a:prstGeom prst="rect">
+            <a:avLst/>
+          </a:prstGeom>
+          <a:noFill/>
+          <a:ln>
+            <a:noFill/>
+          </a:ln>
+        </p:spPr>
+        <p:txBody>
+          <a:bodyPr wrap="none" lIns="0" tIns="0" rIns="0" bIns="0" anchor="t" anchorCtr="0">
+            <a:spAutoFit/>
+          </a:bodyPr>
+          <a:lstStyle/>
+          <a:p>
+            <a:pPr algn="l"/>
+            <a:r>
+              <a:rPr lang="zh-CN" sz="1200" dirty="0">
+                <a:solidFill>
+                  <a:srgbClr val="DDEBFF"/>
+                </a:solidFill>
+                <a:latin typeface="Arial"/>
+                <a:ea typeface="Microsoft YaHei"/>
+                <a:cs typeface="Arial"/>
+              </a:rPr>
+              <a:t>▸ 数据查询 7</a:t>
+            </a:r>
+          </a:p>
+        </p:txBody>
+      </p:sp>
+      <p:sp>
+        <p:nvSpPr>
+          <p:cNvPr id="26" name="TextBox 26"/>
+          <p:cNvSpPr txBox="1"/>
+          <p:nvPr/>
+        </p:nvSpPr>
+        <p:spPr>
+          <a:xfrm>
+            <a:off x="5708904" y="4537710"/>
+            <a:ext cx="932993" cy="234696"/>
+          </a:xfrm>
+          <a:prstGeom prst="rect">
+            <a:avLst/>
+          </a:prstGeom>
+          <a:noFill/>
+          <a:ln>
+            <a:noFill/>
+          </a:ln>
+        </p:spPr>
+        <p:txBody>
+          <a:bodyPr wrap="none" lIns="0" tIns="0" rIns="0" bIns="0" anchor="t" anchorCtr="0">
+            <a:spAutoFit/>
+          </a:bodyPr>
+          <a:lstStyle/>
+          <a:p>
+            <a:pPr algn="l"/>
+            <a:r>
+              <a:rPr lang="zh-CN" sz="1200" dirty="0">
+                <a:solidFill>
+                  <a:srgbClr val="DDEBFF"/>
+                </a:solidFill>
+                <a:latin typeface="Arial"/>
+                <a:ea typeface="Microsoft YaHei"/>
+                <a:cs typeface="Arial"/>
+              </a:rPr>
+              <a:t>▸ 路径规划 4</a:t>
+            </a:r>
+          </a:p>
+        </p:txBody>
+      </p:sp>
+      <p:sp>
+        <p:nvSpPr>
+          <p:cNvPr id="27" name="TextBox 27"/>
+          <p:cNvSpPr txBox="1"/>
+          <p:nvPr/>
+        </p:nvSpPr>
+        <p:spPr>
+          <a:xfrm>
+            <a:off x="5708904" y="4823460"/>
+            <a:ext cx="932993" cy="234696"/>
+          </a:xfrm>
+          <a:prstGeom prst="rect">
+            <a:avLst/>
+          </a:prstGeom>
+          <a:noFill/>
+          <a:ln>
+            <a:noFill/>
+          </a:ln>
+        </p:spPr>
+        <p:txBody>
+          <a:bodyPr wrap="none" lIns="0" tIns="0" rIns="0" bIns="0" anchor="t" anchorCtr="0">
+            <a:spAutoFit/>
+          </a:bodyPr>
+          <a:lstStyle/>
+          <a:p>
+            <a:pPr algn="l"/>
+            <a:r>
+              <a:rPr lang="zh-CN" sz="1200" dirty="0">
+                <a:solidFill>
+                  <a:srgbClr val="DDEBFF"/>
+                </a:solidFill>
+                <a:latin typeface="Arial"/>
+                <a:ea typeface="Microsoft YaHei"/>
+                <a:cs typeface="Arial"/>
+              </a:rPr>
+              <a:t>▸ 站点管理 4</a:t>
+            </a:r>
+          </a:p>
+        </p:txBody>
+      </p:sp>
+      <p:sp>
+        <p:nvSpPr>
+          <p:cNvPr id="28" name="TextBox 28"/>
+          <p:cNvSpPr txBox="1"/>
+          <p:nvPr/>
+        </p:nvSpPr>
+        <p:spPr>
+          <a:xfrm>
+            <a:off x="5708904" y="5109210"/>
+            <a:ext cx="932993" cy="234696"/>
+          </a:xfrm>
+          <a:prstGeom prst="rect">
+            <a:avLst/>
+          </a:prstGeom>
+          <a:noFill/>
+          <a:ln>
+            <a:noFill/>
+          </a:ln>
+        </p:spPr>
+        <p:txBody>
+          <a:bodyPr wrap="none" lIns="0" tIns="0" rIns="0" bIns="0" anchor="t" anchorCtr="0">
+            <a:spAutoFit/>
+          </a:bodyPr>
+          <a:lstStyle/>
+          <a:p>
+            <a:pPr algn="l"/>
+            <a:r>
+              <a:rPr lang="zh-CN" sz="1200" dirty="0">
+                <a:solidFill>
+                  <a:srgbClr val="DDEBFF"/>
+                </a:solidFill>
+                <a:latin typeface="Arial"/>
+                <a:ea typeface="Microsoft YaHei"/>
+                <a:cs typeface="Arial"/>
+              </a:rPr>
+              <a:t>▸ 网络分析 2</a:t>
+            </a:r>
+          </a:p>
+        </p:txBody>
+      </p:sp>
+      <p:sp>
+        <p:nvSpPr>
+          <p:cNvPr id="29" name="TextBox 29"/>
+          <p:cNvSpPr txBox="1"/>
+          <p:nvPr/>
+        </p:nvSpPr>
+        <p:spPr>
+          <a:xfrm>
+            <a:off x="5708904" y="5394960"/>
+            <a:ext cx="609905" cy="234696"/>
+          </a:xfrm>
+          <a:prstGeom prst="rect">
+            <a:avLst/>
+          </a:prstGeom>
+          <a:noFill/>
+          <a:ln>
+            <a:noFill/>
+          </a:ln>
+        </p:spPr>
+        <p:txBody>
+          <a:bodyPr wrap="none" lIns="0" tIns="0" rIns="0" bIns="0" anchor="t" anchorCtr="0">
+            <a:spAutoFit/>
+          </a:bodyPr>
+          <a:lstStyle/>
+          <a:p>
+            <a:pPr algn="l"/>
+            <a:r>
+              <a:rPr lang="zh-CN" sz="1200" dirty="0">
+                <a:solidFill>
+                  <a:srgbClr val="DDEBFF"/>
+                </a:solidFill>
+                <a:latin typeface="Arial"/>
+                <a:ea typeface="Microsoft YaHei"/>
+                <a:cs typeface="Arial"/>
+              </a:rPr>
+              <a:t>▸ 健康 1</a:t>
+            </a:r>
+          </a:p>
+        </p:txBody>
+      </p:sp>
+      <p:sp>
+        <p:nvSpPr>
+          <p:cNvPr id="30" name="TextBox 30"/>
+          <p:cNvSpPr txBox="1"/>
+          <p:nvPr/>
+        </p:nvSpPr>
+        <p:spPr>
+          <a:xfrm>
+            <a:off x="5709666" y="5792152"/>
+            <a:ext cx="2441905" cy="205359"/>
+          </a:xfrm>
+          <a:prstGeom prst="rect">
+            <a:avLst/>
+          </a:prstGeom>
+          <a:noFill/>
+          <a:ln>
+            <a:noFill/>
+          </a:ln>
+        </p:spPr>
+        <p:txBody>
+          <a:bodyPr wrap="none" lIns="0" tIns="0" rIns="0" bIns="0" anchor="t" anchorCtr="0">
+            <a:spAutoFit/>
+          </a:bodyPr>
+          <a:lstStyle/>
+          <a:p>
+            <a:pPr algn="l"/>
+            <a:r>
+              <a:rPr lang="en-US" sz="1050" dirty="0">
+                <a:solidFill>
+                  <a:srgbClr val="FFD54F"/>
+                </a:solidFill>
+                <a:latin typeface="Consolas"/>
+                <a:ea typeface="Consolas"/>
+                <a:cs typeface="Consolas"/>
+              </a:rPr>
+              <a:t>std::shared_mutex g_state_mutex</a:t>
+            </a:r>
+          </a:p>
+        </p:txBody>
+      </p:sp>
+      <p:sp>
+        <p:nvSpPr>
+          <p:cNvPr id="31" name="Rectangle 31"/>
+          <p:cNvSpPr/>
+          <p:nvPr/>
+        </p:nvSpPr>
+        <p:spPr>
+          <a:xfrm>
+            <a:off x="8763000" y="3762375"/>
+            <a:ext cx="3048000" cy="2333625"/>
+          </a:xfrm>
+          <a:prstGeom prst="roundRect">
+            <a:avLst>
+              <a:gd name="adj" fmla="val 4082"/>
+            </a:avLst>
+          </a:prstGeom>
+          <a:solidFill>
+            <a:srgbClr val="132846"/>
+          </a:solidFill>
+          <a:ln w="19050">
+            <a:solidFill>
+              <a:srgbClr val="1E3A5F"/>
+            </a:solidFill>
+          </a:ln>
+        </p:spPr>
+      </p:sp>
+      <p:sp>
+        <p:nvSpPr>
+          <p:cNvPr id="32" name="TextBox 32"/>
+          <p:cNvSpPr txBox="1"/>
+          <p:nvPr/>
+        </p:nvSpPr>
+        <p:spPr>
+          <a:xfrm>
+            <a:off x="8945880" y="3886200"/>
+            <a:ext cx="2305126" cy="293370"/>
+          </a:xfrm>
+          <a:prstGeom prst="rect">
+            <a:avLst/>
+          </a:prstGeom>
+          <a:noFill/>
+          <a:ln>
+            <a:noFill/>
+          </a:ln>
+        </p:spPr>
+        <p:txBody>
+          <a:bodyPr wrap="none" lIns="0" tIns="0" rIns="0" bIns="0" anchor="t" anchorCtr="0">
+            <a:spAutoFit/>
+          </a:bodyPr>
+          <a:lstStyle/>
+          <a:p>
+            <a:pPr algn="l"/>
+            <a:r>
+              <a:rPr lang="zh-CN" sz="1500" b="1" dirty="0">
+                <a:solidFill>
+                  <a:srgbClr val="FFD54F"/>
+                </a:solidFill>
+                <a:latin typeface="Arial"/>
+                <a:ea typeface="Microsoft YaHei"/>
+                <a:cs typeface="Arial"/>
+              </a:rPr>
+              <a:t>并发（shared_mutex）</a:t>
+            </a:r>
+          </a:p>
+        </p:txBody>
+      </p:sp>
+      <p:sp>
+        <p:nvSpPr>
+          <p:cNvPr id="33" name="TextBox 33"/>
+          <p:cNvSpPr txBox="1"/>
+          <p:nvPr/>
+        </p:nvSpPr>
+        <p:spPr>
+          <a:xfrm>
+            <a:off x="8946642" y="4331018"/>
+            <a:ext cx="1912413" cy="264033"/>
+          </a:xfrm>
+          <a:prstGeom prst="rect">
+            <a:avLst/>
+          </a:prstGeom>
+          <a:noFill/>
+          <a:ln>
+            <a:noFill/>
+          </a:ln>
+        </p:spPr>
+        <p:txBody>
+          <a:bodyPr wrap="none" lIns="0" tIns="0" rIns="0" bIns="0" anchor="t" anchorCtr="0">
+            <a:spAutoFit/>
+          </a:bodyPr>
+          <a:lstStyle/>
+          <a:p>
+            <a:pPr algn="l"/>
+            <a:r>
+              <a:rPr lang="zh-CN" sz="1350" b="1" dirty="0">
+                <a:solidFill>
+                  <a:srgbClr val="FFD54F"/>
+                </a:solidFill>
+                <a:latin typeface="Arial"/>
+                <a:ea typeface="Microsoft YaHei"/>
+                <a:cs typeface="Arial"/>
+              </a:rPr>
+              <a:t>读接口 → shared_lock</a:t>
+            </a:r>
+          </a:p>
+        </p:txBody>
+      </p:sp>
+      <p:sp>
+        <p:nvSpPr>
+          <p:cNvPr id="34" name="TextBox 34"/>
+          <p:cNvSpPr txBox="1"/>
+          <p:nvPr/>
+        </p:nvSpPr>
+        <p:spPr>
+          <a:xfrm>
+            <a:off x="9138666" y="4601528"/>
+            <a:ext cx="696220" cy="205359"/>
+          </a:xfrm>
+          <a:prstGeom prst="rect">
+            <a:avLst/>
+          </a:prstGeom>
+          <a:noFill/>
+          <a:ln>
+            <a:noFill/>
+          </a:ln>
+        </p:spPr>
+        <p:txBody>
+          <a:bodyPr wrap="none" lIns="0" tIns="0" rIns="0" bIns="0" anchor="t" anchorCtr="0">
+            <a:spAutoFit/>
+          </a:bodyPr>
+          <a:lstStyle/>
+          <a:p>
+            <a:pPr algn="l"/>
+            <a:r>
+              <a:rPr lang="zh-CN" sz="1050" dirty="0">
+                <a:solidFill>
+                  <a:srgbClr val="B7C7DE"/>
+                </a:solidFill>
+                <a:latin typeface="Arial"/>
+                <a:ea typeface="Microsoft YaHei"/>
+                <a:cs typeface="Arial"/>
+              </a:rPr>
+              <a:t>· 路径规划</a:t>
+            </a:r>
+          </a:p>
+        </p:txBody>
+      </p:sp>
+      <p:sp>
+        <p:nvSpPr>
+          <p:cNvPr id="35" name="TextBox 35"/>
+          <p:cNvSpPr txBox="1"/>
+          <p:nvPr/>
+        </p:nvSpPr>
+        <p:spPr>
+          <a:xfrm>
+            <a:off x="9138666" y="4792028"/>
+            <a:ext cx="696220" cy="205359"/>
+          </a:xfrm>
+          <a:prstGeom prst="rect">
+            <a:avLst/>
+          </a:prstGeom>
+          <a:noFill/>
+          <a:ln>
+            <a:noFill/>
+          </a:ln>
+        </p:spPr>
+        <p:txBody>
+          <a:bodyPr wrap="none" lIns="0" tIns="0" rIns="0" bIns="0" anchor="t" anchorCtr="0">
+            <a:spAutoFit/>
+          </a:bodyPr>
+          <a:lstStyle/>
+          <a:p>
+            <a:pPr algn="l"/>
+            <a:r>
+              <a:rPr lang="zh-CN" sz="1050" dirty="0">
+                <a:solidFill>
+                  <a:srgbClr val="B7C7DE"/>
+                </a:solidFill>
+                <a:latin typeface="Arial"/>
+                <a:ea typeface="Microsoft YaHei"/>
+                <a:cs typeface="Arial"/>
+              </a:rPr>
+              <a:t>· 数据查询</a:t>
+            </a:r>
+          </a:p>
+        </p:txBody>
+      </p:sp>
+      <p:sp>
+        <p:nvSpPr>
+          <p:cNvPr id="36" name="TextBox 36"/>
+          <p:cNvSpPr txBox="1"/>
+          <p:nvPr/>
+        </p:nvSpPr>
+        <p:spPr>
+          <a:xfrm>
+            <a:off x="9138666" y="4982528"/>
+            <a:ext cx="696220" cy="205359"/>
+          </a:xfrm>
+          <a:prstGeom prst="rect">
+            <a:avLst/>
+          </a:prstGeom>
+          <a:noFill/>
+          <a:ln>
+            <a:noFill/>
+          </a:ln>
+        </p:spPr>
+        <p:txBody>
+          <a:bodyPr wrap="none" lIns="0" tIns="0" rIns="0" bIns="0" anchor="t" anchorCtr="0">
+            <a:spAutoFit/>
+          </a:bodyPr>
+          <a:lstStyle/>
+          <a:p>
+            <a:pPr algn="l"/>
+            <a:r>
+              <a:rPr lang="zh-CN" sz="1050" dirty="0">
+                <a:solidFill>
+                  <a:srgbClr val="B7C7DE"/>
+                </a:solidFill>
+                <a:latin typeface="Arial"/>
+                <a:ea typeface="Microsoft YaHei"/>
+                <a:cs typeface="Arial"/>
+              </a:rPr>
+              <a:t>· 网络分析</a:t>
+            </a:r>
+          </a:p>
+        </p:txBody>
+      </p:sp>
+      <p:sp>
+        <p:nvSpPr>
+          <p:cNvPr id="37" name="TextBox 37"/>
+          <p:cNvSpPr txBox="1"/>
+          <p:nvPr/>
+        </p:nvSpPr>
+        <p:spPr>
+          <a:xfrm>
+            <a:off x="8946642" y="5188268"/>
+            <a:ext cx="1864707" cy="264033"/>
+          </a:xfrm>
+          <a:prstGeom prst="rect">
+            <a:avLst/>
+          </a:prstGeom>
+          <a:noFill/>
+          <a:ln>
+            <a:noFill/>
+          </a:ln>
+        </p:spPr>
+        <p:txBody>
+          <a:bodyPr wrap="none" lIns="0" tIns="0" rIns="0" bIns="0" anchor="t" anchorCtr="0">
+            <a:spAutoFit/>
+          </a:bodyPr>
+          <a:lstStyle/>
+          <a:p>
+            <a:pPr algn="l"/>
+            <a:r>
+              <a:rPr lang="zh-CN" sz="1350" b="1" dirty="0">
+                <a:solidFill>
+                  <a:srgbClr val="FFD54F"/>
+                </a:solidFill>
+                <a:latin typeface="Arial"/>
+                <a:ea typeface="Microsoft YaHei"/>
+                <a:cs typeface="Arial"/>
+              </a:rPr>
+              <a:t>写接口 → unique_lock</a:t>
+            </a:r>
+          </a:p>
+        </p:txBody>
+      </p:sp>
+      <p:sp>
+        <p:nvSpPr>
+          <p:cNvPr id="38" name="TextBox 38"/>
+          <p:cNvSpPr txBox="1"/>
+          <p:nvPr/>
+        </p:nvSpPr>
+        <p:spPr>
+          <a:xfrm>
+            <a:off x="9138666" y="5458778"/>
+            <a:ext cx="696220" cy="205359"/>
+          </a:xfrm>
+          <a:prstGeom prst="rect">
+            <a:avLst/>
+          </a:prstGeom>
+          <a:noFill/>
+          <a:ln>
+            <a:noFill/>
+          </a:ln>
+        </p:spPr>
+        <p:txBody>
+          <a:bodyPr wrap="none" lIns="0" tIns="0" rIns="0" bIns="0" anchor="t" anchorCtr="0">
+            <a:spAutoFit/>
+          </a:bodyPr>
+          <a:lstStyle/>
+          <a:p>
+            <a:pPr algn="l"/>
+            <a:r>
+              <a:rPr lang="zh-CN" sz="1050" dirty="0">
+                <a:solidFill>
+                  <a:srgbClr val="B7C7DE"/>
+                </a:solidFill>
+                <a:latin typeface="Arial"/>
+                <a:ea typeface="Microsoft YaHei"/>
+                <a:cs typeface="Arial"/>
+              </a:rPr>
+              <a:t>· 站点开关</a:t>
+            </a:r>
+          </a:p>
+        </p:txBody>
+      </p:sp>
+      <p:sp>
+        <p:nvSpPr>
+          <p:cNvPr id="39" name="TextBox 39"/>
+          <p:cNvSpPr txBox="1"/>
+          <p:nvPr/>
+        </p:nvSpPr>
+        <p:spPr>
+          <a:xfrm>
+            <a:off x="9138666" y="5649278"/>
+            <a:ext cx="773963" cy="205359"/>
+          </a:xfrm>
+          <a:prstGeom prst="rect">
+            <a:avLst/>
+          </a:prstGeom>
+          <a:noFill/>
+          <a:ln>
+            <a:noFill/>
+          </a:ln>
+        </p:spPr>
+        <p:txBody>
+          <a:bodyPr wrap="none" lIns="0" tIns="0" rIns="0" bIns="0" anchor="t" anchorCtr="0">
+            <a:spAutoFit/>
+          </a:bodyPr>
+          <a:lstStyle/>
+          <a:p>
+            <a:pPr algn="l"/>
+            <a:r>
+              <a:rPr lang="zh-CN" sz="1050" dirty="0">
+                <a:solidFill>
+                  <a:srgbClr val="B7C7DE"/>
+                </a:solidFill>
+                <a:latin typeface="Arial"/>
+                <a:ea typeface="Microsoft YaHei"/>
+                <a:cs typeface="Arial"/>
+              </a:rPr>
+              <a:t>· 批量/恢复</a:t>
+            </a:r>
+          </a:p>
+        </p:txBody>
+      </p:sp>
+      <p:sp>
+        <p:nvSpPr>
+          <p:cNvPr id="40" name="TextBox 40"/>
+          <p:cNvSpPr txBox="1"/>
+          <p:nvPr/>
+        </p:nvSpPr>
+        <p:spPr>
+          <a:xfrm>
+            <a:off x="7962900" y="6554152"/>
+            <a:ext cx="3472434" cy="205359"/>
+          </a:xfrm>
+          <a:prstGeom prst="rect">
+            <a:avLst/>
+          </a:prstGeom>
+          <a:noFill/>
+          <a:ln>
+            <a:noFill/>
+          </a:ln>
+        </p:spPr>
+        <p:txBody>
+          <a:bodyPr wrap="none" lIns="0" tIns="0" rIns="0" bIns="0" anchor="t" anchorCtr="0">
+            <a:spAutoFit/>
+          </a:bodyPr>
+          <a:lstStyle/>
+          <a:p>
+            <a:pPr algn="r"/>
+            <a:r>
+              <a:rPr lang="en-US" sz="1050" dirty="0">
+                <a:solidFill>
+                  <a:srgbClr val="91A9C8"/>
+                </a:solidFill>
+                <a:latin typeface="Arial"/>
+                <a:ea typeface="Arial"/>
+                <a:cs typeface="Arial"/>
+              </a:rPr>
+              <a:t>C++17 · CMake · cpp-httplib · Vanilla JS · Tailwind</a:t>
+            </a:r>
+          </a:p>
+        </p:txBody>
+      </p:sp>
+    </p:spTree>
+  </p:cSld>
+  <p:clrMapOvr>
+    <a:masterClrMapping/>
+  </p:clrMapOvr>
+  <p:transition xmlns:p14="http://schemas.microsoft.com/office/powerpoint/2010/main" p14:dur="400">
+    <p:fade/>
+  </p:transition>
+</p:sld>
+</file>
+
+<file path=ppt/slides/slide8.xml><?xml version="1.0" encoding="utf-8"?>
+<p:sld xmlns:a="http://schemas.openxmlformats.org/drawingml/2006/main" xmlns:r="http://schemas.openxmlformats.org/officeDocument/2006/relationships" xmlns:p="http://schemas.openxmlformats.org/presentationml/2006/main">
+  <p:cSld>
+    <p:spTree>
+      <p:nvGrpSpPr>
+        <p:cNvPr id="1" name=""/>
+        <p:cNvGrpSpPr/>
+        <p:nvPr/>
+      </p:nvGrpSpPr>
+      <p:grpSpPr>
+        <a:xfrm>
+          <a:off x="0" y="0"/>
+          <a:ext cx="0" cy="0"/>
+          <a:chOff x="0" y="0"/>
+          <a:chExt cx="0" cy="0"/>
+        </a:xfrm>
+      </p:grpSpPr>
+      <p:sp>
+        <p:nvSpPr>
+          <p:cNvPr id="2" name="Rectangle 2"/>
+          <p:cNvSpPr/>
+          <p:nvPr/>
+        </p:nvSpPr>
+        <p:spPr>
+          <a:xfrm>
+            <a:off x="0" y="0"/>
+            <a:ext cx="12192000" cy="6858000"/>
+          </a:xfrm>
+          <a:prstGeom prst="rect">
+            <a:avLst/>
+          </a:prstGeom>
+          <a:solidFill>
+            <a:srgbClr val="0B1F3A"/>
+          </a:solidFill>
+          <a:ln>
+            <a:noFill/>
+          </a:ln>
+        </p:spPr>
+      </p:sp>
+      <p:sp>
+        <p:nvSpPr>
+          <p:cNvPr id="3" name="TextBox 3"/>
+          <p:cNvSpPr txBox="1"/>
+          <p:nvPr/>
+        </p:nvSpPr>
+        <p:spPr>
+          <a:xfrm>
+            <a:off x="745236" y="501015"/>
+            <a:ext cx="3298736" cy="645414"/>
+          </a:xfrm>
+          <a:prstGeom prst="rect">
+            <a:avLst/>
+          </a:prstGeom>
+          <a:noFill/>
+          <a:ln>
+            <a:noFill/>
+          </a:ln>
+        </p:spPr>
+        <p:txBody>
+          <a:bodyPr wrap="none" lIns="0" tIns="0" rIns="0" bIns="0" anchor="t" anchorCtr="0">
+            <a:spAutoFit/>
+          </a:bodyPr>
+          <a:lstStyle/>
+          <a:p>
+            <a:pPr algn="l"/>
+            <a:r>
+              <a:rPr lang="zh-CN" sz="3300" b="1" dirty="0">
+                <a:solidFill>
+                  <a:srgbClr val="FFFFFF"/>
+                </a:solidFill>
+                <a:latin typeface="Arial"/>
+                <a:ea typeface="Microsoft YaHei"/>
+                <a:cs typeface="Arial"/>
+              </a:rPr>
+              <a:t>测试验证与总结</a:t>
+            </a:r>
+          </a:p>
+        </p:txBody>
+      </p:sp>
+      <p:sp>
+        <p:nvSpPr>
+          <p:cNvPr id="4" name="Line 4"/>
+          <p:cNvSpPr/>
+          <p:nvPr/>
+        </p:nvSpPr>
+        <p:spPr>
+          <a:xfrm>
+            <a:off x="762000" y="1047750"/>
+            <a:ext cx="10668000" cy="9525"/>
+          </a:xfrm>
+          <a:custGeom>
+            <a:avLst/>
+            <a:gdLst/>
+            <a:ahLst/>
+            <a:cxnLst/>
+            <a:rect l="l" t="t" r="r" b="b"/>
+            <a:pathLst>
+              <a:path w="10668000" h="9525">
+                <a:moveTo>
+                  <a:pt x="0" y="0"/>
+                </a:moveTo>
+                <a:lnTo>
+                  <a:pt x="10668000" y="0"/>
+                </a:lnTo>
+              </a:path>
+            </a:pathLst>
+          </a:custGeom>
+          <a:noFill/>
+          <a:ln w="28575" cap="rnd">
+            <a:solidFill>
+              <a:srgbClr val="E4002B"/>
+            </a:solidFill>
+          </a:ln>
+        </p:spPr>
+      </p:sp>
+      <p:sp>
+        <p:nvSpPr>
+          <p:cNvPr id="5" name="Rectangle 5"/>
+          <p:cNvSpPr/>
+          <p:nvPr/>
+        </p:nvSpPr>
+        <p:spPr>
+          <a:xfrm>
+            <a:off x="571500" y="1666875"/>
+            <a:ext cx="5334000" cy="2524125"/>
+          </a:xfrm>
+          <a:prstGeom prst="roundRect">
+            <a:avLst>
+              <a:gd name="adj" fmla="val 3774"/>
+            </a:avLst>
+          </a:prstGeom>
+          <a:solidFill>
+            <a:srgbClr val="132846"/>
+          </a:solidFill>
+          <a:ln w="19050">
+            <a:solidFill>
+              <a:srgbClr val="1E3A5F"/>
+            </a:solidFill>
+          </a:ln>
+        </p:spPr>
+      </p:sp>
+      <p:sp>
+        <p:nvSpPr>
+          <p:cNvPr id="6" name="TextBox 6"/>
+          <p:cNvSpPr txBox="1"/>
+          <p:nvPr/>
+        </p:nvSpPr>
+        <p:spPr>
+          <a:xfrm>
+            <a:off x="752856" y="1805940"/>
+            <a:ext cx="1036015" cy="352044"/>
+          </a:xfrm>
+          <a:prstGeom prst="rect">
+            <a:avLst/>
+          </a:prstGeom>
+          <a:noFill/>
+          <a:ln>
+            <a:noFill/>
+          </a:ln>
+        </p:spPr>
+        <p:txBody>
+          <a:bodyPr wrap="none" lIns="0" tIns="0" rIns="0" bIns="0" anchor="t" anchorCtr="0">
+            <a:spAutoFit/>
+          </a:bodyPr>
+          <a:lstStyle/>
+          <a:p>
+            <a:pPr algn="l"/>
+            <a:r>
+              <a:rPr lang="zh-CN" sz="1800" b="1" dirty="0">
+                <a:solidFill>
+                  <a:srgbClr val="FFD54F"/>
+                </a:solidFill>
+                <a:latin typeface="Arial"/>
+                <a:ea typeface="Microsoft YaHei"/>
+                <a:cs typeface="Arial"/>
+              </a:rPr>
+              <a:t>测试覆盖</a:t>
+            </a:r>
+          </a:p>
+        </p:txBody>
+      </p:sp>
+      <p:sp>
+        <p:nvSpPr>
+          <p:cNvPr id="7" name="TextBox 7"/>
+          <p:cNvSpPr txBox="1"/>
+          <p:nvPr/>
+        </p:nvSpPr>
+        <p:spPr>
+          <a:xfrm>
+            <a:off x="755142" y="2235518"/>
+            <a:ext cx="3458000" cy="264033"/>
+          </a:xfrm>
+          <a:prstGeom prst="rect">
+            <a:avLst/>
+          </a:prstGeom>
+          <a:noFill/>
+          <a:ln>
+            <a:noFill/>
+          </a:ln>
+        </p:spPr>
+        <p:txBody>
+          <a:bodyPr wrap="none" lIns="0" tIns="0" rIns="0" bIns="0" anchor="t" anchorCtr="0">
+            <a:spAutoFit/>
+          </a:bodyPr>
+          <a:lstStyle/>
+          <a:p>
+            <a:pPr algn="l"/>
+            <a:r>
+              <a:rPr lang="zh-CN" sz="1350" dirty="0">
+                <a:solidFill>
+                  <a:srgbClr val="DDEBFF"/>
+                </a:solidFill>
+                <a:latin typeface="Arial"/>
+                <a:ea typeface="Microsoft YaHei"/>
+                <a:cs typeface="Arial"/>
+              </a:rPr>
+              <a:t>test_cases.cpp 41 / 41 ✅ M1-M4 + 扩展</a:t>
+            </a:r>
+          </a:p>
+        </p:txBody>
+      </p:sp>
+      <p:sp>
+        <p:nvSpPr>
+          <p:cNvPr id="8" name="TextBox 8"/>
+          <p:cNvSpPr txBox="1"/>
+          <p:nvPr/>
+        </p:nvSpPr>
+        <p:spPr>
+          <a:xfrm>
+            <a:off x="755142" y="2568892"/>
+            <a:ext cx="2241194" cy="264033"/>
+          </a:xfrm>
+          <a:prstGeom prst="rect">
+            <a:avLst/>
+          </a:prstGeom>
+          <a:noFill/>
+          <a:ln>
+            <a:noFill/>
+          </a:ln>
+        </p:spPr>
+        <p:txBody>
+          <a:bodyPr wrap="none" lIns="0" tIns="0" rIns="0" bIns="0" anchor="t" anchorCtr="0">
+            <a:spAutoFit/>
+          </a:bodyPr>
+          <a:lstStyle/>
+          <a:p>
+            <a:pPr algn="l"/>
+            <a:r>
+              <a:rPr lang="zh-CN" sz="1350" dirty="0">
+                <a:solidFill>
+                  <a:srgbClr val="DDEBFF"/>
+                </a:solidFill>
+                <a:latin typeface="Arial"/>
+                <a:ea typeface="Microsoft YaHei"/>
+                <a:cs typeface="Arial"/>
+              </a:rPr>
+              <a:t>· M1 菜单结构 · 输入验证</a:t>
+            </a:r>
+          </a:p>
+        </p:txBody>
+      </p:sp>
+      <p:sp>
+        <p:nvSpPr>
+          <p:cNvPr id="9" name="TextBox 9"/>
+          <p:cNvSpPr txBox="1"/>
+          <p:nvPr/>
+        </p:nvSpPr>
+        <p:spPr>
+          <a:xfrm>
+            <a:off x="755142" y="2902268"/>
+            <a:ext cx="2846070" cy="264033"/>
+          </a:xfrm>
+          <a:prstGeom prst="rect">
+            <a:avLst/>
+          </a:prstGeom>
+          <a:noFill/>
+          <a:ln>
+            <a:noFill/>
+          </a:ln>
+        </p:spPr>
+        <p:txBody>
+          <a:bodyPr wrap="none" lIns="0" tIns="0" rIns="0" bIns="0" anchor="t" anchorCtr="0">
+            <a:spAutoFit/>
+          </a:bodyPr>
+          <a:lstStyle/>
+          <a:p>
+            <a:pPr algn="l"/>
+            <a:r>
+              <a:rPr lang="zh-CN" sz="1350" dirty="0">
+                <a:solidFill>
+                  <a:srgbClr val="DDEBFF"/>
+                </a:solidFill>
+                <a:latin typeface="Arial"/>
+                <a:ea typeface="Microsoft YaHei"/>
+                <a:cs typeface="Arial"/>
+              </a:rPr>
+              <a:t>· M2 运营管理 · 批量更新 · 恢复</a:t>
+            </a:r>
+          </a:p>
+        </p:txBody>
+      </p:sp>
+      <p:sp>
+        <p:nvSpPr>
+          <p:cNvPr id="10" name="TextBox 10"/>
+          <p:cNvSpPr txBox="1"/>
+          <p:nvPr/>
+        </p:nvSpPr>
+        <p:spPr>
+          <a:xfrm>
+            <a:off x="755142" y="3235642"/>
+            <a:ext cx="2759978" cy="264033"/>
+          </a:xfrm>
+          <a:prstGeom prst="rect">
+            <a:avLst/>
+          </a:prstGeom>
+          <a:noFill/>
+          <a:ln>
+            <a:noFill/>
+          </a:ln>
+        </p:spPr>
+        <p:txBody>
+          <a:bodyPr wrap="none" lIns="0" tIns="0" rIns="0" bIns="0" anchor="t" anchorCtr="0">
+            <a:spAutoFit/>
+          </a:bodyPr>
+          <a:lstStyle/>
+          <a:p>
+            <a:pPr algn="l"/>
+            <a:r>
+              <a:rPr lang="en-US" sz="1350" dirty="0">
+                <a:solidFill>
+                  <a:srgbClr val="DDEBFF"/>
+                </a:solidFill>
+                <a:latin typeface="Arial"/>
+                <a:ea typeface="Arial"/>
+                <a:cs typeface="Arial"/>
+              </a:rPr>
+              <a:t>· M3 Dijkstra · Yen K-shortest</a:t>
+            </a:r>
+          </a:p>
+        </p:txBody>
+      </p:sp>
+      <p:sp>
+        <p:nvSpPr>
+          <p:cNvPr id="11" name="TextBox 11"/>
+          <p:cNvSpPr txBox="1"/>
+          <p:nvPr/>
+        </p:nvSpPr>
+        <p:spPr>
+          <a:xfrm>
+            <a:off x="755142" y="3569018"/>
+            <a:ext cx="3172768" cy="264033"/>
+          </a:xfrm>
+          <a:prstGeom prst="rect">
+            <a:avLst/>
+          </a:prstGeom>
+          <a:noFill/>
+          <a:ln>
+            <a:noFill/>
+          </a:ln>
+        </p:spPr>
+        <p:txBody>
+          <a:bodyPr wrap="none" lIns="0" tIns="0" rIns="0" bIns="0" anchor="t" anchorCtr="0">
+            <a:spAutoFit/>
+          </a:bodyPr>
+          <a:lstStyle/>
+          <a:p>
+            <a:pPr algn="l"/>
+            <a:r>
+              <a:rPr lang="zh-CN" sz="1350" dirty="0">
+                <a:solidFill>
+                  <a:srgbClr val="DDEBFF"/>
+                </a:solidFill>
+                <a:latin typeface="Arial"/>
+                <a:ea typeface="Microsoft YaHei"/>
+                <a:cs typeface="Arial"/>
+              </a:rPr>
+              <a:t>· M4 最少换乘 · Yen K-min-transfer</a:t>
+            </a:r>
+          </a:p>
+        </p:txBody>
+      </p:sp>
+      <p:sp>
+        <p:nvSpPr>
+          <p:cNvPr id="12" name="TextBox 12"/>
+          <p:cNvSpPr txBox="1"/>
+          <p:nvPr/>
+        </p:nvSpPr>
+        <p:spPr>
+          <a:xfrm>
+            <a:off x="755142" y="3854768"/>
+            <a:ext cx="4011930" cy="264033"/>
+          </a:xfrm>
+          <a:prstGeom prst="rect">
+            <a:avLst/>
+          </a:prstGeom>
+          <a:noFill/>
+          <a:ln>
+            <a:noFill/>
+          </a:ln>
+        </p:spPr>
+        <p:txBody>
+          <a:bodyPr wrap="none" lIns="0" tIns="0" rIns="0" bIns="0" anchor="t" anchorCtr="0">
+            <a:spAutoFit/>
+          </a:bodyPr>
+          <a:lstStyle/>
+          <a:p>
+            <a:pPr algn="l"/>
+            <a:r>
+              <a:rPr lang="zh-CN" sz="1350" dirty="0">
+                <a:solidFill>
+                  <a:srgbClr val="DDEBFF"/>
+                </a:solidFill>
+                <a:latin typeface="Arial"/>
+                <a:ea typeface="Microsoft YaHei"/>
+                <a:cs typeface="Arial"/>
+              </a:rPr>
+              <a:t>coursework_check.cpp 53 / 53 ✅ 课设要求映射</a:t>
+            </a:r>
+          </a:p>
+        </p:txBody>
+      </p:sp>
+      <p:sp>
+        <p:nvSpPr>
+          <p:cNvPr id="13" name="Rectangle 13"/>
+          <p:cNvSpPr/>
+          <p:nvPr/>
+        </p:nvSpPr>
+        <p:spPr>
+          <a:xfrm>
+            <a:off x="6286500" y="1666875"/>
+            <a:ext cx="5334000" cy="2524125"/>
+          </a:xfrm>
+          <a:prstGeom prst="roundRect">
+            <a:avLst>
+              <a:gd name="adj" fmla="val 3774"/>
+            </a:avLst>
+          </a:prstGeom>
+          <a:solidFill>
+            <a:srgbClr val="132846"/>
+          </a:solidFill>
+          <a:ln w="19050">
+            <a:solidFill>
+              <a:srgbClr val="1E3A5F"/>
+            </a:solidFill>
+          </a:ln>
+        </p:spPr>
+      </p:sp>
+      <p:sp>
+        <p:nvSpPr>
+          <p:cNvPr id="14" name="TextBox 14"/>
+          <p:cNvSpPr txBox="1"/>
+          <p:nvPr/>
+        </p:nvSpPr>
+        <p:spPr>
+          <a:xfrm>
+            <a:off x="6467856" y="1805940"/>
+            <a:ext cx="1506714" cy="352044"/>
+          </a:xfrm>
+          <a:prstGeom prst="rect">
+            <a:avLst/>
+          </a:prstGeom>
+          <a:noFill/>
+          <a:ln>
+            <a:noFill/>
+          </a:ln>
+        </p:spPr>
+        <p:txBody>
+          <a:bodyPr wrap="none" lIns="0" tIns="0" rIns="0" bIns="0" anchor="t" anchorCtr="0">
+            <a:spAutoFit/>
+          </a:bodyPr>
+          <a:lstStyle/>
+          <a:p>
+            <a:pPr algn="l"/>
+            <a:r>
+              <a:rPr lang="zh-CN" sz="1800" b="1" dirty="0">
+                <a:solidFill>
+                  <a:srgbClr val="FFD54F"/>
+                </a:solidFill>
+                <a:latin typeface="Arial"/>
+                <a:ea typeface="Microsoft YaHei"/>
+                <a:cs typeface="Arial"/>
+              </a:rPr>
+              <a:t>6 大模块覆盖</a:t>
+            </a:r>
+          </a:p>
+        </p:txBody>
+      </p:sp>
+      <p:sp>
+        <p:nvSpPr>
+          <p:cNvPr id="15" name="TextBox 15"/>
+          <p:cNvSpPr txBox="1"/>
+          <p:nvPr/>
+        </p:nvSpPr>
+        <p:spPr>
+          <a:xfrm>
+            <a:off x="6470904" y="2299335"/>
+            <a:ext cx="819912" cy="234696"/>
+          </a:xfrm>
+          <a:prstGeom prst="rect">
+            <a:avLst/>
+          </a:prstGeom>
+          <a:noFill/>
+          <a:ln>
+            <a:noFill/>
+          </a:ln>
+        </p:spPr>
+        <p:txBody>
+          <a:bodyPr wrap="none" lIns="0" tIns="0" rIns="0" bIns="0" anchor="t" anchorCtr="0">
+            <a:spAutoFit/>
+          </a:bodyPr>
+          <a:lstStyle/>
+          <a:p>
+            <a:pPr algn="l"/>
+            <a:r>
+              <a:rPr lang="zh-CN" sz="1200" dirty="0">
+                <a:solidFill>
+                  <a:srgbClr val="DDEBFF"/>
+                </a:solidFill>
+                <a:latin typeface="Arial"/>
+                <a:ea typeface="Microsoft YaHei"/>
+                <a:cs typeface="Arial"/>
+              </a:rPr>
+              <a:t>数据集建设</a:t>
+            </a:r>
+          </a:p>
+        </p:txBody>
+      </p:sp>
+      <p:sp>
+        <p:nvSpPr>
+          <p:cNvPr id="16" name="TextBox 16"/>
+          <p:cNvSpPr txBox="1"/>
+          <p:nvPr/>
+        </p:nvSpPr>
+        <p:spPr>
+          <a:xfrm>
+            <a:off x="8566404" y="2299335"/>
+            <a:ext cx="504901" cy="234696"/>
+          </a:xfrm>
+          <a:prstGeom prst="rect">
+            <a:avLst/>
+          </a:prstGeom>
+          <a:noFill/>
+          <a:ln>
+            <a:noFill/>
+          </a:ln>
+        </p:spPr>
+        <p:txBody>
+          <a:bodyPr wrap="none" lIns="0" tIns="0" rIns="0" bIns="0" anchor="t" anchorCtr="0">
+            <a:spAutoFit/>
+          </a:bodyPr>
+          <a:lstStyle/>
+          <a:p>
+            <a:pPr algn="l"/>
+            <a:r>
+              <a:rPr lang="en-US" sz="1200" dirty="0">
+                <a:solidFill>
+                  <a:srgbClr val="DDEBFF"/>
+                </a:solidFill>
+                <a:latin typeface="Arial"/>
+                <a:ea typeface="Arial"/>
+                <a:cs typeface="Arial"/>
+              </a:rPr>
+              <a:t>10 pts</a:t>
+            </a:r>
+          </a:p>
+        </p:txBody>
+      </p:sp>
+      <p:sp>
+        <p:nvSpPr>
+          <p:cNvPr id="17" name="TextBox 17"/>
+          <p:cNvSpPr txBox="1"/>
+          <p:nvPr/>
+        </p:nvSpPr>
+        <p:spPr>
+          <a:xfrm>
+            <a:off x="9518904" y="2299335"/>
+            <a:ext cx="101041" cy="234696"/>
+          </a:xfrm>
+          <a:prstGeom prst="rect">
+            <a:avLst/>
+          </a:prstGeom>
+          <a:noFill/>
+          <a:ln>
+            <a:noFill/>
+          </a:ln>
+        </p:spPr>
+        <p:txBody>
+          <a:bodyPr wrap="none" lIns="0" tIns="0" rIns="0" bIns="0" anchor="t" anchorCtr="0">
+            <a:spAutoFit/>
+          </a:bodyPr>
+          <a:lstStyle/>
+          <a:p>
+            <a:pPr algn="l"/>
+            <a:r>
+              <a:rPr lang="en-US" sz="1200" dirty="0">
+                <a:solidFill>
+                  <a:srgbClr val="FFD54F"/>
+                </a:solidFill>
+                <a:latin typeface="Arial"/>
+                <a:ea typeface="Arial"/>
+                <a:cs typeface="Arial"/>
+              </a:rPr>
+              <a:t>✅</a:t>
+            </a:r>
+          </a:p>
+        </p:txBody>
+      </p:sp>
+      <p:sp>
+        <p:nvSpPr>
+          <p:cNvPr id="18" name="TextBox 18"/>
+          <p:cNvSpPr txBox="1"/>
+          <p:nvPr/>
+        </p:nvSpPr>
+        <p:spPr>
+          <a:xfrm>
+            <a:off x="9804654" y="2299335"/>
+            <a:ext cx="1275283" cy="234696"/>
+          </a:xfrm>
+          <a:prstGeom prst="rect">
+            <a:avLst/>
+          </a:prstGeom>
+          <a:noFill/>
+          <a:ln>
+            <a:noFill/>
+          </a:ln>
+        </p:spPr>
+        <p:txBody>
+          <a:bodyPr wrap="none" lIns="0" tIns="0" rIns="0" bIns="0" anchor="t" anchorCtr="0">
+            <a:spAutoFit/>
+          </a:bodyPr>
+          <a:lstStyle/>
+          <a:p>
+            <a:pPr algn="l"/>
+            <a:r>
+              <a:rPr lang="zh-CN" sz="1200" dirty="0">
+                <a:solidFill>
+                  <a:srgbClr val="B7C7DE"/>
+                </a:solidFill>
+                <a:latin typeface="Arial"/>
+                <a:ea typeface="Microsoft YaHei"/>
+                <a:cs typeface="Arial"/>
+              </a:rPr>
+              <a:t>20 线路 API 抓取</a:t>
+            </a:r>
+          </a:p>
+        </p:txBody>
+      </p:sp>
+      <p:sp>
+        <p:nvSpPr>
+          <p:cNvPr id="19" name="TextBox 19"/>
+          <p:cNvSpPr txBox="1"/>
+          <p:nvPr/>
+        </p:nvSpPr>
+        <p:spPr>
+          <a:xfrm>
+            <a:off x="6470904" y="2585085"/>
+            <a:ext cx="496824" cy="234696"/>
+          </a:xfrm>
+          <a:prstGeom prst="rect">
+            <a:avLst/>
+          </a:prstGeom>
+          <a:noFill/>
+          <a:ln>
+            <a:noFill/>
+          </a:ln>
+        </p:spPr>
+        <p:txBody>
+          <a:bodyPr wrap="none" lIns="0" tIns="0" rIns="0" bIns="0" anchor="t" anchorCtr="0">
+            <a:spAutoFit/>
+          </a:bodyPr>
+          <a:lstStyle/>
+          <a:p>
+            <a:pPr algn="l"/>
+            <a:r>
+              <a:rPr lang="zh-CN" sz="1200" dirty="0">
+                <a:solidFill>
+                  <a:srgbClr val="DDEBFF"/>
+                </a:solidFill>
+                <a:latin typeface="Arial"/>
+                <a:ea typeface="Microsoft YaHei"/>
+                <a:cs typeface="Arial"/>
+              </a:rPr>
+              <a:t>图拓扑</a:t>
+            </a:r>
+          </a:p>
+        </p:txBody>
+      </p:sp>
+      <p:sp>
+        <p:nvSpPr>
+          <p:cNvPr id="20" name="TextBox 20"/>
+          <p:cNvSpPr txBox="1"/>
+          <p:nvPr/>
+        </p:nvSpPr>
+        <p:spPr>
+          <a:xfrm>
+            <a:off x="8566404" y="2585085"/>
+            <a:ext cx="504901" cy="234696"/>
+          </a:xfrm>
+          <a:prstGeom prst="rect">
+            <a:avLst/>
+          </a:prstGeom>
+          <a:noFill/>
+          <a:ln>
+            <a:noFill/>
+          </a:ln>
+        </p:spPr>
+        <p:txBody>
+          <a:bodyPr wrap="none" lIns="0" tIns="0" rIns="0" bIns="0" anchor="t" anchorCtr="0">
+            <a:spAutoFit/>
+          </a:bodyPr>
+          <a:lstStyle/>
+          <a:p>
+            <a:pPr algn="l"/>
+            <a:r>
+              <a:rPr lang="en-US" sz="1200" dirty="0">
+                <a:solidFill>
+                  <a:srgbClr val="DDEBFF"/>
+                </a:solidFill>
+                <a:latin typeface="Arial"/>
+                <a:ea typeface="Arial"/>
+                <a:cs typeface="Arial"/>
+              </a:rPr>
+              <a:t>10 pts</a:t>
+            </a:r>
+          </a:p>
+        </p:txBody>
+      </p:sp>
+      <p:sp>
+        <p:nvSpPr>
+          <p:cNvPr id="21" name="TextBox 21"/>
+          <p:cNvSpPr txBox="1"/>
+          <p:nvPr/>
+        </p:nvSpPr>
+        <p:spPr>
+          <a:xfrm>
+            <a:off x="9518904" y="2585085"/>
+            <a:ext cx="101041" cy="234696"/>
+          </a:xfrm>
+          <a:prstGeom prst="rect">
+            <a:avLst/>
+          </a:prstGeom>
+          <a:noFill/>
+          <a:ln>
+            <a:noFill/>
+          </a:ln>
+        </p:spPr>
+        <p:txBody>
+          <a:bodyPr wrap="none" lIns="0" tIns="0" rIns="0" bIns="0" anchor="t" anchorCtr="0">
+            <a:spAutoFit/>
+          </a:bodyPr>
+          <a:lstStyle/>
+          <a:p>
+            <a:pPr algn="l"/>
+            <a:r>
+              <a:rPr lang="en-US" sz="1200" dirty="0">
+                <a:solidFill>
+                  <a:srgbClr val="FFD54F"/>
+                </a:solidFill>
+                <a:latin typeface="Arial"/>
+                <a:ea typeface="Arial"/>
+                <a:cs typeface="Arial"/>
+              </a:rPr>
+              <a:t>✅</a:t>
+            </a:r>
+          </a:p>
+        </p:txBody>
+      </p:sp>
+      <p:sp>
+        <p:nvSpPr>
+          <p:cNvPr id="22" name="TextBox 22"/>
+          <p:cNvSpPr txBox="1"/>
+          <p:nvPr/>
+        </p:nvSpPr>
+        <p:spPr>
+          <a:xfrm>
+            <a:off x="9804654" y="2585085"/>
+            <a:ext cx="1482242" cy="234696"/>
+          </a:xfrm>
+          <a:prstGeom prst="rect">
+            <a:avLst/>
+          </a:prstGeom>
+          <a:noFill/>
+          <a:ln>
+            <a:noFill/>
+          </a:ln>
+        </p:spPr>
+        <p:txBody>
+          <a:bodyPr wrap="none" lIns="0" tIns="0" rIns="0" bIns="0" anchor="t" anchorCtr="0">
+            <a:spAutoFit/>
+          </a:bodyPr>
+          <a:lstStyle/>
+          <a:p>
+            <a:pPr algn="l"/>
+            <a:r>
+              <a:rPr lang="zh-CN" sz="1200" dirty="0">
+                <a:solidFill>
+                  <a:srgbClr val="B7C7DE"/>
+                </a:solidFill>
+                <a:latin typeface="Arial"/>
+                <a:ea typeface="Microsoft YaHei"/>
+                <a:cs typeface="Arial"/>
+              </a:rPr>
+              <a:t>800 节点 + 换乘拆分</a:t>
+            </a:r>
+          </a:p>
+        </p:txBody>
+      </p:sp>
+      <p:sp>
+        <p:nvSpPr>
+          <p:cNvPr id="23" name="TextBox 23"/>
+          <p:cNvSpPr txBox="1"/>
+          <p:nvPr/>
+        </p:nvSpPr>
+        <p:spPr>
+          <a:xfrm>
+            <a:off x="6470904" y="2870835"/>
+            <a:ext cx="658368" cy="234696"/>
+          </a:xfrm>
+          <a:prstGeom prst="rect">
+            <a:avLst/>
+          </a:prstGeom>
+          <a:noFill/>
+          <a:ln>
+            <a:noFill/>
+          </a:ln>
+        </p:spPr>
+        <p:txBody>
+          <a:bodyPr wrap="none" lIns="0" tIns="0" rIns="0" bIns="0" anchor="t" anchorCtr="0">
+            <a:spAutoFit/>
+          </a:bodyPr>
+          <a:lstStyle/>
+          <a:p>
+            <a:pPr algn="l"/>
+            <a:r>
+              <a:rPr lang="zh-CN" sz="1200" dirty="0">
+                <a:solidFill>
+                  <a:srgbClr val="DDEBFF"/>
+                </a:solidFill>
+                <a:latin typeface="Arial"/>
+                <a:ea typeface="Microsoft YaHei"/>
+                <a:cs typeface="Arial"/>
+              </a:rPr>
+              <a:t>路径算法</a:t>
+            </a:r>
+          </a:p>
+        </p:txBody>
+      </p:sp>
+      <p:sp>
+        <p:nvSpPr>
+          <p:cNvPr id="24" name="TextBox 24"/>
+          <p:cNvSpPr txBox="1"/>
+          <p:nvPr/>
+        </p:nvSpPr>
+        <p:spPr>
+          <a:xfrm>
+            <a:off x="8566404" y="2870835"/>
+            <a:ext cx="504901" cy="234696"/>
+          </a:xfrm>
+          <a:prstGeom prst="rect">
+            <a:avLst/>
+          </a:prstGeom>
+          <a:noFill/>
+          <a:ln>
+            <a:noFill/>
+          </a:ln>
+        </p:spPr>
+        <p:txBody>
+          <a:bodyPr wrap="none" lIns="0" tIns="0" rIns="0" bIns="0" anchor="t" anchorCtr="0">
+            <a:spAutoFit/>
+          </a:bodyPr>
+          <a:lstStyle/>
+          <a:p>
+            <a:pPr algn="l"/>
+            <a:r>
+              <a:rPr lang="en-US" sz="1200" dirty="0">
+                <a:solidFill>
+                  <a:srgbClr val="DDEBFF"/>
+                </a:solidFill>
+                <a:latin typeface="Arial"/>
+                <a:ea typeface="Arial"/>
+                <a:cs typeface="Arial"/>
+              </a:rPr>
+              <a:t>15 pts</a:t>
+            </a:r>
+          </a:p>
+        </p:txBody>
+      </p:sp>
+      <p:sp>
+        <p:nvSpPr>
+          <p:cNvPr id="25" name="TextBox 25"/>
+          <p:cNvSpPr txBox="1"/>
+          <p:nvPr/>
+        </p:nvSpPr>
+        <p:spPr>
+          <a:xfrm>
+            <a:off x="9518904" y="2870835"/>
+            <a:ext cx="101041" cy="234696"/>
+          </a:xfrm>
+          <a:prstGeom prst="rect">
+            <a:avLst/>
+          </a:prstGeom>
+          <a:noFill/>
+          <a:ln>
+            <a:noFill/>
+          </a:ln>
+        </p:spPr>
+        <p:txBody>
+          <a:bodyPr wrap="none" lIns="0" tIns="0" rIns="0" bIns="0" anchor="t" anchorCtr="0">
+            <a:spAutoFit/>
+          </a:bodyPr>
+          <a:lstStyle/>
+          <a:p>
+            <a:pPr algn="l"/>
+            <a:r>
+              <a:rPr lang="en-US" sz="1200" dirty="0">
+                <a:solidFill>
+                  <a:srgbClr val="FFD54F"/>
+                </a:solidFill>
+                <a:latin typeface="Arial"/>
+                <a:ea typeface="Arial"/>
+                <a:cs typeface="Arial"/>
+              </a:rPr>
+              <a:t>✅</a:t>
+            </a:r>
+          </a:p>
+        </p:txBody>
+      </p:sp>
+      <p:sp>
+        <p:nvSpPr>
+          <p:cNvPr id="26" name="TextBox 26"/>
+          <p:cNvSpPr txBox="1"/>
+          <p:nvPr/>
+        </p:nvSpPr>
+        <p:spPr>
+          <a:xfrm>
+            <a:off x="9804654" y="2870835"/>
+            <a:ext cx="1010717" cy="234696"/>
+          </a:xfrm>
+          <a:prstGeom prst="rect">
+            <a:avLst/>
+          </a:prstGeom>
+          <a:noFill/>
+          <a:ln>
+            <a:noFill/>
+          </a:ln>
+        </p:spPr>
+        <p:txBody>
+          <a:bodyPr wrap="none" lIns="0" tIns="0" rIns="0" bIns="0" anchor="t" anchorCtr="0">
+            <a:spAutoFit/>
+          </a:bodyPr>
+          <a:lstStyle/>
+          <a:p>
+            <a:pPr algn="l"/>
+            <a:r>
+              <a:rPr lang="zh-CN" sz="1200" dirty="0">
+                <a:solidFill>
+                  <a:srgbClr val="B7C7DE"/>
+                </a:solidFill>
+                <a:latin typeface="Arial"/>
+                <a:ea typeface="Microsoft YaHei"/>
+                <a:cs typeface="Arial"/>
+              </a:rPr>
+              <a:t>4 算法 + K 优</a:t>
+            </a:r>
+          </a:p>
+        </p:txBody>
+      </p:sp>
+      <p:sp>
+        <p:nvSpPr>
+          <p:cNvPr id="27" name="TextBox 27"/>
+          <p:cNvSpPr txBox="1"/>
+          <p:nvPr/>
+        </p:nvSpPr>
+        <p:spPr>
+          <a:xfrm>
+            <a:off x="6470904" y="3156585"/>
+            <a:ext cx="658368" cy="234696"/>
+          </a:xfrm>
+          <a:prstGeom prst="rect">
+            <a:avLst/>
+          </a:prstGeom>
+          <a:noFill/>
+          <a:ln>
+            <a:noFill/>
+          </a:ln>
+        </p:spPr>
+        <p:txBody>
+          <a:bodyPr wrap="none" lIns="0" tIns="0" rIns="0" bIns="0" anchor="t" anchorCtr="0">
+            <a:spAutoFit/>
+          </a:bodyPr>
+          <a:lstStyle/>
+          <a:p>
+            <a:pPr algn="l"/>
+            <a:r>
+              <a:rPr lang="zh-CN" sz="1200" dirty="0">
+                <a:solidFill>
+                  <a:srgbClr val="DDEBFF"/>
+                </a:solidFill>
+                <a:latin typeface="Arial"/>
+                <a:ea typeface="Microsoft YaHei"/>
+                <a:cs typeface="Arial"/>
+              </a:rPr>
+              <a:t>运营管理</a:t>
+            </a:r>
+          </a:p>
+        </p:txBody>
+      </p:sp>
+      <p:sp>
+        <p:nvSpPr>
+          <p:cNvPr id="28" name="TextBox 28"/>
+          <p:cNvSpPr txBox="1"/>
+          <p:nvPr/>
+        </p:nvSpPr>
+        <p:spPr>
+          <a:xfrm>
+            <a:off x="8566404" y="3156585"/>
+            <a:ext cx="504901" cy="234696"/>
+          </a:xfrm>
+          <a:prstGeom prst="rect">
+            <a:avLst/>
+          </a:prstGeom>
+          <a:noFill/>
+          <a:ln>
+            <a:noFill/>
+          </a:ln>
+        </p:spPr>
+        <p:txBody>
+          <a:bodyPr wrap="none" lIns="0" tIns="0" rIns="0" bIns="0" anchor="t" anchorCtr="0">
+            <a:spAutoFit/>
+          </a:bodyPr>
+          <a:lstStyle/>
+          <a:p>
+            <a:pPr algn="l"/>
+            <a:r>
+              <a:rPr lang="en-US" sz="1200" dirty="0">
+                <a:solidFill>
+                  <a:srgbClr val="DDEBFF"/>
+                </a:solidFill>
+                <a:latin typeface="Arial"/>
+                <a:ea typeface="Arial"/>
+                <a:cs typeface="Arial"/>
+              </a:rPr>
+              <a:t>15 pts</a:t>
+            </a:r>
+          </a:p>
+        </p:txBody>
+      </p:sp>
+      <p:sp>
+        <p:nvSpPr>
+          <p:cNvPr id="29" name="TextBox 29"/>
+          <p:cNvSpPr txBox="1"/>
+          <p:nvPr/>
+        </p:nvSpPr>
+        <p:spPr>
+          <a:xfrm>
+            <a:off x="9518904" y="3156585"/>
+            <a:ext cx="101041" cy="234696"/>
+          </a:xfrm>
+          <a:prstGeom prst="rect">
+            <a:avLst/>
+          </a:prstGeom>
+          <a:noFill/>
+          <a:ln>
+            <a:noFill/>
+          </a:ln>
+        </p:spPr>
+        <p:txBody>
+          <a:bodyPr wrap="none" lIns="0" tIns="0" rIns="0" bIns="0" anchor="t" anchorCtr="0">
+            <a:spAutoFit/>
+          </a:bodyPr>
+          <a:lstStyle/>
+          <a:p>
+            <a:pPr algn="l"/>
+            <a:r>
+              <a:rPr lang="en-US" sz="1200" dirty="0">
+                <a:solidFill>
+                  <a:srgbClr val="FFD54F"/>
+                </a:solidFill>
+                <a:latin typeface="Arial"/>
+                <a:ea typeface="Arial"/>
+                <a:cs typeface="Arial"/>
+              </a:rPr>
+              <a:t>✅</a:t>
+            </a:r>
+          </a:p>
+        </p:txBody>
+      </p:sp>
+      <p:sp>
+        <p:nvSpPr>
+          <p:cNvPr id="30" name="TextBox 30"/>
+          <p:cNvSpPr txBox="1"/>
+          <p:nvPr/>
+        </p:nvSpPr>
+        <p:spPr>
+          <a:xfrm>
+            <a:off x="9804654" y="3156585"/>
+            <a:ext cx="997610" cy="234696"/>
+          </a:xfrm>
+          <a:prstGeom prst="rect">
+            <a:avLst/>
+          </a:prstGeom>
+          <a:noFill/>
+          <a:ln>
+            <a:noFill/>
+          </a:ln>
+        </p:spPr>
+        <p:txBody>
+          <a:bodyPr wrap="none" lIns="0" tIns="0" rIns="0" bIns="0" anchor="t" anchorCtr="0">
+            <a:spAutoFit/>
+          </a:bodyPr>
+          <a:lstStyle/>
+          <a:p>
+            <a:pPr algn="l"/>
+            <a:r>
+              <a:rPr lang="zh-CN" sz="1200" dirty="0">
+                <a:solidFill>
+                  <a:srgbClr val="B7C7DE"/>
+                </a:solidFill>
+                <a:latin typeface="Arial"/>
+                <a:ea typeface="Microsoft YaHei"/>
+                <a:cs typeface="Arial"/>
+              </a:rPr>
+              <a:t>单/批量/恢复</a:t>
+            </a:r>
+          </a:p>
+        </p:txBody>
+      </p:sp>
+      <p:sp>
+        <p:nvSpPr>
+          <p:cNvPr id="31" name="TextBox 31"/>
+          <p:cNvSpPr txBox="1"/>
+          <p:nvPr/>
+        </p:nvSpPr>
+        <p:spPr>
+          <a:xfrm>
+            <a:off x="6470904" y="3442335"/>
+            <a:ext cx="658368" cy="234696"/>
+          </a:xfrm>
+          <a:prstGeom prst="rect">
+            <a:avLst/>
+          </a:prstGeom>
+          <a:noFill/>
+          <a:ln>
+            <a:noFill/>
+          </a:ln>
+        </p:spPr>
+        <p:txBody>
+          <a:bodyPr wrap="none" lIns="0" tIns="0" rIns="0" bIns="0" anchor="t" anchorCtr="0">
+            <a:spAutoFit/>
+          </a:bodyPr>
+          <a:lstStyle/>
+          <a:p>
+            <a:pPr algn="l"/>
+            <a:r>
+              <a:rPr lang="zh-CN" sz="1200" dirty="0">
+                <a:solidFill>
+                  <a:srgbClr val="DDEBFF"/>
+                </a:solidFill>
+                <a:latin typeface="Arial"/>
+                <a:ea typeface="Microsoft YaHei"/>
+                <a:cs typeface="Arial"/>
+              </a:rPr>
+              <a:t>网络分析</a:t>
+            </a:r>
+          </a:p>
+        </p:txBody>
+      </p:sp>
+      <p:sp>
+        <p:nvSpPr>
+          <p:cNvPr id="32" name="TextBox 32"/>
+          <p:cNvSpPr txBox="1"/>
+          <p:nvPr/>
+        </p:nvSpPr>
+        <p:spPr>
+          <a:xfrm>
+            <a:off x="8566404" y="3442335"/>
+            <a:ext cx="416052" cy="234696"/>
+          </a:xfrm>
+          <a:prstGeom prst="rect">
+            <a:avLst/>
+          </a:prstGeom>
+          <a:noFill/>
+          <a:ln>
+            <a:noFill/>
+          </a:ln>
+        </p:spPr>
+        <p:txBody>
+          <a:bodyPr wrap="none" lIns="0" tIns="0" rIns="0" bIns="0" anchor="t" anchorCtr="0">
+            <a:spAutoFit/>
+          </a:bodyPr>
+          <a:lstStyle/>
+          <a:p>
+            <a:pPr algn="l"/>
+            <a:r>
+              <a:rPr lang="en-US" sz="1200" dirty="0">
+                <a:solidFill>
+                  <a:srgbClr val="DDEBFF"/>
+                </a:solidFill>
+                <a:latin typeface="Arial"/>
+                <a:ea typeface="Arial"/>
+                <a:cs typeface="Arial"/>
+              </a:rPr>
+              <a:t>5 pts</a:t>
+            </a:r>
+          </a:p>
+        </p:txBody>
+      </p:sp>
+      <p:sp>
+        <p:nvSpPr>
+          <p:cNvPr id="33" name="TextBox 33"/>
+          <p:cNvSpPr txBox="1"/>
+          <p:nvPr/>
+        </p:nvSpPr>
+        <p:spPr>
+          <a:xfrm>
+            <a:off x="9518904" y="3442335"/>
+            <a:ext cx="101041" cy="234696"/>
+          </a:xfrm>
+          <a:prstGeom prst="rect">
+            <a:avLst/>
+          </a:prstGeom>
+          <a:noFill/>
+          <a:ln>
+            <a:noFill/>
+          </a:ln>
+        </p:spPr>
+        <p:txBody>
+          <a:bodyPr wrap="none" lIns="0" tIns="0" rIns="0" bIns="0" anchor="t" anchorCtr="0">
+            <a:spAutoFit/>
+          </a:bodyPr>
+          <a:lstStyle/>
+          <a:p>
+            <a:pPr algn="l"/>
+            <a:r>
+              <a:rPr lang="en-US" sz="1200" dirty="0">
+                <a:solidFill>
+                  <a:srgbClr val="FFD54F"/>
+                </a:solidFill>
+                <a:latin typeface="Arial"/>
+                <a:ea typeface="Arial"/>
+                <a:cs typeface="Arial"/>
+              </a:rPr>
+              <a:t>✅</a:t>
+            </a:r>
+          </a:p>
+        </p:txBody>
+      </p:sp>
+      <p:sp>
+        <p:nvSpPr>
+          <p:cNvPr id="34" name="TextBox 34"/>
+          <p:cNvSpPr txBox="1"/>
+          <p:nvPr/>
+        </p:nvSpPr>
+        <p:spPr>
+          <a:xfrm>
+            <a:off x="9804654" y="3442335"/>
+            <a:ext cx="669341" cy="234696"/>
+          </a:xfrm>
+          <a:prstGeom prst="rect">
+            <a:avLst/>
+          </a:prstGeom>
+          <a:noFill/>
+          <a:ln>
+            <a:noFill/>
+          </a:ln>
+        </p:spPr>
+        <p:txBody>
+          <a:bodyPr wrap="none" lIns="0" tIns="0" rIns="0" bIns="0" anchor="t" anchorCtr="0">
+            <a:spAutoFit/>
+          </a:bodyPr>
+          <a:lstStyle/>
+          <a:p>
+            <a:pPr algn="l"/>
+            <a:r>
+              <a:rPr lang="en-US" sz="1200" dirty="0">
+                <a:solidFill>
+                  <a:srgbClr val="B7C7DE"/>
+                </a:solidFill>
+                <a:latin typeface="Arial"/>
+                <a:ea typeface="Arial"/>
+                <a:cs typeface="Arial"/>
+              </a:rPr>
+              <a:t>BFS/DFS</a:t>
+            </a:r>
+          </a:p>
+        </p:txBody>
+      </p:sp>
+      <p:sp>
+        <p:nvSpPr>
+          <p:cNvPr id="35" name="TextBox 35"/>
+          <p:cNvSpPr txBox="1"/>
+          <p:nvPr/>
+        </p:nvSpPr>
+        <p:spPr>
+          <a:xfrm>
+            <a:off x="6470904" y="3728085"/>
+            <a:ext cx="496824" cy="234696"/>
+          </a:xfrm>
+          <a:prstGeom prst="rect">
+            <a:avLst/>
+          </a:prstGeom>
+          <a:noFill/>
+          <a:ln>
+            <a:noFill/>
+          </a:ln>
+        </p:spPr>
+        <p:txBody>
+          <a:bodyPr wrap="none" lIns="0" tIns="0" rIns="0" bIns="0" anchor="t" anchorCtr="0">
+            <a:spAutoFit/>
+          </a:bodyPr>
+          <a:lstStyle/>
+          <a:p>
+            <a:pPr algn="l"/>
+            <a:r>
+              <a:rPr lang="zh-CN" sz="1200" dirty="0">
+                <a:solidFill>
+                  <a:srgbClr val="DDEBFF"/>
+                </a:solidFill>
+                <a:latin typeface="Arial"/>
+                <a:ea typeface="Microsoft YaHei"/>
+                <a:cs typeface="Arial"/>
+              </a:rPr>
+              <a:t>可视化</a:t>
+            </a:r>
+          </a:p>
+        </p:txBody>
+      </p:sp>
+      <p:sp>
+        <p:nvSpPr>
+          <p:cNvPr id="36" name="TextBox 36"/>
+          <p:cNvSpPr txBox="1"/>
+          <p:nvPr/>
+        </p:nvSpPr>
+        <p:spPr>
+          <a:xfrm>
+            <a:off x="8566404" y="3728085"/>
+            <a:ext cx="101041" cy="234696"/>
+          </a:xfrm>
+          <a:prstGeom prst="rect">
+            <a:avLst/>
+          </a:prstGeom>
+          <a:noFill/>
+          <a:ln>
+            <a:noFill/>
+          </a:ln>
+        </p:spPr>
+        <p:txBody>
+          <a:bodyPr wrap="none" lIns="0" tIns="0" rIns="0" bIns="0" anchor="t" anchorCtr="0">
+            <a:spAutoFit/>
+          </a:bodyPr>
+          <a:lstStyle/>
+          <a:p>
+            <a:pPr algn="l"/>
+            <a:r>
+              <a:rPr lang="en-US" sz="1200" dirty="0">
+                <a:solidFill>
+                  <a:srgbClr val="DDEBFF"/>
+                </a:solidFill>
+                <a:latin typeface="Arial"/>
+                <a:ea typeface="Arial"/>
+                <a:cs typeface="Arial"/>
+              </a:rPr>
+              <a:t>—</a:t>
+            </a:r>
+          </a:p>
+        </p:txBody>
+      </p:sp>
+      <p:sp>
+        <p:nvSpPr>
+          <p:cNvPr id="37" name="TextBox 37"/>
+          <p:cNvSpPr txBox="1"/>
+          <p:nvPr/>
+        </p:nvSpPr>
+        <p:spPr>
+          <a:xfrm>
+            <a:off x="9518904" y="3728085"/>
+            <a:ext cx="101041" cy="234696"/>
+          </a:xfrm>
+          <a:prstGeom prst="rect">
+            <a:avLst/>
+          </a:prstGeom>
+          <a:noFill/>
+          <a:ln>
+            <a:noFill/>
+          </a:ln>
+        </p:spPr>
+        <p:txBody>
+          <a:bodyPr wrap="none" lIns="0" tIns="0" rIns="0" bIns="0" anchor="t" anchorCtr="0">
+            <a:spAutoFit/>
+          </a:bodyPr>
+          <a:lstStyle/>
+          <a:p>
+            <a:pPr algn="l"/>
+            <a:r>
+              <a:rPr lang="en-US" sz="1200" dirty="0">
+                <a:solidFill>
+                  <a:srgbClr val="FFD54F"/>
+                </a:solidFill>
+                <a:latin typeface="Arial"/>
+                <a:ea typeface="Arial"/>
+                <a:cs typeface="Arial"/>
+              </a:rPr>
+              <a:t>✅</a:t>
+            </a:r>
+          </a:p>
+        </p:txBody>
+      </p:sp>
+      <p:sp>
+        <p:nvSpPr>
+          <p:cNvPr id="38" name="TextBox 38"/>
+          <p:cNvSpPr txBox="1"/>
+          <p:nvPr/>
+        </p:nvSpPr>
+        <p:spPr>
+          <a:xfrm>
+            <a:off x="9804654" y="3728085"/>
+            <a:ext cx="1373490" cy="234696"/>
+          </a:xfrm>
+          <a:prstGeom prst="rect">
+            <a:avLst/>
+          </a:prstGeom>
+          <a:noFill/>
+          <a:ln>
+            <a:noFill/>
+          </a:ln>
+        </p:spPr>
+        <p:txBody>
+          <a:bodyPr wrap="none" lIns="0" tIns="0" rIns="0" bIns="0" anchor="t" anchorCtr="0">
+            <a:spAutoFit/>
+          </a:bodyPr>
+          <a:lstStyle/>
+          <a:p>
+            <a:pPr algn="l"/>
+            <a:r>
+              <a:rPr lang="zh-CN" sz="1200" dirty="0">
+                <a:solidFill>
+                  <a:srgbClr val="B7C7DE"/>
+                </a:solidFill>
+                <a:latin typeface="Arial"/>
+                <a:ea typeface="Microsoft YaHei"/>
+                <a:cs typeface="Arial"/>
+              </a:rPr>
+              <a:t>Web UI + 官方配色</a:t>
+            </a:r>
+          </a:p>
+        </p:txBody>
+      </p:sp>
+      <p:sp>
+        <p:nvSpPr>
+          <p:cNvPr id="39" name="Rectangle 39"/>
+          <p:cNvSpPr/>
+          <p:nvPr/>
+        </p:nvSpPr>
+        <p:spPr>
+          <a:xfrm>
+            <a:off x="571500" y="4381500"/>
+            <a:ext cx="5334000" cy="2095500"/>
+          </a:xfrm>
+          <a:prstGeom prst="roundRect">
+            <a:avLst>
+              <a:gd name="adj" fmla="val 4545"/>
+            </a:avLst>
+          </a:prstGeom>
+          <a:solidFill>
+            <a:srgbClr val="132846"/>
+          </a:solidFill>
+          <a:ln w="19050">
+            <a:solidFill>
+              <a:srgbClr val="1E3A5F"/>
+            </a:solidFill>
+          </a:ln>
+        </p:spPr>
+      </p:sp>
+      <p:sp>
+        <p:nvSpPr>
+          <p:cNvPr id="40" name="TextBox 40"/>
+          <p:cNvSpPr txBox="1"/>
+          <p:nvPr/>
+        </p:nvSpPr>
+        <p:spPr>
+          <a:xfrm>
+            <a:off x="753618" y="4489132"/>
+            <a:ext cx="483222" cy="322707"/>
+          </a:xfrm>
+          <a:prstGeom prst="rect">
+            <a:avLst/>
+          </a:prstGeom>
+          <a:noFill/>
+          <a:ln>
+            <a:noFill/>
+          </a:ln>
+        </p:spPr>
+        <p:txBody>
+          <a:bodyPr wrap="none" lIns="0" tIns="0" rIns="0" bIns="0" anchor="t" anchorCtr="0">
+            <a:spAutoFit/>
+          </a:bodyPr>
+          <a:lstStyle/>
+          <a:p>
+            <a:pPr algn="l"/>
+            <a:r>
+              <a:rPr lang="zh-CN" sz="1650" b="1" dirty="0">
+                <a:solidFill>
+                  <a:srgbClr val="FFD54F"/>
+                </a:solidFill>
+                <a:latin typeface="Arial"/>
+                <a:ea typeface="Microsoft YaHei"/>
+                <a:cs typeface="Arial"/>
+              </a:rPr>
+              <a:t>收获</a:t>
+            </a:r>
+          </a:p>
+        </p:txBody>
+      </p:sp>
+      <p:sp>
+        <p:nvSpPr>
+          <p:cNvPr id="41" name="TextBox 41"/>
+          <p:cNvSpPr txBox="1"/>
+          <p:nvPr/>
+        </p:nvSpPr>
+        <p:spPr>
+          <a:xfrm>
+            <a:off x="755523" y="4862989"/>
+            <a:ext cx="4266562" cy="249364"/>
+          </a:xfrm>
+          <a:prstGeom prst="rect">
+            <a:avLst/>
+          </a:prstGeom>
+          <a:noFill/>
+          <a:ln>
+            <a:noFill/>
+          </a:ln>
+        </p:spPr>
+        <p:txBody>
+          <a:bodyPr wrap="none" lIns="0" tIns="0" rIns="0" bIns="0" anchor="t" anchorCtr="0">
+            <a:spAutoFit/>
+          </a:bodyPr>
+          <a:lstStyle/>
+          <a:p>
+            <a:pPr algn="l"/>
+            <a:r>
+              <a:rPr lang="zh-CN" sz="1280" dirty="0">
+                <a:solidFill>
+                  <a:srgbClr val="DDEBFF"/>
+                </a:solidFill>
+                <a:latin typeface="Arial"/>
+                <a:ea typeface="Microsoft YaHei"/>
+                <a:cs typeface="Arial"/>
+              </a:rPr>
+              <a:t>▸ C++ 图算法从零实现（Dijkstra · Yen · BFS · DFS）</a:t>
+            </a:r>
+          </a:p>
+        </p:txBody>
+      </p:sp>
+      <p:sp>
+        <p:nvSpPr>
+          <p:cNvPr id="42" name="TextBox 42"/>
+          <p:cNvSpPr txBox="1"/>
+          <p:nvPr/>
+        </p:nvSpPr>
+        <p:spPr>
+          <a:xfrm>
+            <a:off x="755523" y="5243989"/>
+            <a:ext cx="3898312" cy="249364"/>
+          </a:xfrm>
+          <a:prstGeom prst="rect">
+            <a:avLst/>
+          </a:prstGeom>
+          <a:noFill/>
+          <a:ln>
+            <a:noFill/>
+          </a:ln>
+        </p:spPr>
+        <p:txBody>
+          <a:bodyPr wrap="none" lIns="0" tIns="0" rIns="0" bIns="0" anchor="t" anchorCtr="0">
+            <a:spAutoFit/>
+          </a:bodyPr>
+          <a:lstStyle/>
+          <a:p>
+            <a:pPr algn="l"/>
+            <a:r>
+              <a:rPr lang="zh-CN" sz="1280" dirty="0">
+                <a:solidFill>
+                  <a:srgbClr val="DDEBFF"/>
+                </a:solidFill>
+                <a:latin typeface="Arial"/>
+                <a:ea typeface="Microsoft YaHei"/>
+                <a:cs typeface="Arial"/>
+              </a:rPr>
+              <a:t>▸ REST + 并发编程实践（shared_mutex 读写锁）</a:t>
+            </a:r>
+          </a:p>
+        </p:txBody>
+      </p:sp>
+      <p:sp>
+        <p:nvSpPr>
+          <p:cNvPr id="43" name="TextBox 43"/>
+          <p:cNvSpPr txBox="1"/>
+          <p:nvPr/>
+        </p:nvSpPr>
+        <p:spPr>
+          <a:xfrm>
+            <a:off x="755523" y="5624989"/>
+            <a:ext cx="4428973" cy="249364"/>
+          </a:xfrm>
+          <a:prstGeom prst="rect">
+            <a:avLst/>
+          </a:prstGeom>
+          <a:noFill/>
+          <a:ln>
+            <a:noFill/>
+          </a:ln>
+        </p:spPr>
+        <p:txBody>
+          <a:bodyPr wrap="none" lIns="0" tIns="0" rIns="0" bIns="0" anchor="t" anchorCtr="0">
+            <a:spAutoFit/>
+          </a:bodyPr>
+          <a:lstStyle/>
+          <a:p>
+            <a:pPr algn="l"/>
+            <a:r>
+              <a:rPr lang="zh-CN" sz="1280" dirty="0">
+                <a:solidFill>
+                  <a:srgbClr val="DDEBFF"/>
+                </a:solidFill>
+                <a:latin typeface="Arial"/>
+                <a:ea typeface="Microsoft YaHei"/>
+                <a:cs typeface="Arial"/>
+              </a:rPr>
+              <a:t>▸ 真实数据集端到端流水线（API → CSV → 图 → 可视化）</a:t>
+            </a:r>
+          </a:p>
+        </p:txBody>
+      </p:sp>
+      <p:sp>
+        <p:nvSpPr>
+          <p:cNvPr id="44" name="TextBox 44"/>
+          <p:cNvSpPr txBox="1"/>
+          <p:nvPr/>
+        </p:nvSpPr>
+        <p:spPr>
+          <a:xfrm>
+            <a:off x="756666" y="6173152"/>
+            <a:ext cx="4008643" cy="205359"/>
+          </a:xfrm>
+          <a:prstGeom prst="rect">
+            <a:avLst/>
+          </a:prstGeom>
+          <a:noFill/>
+          <a:ln>
+            <a:noFill/>
+          </a:ln>
+        </p:spPr>
+        <p:txBody>
+          <a:bodyPr wrap="none" lIns="0" tIns="0" rIns="0" bIns="0" anchor="t" anchorCtr="0">
+            <a:spAutoFit/>
+          </a:bodyPr>
+          <a:lstStyle/>
+          <a:p>
+            <a:pPr algn="l"/>
+            <a:r>
+              <a:rPr lang="en-US" sz="1050" dirty="0">
+                <a:solidFill>
+                  <a:srgbClr val="91A9C8"/>
+                </a:solidFill>
+                <a:latin typeface="Consolas"/>
+                <a:ea typeface="Consolas"/>
+                <a:cs typeface="Consolas"/>
+              </a:rPr>
+              <a:t>github.com/Weishi-corroding/shanghai-metro-pathfinder</a:t>
+            </a:r>
+          </a:p>
+        </p:txBody>
+      </p:sp>
+      <p:sp>
+        <p:nvSpPr>
+          <p:cNvPr id="45" name="Rectangle 45"/>
+          <p:cNvSpPr/>
+          <p:nvPr/>
+        </p:nvSpPr>
+        <p:spPr>
+          <a:xfrm>
+            <a:off x="6286500" y="4381500"/>
+            <a:ext cx="5334000" cy="2095500"/>
+          </a:xfrm>
+          <a:prstGeom prst="roundRect">
+            <a:avLst>
+              <a:gd name="adj" fmla="val 4545"/>
+            </a:avLst>
+          </a:prstGeom>
+          <a:solidFill>
+            <a:srgbClr val="132846"/>
+          </a:solidFill>
+          <a:ln w="19050">
+            <a:solidFill>
+              <a:srgbClr val="1E3A5F"/>
+            </a:solidFill>
+          </a:ln>
+        </p:spPr>
+      </p:sp>
+      <p:sp>
+        <p:nvSpPr>
+          <p:cNvPr id="46" name="TextBox 46"/>
+          <p:cNvSpPr txBox="1"/>
+          <p:nvPr/>
+        </p:nvSpPr>
+        <p:spPr>
+          <a:xfrm>
+            <a:off x="6468618" y="4489132"/>
+            <a:ext cx="483222" cy="322707"/>
+          </a:xfrm>
+          <a:prstGeom prst="rect">
+            <a:avLst/>
+          </a:prstGeom>
+          <a:noFill/>
+          <a:ln>
+            <a:noFill/>
+          </a:ln>
+        </p:spPr>
+        <p:txBody>
+          <a:bodyPr wrap="none" lIns="0" tIns="0" rIns="0" bIns="0" anchor="t" anchorCtr="0">
+            <a:spAutoFit/>
+          </a:bodyPr>
+          <a:lstStyle/>
+          <a:p>
+            <a:pPr algn="l"/>
+            <a:r>
+              <a:rPr lang="zh-CN" sz="1650" b="1" dirty="0">
+                <a:solidFill>
+                  <a:srgbClr val="FFD54F"/>
+                </a:solidFill>
+                <a:latin typeface="Arial"/>
+                <a:ea typeface="Microsoft YaHei"/>
+                <a:cs typeface="Arial"/>
+              </a:rPr>
+              <a:t>展望</a:t>
+            </a:r>
+          </a:p>
+        </p:txBody>
+      </p:sp>
+      <p:sp>
+        <p:nvSpPr>
+          <p:cNvPr id="47" name="TextBox 47"/>
+          <p:cNvSpPr txBox="1"/>
+          <p:nvPr/>
+        </p:nvSpPr>
+        <p:spPr>
+          <a:xfrm>
+            <a:off x="6470523" y="4862989"/>
+            <a:ext cx="1531972" cy="249364"/>
+          </a:xfrm>
+          <a:prstGeom prst="rect">
+            <a:avLst/>
+          </a:prstGeom>
+          <a:noFill/>
+          <a:ln>
+            <a:noFill/>
+          </a:ln>
+        </p:spPr>
+        <p:txBody>
+          <a:bodyPr wrap="none" lIns="0" tIns="0" rIns="0" bIns="0" anchor="t" anchorCtr="0">
+            <a:spAutoFit/>
+          </a:bodyPr>
+          <a:lstStyle/>
+          <a:p>
+            <a:pPr algn="l"/>
+            <a:r>
+              <a:rPr lang="zh-CN" sz="1280" dirty="0">
+                <a:solidFill>
+                  <a:srgbClr val="DDEBFF"/>
+                </a:solidFill>
+                <a:latin typeface="Arial"/>
+                <a:ea typeface="Microsoft YaHei"/>
+                <a:cs typeface="Arial"/>
+              </a:rPr>
+              <a:t>▸ 实时运营状态接入</a:t>
+            </a:r>
+          </a:p>
+        </p:txBody>
+      </p:sp>
+      <p:sp>
+        <p:nvSpPr>
+          <p:cNvPr id="48" name="TextBox 48"/>
+          <p:cNvSpPr txBox="1"/>
+          <p:nvPr/>
+        </p:nvSpPr>
+        <p:spPr>
+          <a:xfrm>
+            <a:off x="6470523" y="5148739"/>
+            <a:ext cx="1255243" cy="249364"/>
+          </a:xfrm>
+          <a:prstGeom prst="rect">
+            <a:avLst/>
+          </a:prstGeom>
+          <a:noFill/>
+          <a:ln>
+            <a:noFill/>
+          </a:ln>
+        </p:spPr>
+        <p:txBody>
+          <a:bodyPr wrap="none" lIns="0" tIns="0" rIns="0" bIns="0" anchor="t" anchorCtr="0">
+            <a:spAutoFit/>
+          </a:bodyPr>
+          <a:lstStyle/>
+          <a:p>
+            <a:pPr algn="l"/>
+            <a:r>
+              <a:rPr lang="zh-CN" sz="1280" dirty="0">
+                <a:solidFill>
+                  <a:srgbClr val="DDEBFF"/>
+                </a:solidFill>
+                <a:latin typeface="Arial"/>
+                <a:ea typeface="Microsoft YaHei"/>
+                <a:cs typeface="Arial"/>
+              </a:rPr>
+              <a:t>▸ 移动端 / PWA</a:t>
+            </a:r>
+          </a:p>
+        </p:txBody>
+      </p:sp>
+      <p:sp>
+        <p:nvSpPr>
+          <p:cNvPr id="49" name="TextBox 49"/>
+          <p:cNvSpPr txBox="1"/>
+          <p:nvPr/>
+        </p:nvSpPr>
+        <p:spPr>
+          <a:xfrm>
+            <a:off x="6470523" y="5434489"/>
+            <a:ext cx="2072640" cy="249364"/>
+          </a:xfrm>
+          <a:prstGeom prst="rect">
+            <a:avLst/>
+          </a:prstGeom>
+          <a:noFill/>
+          <a:ln>
+            <a:noFill/>
+          </a:ln>
+        </p:spPr>
+        <p:txBody>
+          <a:bodyPr wrap="none" lIns="0" tIns="0" rIns="0" bIns="0" anchor="t" anchorCtr="0">
+            <a:spAutoFit/>
+          </a:bodyPr>
+          <a:lstStyle/>
+          <a:p>
+            <a:pPr algn="l"/>
+            <a:r>
+              <a:rPr lang="zh-CN" sz="1280" dirty="0">
+                <a:solidFill>
+                  <a:srgbClr val="DDEBFF"/>
+                </a:solidFill>
+                <a:latin typeface="Arial"/>
+                <a:ea typeface="Microsoft YaHei"/>
+                <a:cs typeface="Arial"/>
+              </a:rPr>
+              <a:t>▸ 多目标（票价 + 拥挤度）</a:t>
+            </a:r>
+          </a:p>
+        </p:txBody>
+      </p:sp>
+      <p:sp>
+        <p:nvSpPr>
+          <p:cNvPr id="50" name="TextBox 50"/>
+          <p:cNvSpPr txBox="1"/>
+          <p:nvPr/>
+        </p:nvSpPr>
+        <p:spPr>
+          <a:xfrm>
+            <a:off x="6470523" y="5720239"/>
+            <a:ext cx="1531972" cy="249364"/>
+          </a:xfrm>
+          <a:prstGeom prst="rect">
+            <a:avLst/>
+          </a:prstGeom>
+          <a:noFill/>
+          <a:ln>
+            <a:noFill/>
+          </a:ln>
+        </p:spPr>
+        <p:txBody>
+          <a:bodyPr wrap="none" lIns="0" tIns="0" rIns="0" bIns="0" anchor="t" anchorCtr="0">
+            <a:spAutoFit/>
+          </a:bodyPr>
+          <a:lstStyle/>
+          <a:p>
+            <a:pPr algn="l"/>
+            <a:r>
+              <a:rPr lang="zh-CN" sz="1280" dirty="0">
+                <a:solidFill>
+                  <a:srgbClr val="DDEBFF"/>
+                </a:solidFill>
+                <a:latin typeface="Arial"/>
+                <a:ea typeface="Microsoft YaHei"/>
+                <a:cs typeface="Arial"/>
+              </a:rPr>
+              <a:t>▸ 历史行程学习推荐</a:t>
+            </a:r>
+          </a:p>
+        </p:txBody>
+      </p:sp>
+      <p:sp>
+        <p:nvSpPr>
+          <p:cNvPr id="51" name="TextBox 51"/>
+          <p:cNvSpPr txBox="1"/>
+          <p:nvPr/>
+        </p:nvSpPr>
+        <p:spPr>
+          <a:xfrm>
+            <a:off x="8512835" y="6173152"/>
+            <a:ext cx="2922499" cy="205359"/>
+          </a:xfrm>
+          <a:prstGeom prst="rect">
+            <a:avLst/>
+          </a:prstGeom>
+          <a:noFill/>
+          <a:ln>
+            <a:noFill/>
+          </a:ln>
+        </p:spPr>
+        <p:txBody>
+          <a:bodyPr wrap="none" lIns="0" tIns="0" rIns="0" bIns="0" anchor="t" anchorCtr="0">
+            <a:spAutoFit/>
+          </a:bodyPr>
+          <a:lstStyle/>
+          <a:p>
+            <a:pPr algn="r"/>
+            <a:r>
+              <a:rPr lang="zh-CN" sz="1050" dirty="0">
+                <a:solidFill>
+                  <a:srgbClr val="91A9C8"/>
+                </a:solidFill>
+                <a:latin typeface="Consolas"/>
+                <a:ea typeface="Microsoft YaHei"/>
+                <a:cs typeface="Consolas"/>
+              </a:rPr>
+              <a:t>东华大学 · 数据结构课设 · 2026-07 · v2.0.0</a:t>
             </a:r>
           </a:p>
         </p:txBody>

</xml_diff>